<commit_message>
Unify finals poster deck and film with supplied light navy blue gold palette
</commit_message>
<xml_diff>
--- a/deliverables/決賽海報_AI資安框架_A2.pptx
+++ b/deliverables/決賽海報_AI資安框架_A2.pptx
@@ -3197,7 +3197,7 @@
             <a:r>
               <a:rPr sz="1400" b="0">
                 <a:solidFill>
-                  <a:srgbClr val="0070D1"/>
+                  <a:srgbClr val="105186"/>
                 </a:solidFill>
                 <a:latin typeface="Times New Roman"/>
                 <a:ea typeface="DFKai-SB"/>
@@ -3244,7 +3244,7 @@
             <a:r>
               <a:rPr sz="3200" b="0">
                 <a:solidFill>
-                  <a:srgbClr val="121314"/>
+                  <a:srgbClr val="092B42"/>
                 </a:solidFill>
                 <a:latin typeface="Times New Roman"/>
                 <a:ea typeface="DFKai-SB"/>
@@ -3268,7 +3268,7 @@
             <a:r>
               <a:rPr sz="3200" b="0">
                 <a:solidFill>
-                  <a:srgbClr val="121314"/>
+                  <a:srgbClr val="092B42"/>
                 </a:solidFill>
                 <a:latin typeface="Times New Roman"/>
                 <a:ea typeface="DFKai-SB"/>
@@ -3292,7 +3292,7 @@
             <a:r>
               <a:rPr sz="3200" b="0">
                 <a:solidFill>
-                  <a:srgbClr val="121314"/>
+                  <a:srgbClr val="092B42"/>
                 </a:solidFill>
                 <a:latin typeface="Times New Roman"/>
                 <a:ea typeface="DFKai-SB"/>
@@ -3303,7 +3303,7 @@
             <a:r>
               <a:rPr sz="3200" b="0">
                 <a:solidFill>
-                  <a:srgbClr val="121314"/>
+                  <a:srgbClr val="092B42"/>
                 </a:solidFill>
                 <a:latin typeface="Times New Roman"/>
                 <a:ea typeface="DFKai-SB"/>
@@ -3314,7 +3314,7 @@
             <a:r>
               <a:rPr sz="3200" b="0">
                 <a:solidFill>
-                  <a:srgbClr val="121314"/>
+                  <a:srgbClr val="092B42"/>
                 </a:solidFill>
                 <a:latin typeface="Times New Roman"/>
                 <a:ea typeface="DFKai-SB"/>
@@ -3361,7 +3361,7 @@
             <a:r>
               <a:rPr sz="2200" b="0">
                 <a:solidFill>
-                  <a:srgbClr val="0070D1"/>
+                  <a:srgbClr val="105186"/>
                 </a:solidFill>
                 <a:latin typeface="Times New Roman"/>
                 <a:ea typeface="DFKai-SB"/>
@@ -3388,7 +3388,7 @@
           </a:prstGeom>
           <a:ln w="12700">
             <a:solidFill>
-              <a:srgbClr val="CCDCEB"/>
+              <a:srgbClr val="D6DDE0"/>
             </a:solidFill>
           </a:ln>
           <a:effectLst/>
@@ -3468,7 +3468,7 @@
             <a:r>
               <a:rPr sz="2300" b="0">
                 <a:solidFill>
-                  <a:srgbClr val="121314"/>
+                  <a:srgbClr val="171C1D"/>
                 </a:solidFill>
                 <a:latin typeface="Times New Roman"/>
                 <a:ea typeface="DFKai-SB"/>
@@ -3515,7 +3515,7 @@
             <a:r>
               <a:rPr sz="1700" b="0">
                 <a:solidFill>
-                  <a:srgbClr val="526477"/>
+                  <a:srgbClr val="53666E"/>
                 </a:solidFill>
                 <a:latin typeface="Times New Roman"/>
                 <a:ea typeface="DFKai-SB"/>
@@ -3562,7 +3562,7 @@
             <a:r>
               <a:rPr sz="2000" b="1">
                 <a:solidFill>
-                  <a:srgbClr val="0070D1"/>
+                  <a:srgbClr val="105186"/>
                 </a:solidFill>
                 <a:latin typeface="Times New Roman"/>
                 <a:ea typeface="DFKai-SB"/>
@@ -3609,7 +3609,7 @@
             <a:r>
               <a:rPr sz="2400" b="0">
                 <a:solidFill>
-                  <a:srgbClr val="121314"/>
+                  <a:srgbClr val="092B42"/>
                 </a:solidFill>
                 <a:latin typeface="Times New Roman"/>
                 <a:ea typeface="DFKai-SB"/>
@@ -3635,11 +3635,11 @@
             <a:avLst/>
           </a:prstGeom>
           <a:solidFill>
-            <a:srgbClr val="F5F8FC"/>
+            <a:srgbClr val="F0F2F3"/>
           </a:solidFill>
           <a:ln w="10160">
             <a:solidFill>
-              <a:srgbClr val="CCDCEB"/>
+              <a:srgbClr val="D6DDE0"/>
             </a:solidFill>
           </a:ln>
           <a:effectLst/>
@@ -3681,7 +3681,7 @@
             <a:avLst/>
           </a:prstGeom>
           <a:solidFill>
-            <a:srgbClr val="0070D1"/>
+            <a:srgbClr val="105186"/>
           </a:solidFill>
           <a:ln>
             <a:noFill/>
@@ -3746,7 +3746,7 @@
             <a:r>
               <a:rPr sz="1800" b="1">
                 <a:solidFill>
-                  <a:srgbClr val="0070D1"/>
+                  <a:srgbClr val="105186"/>
                 </a:solidFill>
                 <a:latin typeface="Times New Roman"/>
                 <a:ea typeface="DFKai-SB"/>
@@ -3793,7 +3793,7 @@
             <a:r>
               <a:rPr sz="2300" b="0">
                 <a:solidFill>
-                  <a:srgbClr val="121314"/>
+                  <a:srgbClr val="171C1D"/>
                 </a:solidFill>
                 <a:latin typeface="Times New Roman"/>
                 <a:ea typeface="DFKai-SB"/>
@@ -3864,7 +3864,7 @@
             <a:r>
               <a:rPr sz="1800" b="0">
                 <a:solidFill>
-                  <a:srgbClr val="121314"/>
+                  <a:srgbClr val="171C1D"/>
                 </a:solidFill>
                 <a:latin typeface="Times New Roman"/>
                 <a:ea typeface="DFKai-SB"/>
@@ -3875,7 +3875,7 @@
             <a:r>
               <a:rPr sz="1800" b="0">
                 <a:solidFill>
-                  <a:srgbClr val="121314"/>
+                  <a:srgbClr val="171C1D"/>
                 </a:solidFill>
                 <a:latin typeface="Times New Roman"/>
                 <a:ea typeface="DFKai-SB"/>
@@ -3922,7 +3922,7 @@
             <a:r>
               <a:rPr sz="1800" b="0">
                 <a:solidFill>
-                  <a:srgbClr val="121314"/>
+                  <a:srgbClr val="171C1D"/>
                 </a:solidFill>
                 <a:latin typeface="Times New Roman"/>
                 <a:ea typeface="DFKai-SB"/>
@@ -3933,7 +3933,7 @@
             <a:r>
               <a:rPr sz="1800" b="0">
                 <a:solidFill>
-                  <a:srgbClr val="121314"/>
+                  <a:srgbClr val="171C1D"/>
                 </a:solidFill>
                 <a:latin typeface="Times New Roman"/>
                 <a:ea typeface="DFKai-SB"/>
@@ -3959,7 +3959,7 @@
             <a:avLst/>
           </a:prstGeom>
           <a:solidFill>
-            <a:srgbClr val="0070D1"/>
+            <a:srgbClr val="105186"/>
           </a:solidFill>
           <a:ln>
             <a:noFill/>
@@ -4024,7 +4024,7 @@
             <a:r>
               <a:rPr sz="2000" b="1">
                 <a:solidFill>
-                  <a:srgbClr val="0070D1"/>
+                  <a:srgbClr val="105186"/>
                 </a:solidFill>
                 <a:latin typeface="Times New Roman"/>
                 <a:ea typeface="DFKai-SB"/>
@@ -4035,7 +4035,7 @@
             <a:r>
               <a:rPr sz="2000" b="1">
                 <a:solidFill>
-                  <a:srgbClr val="0070D1"/>
+                  <a:srgbClr val="105186"/>
                 </a:solidFill>
                 <a:latin typeface="Times New Roman"/>
                 <a:ea typeface="DFKai-SB"/>
@@ -4046,7 +4046,7 @@
             <a:r>
               <a:rPr sz="2000" b="1">
                 <a:solidFill>
-                  <a:srgbClr val="0070D1"/>
+                  <a:srgbClr val="105186"/>
                 </a:solidFill>
                 <a:latin typeface="Times New Roman"/>
                 <a:ea typeface="DFKai-SB"/>
@@ -4093,7 +4093,7 @@
             <a:r>
               <a:rPr sz="1500" b="0">
                 <a:solidFill>
-                  <a:srgbClr val="526477"/>
+                  <a:srgbClr val="53666E"/>
                 </a:solidFill>
                 <a:latin typeface="Times New Roman"/>
                 <a:ea typeface="DFKai-SB"/>
@@ -4104,7 +4104,7 @@
             <a:r>
               <a:rPr sz="1500" b="0">
                 <a:solidFill>
-                  <a:srgbClr val="526477"/>
+                  <a:srgbClr val="53666E"/>
                 </a:solidFill>
                 <a:latin typeface="Times New Roman"/>
                 <a:ea typeface="DFKai-SB"/>
@@ -4115,7 +4115,7 @@
             <a:r>
               <a:rPr sz="1500" b="0">
                 <a:solidFill>
-                  <a:srgbClr val="526477"/>
+                  <a:srgbClr val="53666E"/>
                 </a:solidFill>
                 <a:latin typeface="Times New Roman"/>
                 <a:ea typeface="DFKai-SB"/>
@@ -4126,7 +4126,7 @@
             <a:r>
               <a:rPr sz="1500" b="0">
                 <a:solidFill>
-                  <a:srgbClr val="526477"/>
+                  <a:srgbClr val="53666E"/>
                 </a:solidFill>
                 <a:latin typeface="Times New Roman"/>
                 <a:ea typeface="DFKai-SB"/>
@@ -4137,7 +4137,7 @@
             <a:r>
               <a:rPr sz="1500" b="0">
                 <a:solidFill>
-                  <a:srgbClr val="526477"/>
+                  <a:srgbClr val="53666E"/>
                 </a:solidFill>
                 <a:latin typeface="Times New Roman"/>
                 <a:ea typeface="DFKai-SB"/>
@@ -4163,11 +4163,11 @@
             <a:avLst/>
           </a:prstGeom>
           <a:solidFill>
-            <a:srgbClr val="F5F8FC"/>
+            <a:srgbClr val="F0F2F3"/>
           </a:solidFill>
           <a:ln w="10160">
             <a:solidFill>
-              <a:srgbClr val="CCDCEB"/>
+              <a:srgbClr val="D6DDE0"/>
             </a:solidFill>
           </a:ln>
           <a:effectLst/>
@@ -4209,7 +4209,7 @@
             <a:avLst/>
           </a:prstGeom>
           <a:solidFill>
-            <a:srgbClr val="0070D1"/>
+            <a:srgbClr val="105186"/>
           </a:solidFill>
           <a:ln>
             <a:noFill/>
@@ -4274,7 +4274,7 @@
             <a:r>
               <a:rPr sz="1800" b="1">
                 <a:solidFill>
-                  <a:srgbClr val="0070D1"/>
+                  <a:srgbClr val="105186"/>
                 </a:solidFill>
                 <a:latin typeface="Times New Roman"/>
                 <a:ea typeface="DFKai-SB"/>
@@ -4321,7 +4321,7 @@
             <a:r>
               <a:rPr sz="2300" b="0">
                 <a:solidFill>
-                  <a:srgbClr val="121314"/>
+                  <a:srgbClr val="171C1D"/>
                 </a:solidFill>
                 <a:latin typeface="Times New Roman"/>
                 <a:ea typeface="DFKai-SB"/>
@@ -4392,7 +4392,7 @@
             <a:r>
               <a:rPr sz="2000" b="0">
                 <a:solidFill>
-                  <a:srgbClr val="121314"/>
+                  <a:srgbClr val="171C1D"/>
                 </a:solidFill>
                 <a:latin typeface="Times New Roman"/>
                 <a:ea typeface="DFKai-SB"/>
@@ -4403,7 +4403,7 @@
             <a:r>
               <a:rPr sz="2000" b="0">
                 <a:solidFill>
-                  <a:srgbClr val="121314"/>
+                  <a:srgbClr val="171C1D"/>
                 </a:solidFill>
                 <a:latin typeface="Times New Roman"/>
                 <a:ea typeface="DFKai-SB"/>
@@ -4414,7 +4414,7 @@
             <a:r>
               <a:rPr sz="2000" b="0">
                 <a:solidFill>
-                  <a:srgbClr val="121314"/>
+                  <a:srgbClr val="171C1D"/>
                 </a:solidFill>
                 <a:latin typeface="Times New Roman"/>
                 <a:ea typeface="DFKai-SB"/>
@@ -4425,7 +4425,7 @@
             <a:r>
               <a:rPr sz="2000" b="0">
                 <a:solidFill>
-                  <a:srgbClr val="121314"/>
+                  <a:srgbClr val="171C1D"/>
                 </a:solidFill>
                 <a:latin typeface="Times New Roman"/>
                 <a:ea typeface="DFKai-SB"/>
@@ -4472,7 +4472,7 @@
             <a:r>
               <a:rPr sz="1800" b="0">
                 <a:solidFill>
-                  <a:srgbClr val="121314"/>
+                  <a:srgbClr val="171C1D"/>
                 </a:solidFill>
                 <a:latin typeface="Times New Roman"/>
                 <a:ea typeface="DFKai-SB"/>
@@ -4483,7 +4483,7 @@
             <a:r>
               <a:rPr sz="1800" b="0">
                 <a:solidFill>
-                  <a:srgbClr val="121314"/>
+                  <a:srgbClr val="171C1D"/>
                 </a:solidFill>
                 <a:latin typeface="Times New Roman"/>
                 <a:ea typeface="DFKai-SB"/>
@@ -4494,7 +4494,7 @@
             <a:r>
               <a:rPr sz="1800" b="0">
                 <a:solidFill>
-                  <a:srgbClr val="121314"/>
+                  <a:srgbClr val="171C1D"/>
                 </a:solidFill>
                 <a:latin typeface="Times New Roman"/>
                 <a:ea typeface="DFKai-SB"/>
@@ -4505,7 +4505,7 @@
             <a:r>
               <a:rPr sz="1800" b="0">
                 <a:solidFill>
-                  <a:srgbClr val="121314"/>
+                  <a:srgbClr val="171C1D"/>
                 </a:solidFill>
                 <a:latin typeface="Times New Roman"/>
                 <a:ea typeface="DFKai-SB"/>
@@ -4531,7 +4531,7 @@
             <a:avLst/>
           </a:prstGeom>
           <a:solidFill>
-            <a:srgbClr val="0070D1"/>
+            <a:srgbClr val="105186"/>
           </a:solidFill>
           <a:ln>
             <a:noFill/>
@@ -4596,7 +4596,7 @@
             <a:r>
               <a:rPr sz="2000" b="1">
                 <a:solidFill>
-                  <a:srgbClr val="0070D1"/>
+                  <a:srgbClr val="105186"/>
                 </a:solidFill>
                 <a:latin typeface="Times New Roman"/>
                 <a:ea typeface="DFKai-SB"/>
@@ -4607,7 +4607,7 @@
             <a:r>
               <a:rPr sz="2000" b="1">
                 <a:solidFill>
-                  <a:srgbClr val="0070D1"/>
+                  <a:srgbClr val="105186"/>
                 </a:solidFill>
                 <a:latin typeface="Times New Roman"/>
                 <a:ea typeface="DFKai-SB"/>
@@ -4654,7 +4654,7 @@
             <a:r>
               <a:rPr sz="1500" b="0">
                 <a:solidFill>
-                  <a:srgbClr val="526477"/>
+                  <a:srgbClr val="53666E"/>
                 </a:solidFill>
                 <a:latin typeface="Times New Roman"/>
                 <a:ea typeface="DFKai-SB"/>
@@ -4680,7 +4680,7 @@
             <a:avLst/>
           </a:prstGeom>
           <a:solidFill>
-            <a:srgbClr val="0070D1"/>
+            <a:srgbClr val="105186"/>
           </a:solidFill>
           <a:ln>
             <a:noFill/>
@@ -4724,7 +4724,7 @@
             <a:avLst/>
           </a:prstGeom>
           <a:solidFill>
-            <a:srgbClr val="0070D1"/>
+            <a:srgbClr val="105186"/>
           </a:solidFill>
           <a:ln>
             <a:noFill/>
@@ -4768,11 +4768,11 @@
             <a:avLst/>
           </a:prstGeom>
           <a:solidFill>
-            <a:srgbClr val="F5F8FC"/>
+            <a:srgbClr val="F0F2F3"/>
           </a:solidFill>
           <a:ln w="10160">
             <a:solidFill>
-              <a:srgbClr val="CCDCEB"/>
+              <a:srgbClr val="D6DDE0"/>
             </a:solidFill>
           </a:ln>
           <a:effectLst/>
@@ -4814,7 +4814,7 @@
             <a:avLst/>
           </a:prstGeom>
           <a:solidFill>
-            <a:srgbClr val="0070D1"/>
+            <a:srgbClr val="105186"/>
           </a:solidFill>
           <a:ln>
             <a:noFill/>
@@ -4879,7 +4879,7 @@
             <a:r>
               <a:rPr sz="1800" b="1">
                 <a:solidFill>
-                  <a:srgbClr val="0070D1"/>
+                  <a:srgbClr val="105186"/>
                 </a:solidFill>
                 <a:latin typeface="Times New Roman"/>
                 <a:ea typeface="DFKai-SB"/>
@@ -4926,7 +4926,7 @@
             <a:r>
               <a:rPr sz="2300" b="0">
                 <a:solidFill>
-                  <a:srgbClr val="121314"/>
+                  <a:srgbClr val="171C1D"/>
                 </a:solidFill>
                 <a:latin typeface="Times New Roman"/>
                 <a:ea typeface="DFKai-SB"/>
@@ -4937,7 +4937,7 @@
             <a:r>
               <a:rPr sz="2300" b="0">
                 <a:solidFill>
-                  <a:srgbClr val="121314"/>
+                  <a:srgbClr val="171C1D"/>
                 </a:solidFill>
                 <a:latin typeface="Times New Roman"/>
                 <a:ea typeface="DFKai-SB"/>
@@ -4948,7 +4948,7 @@
             <a:r>
               <a:rPr sz="2300" b="0">
                 <a:solidFill>
-                  <a:srgbClr val="121314"/>
+                  <a:srgbClr val="171C1D"/>
                 </a:solidFill>
                 <a:latin typeface="Times New Roman"/>
                 <a:ea typeface="DFKai-SB"/>
@@ -4978,7 +4978,7 @@
           </a:solidFill>
           <a:ln w="10160">
             <a:solidFill>
-              <a:srgbClr val="0070D1"/>
+              <a:srgbClr val="105186"/>
             </a:solidFill>
           </a:ln>
           <a:effectLst/>
@@ -5021,7 +5021,7 @@
           </a:prstGeom>
           <a:ln w="12700">
             <a:solidFill>
-              <a:srgbClr val="0070D1"/>
+              <a:srgbClr val="105186"/>
             </a:solidFill>
           </a:ln>
           <a:effectLst/>
@@ -5057,7 +5057,7 @@
           </a:prstGeom>
           <a:ln w="12700">
             <a:solidFill>
-              <a:srgbClr val="0070D1"/>
+              <a:srgbClr val="105186"/>
             </a:solidFill>
           </a:ln>
           <a:effectLst/>
@@ -5093,7 +5093,7 @@
           </a:prstGeom>
           <a:ln w="12700">
             <a:solidFill>
-              <a:srgbClr val="0070D1"/>
+              <a:srgbClr val="105186"/>
             </a:solidFill>
           </a:ln>
           <a:effectLst/>
@@ -5129,7 +5129,7 @@
           </a:prstGeom>
           <a:ln w="25400">
             <a:solidFill>
-              <a:srgbClr val="0070D1"/>
+              <a:srgbClr val="105186"/>
             </a:solidFill>
           </a:ln>
           <a:effectLst/>
@@ -5165,7 +5165,7 @@
           </a:prstGeom>
           <a:ln w="25400">
             <a:solidFill>
-              <a:srgbClr val="0070D1"/>
+              <a:srgbClr val="105186"/>
             </a:solidFill>
           </a:ln>
           <a:effectLst/>
@@ -5221,7 +5221,7 @@
             <a:r>
               <a:rPr sz="1900" b="0">
                 <a:solidFill>
-                  <a:srgbClr val="121314"/>
+                  <a:srgbClr val="171C1D"/>
                 </a:solidFill>
                 <a:latin typeface="Times New Roman"/>
                 <a:ea typeface="DFKai-SB"/>
@@ -5268,7 +5268,7 @@
             <a:r>
               <a:rPr sz="1900" b="0">
                 <a:solidFill>
-                  <a:srgbClr val="121314"/>
+                  <a:srgbClr val="171C1D"/>
                 </a:solidFill>
                 <a:latin typeface="Times New Roman"/>
                 <a:ea typeface="DFKai-SB"/>
@@ -5294,7 +5294,7 @@
             <a:avLst/>
           </a:prstGeom>
           <a:solidFill>
-            <a:srgbClr val="E2EDF8"/>
+            <a:srgbClr val="EAF0F4"/>
           </a:solidFill>
           <a:ln>
             <a:noFill/>
@@ -5359,7 +5359,7 @@
             <a:r>
               <a:rPr sz="2000" b="0">
                 <a:solidFill>
-                  <a:srgbClr val="0070D1"/>
+                  <a:srgbClr val="105186"/>
                 </a:solidFill>
                 <a:latin typeface="Times New Roman"/>
                 <a:ea typeface="DFKai-SB"/>
@@ -5385,7 +5385,7 @@
             <a:avLst/>
           </a:prstGeom>
           <a:solidFill>
-            <a:srgbClr val="E2EDF8"/>
+            <a:srgbClr val="EAF0F4"/>
           </a:solidFill>
           <a:ln>
             <a:noFill/>
@@ -5450,7 +5450,7 @@
             <a:r>
               <a:rPr sz="2000" b="0">
                 <a:solidFill>
-                  <a:srgbClr val="0070D1"/>
+                  <a:srgbClr val="105186"/>
                 </a:solidFill>
                 <a:latin typeface="Times New Roman"/>
                 <a:ea typeface="DFKai-SB"/>
@@ -5476,7 +5476,7 @@
             <a:avLst/>
           </a:prstGeom>
           <a:solidFill>
-            <a:srgbClr val="E2EDF8"/>
+            <a:srgbClr val="EAF0F4"/>
           </a:solidFill>
           <a:ln>
             <a:noFill/>
@@ -5541,7 +5541,7 @@
             <a:r>
               <a:rPr sz="2000" b="0">
                 <a:solidFill>
-                  <a:srgbClr val="0070D1"/>
+                  <a:srgbClr val="105186"/>
                 </a:solidFill>
                 <a:latin typeface="Times New Roman"/>
                 <a:ea typeface="DFKai-SB"/>
@@ -5588,7 +5588,7 @@
             <a:r>
               <a:rPr sz="1500" b="0">
                 <a:solidFill>
-                  <a:srgbClr val="526477"/>
+                  <a:srgbClr val="53666E"/>
                 </a:solidFill>
                 <a:latin typeface="Times New Roman"/>
                 <a:ea typeface="DFKai-SB"/>
@@ -5614,11 +5614,11 @@
             <a:avLst/>
           </a:prstGeom>
           <a:solidFill>
-            <a:srgbClr val="F5F8FC"/>
+            <a:srgbClr val="F0F2F3"/>
           </a:solidFill>
           <a:ln w="10160">
             <a:solidFill>
-              <a:srgbClr val="CCDCEB"/>
+              <a:srgbClr val="D6DDE0"/>
             </a:solidFill>
           </a:ln>
           <a:effectLst/>
@@ -5660,7 +5660,7 @@
             <a:avLst/>
           </a:prstGeom>
           <a:solidFill>
-            <a:srgbClr val="0070D1"/>
+            <a:srgbClr val="105186"/>
           </a:solidFill>
           <a:ln>
             <a:noFill/>
@@ -5725,7 +5725,7 @@
             <a:r>
               <a:rPr sz="1800" b="1">
                 <a:solidFill>
-                  <a:srgbClr val="0070D1"/>
+                  <a:srgbClr val="105186"/>
                 </a:solidFill>
                 <a:latin typeface="Times New Roman"/>
                 <a:ea typeface="DFKai-SB"/>
@@ -5772,7 +5772,7 @@
             <a:r>
               <a:rPr sz="2300" b="0">
                 <a:solidFill>
-                  <a:srgbClr val="121314"/>
+                  <a:srgbClr val="171C1D"/>
                 </a:solidFill>
                 <a:latin typeface="Times New Roman"/>
                 <a:ea typeface="DFKai-SB"/>
@@ -5843,7 +5843,7 @@
             <a:r>
               <a:rPr sz="1900" b="0">
                 <a:solidFill>
-                  <a:srgbClr val="121314"/>
+                  <a:srgbClr val="171C1D"/>
                 </a:solidFill>
                 <a:latin typeface="Times New Roman"/>
                 <a:ea typeface="DFKai-SB"/>
@@ -5890,7 +5890,7 @@
             <a:r>
               <a:rPr sz="1900" b="0">
                 <a:solidFill>
-                  <a:srgbClr val="121314"/>
+                  <a:srgbClr val="171C1D"/>
                 </a:solidFill>
                 <a:latin typeface="Times New Roman"/>
                 <a:ea typeface="DFKai-SB"/>
@@ -5937,7 +5937,7 @@
             <a:r>
               <a:rPr sz="2100" b="0">
                 <a:solidFill>
-                  <a:srgbClr val="0070D1"/>
+                  <a:srgbClr val="105186"/>
                 </a:solidFill>
                 <a:latin typeface="Times New Roman"/>
                 <a:ea typeface="DFKai-SB"/>
@@ -5963,7 +5963,7 @@
             <a:avLst/>
           </a:prstGeom>
           <a:solidFill>
-            <a:srgbClr val="0070D1"/>
+            <a:srgbClr val="105186"/>
           </a:solidFill>
           <a:ln>
             <a:noFill/>
@@ -6028,7 +6028,7 @@
             <a:r>
               <a:rPr sz="2100" b="0">
                 <a:solidFill>
-                  <a:srgbClr val="0070D1"/>
+                  <a:srgbClr val="105186"/>
                 </a:solidFill>
                 <a:latin typeface="Times New Roman"/>
                 <a:ea typeface="DFKai-SB"/>
@@ -6054,7 +6054,7 @@
             <a:avLst/>
           </a:prstGeom>
           <a:solidFill>
-            <a:srgbClr val="0070D1"/>
+            <a:srgbClr val="105186"/>
           </a:solidFill>
           <a:ln>
             <a:noFill/>
@@ -6119,7 +6119,7 @@
             <a:r>
               <a:rPr sz="2100" b="0">
                 <a:solidFill>
-                  <a:srgbClr val="0070D1"/>
+                  <a:srgbClr val="105186"/>
                 </a:solidFill>
                 <a:latin typeface="Times New Roman"/>
                 <a:ea typeface="DFKai-SB"/>
@@ -6166,7 +6166,7 @@
             <a:r>
               <a:rPr sz="1500" b="0">
                 <a:solidFill>
-                  <a:srgbClr val="526477"/>
+                  <a:srgbClr val="53666E"/>
                 </a:solidFill>
                 <a:latin typeface="Times New Roman"/>
                 <a:ea typeface="DFKai-SB"/>
@@ -6192,7 +6192,7 @@
             <a:avLst/>
           </a:prstGeom>
           <a:solidFill>
-            <a:srgbClr val="0070D1"/>
+            <a:srgbClr val="105186"/>
           </a:solidFill>
           <a:ln>
             <a:noFill/>
@@ -6236,7 +6236,7 @@
             <a:avLst/>
           </a:prstGeom>
           <a:solidFill>
-            <a:srgbClr val="EEF5FC"/>
+            <a:srgbClr val="FFF4DD"/>
           </a:solidFill>
           <a:ln>
             <a:noFill/>
@@ -6301,7 +6301,7 @@
             <a:r>
               <a:rPr sz="1800" b="0">
                 <a:solidFill>
-                  <a:srgbClr val="0070D1"/>
+                  <a:srgbClr val="092B42"/>
                 </a:solidFill>
                 <a:latin typeface="Times New Roman"/>
                 <a:ea typeface="DFKai-SB"/>
@@ -6348,7 +6348,7 @@
             <a:r>
               <a:rPr sz="2000" b="1">
                 <a:solidFill>
-                  <a:srgbClr val="0070D1"/>
+                  <a:srgbClr val="105186"/>
                 </a:solidFill>
                 <a:latin typeface="Times New Roman"/>
                 <a:ea typeface="DFKai-SB"/>
@@ -6395,7 +6395,7 @@
             <a:r>
               <a:rPr sz="2400" b="0">
                 <a:solidFill>
-                  <a:srgbClr val="121314"/>
+                  <a:srgbClr val="092B42"/>
                 </a:solidFill>
                 <a:latin typeface="Times New Roman"/>
                 <a:ea typeface="DFKai-SB"/>
@@ -6442,7 +6442,7 @@
             <a:r>
               <a:rPr sz="2300" b="0">
                 <a:solidFill>
-                  <a:srgbClr val="0070D1"/>
+                  <a:srgbClr val="105186"/>
                 </a:solidFill>
                 <a:latin typeface="Times New Roman"/>
                 <a:ea typeface="DFKai-SB"/>
@@ -6489,7 +6489,7 @@
             <a:r>
               <a:rPr sz="1600" b="0">
                 <a:solidFill>
-                  <a:srgbClr val="526477"/>
+                  <a:srgbClr val="53666E"/>
                 </a:solidFill>
                 <a:latin typeface="Times New Roman"/>
                 <a:ea typeface="DFKai-SB"/>
@@ -6513,7 +6513,7 @@
             <a:r>
               <a:rPr sz="1600" b="0">
                 <a:solidFill>
-                  <a:srgbClr val="526477"/>
+                  <a:srgbClr val="53666E"/>
                 </a:solidFill>
                 <a:latin typeface="Times New Roman"/>
                 <a:ea typeface="DFKai-SB"/>
@@ -6524,7 +6524,7 @@
             <a:r>
               <a:rPr sz="1600" b="0">
                 <a:solidFill>
-                  <a:srgbClr val="526477"/>
+                  <a:srgbClr val="53666E"/>
                 </a:solidFill>
                 <a:latin typeface="Times New Roman"/>
                 <a:ea typeface="DFKai-SB"/>
@@ -6535,7 +6535,7 @@
             <a:r>
               <a:rPr sz="1600" b="0">
                 <a:solidFill>
-                  <a:srgbClr val="526477"/>
+                  <a:srgbClr val="53666E"/>
                 </a:solidFill>
                 <a:latin typeface="Times New Roman"/>
                 <a:ea typeface="DFKai-SB"/>
@@ -6562,7 +6562,7 @@
           </a:prstGeom>
           <a:ln w="12700">
             <a:solidFill>
-              <a:srgbClr val="CCDCEB"/>
+              <a:srgbClr val="D6DDE0"/>
             </a:solidFill>
           </a:ln>
           <a:effectLst/>
@@ -6618,7 +6618,7 @@
             <a:r>
               <a:rPr sz="2300" b="0">
                 <a:solidFill>
-                  <a:srgbClr val="0070D1"/>
+                  <a:srgbClr val="105186"/>
                 </a:solidFill>
                 <a:latin typeface="Times New Roman"/>
                 <a:ea typeface="DFKai-SB"/>
@@ -6665,7 +6665,7 @@
             <a:r>
               <a:rPr sz="1600" b="0">
                 <a:solidFill>
-                  <a:srgbClr val="526477"/>
+                  <a:srgbClr val="53666E"/>
                 </a:solidFill>
                 <a:latin typeface="Times New Roman"/>
                 <a:ea typeface="DFKai-SB"/>
@@ -6689,7 +6689,7 @@
             <a:r>
               <a:rPr sz="1600" b="0">
                 <a:solidFill>
-                  <a:srgbClr val="526477"/>
+                  <a:srgbClr val="53666E"/>
                 </a:solidFill>
                 <a:latin typeface="Times New Roman"/>
                 <a:ea typeface="DFKai-SB"/>
@@ -6716,7 +6716,7 @@
           </a:prstGeom>
           <a:ln w="12700">
             <a:solidFill>
-              <a:srgbClr val="CCDCEB"/>
+              <a:srgbClr val="D6DDE0"/>
             </a:solidFill>
           </a:ln>
           <a:effectLst/>
@@ -6772,7 +6772,7 @@
             <a:r>
               <a:rPr sz="2300" b="0">
                 <a:solidFill>
-                  <a:srgbClr val="0070D1"/>
+                  <a:srgbClr val="105186"/>
                 </a:solidFill>
                 <a:latin typeface="Times New Roman"/>
                 <a:ea typeface="DFKai-SB"/>
@@ -6819,7 +6819,7 @@
             <a:r>
               <a:rPr sz="1600" b="0">
                 <a:solidFill>
-                  <a:srgbClr val="526477"/>
+                  <a:srgbClr val="53666E"/>
                 </a:solidFill>
                 <a:latin typeface="Times New Roman"/>
                 <a:ea typeface="DFKai-SB"/>
@@ -6843,7 +6843,7 @@
             <a:r>
               <a:rPr sz="1600" b="0">
                 <a:solidFill>
-                  <a:srgbClr val="526477"/>
+                  <a:srgbClr val="53666E"/>
                 </a:solidFill>
                 <a:latin typeface="Times New Roman"/>
                 <a:ea typeface="DFKai-SB"/>
@@ -6890,7 +6890,7 @@
             <a:r>
               <a:rPr sz="2000" b="1">
                 <a:solidFill>
-                  <a:srgbClr val="0070D1"/>
+                  <a:srgbClr val="105186"/>
                 </a:solidFill>
                 <a:latin typeface="Times New Roman"/>
                 <a:ea typeface="DFKai-SB"/>
@@ -6937,7 +6937,7 @@
             <a:r>
               <a:rPr sz="2400" b="0">
                 <a:solidFill>
-                  <a:srgbClr val="121314"/>
+                  <a:srgbClr val="092B42"/>
                 </a:solidFill>
                 <a:latin typeface="Times New Roman"/>
                 <a:ea typeface="DFKai-SB"/>
@@ -6984,7 +6984,7 @@
             <a:r>
               <a:rPr sz="1800" b="0">
                 <a:solidFill>
-                  <a:srgbClr val="121314"/>
+                  <a:srgbClr val="171C1D"/>
                 </a:solidFill>
                 <a:latin typeface="Times New Roman"/>
                 <a:ea typeface="DFKai-SB"/>
@@ -6995,7 +6995,7 @@
             <a:r>
               <a:rPr sz="1800" b="0">
                 <a:solidFill>
-                  <a:srgbClr val="121314"/>
+                  <a:srgbClr val="171C1D"/>
                 </a:solidFill>
                 <a:latin typeface="Times New Roman"/>
                 <a:ea typeface="DFKai-SB"/>
@@ -7006,7 +7006,7 @@
             <a:r>
               <a:rPr sz="1800" b="0">
                 <a:solidFill>
-                  <a:srgbClr val="121314"/>
+                  <a:srgbClr val="171C1D"/>
                 </a:solidFill>
                 <a:latin typeface="Times New Roman"/>
                 <a:ea typeface="DFKai-SB"/>
@@ -7017,7 +7017,7 @@
             <a:r>
               <a:rPr sz="1800" b="0">
                 <a:solidFill>
-                  <a:srgbClr val="121314"/>
+                  <a:srgbClr val="171C1D"/>
                 </a:solidFill>
                 <a:latin typeface="Times New Roman"/>
                 <a:ea typeface="DFKai-SB"/>
@@ -7064,7 +7064,7 @@
             <a:r>
               <a:rPr sz="1800" b="0">
                 <a:solidFill>
-                  <a:srgbClr val="121314"/>
+                  <a:srgbClr val="171C1D"/>
                 </a:solidFill>
                 <a:latin typeface="Times New Roman"/>
                 <a:ea typeface="DFKai-SB"/>
@@ -7090,7 +7090,7 @@
             <a:avLst/>
           </a:prstGeom>
           <a:solidFill>
-            <a:srgbClr val="E8EEF4"/>
+            <a:srgbClr val="F0F2F3"/>
           </a:solidFill>
           <a:ln>
             <a:noFill/>
@@ -7134,7 +7134,7 @@
             <a:avLst/>
           </a:prstGeom>
           <a:solidFill>
-            <a:srgbClr val="9DB5CA"/>
+            <a:srgbClr val="7294A9"/>
           </a:solidFill>
           <a:ln>
             <a:noFill/>
@@ -7199,7 +7199,7 @@
             <a:r>
               <a:rPr sz="2100" b="0">
                 <a:solidFill>
-                  <a:srgbClr val="121314"/>
+                  <a:srgbClr val="171C1D"/>
                 </a:solidFill>
                 <a:latin typeface="Times New Roman"/>
                 <a:ea typeface="DFKai-SB"/>
@@ -7246,7 +7246,7 @@
             <a:r>
               <a:rPr sz="1800" b="0">
                 <a:solidFill>
-                  <a:srgbClr val="121314"/>
+                  <a:srgbClr val="171C1D"/>
                 </a:solidFill>
                 <a:latin typeface="Times New Roman"/>
                 <a:ea typeface="DFKai-SB"/>
@@ -7272,7 +7272,7 @@
             <a:avLst/>
           </a:prstGeom>
           <a:solidFill>
-            <a:srgbClr val="E8EEF4"/>
+            <a:srgbClr val="F0F2F3"/>
           </a:solidFill>
           <a:ln>
             <a:noFill/>
@@ -7316,7 +7316,7 @@
             <a:avLst/>
           </a:prstGeom>
           <a:solidFill>
-            <a:srgbClr val="9DB5CA"/>
+            <a:srgbClr val="7294A9"/>
           </a:solidFill>
           <a:ln>
             <a:noFill/>
@@ -7381,7 +7381,7 @@
             <a:r>
               <a:rPr sz="2100" b="0">
                 <a:solidFill>
-                  <a:srgbClr val="121314"/>
+                  <a:srgbClr val="171C1D"/>
                 </a:solidFill>
                 <a:latin typeface="Times New Roman"/>
                 <a:ea typeface="DFKai-SB"/>
@@ -7428,7 +7428,7 @@
             <a:r>
               <a:rPr sz="1800" b="1">
                 <a:solidFill>
-                  <a:srgbClr val="0070D1"/>
+                  <a:srgbClr val="105186"/>
                 </a:solidFill>
                 <a:latin typeface="Times New Roman"/>
                 <a:ea typeface="DFKai-SB"/>
@@ -7454,7 +7454,7 @@
             <a:avLst/>
           </a:prstGeom>
           <a:solidFill>
-            <a:srgbClr val="E8EEF4"/>
+            <a:srgbClr val="F0F2F3"/>
           </a:solidFill>
           <a:ln>
             <a:noFill/>
@@ -7498,7 +7498,7 @@
             <a:avLst/>
           </a:prstGeom>
           <a:solidFill>
-            <a:srgbClr val="0070D1"/>
+            <a:srgbClr val="FDB338"/>
           </a:solidFill>
           <a:ln>
             <a:noFill/>
@@ -7563,7 +7563,7 @@
             <a:r>
               <a:rPr sz="2100" b="1">
                 <a:solidFill>
-                  <a:srgbClr val="0070D1"/>
+                  <a:srgbClr val="105186"/>
                 </a:solidFill>
                 <a:latin typeface="Times New Roman"/>
                 <a:ea typeface="DFKai-SB"/>
@@ -7610,7 +7610,7 @@
             <a:r>
               <a:rPr sz="1700" b="0">
                 <a:solidFill>
-                  <a:srgbClr val="526477"/>
+                  <a:srgbClr val="53666E"/>
                 </a:solidFill>
                 <a:latin typeface="Times New Roman"/>
                 <a:ea typeface="DFKai-SB"/>
@@ -7621,7 +7621,7 @@
             <a:r>
               <a:rPr sz="1700" b="0">
                 <a:solidFill>
-                  <a:srgbClr val="526477"/>
+                  <a:srgbClr val="53666E"/>
                 </a:solidFill>
                 <a:latin typeface="Times New Roman"/>
                 <a:ea typeface="DFKai-SB"/>
@@ -7668,7 +7668,7 @@
             <a:r>
               <a:rPr sz="1500" b="0">
                 <a:solidFill>
-                  <a:srgbClr val="526477"/>
+                  <a:srgbClr val="53666E"/>
                 </a:solidFill>
                 <a:latin typeface="Times New Roman"/>
                 <a:ea typeface="DFKai-SB"/>
@@ -7679,7 +7679,7 @@
             <a:r>
               <a:rPr sz="1500" b="0">
                 <a:solidFill>
-                  <a:srgbClr val="526477"/>
+                  <a:srgbClr val="53666E"/>
                 </a:solidFill>
                 <a:latin typeface="Times New Roman"/>
                 <a:ea typeface="DFKai-SB"/>
@@ -7690,7 +7690,7 @@
             <a:r>
               <a:rPr sz="1500" b="0">
                 <a:solidFill>
-                  <a:srgbClr val="526477"/>
+                  <a:srgbClr val="53666E"/>
                 </a:solidFill>
                 <a:latin typeface="Times New Roman"/>
                 <a:ea typeface="DFKai-SB"/>
@@ -7717,7 +7717,7 @@
           </a:prstGeom>
           <a:ln w="12700">
             <a:solidFill>
-              <a:srgbClr val="CCDCEB"/>
+              <a:srgbClr val="D6DDE0"/>
             </a:solidFill>
           </a:ln>
           <a:effectLst/>
@@ -7773,7 +7773,7 @@
             <a:r>
               <a:rPr sz="1800" b="0">
                 <a:solidFill>
-                  <a:srgbClr val="121314"/>
+                  <a:srgbClr val="171C1D"/>
                 </a:solidFill>
                 <a:latin typeface="Times New Roman"/>
                 <a:ea typeface="DFKai-SB"/>
@@ -7784,7 +7784,7 @@
             <a:r>
               <a:rPr sz="1800" b="0">
                 <a:solidFill>
-                  <a:srgbClr val="121314"/>
+                  <a:srgbClr val="171C1D"/>
                 </a:solidFill>
                 <a:latin typeface="Times New Roman"/>
                 <a:ea typeface="DFKai-SB"/>
@@ -7795,7 +7795,7 @@
             <a:r>
               <a:rPr sz="1800" b="0">
                 <a:solidFill>
-                  <a:srgbClr val="121314"/>
+                  <a:srgbClr val="171C1D"/>
                 </a:solidFill>
                 <a:latin typeface="Times New Roman"/>
                 <a:ea typeface="DFKai-SB"/>
@@ -7806,7 +7806,7 @@
             <a:r>
               <a:rPr sz="1800" b="0">
                 <a:solidFill>
-                  <a:srgbClr val="121314"/>
+                  <a:srgbClr val="171C1D"/>
                 </a:solidFill>
                 <a:latin typeface="Times New Roman"/>
                 <a:ea typeface="DFKai-SB"/>
@@ -7853,7 +7853,7 @@
             <a:r>
               <a:rPr sz="2800" b="1">
                 <a:solidFill>
-                  <a:srgbClr val="0070D1"/>
+                  <a:srgbClr val="105186"/>
                 </a:solidFill>
                 <a:latin typeface="Times New Roman"/>
                 <a:ea typeface="DFKai-SB"/>
@@ -7900,7 +7900,7 @@
             <a:r>
               <a:rPr sz="1600" b="0">
                 <a:solidFill>
-                  <a:srgbClr val="526477"/>
+                  <a:srgbClr val="53666E"/>
                 </a:solidFill>
                 <a:latin typeface="Times New Roman"/>
                 <a:ea typeface="DFKai-SB"/>
@@ -7911,7 +7911,7 @@
             <a:r>
               <a:rPr sz="1600" b="0">
                 <a:solidFill>
-                  <a:srgbClr val="526477"/>
+                  <a:srgbClr val="53666E"/>
                 </a:solidFill>
                 <a:latin typeface="Times New Roman"/>
                 <a:ea typeface="DFKai-SB"/>
@@ -7922,7 +7922,7 @@
             <a:r>
               <a:rPr sz="1600" b="0">
                 <a:solidFill>
-                  <a:srgbClr val="526477"/>
+                  <a:srgbClr val="53666E"/>
                 </a:solidFill>
                 <a:latin typeface="Times New Roman"/>
                 <a:ea typeface="DFKai-SB"/>
@@ -7969,7 +7969,7 @@
             <a:r>
               <a:rPr sz="2700" b="0">
                 <a:solidFill>
-                  <a:srgbClr val="0070D1"/>
+                  <a:srgbClr val="105186"/>
                 </a:solidFill>
                 <a:latin typeface="Times New Roman"/>
                 <a:ea typeface="DFKai-SB"/>
@@ -8016,7 +8016,7 @@
             <a:r>
               <a:rPr sz="1800" b="0">
                 <a:solidFill>
-                  <a:srgbClr val="121314"/>
+                  <a:srgbClr val="171C1D"/>
                 </a:solidFill>
                 <a:latin typeface="Times New Roman"/>
                 <a:ea typeface="DFKai-SB"/>
@@ -8063,7 +8063,7 @@
             <a:r>
               <a:rPr sz="2700" b="0">
                 <a:solidFill>
-                  <a:srgbClr val="0070D1"/>
+                  <a:srgbClr val="105186"/>
                 </a:solidFill>
                 <a:latin typeface="Times New Roman"/>
                 <a:ea typeface="DFKai-SB"/>
@@ -8110,7 +8110,7 @@
             <a:r>
               <a:rPr sz="1800" b="0">
                 <a:solidFill>
-                  <a:srgbClr val="121314"/>
+                  <a:srgbClr val="171C1D"/>
                 </a:solidFill>
                 <a:latin typeface="Times New Roman"/>
                 <a:ea typeface="DFKai-SB"/>
@@ -8157,7 +8157,7 @@
             <a:r>
               <a:rPr sz="2700" b="0">
                 <a:solidFill>
-                  <a:srgbClr val="0070D1"/>
+                  <a:srgbClr val="105186"/>
                 </a:solidFill>
                 <a:latin typeface="Times New Roman"/>
                 <a:ea typeface="DFKai-SB"/>
@@ -8204,7 +8204,7 @@
             <a:r>
               <a:rPr sz="1800" b="0">
                 <a:solidFill>
-                  <a:srgbClr val="121314"/>
+                  <a:srgbClr val="171C1D"/>
                 </a:solidFill>
                 <a:latin typeface="Times New Roman"/>
                 <a:ea typeface="DFKai-SB"/>
@@ -8251,7 +8251,7 @@
             <a:r>
               <a:rPr sz="1400" b="0">
                 <a:solidFill>
-                  <a:srgbClr val="526477"/>
+                  <a:srgbClr val="53666E"/>
                 </a:solidFill>
                 <a:latin typeface="Times New Roman"/>
                 <a:ea typeface="DFKai-SB"/>
@@ -8262,7 +8262,7 @@
             <a:r>
               <a:rPr sz="1400" b="0">
                 <a:solidFill>
-                  <a:srgbClr val="526477"/>
+                  <a:srgbClr val="53666E"/>
                 </a:solidFill>
                 <a:latin typeface="Times New Roman"/>
                 <a:ea typeface="DFKai-SB"/>
@@ -8273,7 +8273,7 @@
             <a:r>
               <a:rPr sz="1400" b="0">
                 <a:solidFill>
-                  <a:srgbClr val="526477"/>
+                  <a:srgbClr val="53666E"/>
                 </a:solidFill>
                 <a:latin typeface="Times New Roman"/>
                 <a:ea typeface="DFKai-SB"/>
@@ -8284,7 +8284,7 @@
             <a:r>
               <a:rPr sz="1400" b="0">
                 <a:solidFill>
-                  <a:srgbClr val="526477"/>
+                  <a:srgbClr val="53666E"/>
                 </a:solidFill>
                 <a:latin typeface="Times New Roman"/>
                 <a:ea typeface="DFKai-SB"/>
@@ -8308,7 +8308,7 @@
             <a:r>
               <a:rPr sz="1400" b="0">
                 <a:solidFill>
-                  <a:srgbClr val="526477"/>
+                  <a:srgbClr val="53666E"/>
                 </a:solidFill>
                 <a:latin typeface="Times New Roman"/>
                 <a:ea typeface="DFKai-SB"/>
@@ -8319,7 +8319,7 @@
             <a:r>
               <a:rPr sz="1400" b="0">
                 <a:solidFill>
-                  <a:srgbClr val="526477"/>
+                  <a:srgbClr val="53666E"/>
                 </a:solidFill>
                 <a:latin typeface="Times New Roman"/>
                 <a:ea typeface="DFKai-SB"/>
@@ -8330,7 +8330,7 @@
             <a:r>
               <a:rPr sz="1400" b="0">
                 <a:solidFill>
-                  <a:srgbClr val="526477"/>
+                  <a:srgbClr val="53666E"/>
                 </a:solidFill>
                 <a:latin typeface="Times New Roman"/>
                 <a:ea typeface="DFKai-SB"/>
@@ -8357,7 +8357,7 @@
           </a:prstGeom>
           <a:ln w="12700">
             <a:solidFill>
-              <a:srgbClr val="CCDCEB"/>
+              <a:srgbClr val="D6DDE0"/>
             </a:solidFill>
           </a:ln>
           <a:effectLst/>
@@ -8413,7 +8413,7 @@
             <a:r>
               <a:rPr sz="1700" b="0">
                 <a:solidFill>
-                  <a:srgbClr val="0070D1"/>
+                  <a:srgbClr val="105186"/>
                 </a:solidFill>
                 <a:latin typeface="Times New Roman"/>
                 <a:ea typeface="DFKai-SB"/>
@@ -8424,7 +8424,7 @@
             <a:r>
               <a:rPr sz="1700" b="0">
                 <a:solidFill>
-                  <a:srgbClr val="0070D1"/>
+                  <a:srgbClr val="105186"/>
                 </a:solidFill>
                 <a:latin typeface="Times New Roman"/>
                 <a:ea typeface="DFKai-SB"/>
@@ -8435,7 +8435,7 @@
             <a:r>
               <a:rPr sz="1700" b="0">
                 <a:solidFill>
-                  <a:srgbClr val="0070D1"/>
+                  <a:srgbClr val="105186"/>
                 </a:solidFill>
                 <a:latin typeface="Times New Roman"/>
                 <a:ea typeface="DFKai-SB"/>
@@ -8446,7 +8446,7 @@
             <a:r>
               <a:rPr sz="1700" b="0">
                 <a:solidFill>
-                  <a:srgbClr val="0070D1"/>
+                  <a:srgbClr val="105186"/>
                 </a:solidFill>
                 <a:latin typeface="Times New Roman"/>
                 <a:ea typeface="DFKai-SB"/>
@@ -8457,7 +8457,7 @@
             <a:r>
               <a:rPr sz="1700" b="0">
                 <a:solidFill>
-                  <a:srgbClr val="0070D1"/>
+                  <a:srgbClr val="105186"/>
                 </a:solidFill>
                 <a:latin typeface="Times New Roman"/>
                 <a:ea typeface="DFKai-SB"/>
@@ -8468,7 +8468,7 @@
             <a:r>
               <a:rPr sz="1700" b="0">
                 <a:solidFill>
-                  <a:srgbClr val="0070D1"/>
+                  <a:srgbClr val="105186"/>
                 </a:solidFill>
                 <a:latin typeface="Times New Roman"/>
                 <a:ea typeface="DFKai-SB"/>
@@ -8479,7 +8479,7 @@
             <a:r>
               <a:rPr sz="1700" b="0">
                 <a:solidFill>
-                  <a:srgbClr val="0070D1"/>
+                  <a:srgbClr val="105186"/>
                 </a:solidFill>
                 <a:latin typeface="Times New Roman"/>
                 <a:ea typeface="DFKai-SB"/>
@@ -8490,7 +8490,7 @@
             <a:r>
               <a:rPr sz="1700" b="0">
                 <a:solidFill>
-                  <a:srgbClr val="0070D1"/>
+                  <a:srgbClr val="105186"/>
                 </a:solidFill>
                 <a:latin typeface="Times New Roman"/>
                 <a:ea typeface="DFKai-SB"/>
@@ -8501,7 +8501,7 @@
             <a:r>
               <a:rPr sz="1700" b="0">
                 <a:solidFill>
-                  <a:srgbClr val="0070D1"/>
+                  <a:srgbClr val="105186"/>
                 </a:solidFill>
                 <a:latin typeface="Times New Roman"/>
                 <a:ea typeface="DFKai-SB"/>
@@ -8548,7 +8548,7 @@
             <a:r>
               <a:rPr sz="1150" b="0">
                 <a:solidFill>
-                  <a:srgbClr val="526477"/>
+                  <a:srgbClr val="53666E"/>
                 </a:solidFill>
                 <a:latin typeface="Times New Roman"/>
                 <a:ea typeface="DFKai-SB"/>
@@ -8559,7 +8559,7 @@
             <a:r>
               <a:rPr sz="1150" b="0">
                 <a:solidFill>
-                  <a:srgbClr val="526477"/>
+                  <a:srgbClr val="53666E"/>
                 </a:solidFill>
                 <a:latin typeface="Times New Roman"/>
                 <a:ea typeface="DFKai-SB"/>
@@ -8570,7 +8570,7 @@
             <a:r>
               <a:rPr sz="1150" b="0">
                 <a:solidFill>
-                  <a:srgbClr val="526477"/>
+                  <a:srgbClr val="53666E"/>
                 </a:solidFill>
                 <a:latin typeface="Times New Roman"/>
                 <a:ea typeface="DFKai-SB"/>
@@ -8581,7 +8581,7 @@
             <a:r>
               <a:rPr sz="1150" b="0">
                 <a:solidFill>
-                  <a:srgbClr val="526477"/>
+                  <a:srgbClr val="53666E"/>
                 </a:solidFill>
                 <a:latin typeface="Times New Roman"/>
                 <a:ea typeface="DFKai-SB"/>
@@ -8592,7 +8592,7 @@
             <a:r>
               <a:rPr sz="1150" b="0">
                 <a:solidFill>
-                  <a:srgbClr val="526477"/>
+                  <a:srgbClr val="53666E"/>
                 </a:solidFill>
                 <a:latin typeface="Times New Roman"/>
                 <a:ea typeface="DFKai-SB"/>
@@ -8603,7 +8603,7 @@
             <a:r>
               <a:rPr sz="1150" b="0">
                 <a:solidFill>
-                  <a:srgbClr val="526477"/>
+                  <a:srgbClr val="53666E"/>
                 </a:solidFill>
                 <a:latin typeface="Times New Roman"/>
                 <a:ea typeface="DFKai-SB"/>
@@ -8614,7 +8614,7 @@
             <a:r>
               <a:rPr sz="1150" b="0">
                 <a:solidFill>
-                  <a:srgbClr val="526477"/>
+                  <a:srgbClr val="53666E"/>
                 </a:solidFill>
                 <a:latin typeface="Times New Roman"/>
                 <a:ea typeface="DFKai-SB"/>
@@ -8625,7 +8625,7 @@
             <a:r>
               <a:rPr sz="1150" b="0">
                 <a:solidFill>
-                  <a:srgbClr val="526477"/>
+                  <a:srgbClr val="53666E"/>
                 </a:solidFill>
                 <a:latin typeface="Times New Roman"/>
                 <a:ea typeface="DFKai-SB"/>

</xml_diff>

<commit_message>
Complete finals quality pass with verified live chain and refined media
</commit_message>
<xml_diff>
--- a/deliverables/決賽海報_AI資安框架_A2.pptx
+++ b/deliverables/決賽海報_AI資安框架_A2.pptx
@@ -3325,9 +3325,33 @@
           </a:p>
         </p:txBody>
       </p:sp>
-      <p:sp>
-        <p:nvSpPr>
-          <p:cNvPr id="4" name="TextBox 3"/>
+      <p:pic>
+        <p:nvPicPr>
+          <p:cNvPr id="4" name="Picture 3" descr="icon-4.png"/>
+          <p:cNvPicPr>
+            <a:picLocks noChangeAspect="1"/>
+          </p:cNvPicPr>
+          <p:nvPr/>
+        </p:nvPicPr>
+        <p:blipFill>
+          <a:blip r:embed="rId2"/>
+          <a:stretch>
+            <a:fillRect/>
+          </a:stretch>
+        </p:blipFill>
+        <p:spPr>
+          <a:xfrm>
+            <a:off x="12384000" y="1044000"/>
+            <a:ext cx="1800000" cy="1800000"/>
+          </a:xfrm>
+          <a:prstGeom prst="rect">
+            <a:avLst/>
+          </a:prstGeom>
+        </p:spPr>
+      </p:pic>
+      <p:sp>
+        <p:nvSpPr>
+          <p:cNvPr id="5" name="TextBox 4"/>
           <p:cNvSpPr txBox="1"/>
           <p:nvPr/>
         </p:nvSpPr>
@@ -3374,7 +3398,7 @@
       </p:sp>
       <p:cxnSp>
         <p:nvCxnSpPr>
-          <p:cNvPr id="5" name="Connector 4"/>
+          <p:cNvPr id="6" name="Connector 5"/>
           <p:cNvCxnSpPr/>
           <p:nvPr/>
         </p:nvCxnSpPr>
@@ -3410,14 +3434,14 @@
       </p:cxnSp>
       <p:pic>
         <p:nvPicPr>
-          <p:cNvPr id="6" name="Picture 5" descr="icon-1.png"/>
+          <p:cNvPr id="7" name="Picture 6" descr="icon-1.png"/>
           <p:cNvPicPr>
             <a:picLocks noChangeAspect="1"/>
           </p:cNvPicPr>
           <p:nvPr/>
         </p:nvPicPr>
         <p:blipFill>
-          <a:blip r:embed="rId2"/>
+          <a:blip r:embed="rId3"/>
           <a:stretch>
             <a:fillRect/>
           </a:stretch>
@@ -3434,7 +3458,7 @@
       </p:pic>
       <p:sp>
         <p:nvSpPr>
-          <p:cNvPr id="7" name="TextBox 6"/>
+          <p:cNvPr id="8" name="TextBox 7"/>
           <p:cNvSpPr txBox="1"/>
           <p:nvPr/>
         </p:nvSpPr>
@@ -3481,7 +3505,7 @@
       </p:sp>
       <p:sp>
         <p:nvSpPr>
-          <p:cNvPr id="8" name="TextBox 7"/>
+          <p:cNvPr id="9" name="TextBox 8"/>
           <p:cNvSpPr txBox="1"/>
           <p:nvPr/>
         </p:nvSpPr>
@@ -3528,7 +3552,7 @@
       </p:sp>
       <p:sp>
         <p:nvSpPr>
-          <p:cNvPr id="9" name="TextBox 8"/>
+          <p:cNvPr id="10" name="TextBox 9"/>
           <p:cNvSpPr txBox="1"/>
           <p:nvPr/>
         </p:nvSpPr>
@@ -3575,7 +3599,7 @@
       </p:sp>
       <p:sp>
         <p:nvSpPr>
-          <p:cNvPr id="10" name="TextBox 9"/>
+          <p:cNvPr id="11" name="TextBox 10"/>
           <p:cNvSpPr txBox="1"/>
           <p:nvPr/>
         </p:nvSpPr>
@@ -3622,7 +3646,7 @@
       </p:sp>
       <p:sp>
         <p:nvSpPr>
-          <p:cNvPr id="11" name="Rectangle 10"/>
+          <p:cNvPr id="12" name="Rectangle 11"/>
           <p:cNvSpPr/>
           <p:nvPr/>
         </p:nvSpPr>
@@ -3668,7 +3692,7 @@
       </p:sp>
       <p:sp>
         <p:nvSpPr>
-          <p:cNvPr id="12" name="Rectangle 11"/>
+          <p:cNvPr id="13" name="Rectangle 12"/>
           <p:cNvSpPr/>
           <p:nvPr/>
         </p:nvSpPr>
@@ -3712,7 +3736,7 @@
       </p:sp>
       <p:sp>
         <p:nvSpPr>
-          <p:cNvPr id="13" name="TextBox 12"/>
+          <p:cNvPr id="14" name="TextBox 13"/>
           <p:cNvSpPr txBox="1"/>
           <p:nvPr/>
         </p:nvSpPr>
@@ -3759,7 +3783,7 @@
       </p:sp>
       <p:sp>
         <p:nvSpPr>
-          <p:cNvPr id="14" name="TextBox 13"/>
+          <p:cNvPr id="15" name="TextBox 14"/>
           <p:cNvSpPr txBox="1"/>
           <p:nvPr/>
         </p:nvSpPr>
@@ -3806,14 +3830,14 @@
       </p:sp>
       <p:pic>
         <p:nvPicPr>
-          <p:cNvPr id="15" name="Picture 14" descr="icon-2.png"/>
+          <p:cNvPr id="16" name="Picture 15" descr="icon-2.png"/>
           <p:cNvPicPr>
             <a:picLocks noChangeAspect="1"/>
           </p:cNvPicPr>
           <p:nvPr/>
         </p:nvPicPr>
         <p:blipFill>
-          <a:blip r:embed="rId3"/>
+          <a:blip r:embed="rId4"/>
           <a:stretch>
             <a:fillRect/>
           </a:stretch>
@@ -3830,7 +3854,7 @@
       </p:pic>
       <p:sp>
         <p:nvSpPr>
-          <p:cNvPr id="16" name="TextBox 15"/>
+          <p:cNvPr id="17" name="TextBox 16"/>
           <p:cNvSpPr txBox="1"/>
           <p:nvPr/>
         </p:nvSpPr>
@@ -3888,7 +3912,7 @@
       </p:sp>
       <p:sp>
         <p:nvSpPr>
-          <p:cNvPr id="17" name="TextBox 16"/>
+          <p:cNvPr id="18" name="TextBox 17"/>
           <p:cNvSpPr txBox="1"/>
           <p:nvPr/>
         </p:nvSpPr>
@@ -3946,7 +3970,7 @@
       </p:sp>
       <p:sp>
         <p:nvSpPr>
-          <p:cNvPr id="18" name="Down Arrow 17"/>
+          <p:cNvPr id="19" name="Down Arrow 18"/>
           <p:cNvSpPr/>
           <p:nvPr/>
         </p:nvSpPr>
@@ -3990,7 +4014,7 @@
       </p:sp>
       <p:sp>
         <p:nvSpPr>
-          <p:cNvPr id="19" name="TextBox 18"/>
+          <p:cNvPr id="20" name="TextBox 19"/>
           <p:cNvSpPr txBox="1"/>
           <p:nvPr/>
         </p:nvSpPr>
@@ -4059,7 +4083,7 @@
       </p:sp>
       <p:sp>
         <p:nvSpPr>
-          <p:cNvPr id="20" name="TextBox 19"/>
+          <p:cNvPr id="21" name="TextBox 20"/>
           <p:cNvSpPr txBox="1"/>
           <p:nvPr/>
         </p:nvSpPr>
@@ -4150,7 +4174,7 @@
       </p:sp>
       <p:sp>
         <p:nvSpPr>
-          <p:cNvPr id="21" name="Rectangle 20"/>
+          <p:cNvPr id="22" name="Rectangle 21"/>
           <p:cNvSpPr/>
           <p:nvPr/>
         </p:nvSpPr>
@@ -4196,7 +4220,7 @@
       </p:sp>
       <p:sp>
         <p:nvSpPr>
-          <p:cNvPr id="22" name="Rectangle 21"/>
+          <p:cNvPr id="23" name="Rectangle 22"/>
           <p:cNvSpPr/>
           <p:nvPr/>
         </p:nvSpPr>
@@ -4240,7 +4264,7 @@
       </p:sp>
       <p:sp>
         <p:nvSpPr>
-          <p:cNvPr id="23" name="TextBox 22"/>
+          <p:cNvPr id="24" name="TextBox 23"/>
           <p:cNvSpPr txBox="1"/>
           <p:nvPr/>
         </p:nvSpPr>
@@ -4287,7 +4311,7 @@
       </p:sp>
       <p:sp>
         <p:nvSpPr>
-          <p:cNvPr id="24" name="TextBox 23"/>
+          <p:cNvPr id="25" name="TextBox 24"/>
           <p:cNvSpPr txBox="1"/>
           <p:nvPr/>
         </p:nvSpPr>
@@ -4334,14 +4358,14 @@
       </p:sp>
       <p:pic>
         <p:nvPicPr>
-          <p:cNvPr id="25" name="Picture 24" descr="icon-3.png"/>
+          <p:cNvPr id="26" name="Picture 25" descr="icon-3.png"/>
           <p:cNvPicPr>
             <a:picLocks noChangeAspect="1"/>
           </p:cNvPicPr>
           <p:nvPr/>
         </p:nvPicPr>
         <p:blipFill>
-          <a:blip r:embed="rId4"/>
+          <a:blip r:embed="rId5"/>
           <a:stretch>
             <a:fillRect/>
           </a:stretch>
@@ -4358,7 +4382,7 @@
       </p:pic>
       <p:sp>
         <p:nvSpPr>
-          <p:cNvPr id="26" name="TextBox 25"/>
+          <p:cNvPr id="27" name="TextBox 26"/>
           <p:cNvSpPr txBox="1"/>
           <p:nvPr/>
         </p:nvSpPr>
@@ -4438,7 +4462,7 @@
       </p:sp>
       <p:sp>
         <p:nvSpPr>
-          <p:cNvPr id="27" name="TextBox 26"/>
+          <p:cNvPr id="28" name="TextBox 27"/>
           <p:cNvSpPr txBox="1"/>
           <p:nvPr/>
         </p:nvSpPr>
@@ -4518,7 +4542,7 @@
       </p:sp>
       <p:sp>
         <p:nvSpPr>
-          <p:cNvPr id="28" name="Down Arrow 27"/>
+          <p:cNvPr id="29" name="Down Arrow 28"/>
           <p:cNvSpPr/>
           <p:nvPr/>
         </p:nvSpPr>
@@ -4562,7 +4586,7 @@
       </p:sp>
       <p:sp>
         <p:nvSpPr>
-          <p:cNvPr id="29" name="TextBox 28"/>
+          <p:cNvPr id="30" name="TextBox 29"/>
           <p:cNvSpPr txBox="1"/>
           <p:nvPr/>
         </p:nvSpPr>
@@ -4620,7 +4644,7 @@
       </p:sp>
       <p:sp>
         <p:nvSpPr>
-          <p:cNvPr id="30" name="TextBox 29"/>
+          <p:cNvPr id="31" name="TextBox 30"/>
           <p:cNvSpPr txBox="1"/>
           <p:nvPr/>
         </p:nvSpPr>
@@ -4667,7 +4691,7 @@
       </p:sp>
       <p:sp>
         <p:nvSpPr>
-          <p:cNvPr id="31" name="Right Arrow 30"/>
+          <p:cNvPr id="32" name="Right Arrow 31"/>
           <p:cNvSpPr/>
           <p:nvPr/>
         </p:nvSpPr>
@@ -4711,7 +4735,7 @@
       </p:sp>
       <p:sp>
         <p:nvSpPr>
-          <p:cNvPr id="32" name="Down Arrow 31"/>
+          <p:cNvPr id="33" name="Down Arrow 32"/>
           <p:cNvSpPr/>
           <p:nvPr/>
         </p:nvSpPr>
@@ -4755,7 +4779,7 @@
       </p:sp>
       <p:sp>
         <p:nvSpPr>
-          <p:cNvPr id="33" name="Rectangle 32"/>
+          <p:cNvPr id="34" name="Rectangle 33"/>
           <p:cNvSpPr/>
           <p:nvPr/>
         </p:nvSpPr>
@@ -4801,7 +4825,7 @@
       </p:sp>
       <p:sp>
         <p:nvSpPr>
-          <p:cNvPr id="34" name="Rectangle 33"/>
+          <p:cNvPr id="35" name="Rectangle 34"/>
           <p:cNvSpPr/>
           <p:nvPr/>
         </p:nvSpPr>
@@ -4845,7 +4869,7 @@
       </p:sp>
       <p:sp>
         <p:nvSpPr>
-          <p:cNvPr id="35" name="TextBox 34"/>
+          <p:cNvPr id="36" name="TextBox 35"/>
           <p:cNvSpPr txBox="1"/>
           <p:nvPr/>
         </p:nvSpPr>
@@ -4892,7 +4916,7 @@
       </p:sp>
       <p:sp>
         <p:nvSpPr>
-          <p:cNvPr id="36" name="TextBox 35"/>
+          <p:cNvPr id="37" name="TextBox 36"/>
           <p:cNvSpPr txBox="1"/>
           <p:nvPr/>
         </p:nvSpPr>
@@ -4961,7 +4985,7 @@
       </p:sp>
       <p:sp>
         <p:nvSpPr>
-          <p:cNvPr id="37" name="Rectangle 36"/>
+          <p:cNvPr id="38" name="Rectangle 37"/>
           <p:cNvSpPr/>
           <p:nvPr/>
         </p:nvSpPr>
@@ -5007,49 +5031,13 @@
       </p:sp>
       <p:cxnSp>
         <p:nvCxnSpPr>
-          <p:cNvPr id="38" name="Connector 37"/>
-          <p:cNvCxnSpPr/>
-          <p:nvPr/>
-        </p:nvCxnSpPr>
-        <p:spPr>
-          <a:xfrm>
-            <a:off x="8460000" y="10152000"/>
-            <a:ext cx="360000" cy="0"/>
-          </a:xfrm>
-          <a:prstGeom prst="line">
-            <a:avLst/>
-          </a:prstGeom>
-          <a:ln w="12700">
-            <a:solidFill>
-              <a:srgbClr val="105186"/>
-            </a:solidFill>
-          </a:ln>
-          <a:effectLst/>
-        </p:spPr>
-        <p:style>
-          <a:lnRef idx="2">
-            <a:schemeClr val="accent1"/>
-          </a:lnRef>
-          <a:fillRef idx="0">
-            <a:schemeClr val="accent1"/>
-          </a:fillRef>
-          <a:effectRef idx="1">
-            <a:schemeClr val="accent1"/>
-          </a:effectRef>
-          <a:fontRef idx="minor">
-            <a:schemeClr val="tx1"/>
-          </a:fontRef>
-        </p:style>
-      </p:cxnSp>
-      <p:cxnSp>
-        <p:nvCxnSpPr>
           <p:cNvPr id="39" name="Connector 38"/>
           <p:cNvCxnSpPr/>
           <p:nvPr/>
         </p:nvCxnSpPr>
         <p:spPr>
           <a:xfrm>
-            <a:off x="8460000" y="10332000"/>
+            <a:off x="8460000" y="10152000"/>
             <a:ext cx="360000" cy="0"/>
           </a:xfrm>
           <a:prstGeom prst="line">
@@ -5085,7 +5073,7 @@
         </p:nvCxnSpPr>
         <p:spPr>
           <a:xfrm>
-            <a:off x="8460000" y="10512000"/>
+            <a:off x="8460000" y="10332000"/>
             <a:ext cx="360000" cy="0"/>
           </a:xfrm>
           <a:prstGeom prst="line">
@@ -5121,13 +5109,13 @@
         </p:nvCxnSpPr>
         <p:spPr>
           <a:xfrm>
-            <a:off x="8820000" y="10620000"/>
-            <a:ext cx="144000" cy="144000"/>
+            <a:off x="8460000" y="10512000"/>
+            <a:ext cx="360000" cy="0"/>
           </a:xfrm>
           <a:prstGeom prst="line">
             <a:avLst/>
           </a:prstGeom>
-          <a:ln w="25400">
+          <a:ln w="12700">
             <a:solidFill>
               <a:srgbClr val="105186"/>
             </a:solidFill>
@@ -5156,9 +5144,9 @@
           <p:nvPr/>
         </p:nvCxnSpPr>
         <p:spPr>
-          <a:xfrm flipV="1">
-            <a:off x="8964000" y="10440000"/>
-            <a:ext cx="216000" cy="324000"/>
+          <a:xfrm>
+            <a:off x="8820000" y="10620000"/>
+            <a:ext cx="144000" cy="144000"/>
           </a:xfrm>
           <a:prstGeom prst="line">
             <a:avLst/>
@@ -5185,9 +5173,45 @@
           </a:fontRef>
         </p:style>
       </p:cxnSp>
-      <p:sp>
-        <p:nvSpPr>
-          <p:cNvPr id="43" name="TextBox 42"/>
+      <p:cxnSp>
+        <p:nvCxnSpPr>
+          <p:cNvPr id="43" name="Connector 42"/>
+          <p:cNvCxnSpPr/>
+          <p:nvPr/>
+        </p:nvCxnSpPr>
+        <p:spPr>
+          <a:xfrm flipV="1">
+            <a:off x="8964000" y="10440000"/>
+            <a:ext cx="216000" cy="324000"/>
+          </a:xfrm>
+          <a:prstGeom prst="line">
+            <a:avLst/>
+          </a:prstGeom>
+          <a:ln w="25400">
+            <a:solidFill>
+              <a:srgbClr val="105186"/>
+            </a:solidFill>
+          </a:ln>
+          <a:effectLst/>
+        </p:spPr>
+        <p:style>
+          <a:lnRef idx="2">
+            <a:schemeClr val="accent1"/>
+          </a:lnRef>
+          <a:fillRef idx="0">
+            <a:schemeClr val="accent1"/>
+          </a:fillRef>
+          <a:effectRef idx="1">
+            <a:schemeClr val="accent1"/>
+          </a:effectRef>
+          <a:fontRef idx="minor">
+            <a:schemeClr val="tx1"/>
+          </a:fontRef>
+        </p:style>
+      </p:cxnSp>
+      <p:sp>
+        <p:nvSpPr>
+          <p:cNvPr id="44" name="TextBox 43"/>
           <p:cNvSpPr txBox="1"/>
           <p:nvPr/>
         </p:nvSpPr>
@@ -5234,7 +5258,7 @@
       </p:sp>
       <p:sp>
         <p:nvSpPr>
-          <p:cNvPr id="44" name="TextBox 43"/>
+          <p:cNvPr id="45" name="TextBox 44"/>
           <p:cNvSpPr txBox="1"/>
           <p:nvPr/>
         </p:nvSpPr>
@@ -5281,7 +5305,7 @@
       </p:sp>
       <p:sp>
         <p:nvSpPr>
-          <p:cNvPr id="45" name="Rectangle 44"/>
+          <p:cNvPr id="46" name="Rectangle 45"/>
           <p:cNvSpPr/>
           <p:nvPr/>
         </p:nvSpPr>
@@ -5325,7 +5349,7 @@
       </p:sp>
       <p:sp>
         <p:nvSpPr>
-          <p:cNvPr id="46" name="TextBox 45"/>
+          <p:cNvPr id="47" name="TextBox 46"/>
           <p:cNvSpPr txBox="1"/>
           <p:nvPr/>
         </p:nvSpPr>
@@ -5372,7 +5396,7 @@
       </p:sp>
       <p:sp>
         <p:nvSpPr>
-          <p:cNvPr id="47" name="Rectangle 46"/>
+          <p:cNvPr id="48" name="Rectangle 47"/>
           <p:cNvSpPr/>
           <p:nvPr/>
         </p:nvSpPr>
@@ -5416,7 +5440,7 @@
       </p:sp>
       <p:sp>
         <p:nvSpPr>
-          <p:cNvPr id="48" name="TextBox 47"/>
+          <p:cNvPr id="49" name="TextBox 48"/>
           <p:cNvSpPr txBox="1"/>
           <p:nvPr/>
         </p:nvSpPr>
@@ -5463,7 +5487,7 @@
       </p:sp>
       <p:sp>
         <p:nvSpPr>
-          <p:cNvPr id="49" name="Rectangle 48"/>
+          <p:cNvPr id="50" name="Rectangle 49"/>
           <p:cNvSpPr/>
           <p:nvPr/>
         </p:nvSpPr>
@@ -5507,7 +5531,7 @@
       </p:sp>
       <p:sp>
         <p:nvSpPr>
-          <p:cNvPr id="50" name="TextBox 49"/>
+          <p:cNvPr id="51" name="TextBox 50"/>
           <p:cNvSpPr txBox="1"/>
           <p:nvPr/>
         </p:nvSpPr>
@@ -5554,7 +5578,7 @@
       </p:sp>
       <p:sp>
         <p:nvSpPr>
-          <p:cNvPr id="51" name="TextBox 50"/>
+          <p:cNvPr id="52" name="TextBox 51"/>
           <p:cNvSpPr txBox="1"/>
           <p:nvPr/>
         </p:nvSpPr>
@@ -5601,7 +5625,7 @@
       </p:sp>
       <p:sp>
         <p:nvSpPr>
-          <p:cNvPr id="52" name="Rectangle 51"/>
+          <p:cNvPr id="53" name="Rectangle 52"/>
           <p:cNvSpPr/>
           <p:nvPr/>
         </p:nvSpPr>
@@ -5647,7 +5671,7 @@
       </p:sp>
       <p:sp>
         <p:nvSpPr>
-          <p:cNvPr id="53" name="Rectangle 52"/>
+          <p:cNvPr id="54" name="Rectangle 53"/>
           <p:cNvSpPr/>
           <p:nvPr/>
         </p:nvSpPr>
@@ -5691,7 +5715,7 @@
       </p:sp>
       <p:sp>
         <p:nvSpPr>
-          <p:cNvPr id="54" name="TextBox 53"/>
+          <p:cNvPr id="55" name="TextBox 54"/>
           <p:cNvSpPr txBox="1"/>
           <p:nvPr/>
         </p:nvSpPr>
@@ -5738,7 +5762,7 @@
       </p:sp>
       <p:sp>
         <p:nvSpPr>
-          <p:cNvPr id="55" name="TextBox 54"/>
+          <p:cNvPr id="56" name="TextBox 55"/>
           <p:cNvSpPr txBox="1"/>
           <p:nvPr/>
         </p:nvSpPr>
@@ -5785,14 +5809,14 @@
       </p:sp>
       <p:pic>
         <p:nvPicPr>
-          <p:cNvPr id="56" name="Picture 55" descr="icon-4.png"/>
+          <p:cNvPr id="57" name="Picture 56" descr="icon-4.png"/>
           <p:cNvPicPr>
             <a:picLocks noChangeAspect="1"/>
           </p:cNvPicPr>
           <p:nvPr/>
         </p:nvPicPr>
         <p:blipFill>
-          <a:blip r:embed="rId5"/>
+          <a:blip r:embed="rId2"/>
           <a:stretch>
             <a:fillRect/>
           </a:stretch>
@@ -5809,7 +5833,7 @@
       </p:pic>
       <p:sp>
         <p:nvSpPr>
-          <p:cNvPr id="57" name="TextBox 56"/>
+          <p:cNvPr id="58" name="TextBox 57"/>
           <p:cNvSpPr txBox="1"/>
           <p:nvPr/>
         </p:nvSpPr>
@@ -5849,14 +5873,14 @@
                 <a:ea typeface="DFKai-SB"/>
                 <a:cs typeface="Times New Roman"/>
               </a:rPr>
-              <a:t>檢查範圍、白名單與期限</a:t>
-            </a:r>
-          </a:p>
-        </p:txBody>
-      </p:sp>
-      <p:sp>
-        <p:nvSpPr>
-          <p:cNvPr id="58" name="TextBox 57"/>
+              <a:t>檢查範圍、允許動作與期限</a:t>
+            </a:r>
+          </a:p>
+        </p:txBody>
+      </p:sp>
+      <p:sp>
+        <p:nvSpPr>
+          <p:cNvPr id="59" name="TextBox 58"/>
           <p:cNvSpPr txBox="1"/>
           <p:nvPr/>
         </p:nvSpPr>
@@ -5903,7 +5927,7 @@
       </p:sp>
       <p:sp>
         <p:nvSpPr>
-          <p:cNvPr id="59" name="TextBox 58"/>
+          <p:cNvPr id="60" name="TextBox 59"/>
           <p:cNvSpPr txBox="1"/>
           <p:nvPr/>
         </p:nvSpPr>
@@ -5950,7 +5974,7 @@
       </p:sp>
       <p:sp>
         <p:nvSpPr>
-          <p:cNvPr id="60" name="Right Arrow 59"/>
+          <p:cNvPr id="61" name="Right Arrow 60"/>
           <p:cNvSpPr/>
           <p:nvPr/>
         </p:nvSpPr>
@@ -5994,7 +6018,7 @@
       </p:sp>
       <p:sp>
         <p:nvSpPr>
-          <p:cNvPr id="61" name="TextBox 60"/>
+          <p:cNvPr id="62" name="TextBox 61"/>
           <p:cNvSpPr txBox="1"/>
           <p:nvPr/>
         </p:nvSpPr>
@@ -6041,7 +6065,7 @@
       </p:sp>
       <p:sp>
         <p:nvSpPr>
-          <p:cNvPr id="62" name="Right Arrow 61"/>
+          <p:cNvPr id="63" name="Right Arrow 62"/>
           <p:cNvSpPr/>
           <p:nvPr/>
         </p:nvSpPr>
@@ -6085,7 +6109,7 @@
       </p:sp>
       <p:sp>
         <p:nvSpPr>
-          <p:cNvPr id="63" name="TextBox 62"/>
+          <p:cNvPr id="64" name="TextBox 63"/>
           <p:cNvSpPr txBox="1"/>
           <p:nvPr/>
         </p:nvSpPr>
@@ -6132,7 +6156,7 @@
       </p:sp>
       <p:sp>
         <p:nvSpPr>
-          <p:cNvPr id="64" name="TextBox 63"/>
+          <p:cNvPr id="65" name="TextBox 64"/>
           <p:cNvSpPr txBox="1"/>
           <p:nvPr/>
         </p:nvSpPr>
@@ -6179,7 +6203,7 @@
       </p:sp>
       <p:sp>
         <p:nvSpPr>
-          <p:cNvPr id="65" name="Left Arrow 64"/>
+          <p:cNvPr id="66" name="Left Arrow 65"/>
           <p:cNvSpPr/>
           <p:nvPr/>
         </p:nvSpPr>
@@ -6223,7 +6247,7 @@
       </p:sp>
       <p:sp>
         <p:nvSpPr>
-          <p:cNvPr id="66" name="Rectangle 65"/>
+          <p:cNvPr id="67" name="Rectangle 66"/>
           <p:cNvSpPr/>
           <p:nvPr/>
         </p:nvSpPr>
@@ -6267,7 +6291,7 @@
       </p:sp>
       <p:sp>
         <p:nvSpPr>
-          <p:cNvPr id="67" name="TextBox 66"/>
+          <p:cNvPr id="68" name="TextBox 67"/>
           <p:cNvSpPr txBox="1"/>
           <p:nvPr/>
         </p:nvSpPr>
@@ -6314,7 +6338,7 @@
       </p:sp>
       <p:sp>
         <p:nvSpPr>
-          <p:cNvPr id="68" name="TextBox 67"/>
+          <p:cNvPr id="69" name="TextBox 68"/>
           <p:cNvSpPr txBox="1"/>
           <p:nvPr/>
         </p:nvSpPr>
@@ -6361,7 +6385,7 @@
       </p:sp>
       <p:sp>
         <p:nvSpPr>
-          <p:cNvPr id="69" name="TextBox 68"/>
+          <p:cNvPr id="70" name="TextBox 69"/>
           <p:cNvSpPr txBox="1"/>
           <p:nvPr/>
         </p:nvSpPr>
@@ -6408,7 +6432,7 @@
       </p:sp>
       <p:sp>
         <p:nvSpPr>
-          <p:cNvPr id="70" name="TextBox 69"/>
+          <p:cNvPr id="71" name="TextBox 70"/>
           <p:cNvSpPr txBox="1"/>
           <p:nvPr/>
         </p:nvSpPr>
@@ -6455,7 +6479,7 @@
       </p:sp>
       <p:sp>
         <p:nvSpPr>
-          <p:cNvPr id="71" name="TextBox 70"/>
+          <p:cNvPr id="72" name="TextBox 71"/>
           <p:cNvSpPr txBox="1"/>
           <p:nvPr/>
         </p:nvSpPr>
@@ -6548,7 +6572,7 @@
       </p:sp>
       <p:cxnSp>
         <p:nvCxnSpPr>
-          <p:cNvPr id="72" name="Connector 71"/>
+          <p:cNvPr id="73" name="Connector 72"/>
           <p:cNvCxnSpPr/>
           <p:nvPr/>
         </p:nvCxnSpPr>
@@ -6584,7 +6608,7 @@
       </p:cxnSp>
       <p:sp>
         <p:nvSpPr>
-          <p:cNvPr id="73" name="TextBox 72"/>
+          <p:cNvPr id="74" name="TextBox 73"/>
           <p:cNvSpPr txBox="1"/>
           <p:nvPr/>
         </p:nvSpPr>
@@ -6631,7 +6655,7 @@
       </p:sp>
       <p:sp>
         <p:nvSpPr>
-          <p:cNvPr id="74" name="TextBox 73"/>
+          <p:cNvPr id="75" name="TextBox 74"/>
           <p:cNvSpPr txBox="1"/>
           <p:nvPr/>
         </p:nvSpPr>
@@ -6702,7 +6726,7 @@
       </p:sp>
       <p:cxnSp>
         <p:nvCxnSpPr>
-          <p:cNvPr id="75" name="Connector 74"/>
+          <p:cNvPr id="76" name="Connector 75"/>
           <p:cNvCxnSpPr/>
           <p:nvPr/>
         </p:nvCxnSpPr>
@@ -6738,7 +6762,7 @@
       </p:cxnSp>
       <p:sp>
         <p:nvSpPr>
-          <p:cNvPr id="76" name="TextBox 75"/>
+          <p:cNvPr id="77" name="TextBox 76"/>
           <p:cNvSpPr txBox="1"/>
           <p:nvPr/>
         </p:nvSpPr>
@@ -6785,7 +6809,7 @@
       </p:sp>
       <p:sp>
         <p:nvSpPr>
-          <p:cNvPr id="77" name="TextBox 76"/>
+          <p:cNvPr id="78" name="TextBox 77"/>
           <p:cNvSpPr txBox="1"/>
           <p:nvPr/>
         </p:nvSpPr>
@@ -6856,7 +6880,7 @@
       </p:sp>
       <p:sp>
         <p:nvSpPr>
-          <p:cNvPr id="78" name="TextBox 77"/>
+          <p:cNvPr id="79" name="TextBox 78"/>
           <p:cNvSpPr txBox="1"/>
           <p:nvPr/>
         </p:nvSpPr>
@@ -6903,7 +6927,7 @@
       </p:sp>
       <p:sp>
         <p:nvSpPr>
-          <p:cNvPr id="79" name="TextBox 78"/>
+          <p:cNvPr id="80" name="TextBox 79"/>
           <p:cNvSpPr txBox="1"/>
           <p:nvPr/>
         </p:nvSpPr>
@@ -6950,7 +6974,7 @@
       </p:sp>
       <p:sp>
         <p:nvSpPr>
-          <p:cNvPr id="80" name="TextBox 79"/>
+          <p:cNvPr id="81" name="TextBox 80"/>
           <p:cNvSpPr txBox="1"/>
           <p:nvPr/>
         </p:nvSpPr>
@@ -7030,7 +7054,7 @@
       </p:sp>
       <p:sp>
         <p:nvSpPr>
-          <p:cNvPr id="81" name="TextBox 80"/>
+          <p:cNvPr id="82" name="TextBox 81"/>
           <p:cNvSpPr txBox="1"/>
           <p:nvPr/>
         </p:nvSpPr>
@@ -7077,7 +7101,7 @@
       </p:sp>
       <p:sp>
         <p:nvSpPr>
-          <p:cNvPr id="82" name="Rectangle 81"/>
+          <p:cNvPr id="83" name="Rectangle 82"/>
           <p:cNvSpPr/>
           <p:nvPr/>
         </p:nvSpPr>
@@ -7121,7 +7145,7 @@
       </p:sp>
       <p:sp>
         <p:nvSpPr>
-          <p:cNvPr id="83" name="Rectangle 82"/>
+          <p:cNvPr id="84" name="Rectangle 83"/>
           <p:cNvSpPr/>
           <p:nvPr/>
         </p:nvSpPr>
@@ -7165,7 +7189,7 @@
       </p:sp>
       <p:sp>
         <p:nvSpPr>
-          <p:cNvPr id="84" name="TextBox 83"/>
+          <p:cNvPr id="85" name="TextBox 84"/>
           <p:cNvSpPr txBox="1"/>
           <p:nvPr/>
         </p:nvSpPr>
@@ -7212,7 +7236,7 @@
       </p:sp>
       <p:sp>
         <p:nvSpPr>
-          <p:cNvPr id="85" name="TextBox 84"/>
+          <p:cNvPr id="86" name="TextBox 85"/>
           <p:cNvSpPr txBox="1"/>
           <p:nvPr/>
         </p:nvSpPr>
@@ -7259,7 +7283,7 @@
       </p:sp>
       <p:sp>
         <p:nvSpPr>
-          <p:cNvPr id="86" name="Rectangle 85"/>
+          <p:cNvPr id="87" name="Rectangle 86"/>
           <p:cNvSpPr/>
           <p:nvPr/>
         </p:nvSpPr>
@@ -7303,7 +7327,7 @@
       </p:sp>
       <p:sp>
         <p:nvSpPr>
-          <p:cNvPr id="87" name="Rectangle 86"/>
+          <p:cNvPr id="88" name="Rectangle 87"/>
           <p:cNvSpPr/>
           <p:nvPr/>
         </p:nvSpPr>
@@ -7347,7 +7371,7 @@
       </p:sp>
       <p:sp>
         <p:nvSpPr>
-          <p:cNvPr id="88" name="TextBox 87"/>
+          <p:cNvPr id="89" name="TextBox 88"/>
           <p:cNvSpPr txBox="1"/>
           <p:nvPr/>
         </p:nvSpPr>
@@ -7394,7 +7418,7 @@
       </p:sp>
       <p:sp>
         <p:nvSpPr>
-          <p:cNvPr id="89" name="TextBox 88"/>
+          <p:cNvPr id="90" name="TextBox 89"/>
           <p:cNvSpPr txBox="1"/>
           <p:nvPr/>
         </p:nvSpPr>
@@ -7441,7 +7465,7 @@
       </p:sp>
       <p:sp>
         <p:nvSpPr>
-          <p:cNvPr id="90" name="Rectangle 89"/>
+          <p:cNvPr id="91" name="Rectangle 90"/>
           <p:cNvSpPr/>
           <p:nvPr/>
         </p:nvSpPr>
@@ -7485,7 +7509,7 @@
       </p:sp>
       <p:sp>
         <p:nvSpPr>
-          <p:cNvPr id="91" name="Rectangle 90"/>
+          <p:cNvPr id="92" name="Rectangle 91"/>
           <p:cNvSpPr/>
           <p:nvPr/>
         </p:nvSpPr>
@@ -7529,7 +7553,7 @@
       </p:sp>
       <p:sp>
         <p:nvSpPr>
-          <p:cNvPr id="92" name="TextBox 91"/>
+          <p:cNvPr id="93" name="TextBox 92"/>
           <p:cNvSpPr txBox="1"/>
           <p:nvPr/>
         </p:nvSpPr>
@@ -7576,7 +7600,7 @@
       </p:sp>
       <p:sp>
         <p:nvSpPr>
-          <p:cNvPr id="93" name="TextBox 92"/>
+          <p:cNvPr id="94" name="TextBox 93"/>
           <p:cNvSpPr txBox="1"/>
           <p:nvPr/>
         </p:nvSpPr>
@@ -7634,7 +7658,7 @@
       </p:sp>
       <p:sp>
         <p:nvSpPr>
-          <p:cNvPr id="94" name="TextBox 93"/>
+          <p:cNvPr id="95" name="TextBox 94"/>
           <p:cNvSpPr txBox="1"/>
           <p:nvPr/>
         </p:nvSpPr>
@@ -7703,7 +7727,7 @@
       </p:sp>
       <p:cxnSp>
         <p:nvCxnSpPr>
-          <p:cNvPr id="95" name="Connector 94"/>
+          <p:cNvPr id="96" name="Connector 95"/>
           <p:cNvCxnSpPr/>
           <p:nvPr/>
         </p:nvCxnSpPr>
@@ -7739,7 +7763,7 @@
       </p:cxnSp>
       <p:sp>
         <p:nvSpPr>
-          <p:cNvPr id="96" name="TextBox 95"/>
+          <p:cNvPr id="97" name="TextBox 96"/>
           <p:cNvSpPr txBox="1"/>
           <p:nvPr/>
         </p:nvSpPr>
@@ -7819,7 +7843,7 @@
       </p:sp>
       <p:sp>
         <p:nvSpPr>
-          <p:cNvPr id="97" name="TextBox 96"/>
+          <p:cNvPr id="98" name="TextBox 97"/>
           <p:cNvSpPr txBox="1"/>
           <p:nvPr/>
         </p:nvSpPr>
@@ -7866,7 +7890,7 @@
       </p:sp>
       <p:sp>
         <p:nvSpPr>
-          <p:cNvPr id="98" name="TextBox 97"/>
+          <p:cNvPr id="99" name="TextBox 98"/>
           <p:cNvSpPr txBox="1"/>
           <p:nvPr/>
         </p:nvSpPr>
@@ -7935,7 +7959,7 @@
       </p:sp>
       <p:sp>
         <p:nvSpPr>
-          <p:cNvPr id="99" name="TextBox 98"/>
+          <p:cNvPr id="100" name="TextBox 99"/>
           <p:cNvSpPr txBox="1"/>
           <p:nvPr/>
         </p:nvSpPr>
@@ -7982,7 +8006,7 @@
       </p:sp>
       <p:sp>
         <p:nvSpPr>
-          <p:cNvPr id="100" name="TextBox 99"/>
+          <p:cNvPr id="101" name="TextBox 100"/>
           <p:cNvSpPr txBox="1"/>
           <p:nvPr/>
         </p:nvSpPr>
@@ -8029,7 +8053,7 @@
       </p:sp>
       <p:sp>
         <p:nvSpPr>
-          <p:cNvPr id="101" name="TextBox 100"/>
+          <p:cNvPr id="102" name="TextBox 101"/>
           <p:cNvSpPr txBox="1"/>
           <p:nvPr/>
         </p:nvSpPr>
@@ -8076,7 +8100,7 @@
       </p:sp>
       <p:sp>
         <p:nvSpPr>
-          <p:cNvPr id="102" name="TextBox 101"/>
+          <p:cNvPr id="103" name="TextBox 102"/>
           <p:cNvSpPr txBox="1"/>
           <p:nvPr/>
         </p:nvSpPr>
@@ -8123,7 +8147,7 @@
       </p:sp>
       <p:sp>
         <p:nvSpPr>
-          <p:cNvPr id="103" name="TextBox 102"/>
+          <p:cNvPr id="104" name="TextBox 103"/>
           <p:cNvSpPr txBox="1"/>
           <p:nvPr/>
         </p:nvSpPr>
@@ -8170,7 +8194,7 @@
       </p:sp>
       <p:sp>
         <p:nvSpPr>
-          <p:cNvPr id="104" name="TextBox 103"/>
+          <p:cNvPr id="105" name="TextBox 104"/>
           <p:cNvSpPr txBox="1"/>
           <p:nvPr/>
         </p:nvSpPr>
@@ -8217,7 +8241,7 @@
       </p:sp>
       <p:sp>
         <p:nvSpPr>
-          <p:cNvPr id="105" name="TextBox 104"/>
+          <p:cNvPr id="106" name="TextBox 105"/>
           <p:cNvSpPr txBox="1"/>
           <p:nvPr/>
         </p:nvSpPr>
@@ -8343,7 +8367,7 @@
       </p:sp>
       <p:cxnSp>
         <p:nvCxnSpPr>
-          <p:cNvPr id="106" name="Connector 105"/>
+          <p:cNvPr id="107" name="Connector 106"/>
           <p:cNvCxnSpPr/>
           <p:nvPr/>
         </p:nvCxnSpPr>
@@ -8379,7 +8403,7 @@
       </p:cxnSp>
       <p:sp>
         <p:nvSpPr>
-          <p:cNvPr id="107" name="TextBox 106"/>
+          <p:cNvPr id="108" name="TextBox 107"/>
           <p:cNvSpPr txBox="1"/>
           <p:nvPr/>
         </p:nvSpPr>
@@ -8514,7 +8538,7 @@
       </p:sp>
       <p:sp>
         <p:nvSpPr>
-          <p:cNvPr id="108" name="TextBox 107"/>
+          <p:cNvPr id="109" name="TextBox 108"/>
           <p:cNvSpPr txBox="1"/>
           <p:nvPr/>
         </p:nvSpPr>

</xml_diff>

<commit_message>
Improve poster scope readability and control chapter timing
</commit_message>
<xml_diff>
--- a/deliverables/決賽海報_AI資安框架_A2.pptx
+++ b/deliverables/決賽海報_AI資安框架_A2.pptx
@@ -8828,7 +8828,7 @@
         </p:nvSpPr>
         <p:spPr>
           <a:xfrm>
-            <a:off x="576000" y="14364000"/>
+            <a:off x="576000" y="14292000"/>
             <a:ext cx="432000" cy="360000"/>
           </a:xfrm>
           <a:prstGeom prst="rect">
@@ -8879,7 +8879,7 @@
         </p:nvSpPr>
         <p:spPr>
           <a:xfrm>
-            <a:off x="1116000" y="14364000"/>
+            <a:off x="1116000" y="14292000"/>
             <a:ext cx="13320000" cy="360000"/>
           </a:xfrm>
           <a:prstGeom prst="rect">
@@ -8930,7 +8930,7 @@
         </p:nvSpPr>
         <p:spPr>
           <a:xfrm>
-            <a:off x="576000" y="14976000"/>
+            <a:off x="576000" y="14868000"/>
             <a:ext cx="4392000" cy="396000"/>
           </a:xfrm>
           <a:prstGeom prst="rect">
@@ -8981,8 +8981,8 @@
         </p:nvSpPr>
         <p:spPr>
           <a:xfrm>
-            <a:off x="576000" y="15516000"/>
-            <a:ext cx="4464000" cy="828000"/>
+            <a:off x="576000" y="15336000"/>
+            <a:ext cx="4464000" cy="792000"/>
           </a:xfrm>
           <a:prstGeom prst="rect">
             <a:avLst/>
@@ -9052,8 +9052,8 @@
         </p:nvCxnSpPr>
         <p:spPr>
           <a:xfrm>
-            <a:off x="5148000" y="15012000"/>
-            <a:ext cx="0" cy="1368000"/>
+            <a:off x="5148000" y="14904000"/>
+            <a:ext cx="0" cy="1224000"/>
           </a:xfrm>
           <a:prstGeom prst="line">
             <a:avLst/>
@@ -9092,7 +9092,7 @@
         </p:nvSpPr>
         <p:spPr>
           <a:xfrm>
-            <a:off x="5364000" y="14976000"/>
+            <a:off x="5364000" y="14868000"/>
             <a:ext cx="4392000" cy="396000"/>
           </a:xfrm>
           <a:prstGeom prst="rect">
@@ -9143,8 +9143,8 @@
         </p:nvSpPr>
         <p:spPr>
           <a:xfrm>
-            <a:off x="5364000" y="15516000"/>
-            <a:ext cx="4464000" cy="828000"/>
+            <a:off x="5364000" y="15336000"/>
+            <a:ext cx="4464000" cy="792000"/>
           </a:xfrm>
           <a:prstGeom prst="rect">
             <a:avLst/>
@@ -9214,8 +9214,8 @@
         </p:nvCxnSpPr>
         <p:spPr>
           <a:xfrm>
-            <a:off x="9936000" y="15012000"/>
-            <a:ext cx="0" cy="1368000"/>
+            <a:off x="9936000" y="14904000"/>
+            <a:ext cx="0" cy="1224000"/>
           </a:xfrm>
           <a:prstGeom prst="line">
             <a:avLst/>
@@ -9254,7 +9254,7 @@
         </p:nvSpPr>
         <p:spPr>
           <a:xfrm>
-            <a:off x="10152000" y="14976000"/>
+            <a:off x="10152000" y="14868000"/>
             <a:ext cx="4392000" cy="396000"/>
           </a:xfrm>
           <a:prstGeom prst="rect">
@@ -9305,8 +9305,8 @@
         </p:nvSpPr>
         <p:spPr>
           <a:xfrm>
-            <a:off x="10152000" y="15516000"/>
-            <a:ext cx="4464000" cy="828000"/>
+            <a:off x="10152000" y="15336000"/>
+            <a:ext cx="4464000" cy="792000"/>
           </a:xfrm>
           <a:prstGeom prst="rect">
             <a:avLst/>
@@ -9380,7 +9380,7 @@
         </p:nvSpPr>
         <p:spPr>
           <a:xfrm>
-            <a:off x="576000" y="16740000"/>
+            <a:off x="576000" y="16380000"/>
             <a:ext cx="432000" cy="360000"/>
           </a:xfrm>
           <a:prstGeom prst="rect">
@@ -9431,7 +9431,7 @@
         </p:nvSpPr>
         <p:spPr>
           <a:xfrm>
-            <a:off x="1116000" y="16740000"/>
+            <a:off x="1116000" y="16380000"/>
             <a:ext cx="13320000" cy="360000"/>
           </a:xfrm>
           <a:prstGeom prst="rect">
@@ -9482,7 +9482,7 @@
         </p:nvSpPr>
         <p:spPr>
           <a:xfrm>
-            <a:off x="576000" y="17280000"/>
+            <a:off x="576000" y="16920000"/>
             <a:ext cx="6624000" cy="360000"/>
           </a:xfrm>
           <a:prstGeom prst="rect">
@@ -9533,7 +9533,7 @@
         </p:nvSpPr>
         <p:spPr>
           <a:xfrm>
-            <a:off x="576000" y="17784000"/>
+            <a:off x="576000" y="17424000"/>
             <a:ext cx="1584000" cy="360000"/>
           </a:xfrm>
           <a:prstGeom prst="rect">
@@ -9580,7 +9580,7 @@
         </p:nvSpPr>
         <p:spPr>
           <a:xfrm>
-            <a:off x="2304000" y="17856000"/>
+            <a:off x="2304000" y="17496000"/>
             <a:ext cx="3384000" cy="216000"/>
           </a:xfrm>
           <a:prstGeom prst="rect">
@@ -9629,7 +9629,7 @@
         </p:nvSpPr>
         <p:spPr>
           <a:xfrm>
-            <a:off x="2304000" y="17856000"/>
+            <a:off x="2304000" y="17496000"/>
             <a:ext cx="2698671" cy="216000"/>
           </a:xfrm>
           <a:prstGeom prst="rect">
@@ -9682,7 +9682,7 @@
         </p:nvSpPr>
         <p:spPr>
           <a:xfrm>
-            <a:off x="5729975" y="17784000"/>
+            <a:off x="5729975" y="17424000"/>
             <a:ext cx="1404000" cy="360000"/>
           </a:xfrm>
           <a:prstGeom prst="rect">
@@ -9733,7 +9733,7 @@
         </p:nvSpPr>
         <p:spPr>
           <a:xfrm>
-            <a:off x="576000" y="18396000"/>
+            <a:off x="576000" y="18036000"/>
             <a:ext cx="1584000" cy="360000"/>
           </a:xfrm>
           <a:prstGeom prst="rect">
@@ -9780,7 +9780,7 @@
         </p:nvSpPr>
         <p:spPr>
           <a:xfrm>
-            <a:off x="2304000" y="18468000"/>
+            <a:off x="2304000" y="18108000"/>
             <a:ext cx="3384000" cy="216000"/>
           </a:xfrm>
           <a:prstGeom prst="rect">
@@ -9829,7 +9829,7 @@
         </p:nvSpPr>
         <p:spPr>
           <a:xfrm>
-            <a:off x="2304000" y="18468000"/>
+            <a:off x="2304000" y="18108000"/>
             <a:ext cx="3116757" cy="216000"/>
           </a:xfrm>
           <a:prstGeom prst="rect">
@@ -9882,7 +9882,7 @@
         </p:nvSpPr>
         <p:spPr>
           <a:xfrm>
-            <a:off x="5729975" y="18396000"/>
+            <a:off x="5729975" y="18036000"/>
             <a:ext cx="1404000" cy="360000"/>
           </a:xfrm>
           <a:prstGeom prst="rect">
@@ -9933,7 +9933,7 @@
         </p:nvSpPr>
         <p:spPr>
           <a:xfrm>
-            <a:off x="576000" y="19008000"/>
+            <a:off x="576000" y="18648000"/>
             <a:ext cx="1584000" cy="360000"/>
           </a:xfrm>
           <a:prstGeom prst="rect">
@@ -9980,7 +9980,7 @@
         </p:nvSpPr>
         <p:spPr>
           <a:xfrm>
-            <a:off x="2304000" y="19080000"/>
+            <a:off x="2304000" y="18720000"/>
             <a:ext cx="3384000" cy="216000"/>
           </a:xfrm>
           <a:prstGeom prst="rect">
@@ -10029,7 +10029,7 @@
         </p:nvSpPr>
         <p:spPr>
           <a:xfrm>
-            <a:off x="2304000" y="19080000"/>
+            <a:off x="2304000" y="18720000"/>
             <a:ext cx="3148824" cy="216000"/>
           </a:xfrm>
           <a:prstGeom prst="rect">
@@ -10082,7 +10082,7 @@
         </p:nvSpPr>
         <p:spPr>
           <a:xfrm>
-            <a:off x="5729975" y="19008000"/>
+            <a:off x="5729975" y="18648000"/>
             <a:ext cx="1404000" cy="360000"/>
           </a:xfrm>
           <a:prstGeom prst="rect">
@@ -10133,7 +10133,7 @@
         </p:nvSpPr>
         <p:spPr>
           <a:xfrm>
-            <a:off x="576000" y="19620000"/>
+            <a:off x="576000" y="19260000"/>
             <a:ext cx="6624000" cy="324000"/>
           </a:xfrm>
           <a:prstGeom prst="rect">
@@ -10180,7 +10180,7 @@
         </p:nvCxnSpPr>
         <p:spPr>
           <a:xfrm>
-            <a:off x="7560000" y="17280000"/>
+            <a:off x="7560000" y="16920000"/>
             <a:ext cx="0" cy="2844000"/>
           </a:xfrm>
           <a:prstGeom prst="line">
@@ -10220,7 +10220,7 @@
         </p:nvSpPr>
         <p:spPr>
           <a:xfrm>
-            <a:off x="7920000" y="17280000"/>
+            <a:off x="7920000" y="16920000"/>
             <a:ext cx="6624000" cy="360000"/>
           </a:xfrm>
           <a:prstGeom prst="rect">
@@ -10271,7 +10271,7 @@
         </p:nvSpPr>
         <p:spPr>
           <a:xfrm>
-            <a:off x="7920000" y="17712000"/>
+            <a:off x="7920000" y="17352000"/>
             <a:ext cx="6624000" cy="432000"/>
           </a:xfrm>
           <a:prstGeom prst="rect">
@@ -10322,7 +10322,7 @@
         </p:nvSpPr>
         <p:spPr>
           <a:xfrm>
-            <a:off x="7920000" y="18252000"/>
+            <a:off x="7920000" y="17892000"/>
             <a:ext cx="6624000" cy="360000"/>
           </a:xfrm>
           <a:prstGeom prst="rect">
@@ -10373,7 +10373,7 @@
         </p:nvSpPr>
         <p:spPr>
           <a:xfrm>
-            <a:off x="7878725" y="18720000"/>
+            <a:off x="7878725" y="18360000"/>
             <a:ext cx="2088000" cy="432000"/>
           </a:xfrm>
           <a:prstGeom prst="rect">
@@ -10424,7 +10424,7 @@
         </p:nvSpPr>
         <p:spPr>
           <a:xfrm>
-            <a:off x="7893013" y="19188000"/>
+            <a:off x="7893013" y="18828000"/>
             <a:ext cx="2088000" cy="324000"/>
           </a:xfrm>
           <a:prstGeom prst="rect">
@@ -10475,7 +10475,7 @@
         </p:nvSpPr>
         <p:spPr>
           <a:xfrm>
-            <a:off x="10146725" y="18720000"/>
+            <a:off x="10146725" y="18360000"/>
             <a:ext cx="2088000" cy="432000"/>
           </a:xfrm>
           <a:prstGeom prst="rect">
@@ -10526,7 +10526,7 @@
         </p:nvSpPr>
         <p:spPr>
           <a:xfrm>
-            <a:off x="10161012" y="19188000"/>
+            <a:off x="10161012" y="18828000"/>
             <a:ext cx="2088000" cy="324000"/>
           </a:xfrm>
           <a:prstGeom prst="rect">
@@ -10577,7 +10577,7 @@
         </p:nvSpPr>
         <p:spPr>
           <a:xfrm>
-            <a:off x="12414726" y="18720000"/>
+            <a:off x="12414726" y="18360000"/>
             <a:ext cx="2088000" cy="432000"/>
           </a:xfrm>
           <a:prstGeom prst="rect">
@@ -10628,7 +10628,7 @@
         </p:nvSpPr>
         <p:spPr>
           <a:xfrm>
-            <a:off x="12429013" y="19188000"/>
+            <a:off x="12429013" y="18828000"/>
             <a:ext cx="2088000" cy="324000"/>
           </a:xfrm>
           <a:prstGeom prst="rect">
@@ -10679,7 +10679,7 @@
         </p:nvSpPr>
         <p:spPr>
           <a:xfrm>
-            <a:off x="7920000" y="19656000"/>
+            <a:off x="7920000" y="19296000"/>
             <a:ext cx="6624000" cy="504000"/>
           </a:xfrm>
           <a:prstGeom prst="rect">
@@ -10705,7 +10705,7 @@
               </a:spcAft>
             </a:pPr>
             <a:r>
-              <a:rPr sz="1350" b="0">
+              <a:rPr sz="1450" b="0">
                 <a:solidFill>
                   <a:srgbClr val="53666E"/>
                 </a:solidFill>
@@ -10729,7 +10729,7 @@
               </a:spcAft>
             </a:pPr>
             <a:r>
-              <a:rPr sz="1350" b="0">
+              <a:rPr sz="1450" b="0">
                 <a:solidFill>
                   <a:srgbClr val="53666E"/>
                 </a:solidFill>
@@ -10750,7 +10750,7 @@
         </p:nvCxnSpPr>
         <p:spPr>
           <a:xfrm>
-            <a:off x="576000" y="20232000"/>
+            <a:off x="576000" y="19872000"/>
             <a:ext cx="13968000" cy="0"/>
           </a:xfrm>
           <a:prstGeom prst="line">
@@ -10790,8 +10790,8 @@
         </p:nvSpPr>
         <p:spPr>
           <a:xfrm>
-            <a:off x="576000" y="20340000"/>
-            <a:ext cx="13968000" cy="324000"/>
+            <a:off x="576000" y="19980000"/>
+            <a:ext cx="13968000" cy="288000"/>
           </a:xfrm>
           <a:prstGeom prst="rect">
             <a:avLst/>
@@ -10841,8 +10841,8 @@
         </p:nvSpPr>
         <p:spPr>
           <a:xfrm>
-            <a:off x="576000" y="20664000"/>
-            <a:ext cx="13968000" cy="180000"/>
+            <a:off x="576000" y="20322000"/>
+            <a:ext cx="13968000" cy="504000"/>
           </a:xfrm>
           <a:prstGeom prst="rect">
             <a:avLst/>
@@ -10867,7 +10867,7 @@
               </a:spcAft>
             </a:pPr>
             <a:r>
-              <a:rPr sz="1100" b="0">
+              <a:rPr sz="1600" b="0">
                 <a:solidFill>
                   <a:srgbClr val="53666E"/>
                 </a:solidFill>
@@ -10875,7 +10875,31 @@
                 <a:ea typeface="DFKai-SB"/>
                 <a:cs typeface="Times New Roman"/>
               </a:rPr>
-              <a:t>6種情境含4種套用規則、2種監測或蒐證；6/6為隔離交易與回復結果，非原生攻擊防禦率。</a:t>
+              <a:t>6種隔離情境：4種套用規則、2種監測或蒐證。</a:t>
+            </a:r>
+          </a:p>
+          <a:p>
+            <a:pPr algn="l">
+              <a:lnSpc>
+                <a:spcPct val="110000"/>
+              </a:lnSpc>
+              <a:spcBef>
+                <a:spcPts val="0"/>
+              </a:spcBef>
+              <a:spcAft>
+                <a:spcPts val="0"/>
+              </a:spcAft>
+            </a:pPr>
+            <a:r>
+              <a:rPr sz="1600" b="0">
+                <a:solidFill>
+                  <a:srgbClr val="53666E"/>
+                </a:solidFill>
+                <a:latin typeface="Times New Roman"/>
+                <a:ea typeface="DFKai-SB"/>
+                <a:cs typeface="Times New Roman"/>
+              </a:rPr>
+              <a:t>6/6為隔離交易與回復結果，非原生攻擊防禦率。</a:t>
             </a:r>
           </a:p>
         </p:txBody>

</xml_diff>

<commit_message>
Enrich A2 poster with stage outputs and measured scenario cards
</commit_message>
<xml_diff>
--- a/deliverables/決賽海報_AI資安框架_A2.pptx
+++ b/deliverables/決賽海報_AI資安框架_A2.pptx
@@ -4384,8 +4384,8 @@
         </p:nvSpPr>
         <p:spPr>
           <a:xfrm>
-            <a:off x="576000" y="3888000"/>
-            <a:ext cx="13968000" cy="360000"/>
+            <a:off x="576000" y="3780000"/>
+            <a:ext cx="13968000" cy="324000"/>
           </a:xfrm>
           <a:prstGeom prst="rect">
             <a:avLst/>
@@ -4435,8 +4435,8 @@
         </p:nvSpPr>
         <p:spPr>
           <a:xfrm>
-            <a:off x="576000" y="4608000"/>
-            <a:ext cx="432000" cy="360000"/>
+            <a:off x="576000" y="4176000"/>
+            <a:ext cx="13968000" cy="288000"/>
           </a:xfrm>
           <a:prstGeom prst="rect">
             <a:avLst/>
@@ -4461,15 +4461,15 @@
               </a:spcAft>
             </a:pPr>
             <a:r>
-              <a:rPr sz="2000" b="1">
+              <a:rPr sz="1600" b="0">
                 <a:solidFill>
-                  <a:srgbClr val="105186"/>
+                  <a:srgbClr val="171C1D"/>
                 </a:solidFill>
                 <a:latin typeface="Times New Roman"/>
                 <a:ea typeface="DFKai-SB"/>
                 <a:cs typeface="Times New Roman"/>
               </a:rPr>
-              <a:t>01</a:t>
+              <a:t>面向校園與中小型組織的告警判讀，以案例證據協助核對事件，再依策略執行與回復。</a:t>
             </a:r>
           </a:p>
         </p:txBody>
@@ -4486,8 +4486,8 @@
         </p:nvSpPr>
         <p:spPr>
           <a:xfrm>
-            <a:off x="1116000" y="4608000"/>
-            <a:ext cx="13320000" cy="360000"/>
+            <a:off x="576000" y="4608000"/>
+            <a:ext cx="432000" cy="360000"/>
           </a:xfrm>
           <a:prstGeom prst="rect">
             <a:avLst/>
@@ -4512,6 +4512,57 @@
               </a:spcAft>
             </a:pPr>
             <a:r>
+              <a:rPr sz="2000" b="1">
+                <a:solidFill>
+                  <a:srgbClr val="105186"/>
+                </a:solidFill>
+                <a:latin typeface="Times New Roman"/>
+                <a:ea typeface="DFKai-SB"/>
+                <a:cs typeface="Times New Roman"/>
+              </a:rPr>
+              <a:t>01</a:t>
+            </a:r>
+          </a:p>
+        </p:txBody>
+      </p:sp>
+      <p:sp>
+        <p:nvSpPr>
+          <p:cNvPr id="11" name="TextBox 10"/>
+          <p:cNvSpPr txBox="1"/>
+          <p:nvPr>
+            <p:custDataLst>
+              <p:tags r:id="rId7"/>
+            </p:custDataLst>
+          </p:nvPr>
+        </p:nvSpPr>
+        <p:spPr>
+          <a:xfrm>
+            <a:off x="1116000" y="4608000"/>
+            <a:ext cx="13320000" cy="360000"/>
+          </a:xfrm>
+          <a:prstGeom prst="rect">
+            <a:avLst/>
+          </a:prstGeom>
+          <a:noFill/>
+        </p:spPr>
+        <p:txBody>
+          <a:bodyPr wrap="none" lIns="0" tIns="0" rIns="0" bIns="0" anchor="ctr">
+            <a:spAutoFit/>
+          </a:bodyPr>
+          <a:lstStyle/>
+          <a:p>
+            <a:pPr algn="l">
+              <a:lnSpc>
+                <a:spcPct val="110000"/>
+              </a:lnSpc>
+              <a:spcBef>
+                <a:spcPts val="0"/>
+              </a:spcBef>
+              <a:spcAft>
+                <a:spcPts val="0"/>
+              </a:spcAft>
+            </a:pPr>
+            <a:r>
               <a:rPr sz="2400" b="0">
                 <a:solidFill>
                   <a:srgbClr val="092B42"/>
@@ -4527,7 +4578,7 @@
       </p:sp>
       <p:sp>
         <p:nvSpPr>
-          <p:cNvPr id="11" name="Rectangle 10"/>
+          <p:cNvPr id="12" name="Rectangle 11"/>
           <p:cNvSpPr/>
           <p:nvPr/>
         </p:nvSpPr>
@@ -4578,7 +4629,7 @@
       </p:sp>
       <p:sp>
         <p:nvSpPr>
-          <p:cNvPr id="12" name="Rectangle 11"/>
+          <p:cNvPr id="13" name="Rectangle 12"/>
           <p:cNvSpPr/>
           <p:nvPr/>
         </p:nvSpPr>
@@ -4627,11 +4678,11 @@
       </p:sp>
       <p:sp>
         <p:nvSpPr>
-          <p:cNvPr id="13" name="TextBox 12"/>
+          <p:cNvPr id="14" name="TextBox 13"/>
           <p:cNvSpPr txBox="1"/>
           <p:nvPr>
             <p:custDataLst>
-              <p:tags r:id="rId7"/>
+              <p:tags r:id="rId8"/>
             </p:custDataLst>
           </p:nvPr>
         </p:nvSpPr>
@@ -4678,11 +4729,11 @@
       </p:sp>
       <p:sp>
         <p:nvSpPr>
-          <p:cNvPr id="14" name="TextBox 13"/>
+          <p:cNvPr id="15" name="TextBox 14"/>
           <p:cNvSpPr txBox="1"/>
           <p:nvPr>
             <p:custDataLst>
-              <p:tags r:id="rId8"/>
+              <p:tags r:id="rId9"/>
             </p:custDataLst>
           </p:nvPr>
         </p:nvSpPr>
@@ -4729,11 +4780,11 @@
       </p:sp>
       <p:sp>
         <p:nvSpPr>
-          <p:cNvPr id="15" name="TextBox 14"/>
+          <p:cNvPr id="16" name="TextBox 15"/>
           <p:cNvSpPr txBox="1"/>
           <p:nvPr>
             <p:custDataLst>
-              <p:tags r:id="rId9"/>
+              <p:tags r:id="rId10"/>
             </p:custDataLst>
           </p:nvPr>
         </p:nvSpPr>
@@ -4780,14 +4831,14 @@
       </p:sp>
       <p:pic>
         <p:nvPicPr>
-          <p:cNvPr id="16" name="Picture 15" descr="flat-icon-2.png"/>
+          <p:cNvPr id="17" name="Picture 16" descr="flat-icon-2.png"/>
           <p:cNvPicPr>
             <a:picLocks noChangeAspect="1"/>
           </p:cNvPicPr>
           <p:nvPr/>
         </p:nvPicPr>
         <p:blipFill>
-          <a:blip r:embed="rId77"/>
+          <a:blip r:embed="rId99"/>
           <a:stretch>
             <a:fillRect/>
           </a:stretch>
@@ -4804,7 +4855,82 @@
       </p:pic>
       <p:sp>
         <p:nvSpPr>
-          <p:cNvPr id="17" name="Down Arrow 16"/>
+          <p:cNvPr id="18" name="TextBox 17"/>
+          <p:cNvSpPr txBox="1"/>
+          <p:nvPr>
+            <p:custDataLst>
+              <p:tags r:id="rId11"/>
+            </p:custDataLst>
+          </p:nvPr>
+        </p:nvSpPr>
+        <p:spPr>
+          <a:xfrm>
+            <a:off x="1872000" y="6120000"/>
+            <a:ext cx="2196000" cy="756000"/>
+          </a:xfrm>
+          <a:prstGeom prst="rect">
+            <a:avLst/>
+          </a:prstGeom>
+          <a:noFill/>
+        </p:spPr>
+        <p:txBody>
+          <a:bodyPr wrap="none" lIns="0" tIns="0" rIns="0" bIns="0" anchor="ctr">
+            <a:spAutoFit/>
+          </a:bodyPr>
+          <a:lstStyle/>
+          <a:p>
+            <a:pPr algn="l">
+              <a:lnSpc>
+                <a:spcPct val="110000"/>
+              </a:lnSpc>
+              <a:spcBef>
+                <a:spcPts val="0"/>
+              </a:spcBef>
+              <a:spcAft>
+                <a:spcPts val="0"/>
+              </a:spcAft>
+            </a:pPr>
+            <a:r>
+              <a:rPr sz="1600" b="0">
+                <a:solidFill>
+                  <a:srgbClr val="171C1D"/>
+                </a:solidFill>
+                <a:latin typeface="Times New Roman"/>
+                <a:ea typeface="DFKai-SB"/>
+                <a:cs typeface="Times New Roman"/>
+              </a:rPr>
+              <a:t>產生正式類別、</a:t>
+            </a:r>
+          </a:p>
+          <a:p>
+            <a:pPr algn="l">
+              <a:lnSpc>
+                <a:spcPct val="110000"/>
+              </a:lnSpc>
+              <a:spcBef>
+                <a:spcPts val="0"/>
+              </a:spcBef>
+              <a:spcAft>
+                <a:spcPts val="0"/>
+              </a:spcAft>
+            </a:pPr>
+            <a:r>
+              <a:rPr sz="1600" b="0">
+                <a:solidFill>
+                  <a:srgbClr val="171C1D"/>
+                </a:solidFill>
+                <a:latin typeface="Times New Roman"/>
+                <a:ea typeface="DFKai-SB"/>
+                <a:cs typeface="Times New Roman"/>
+              </a:rPr>
+              <a:t>信心與流量表徵</a:t>
+            </a:r>
+          </a:p>
+        </p:txBody>
+      </p:sp>
+      <p:sp>
+        <p:nvSpPr>
+          <p:cNvPr id="19" name="Down Arrow 18"/>
           <p:cNvSpPr/>
           <p:nvPr/>
         </p:nvSpPr>
@@ -4853,7 +4979,7 @@
       </p:sp>
       <p:sp>
         <p:nvSpPr>
-          <p:cNvPr id="18" name="Rectangle 17"/>
+          <p:cNvPr id="20" name="Rectangle 19"/>
           <p:cNvSpPr/>
           <p:nvPr/>
         </p:nvSpPr>
@@ -4904,7 +5030,7 @@
       </p:sp>
       <p:sp>
         <p:nvSpPr>
-          <p:cNvPr id="19" name="Rectangle 18"/>
+          <p:cNvPr id="21" name="Rectangle 20"/>
           <p:cNvSpPr/>
           <p:nvPr/>
         </p:nvSpPr>
@@ -4953,11 +5079,11 @@
       </p:sp>
       <p:sp>
         <p:nvSpPr>
-          <p:cNvPr id="20" name="TextBox 19"/>
+          <p:cNvPr id="22" name="TextBox 21"/>
           <p:cNvSpPr txBox="1"/>
           <p:nvPr>
             <p:custDataLst>
-              <p:tags r:id="rId10"/>
+              <p:tags r:id="rId12"/>
             </p:custDataLst>
           </p:nvPr>
         </p:nvSpPr>
@@ -5004,11 +5130,11 @@
       </p:sp>
       <p:sp>
         <p:nvSpPr>
-          <p:cNvPr id="21" name="TextBox 20"/>
+          <p:cNvPr id="23" name="TextBox 22"/>
           <p:cNvSpPr txBox="1"/>
           <p:nvPr>
             <p:custDataLst>
-              <p:tags r:id="rId11"/>
+              <p:tags r:id="rId13"/>
             </p:custDataLst>
           </p:nvPr>
         </p:nvSpPr>
@@ -5055,11 +5181,11 @@
       </p:sp>
       <p:sp>
         <p:nvSpPr>
-          <p:cNvPr id="22" name="TextBox 21"/>
+          <p:cNvPr id="24" name="TextBox 23"/>
           <p:cNvSpPr txBox="1"/>
           <p:nvPr>
             <p:custDataLst>
-              <p:tags r:id="rId12"/>
+              <p:tags r:id="rId14"/>
             </p:custDataLst>
           </p:nvPr>
         </p:nvSpPr>
@@ -5106,14 +5232,14 @@
       </p:sp>
       <p:pic>
         <p:nvPicPr>
-          <p:cNvPr id="23" name="Picture 22" descr="flat-icon-3.png"/>
+          <p:cNvPr id="25" name="Picture 24" descr="flat-icon-3.png"/>
           <p:cNvPicPr>
             <a:picLocks noChangeAspect="1"/>
           </p:cNvPicPr>
           <p:nvPr/>
         </p:nvPicPr>
         <p:blipFill>
-          <a:blip r:embed="rId78"/>
+          <a:blip r:embed="rId100"/>
           <a:stretch>
             <a:fillRect/>
           </a:stretch>
@@ -5130,7 +5256,82 @@
       </p:pic>
       <p:sp>
         <p:nvSpPr>
-          <p:cNvPr id="24" name="Down Arrow 23"/>
+          <p:cNvPr id="26" name="TextBox 25"/>
+          <p:cNvSpPr txBox="1"/>
+          <p:nvPr>
+            <p:custDataLst>
+              <p:tags r:id="rId15"/>
+            </p:custDataLst>
+          </p:nvPr>
+        </p:nvSpPr>
+        <p:spPr>
+          <a:xfrm>
+            <a:off x="1872000" y="8136000"/>
+            <a:ext cx="2196000" cy="756000"/>
+          </a:xfrm>
+          <a:prstGeom prst="rect">
+            <a:avLst/>
+          </a:prstGeom>
+          <a:noFill/>
+        </p:spPr>
+        <p:txBody>
+          <a:bodyPr wrap="none" lIns="0" tIns="0" rIns="0" bIns="0" anchor="ctr">
+            <a:spAutoFit/>
+          </a:bodyPr>
+          <a:lstStyle/>
+          <a:p>
+            <a:pPr algn="l">
+              <a:lnSpc>
+                <a:spcPct val="110000"/>
+              </a:lnSpc>
+              <a:spcBef>
+                <a:spcPts val="0"/>
+              </a:spcBef>
+              <a:spcAft>
+                <a:spcPts val="0"/>
+              </a:spcAft>
+            </a:pPr>
+            <a:r>
+              <a:rPr sz="1600" b="0">
+                <a:solidFill>
+                  <a:srgbClr val="171C1D"/>
+                </a:solidFill>
+                <a:latin typeface="Times New Roman"/>
+                <a:ea typeface="DFKai-SB"/>
+                <a:cs typeface="Times New Roman"/>
+              </a:rPr>
+              <a:t>依事件任務找案例</a:t>
+            </a:r>
+          </a:p>
+          <a:p>
+            <a:pPr algn="l">
+              <a:lnSpc>
+                <a:spcPct val="110000"/>
+              </a:lnSpc>
+              <a:spcBef>
+                <a:spcPts val="0"/>
+              </a:spcBef>
+              <a:spcAft>
+                <a:spcPts val="0"/>
+              </a:spcAft>
+            </a:pPr>
+            <a:r>
+              <a:rPr sz="1600" b="0">
+                <a:solidFill>
+                  <a:srgbClr val="171C1D"/>
+                </a:solidFill>
+                <a:latin typeface="Times New Roman"/>
+                <a:ea typeface="DFKai-SB"/>
+                <a:cs typeface="Times New Roman"/>
+              </a:rPr>
+              <a:t>附上相似類別證據</a:t>
+            </a:r>
+          </a:p>
+        </p:txBody>
+      </p:sp>
+      <p:sp>
+        <p:nvSpPr>
+          <p:cNvPr id="27" name="Down Arrow 26"/>
           <p:cNvSpPr/>
           <p:nvPr/>
         </p:nvSpPr>
@@ -5179,7 +5380,7 @@
       </p:sp>
       <p:sp>
         <p:nvSpPr>
-          <p:cNvPr id="25" name="Rectangle 24"/>
+          <p:cNvPr id="28" name="Rectangle 27"/>
           <p:cNvSpPr/>
           <p:nvPr/>
         </p:nvSpPr>
@@ -5230,7 +5431,7 @@
       </p:sp>
       <p:sp>
         <p:nvSpPr>
-          <p:cNvPr id="26" name="Rectangle 25"/>
+          <p:cNvPr id="29" name="Rectangle 28"/>
           <p:cNvSpPr/>
           <p:nvPr/>
         </p:nvSpPr>
@@ -5279,11 +5480,11 @@
       </p:sp>
       <p:sp>
         <p:nvSpPr>
-          <p:cNvPr id="27" name="TextBox 26"/>
+          <p:cNvPr id="30" name="TextBox 29"/>
           <p:cNvSpPr txBox="1"/>
           <p:nvPr>
             <p:custDataLst>
-              <p:tags r:id="rId13"/>
+              <p:tags r:id="rId16"/>
             </p:custDataLst>
           </p:nvPr>
         </p:nvSpPr>
@@ -5330,11 +5531,11 @@
       </p:sp>
       <p:sp>
         <p:nvSpPr>
-          <p:cNvPr id="28" name="TextBox 27"/>
+          <p:cNvPr id="31" name="TextBox 30"/>
           <p:cNvSpPr txBox="1"/>
           <p:nvPr>
             <p:custDataLst>
-              <p:tags r:id="rId14"/>
+              <p:tags r:id="rId17"/>
             </p:custDataLst>
           </p:nvPr>
         </p:nvSpPr>
@@ -5381,11 +5582,11 @@
       </p:sp>
       <p:sp>
         <p:nvSpPr>
-          <p:cNvPr id="29" name="TextBox 28"/>
+          <p:cNvPr id="32" name="TextBox 31"/>
           <p:cNvSpPr txBox="1"/>
           <p:nvPr>
             <p:custDataLst>
-              <p:tags r:id="rId15"/>
+              <p:tags r:id="rId18"/>
             </p:custDataLst>
           </p:nvPr>
         </p:nvSpPr>
@@ -5432,7 +5633,7 @@
       </p:sp>
       <p:sp>
         <p:nvSpPr>
-          <p:cNvPr id="30" name="Rectangle 29"/>
+          <p:cNvPr id="33" name="Rectangle 32"/>
           <p:cNvSpPr/>
           <p:nvPr/>
         </p:nvSpPr>
@@ -5483,7 +5684,7 @@
       </p:sp>
       <p:cxnSp>
         <p:nvCxnSpPr>
-          <p:cNvPr id="31" name="Connector 30"/>
+          <p:cNvPr id="34" name="Connector 33"/>
           <p:cNvCxnSpPr/>
           <p:nvPr/>
         </p:nvCxnSpPr>
@@ -5519,7 +5720,7 @@
       </p:cxnSp>
       <p:cxnSp>
         <p:nvCxnSpPr>
-          <p:cNvPr id="32" name="Connector 31"/>
+          <p:cNvPr id="35" name="Connector 34"/>
           <p:cNvCxnSpPr/>
           <p:nvPr/>
         </p:nvCxnSpPr>
@@ -5555,7 +5756,7 @@
       </p:cxnSp>
       <p:cxnSp>
         <p:nvCxnSpPr>
-          <p:cNvPr id="33" name="Connector 32"/>
+          <p:cNvPr id="36" name="Connector 35"/>
           <p:cNvCxnSpPr/>
           <p:nvPr/>
         </p:nvCxnSpPr>
@@ -5591,7 +5792,82 @@
       </p:cxnSp>
       <p:sp>
         <p:nvSpPr>
-          <p:cNvPr id="34" name="Down Arrow 33"/>
+          <p:cNvPr id="37" name="TextBox 36"/>
+          <p:cNvSpPr txBox="1"/>
+          <p:nvPr>
+            <p:custDataLst>
+              <p:tags r:id="rId19"/>
+            </p:custDataLst>
+          </p:nvPr>
+        </p:nvSpPr>
+        <p:spPr>
+          <a:xfrm>
+            <a:off x="1872000" y="10152000"/>
+            <a:ext cx="2196000" cy="756000"/>
+          </a:xfrm>
+          <a:prstGeom prst="rect">
+            <a:avLst/>
+          </a:prstGeom>
+          <a:noFill/>
+        </p:spPr>
+        <p:txBody>
+          <a:bodyPr wrap="none" lIns="0" tIns="0" rIns="0" bIns="0" anchor="ctr">
+            <a:spAutoFit/>
+          </a:bodyPr>
+          <a:lstStyle/>
+          <a:p>
+            <a:pPr algn="l">
+              <a:lnSpc>
+                <a:spcPct val="110000"/>
+              </a:lnSpc>
+              <a:spcBef>
+                <a:spcPts val="0"/>
+              </a:spcBef>
+              <a:spcAft>
+                <a:spcPts val="0"/>
+              </a:spcAft>
+            </a:pPr>
+            <a:r>
+              <a:rPr sz="1600" b="0">
+                <a:solidFill>
+                  <a:srgbClr val="171C1D"/>
+                </a:solidFill>
+                <a:latin typeface="Times New Roman"/>
+                <a:ea typeface="DFKai-SB"/>
+                <a:cs typeface="Times New Roman"/>
+              </a:rPr>
+              <a:t>核對判定與案例</a:t>
+            </a:r>
+          </a:p>
+          <a:p>
+            <a:pPr algn="l">
+              <a:lnSpc>
+                <a:spcPct val="110000"/>
+              </a:lnSpc>
+              <a:spcBef>
+                <a:spcPts val="0"/>
+              </a:spcBef>
+              <a:spcAft>
+                <a:spcPts val="0"/>
+              </a:spcAft>
+            </a:pPr>
+            <a:r>
+              <a:rPr sz="1600" b="0">
+                <a:solidFill>
+                  <a:srgbClr val="171C1D"/>
+                </a:solidFill>
+                <a:latin typeface="Times New Roman"/>
+                <a:ea typeface="DFKai-SB"/>
+                <a:cs typeface="Times New Roman"/>
+              </a:rPr>
+              <a:t>附加三態稽核結論</a:t>
+            </a:r>
+          </a:p>
+        </p:txBody>
+      </p:sp>
+      <p:sp>
+        <p:nvSpPr>
+          <p:cNvPr id="38" name="Down Arrow 37"/>
           <p:cNvSpPr/>
           <p:nvPr/>
         </p:nvSpPr>
@@ -5640,7 +5916,7 @@
       </p:sp>
       <p:sp>
         <p:nvSpPr>
-          <p:cNvPr id="35" name="Rectangle 34"/>
+          <p:cNvPr id="39" name="Rectangle 38"/>
           <p:cNvSpPr/>
           <p:nvPr/>
         </p:nvSpPr>
@@ -5691,7 +5967,7 @@
       </p:sp>
       <p:sp>
         <p:nvSpPr>
-          <p:cNvPr id="36" name="Rectangle 35"/>
+          <p:cNvPr id="40" name="Rectangle 39"/>
           <p:cNvSpPr/>
           <p:nvPr/>
         </p:nvSpPr>
@@ -5740,11 +6016,11 @@
       </p:sp>
       <p:sp>
         <p:nvSpPr>
-          <p:cNvPr id="37" name="TextBox 36"/>
+          <p:cNvPr id="41" name="TextBox 40"/>
           <p:cNvSpPr txBox="1"/>
           <p:nvPr>
             <p:custDataLst>
-              <p:tags r:id="rId16"/>
+              <p:tags r:id="rId20"/>
             </p:custDataLst>
           </p:nvPr>
         </p:nvSpPr>
@@ -5791,11 +6067,11 @@
       </p:sp>
       <p:sp>
         <p:nvSpPr>
-          <p:cNvPr id="38" name="TextBox 37"/>
+          <p:cNvPr id="42" name="TextBox 41"/>
           <p:cNvSpPr txBox="1"/>
           <p:nvPr>
             <p:custDataLst>
-              <p:tags r:id="rId17"/>
+              <p:tags r:id="rId21"/>
             </p:custDataLst>
           </p:nvPr>
         </p:nvSpPr>
@@ -5842,11 +6118,11 @@
       </p:sp>
       <p:sp>
         <p:nvSpPr>
-          <p:cNvPr id="39" name="TextBox 38"/>
+          <p:cNvPr id="43" name="TextBox 42"/>
           <p:cNvSpPr txBox="1"/>
           <p:nvPr>
             <p:custDataLst>
-              <p:tags r:id="rId18"/>
+              <p:tags r:id="rId22"/>
             </p:custDataLst>
           </p:nvPr>
         </p:nvSpPr>
@@ -5893,14 +6169,14 @@
       </p:sp>
       <p:pic>
         <p:nvPicPr>
-          <p:cNvPr id="40" name="Picture 39" descr="flat-icon-4.png"/>
+          <p:cNvPr id="44" name="Picture 43" descr="flat-icon-4.png"/>
           <p:cNvPicPr>
             <a:picLocks noChangeAspect="1"/>
           </p:cNvPicPr>
           <p:nvPr/>
         </p:nvPicPr>
         <p:blipFill>
-          <a:blip r:embed="rId79"/>
+          <a:blip r:embed="rId101"/>
           <a:stretch>
             <a:fillRect/>
           </a:stretch>
@@ -5917,7 +6193,82 @@
       </p:pic>
       <p:sp>
         <p:nvSpPr>
-          <p:cNvPr id="41" name="Rectangle 40"/>
+          <p:cNvPr id="45" name="TextBox 44"/>
+          <p:cNvSpPr txBox="1"/>
+          <p:nvPr>
+            <p:custDataLst>
+              <p:tags r:id="rId23"/>
+            </p:custDataLst>
+          </p:nvPr>
+        </p:nvSpPr>
+        <p:spPr>
+          <a:xfrm>
+            <a:off x="1872000" y="12168000"/>
+            <a:ext cx="2196000" cy="756000"/>
+          </a:xfrm>
+          <a:prstGeom prst="rect">
+            <a:avLst/>
+          </a:prstGeom>
+          <a:noFill/>
+        </p:spPr>
+        <p:txBody>
+          <a:bodyPr wrap="none" lIns="0" tIns="0" rIns="0" bIns="0" anchor="ctr">
+            <a:spAutoFit/>
+          </a:bodyPr>
+          <a:lstStyle/>
+          <a:p>
+            <a:pPr algn="l">
+              <a:lnSpc>
+                <a:spcPct val="110000"/>
+              </a:lnSpc>
+              <a:spcBef>
+                <a:spcPts val="0"/>
+              </a:spcBef>
+              <a:spcAft>
+                <a:spcPts val="0"/>
+              </a:spcAft>
+            </a:pPr>
+            <a:r>
+              <a:rPr sz="1600" b="0">
+                <a:solidFill>
+                  <a:srgbClr val="171C1D"/>
+                </a:solidFill>
+                <a:latin typeface="Times New Roman"/>
+                <a:ea typeface="DFKai-SB"/>
+                <a:cs typeface="Times New Roman"/>
+              </a:rPr>
+              <a:t>策略允許才介入</a:t>
+            </a:r>
+          </a:p>
+          <a:p>
+            <a:pPr algn="l">
+              <a:lnSpc>
+                <a:spcPct val="110000"/>
+              </a:lnSpc>
+              <a:spcBef>
+                <a:spcPts val="0"/>
+              </a:spcBef>
+              <a:spcAft>
+                <a:spcPts val="0"/>
+              </a:spcAft>
+            </a:pPr>
+            <a:r>
+              <a:rPr sz="1600" b="0">
+                <a:solidFill>
+                  <a:srgbClr val="171C1D"/>
+                </a:solidFill>
+                <a:latin typeface="Times New Roman"/>
+                <a:ea typeface="DFKai-SB"/>
+                <a:cs typeface="Times New Roman"/>
+              </a:rPr>
+              <a:t>讀回並確認回復</a:t>
+            </a:r>
+          </a:p>
+        </p:txBody>
+      </p:sp>
+      <p:sp>
+        <p:nvSpPr>
+          <p:cNvPr id="46" name="Rectangle 45"/>
           <p:cNvSpPr/>
           <p:nvPr/>
         </p:nvSpPr>
@@ -5966,11 +6317,11 @@
       </p:sp>
       <p:sp>
         <p:nvSpPr>
-          <p:cNvPr id="42" name="TextBox 41"/>
+          <p:cNvPr id="47" name="TextBox 46"/>
           <p:cNvSpPr txBox="1"/>
           <p:nvPr>
             <p:custDataLst>
-              <p:tags r:id="rId19"/>
+              <p:tags r:id="rId24"/>
             </p:custDataLst>
           </p:nvPr>
         </p:nvSpPr>
@@ -6017,11 +6368,11 @@
       </p:sp>
       <p:sp>
         <p:nvSpPr>
-          <p:cNvPr id="43" name="TextBox 42"/>
+          <p:cNvPr id="48" name="TextBox 47"/>
           <p:cNvSpPr txBox="1"/>
           <p:nvPr>
             <p:custDataLst>
-              <p:tags r:id="rId20"/>
+              <p:tags r:id="rId25"/>
             </p:custDataLst>
           </p:nvPr>
         </p:nvSpPr>
@@ -6068,7 +6419,7 @@
       </p:sp>
       <p:sp>
         <p:nvSpPr>
-          <p:cNvPr id="44" name="Rectangle 43"/>
+          <p:cNvPr id="49" name="Rectangle 48"/>
           <p:cNvSpPr/>
           <p:nvPr/>
         </p:nvSpPr>
@@ -6117,11 +6468,11 @@
       </p:sp>
       <p:sp>
         <p:nvSpPr>
-          <p:cNvPr id="45" name="TextBox 44"/>
+          <p:cNvPr id="50" name="TextBox 49"/>
           <p:cNvSpPr txBox="1"/>
           <p:nvPr>
             <p:custDataLst>
-              <p:tags r:id="rId21"/>
+              <p:tags r:id="rId26"/>
             </p:custDataLst>
           </p:nvPr>
         </p:nvSpPr>
@@ -6168,11 +6519,11 @@
       </p:sp>
       <p:sp>
         <p:nvSpPr>
-          <p:cNvPr id="46" name="TextBox 45"/>
+          <p:cNvPr id="51" name="TextBox 50"/>
           <p:cNvSpPr txBox="1"/>
           <p:nvPr>
             <p:custDataLst>
-              <p:tags r:id="rId22"/>
+              <p:tags r:id="rId27"/>
             </p:custDataLst>
           </p:nvPr>
         </p:nvSpPr>
@@ -6219,7 +6570,7 @@
       </p:sp>
       <p:cxnSp>
         <p:nvCxnSpPr>
-          <p:cNvPr id="47" name="Connector 46"/>
+          <p:cNvPr id="52" name="Connector 51"/>
           <p:cNvCxnSpPr/>
           <p:nvPr/>
         </p:nvCxnSpPr>
@@ -6255,7 +6606,7 @@
       </p:cxnSp>
       <p:cxnSp>
         <p:nvCxnSpPr>
-          <p:cNvPr id="48" name="Connector 47"/>
+          <p:cNvPr id="53" name="Connector 52"/>
           <p:cNvCxnSpPr/>
           <p:nvPr/>
         </p:nvCxnSpPr>
@@ -6291,7 +6642,7 @@
       </p:cxnSp>
       <p:cxnSp>
         <p:nvCxnSpPr>
-          <p:cNvPr id="49" name="Connector 48"/>
+          <p:cNvPr id="54" name="Connector 53"/>
           <p:cNvCxnSpPr/>
           <p:nvPr/>
         </p:nvCxnSpPr>
@@ -6327,7 +6678,7 @@
       </p:cxnSp>
       <p:sp>
         <p:nvSpPr>
-          <p:cNvPr id="50" name="Right Arrow 49"/>
+          <p:cNvPr id="55" name="Right Arrow 54"/>
           <p:cNvSpPr/>
           <p:nvPr/>
         </p:nvSpPr>
@@ -6376,7 +6727,7 @@
       </p:sp>
       <p:sp>
         <p:nvSpPr>
-          <p:cNvPr id="51" name="Rectangle 50"/>
+          <p:cNvPr id="56" name="Rectangle 55"/>
           <p:cNvSpPr/>
           <p:nvPr/>
         </p:nvSpPr>
@@ -6425,11 +6776,11 @@
       </p:sp>
       <p:sp>
         <p:nvSpPr>
-          <p:cNvPr id="52" name="TextBox 51"/>
+          <p:cNvPr id="57" name="TextBox 56"/>
           <p:cNvSpPr txBox="1"/>
           <p:nvPr>
             <p:custDataLst>
-              <p:tags r:id="rId23"/>
+              <p:tags r:id="rId28"/>
             </p:custDataLst>
           </p:nvPr>
         </p:nvSpPr>
@@ -6476,11 +6827,11 @@
       </p:sp>
       <p:sp>
         <p:nvSpPr>
-          <p:cNvPr id="53" name="TextBox 52"/>
+          <p:cNvPr id="58" name="TextBox 57"/>
           <p:cNvSpPr txBox="1"/>
           <p:nvPr>
             <p:custDataLst>
-              <p:tags r:id="rId24"/>
+              <p:tags r:id="rId29"/>
             </p:custDataLst>
           </p:nvPr>
         </p:nvSpPr>
@@ -6527,7 +6878,7 @@
       </p:sp>
       <p:sp>
         <p:nvSpPr>
-          <p:cNvPr id="54" name="Right Arrow 53"/>
+          <p:cNvPr id="59" name="Right Arrow 58"/>
           <p:cNvSpPr/>
           <p:nvPr/>
         </p:nvSpPr>
@@ -6576,7 +6927,7 @@
       </p:sp>
       <p:sp>
         <p:nvSpPr>
-          <p:cNvPr id="55" name="Rectangle 54"/>
+          <p:cNvPr id="60" name="Rectangle 59"/>
           <p:cNvSpPr/>
           <p:nvPr/>
         </p:nvSpPr>
@@ -6625,11 +6976,11 @@
       </p:sp>
       <p:sp>
         <p:nvSpPr>
-          <p:cNvPr id="56" name="TextBox 55"/>
+          <p:cNvPr id="61" name="TextBox 60"/>
           <p:cNvSpPr txBox="1"/>
           <p:nvPr>
             <p:custDataLst>
-              <p:tags r:id="rId25"/>
+              <p:tags r:id="rId30"/>
             </p:custDataLst>
           </p:nvPr>
         </p:nvSpPr>
@@ -6676,11 +7027,11 @@
       </p:sp>
       <p:sp>
         <p:nvSpPr>
-          <p:cNvPr id="57" name="TextBox 56"/>
+          <p:cNvPr id="62" name="TextBox 61"/>
           <p:cNvSpPr txBox="1"/>
           <p:nvPr>
             <p:custDataLst>
-              <p:tags r:id="rId26"/>
+              <p:tags r:id="rId31"/>
             </p:custDataLst>
           </p:nvPr>
         </p:nvSpPr>
@@ -6727,7 +7078,7 @@
       </p:sp>
       <p:sp>
         <p:nvSpPr>
-          <p:cNvPr id="58" name="Rectangle 57"/>
+          <p:cNvPr id="63" name="Rectangle 62"/>
           <p:cNvSpPr/>
           <p:nvPr/>
         </p:nvSpPr>
@@ -6776,11 +7127,11 @@
       </p:sp>
       <p:sp>
         <p:nvSpPr>
-          <p:cNvPr id="59" name="TextBox 58"/>
+          <p:cNvPr id="64" name="TextBox 63"/>
           <p:cNvSpPr txBox="1"/>
           <p:nvPr>
             <p:custDataLst>
-              <p:tags r:id="rId27"/>
+              <p:tags r:id="rId32"/>
             </p:custDataLst>
           </p:nvPr>
         </p:nvSpPr>
@@ -6827,7 +7178,7 @@
       </p:sp>
       <p:sp>
         <p:nvSpPr>
-          <p:cNvPr id="60" name="Rectangle 59"/>
+          <p:cNvPr id="65" name="Rectangle 64"/>
           <p:cNvSpPr/>
           <p:nvPr/>
         </p:nvSpPr>
@@ -6876,11 +7227,11 @@
       </p:sp>
       <p:sp>
         <p:nvSpPr>
-          <p:cNvPr id="61" name="TextBox 60"/>
+          <p:cNvPr id="66" name="TextBox 65"/>
           <p:cNvSpPr txBox="1"/>
           <p:nvPr>
             <p:custDataLst>
-              <p:tags r:id="rId28"/>
+              <p:tags r:id="rId33"/>
             </p:custDataLst>
           </p:nvPr>
         </p:nvSpPr>
@@ -6927,7 +7278,7 @@
       </p:sp>
       <p:cxnSp>
         <p:nvCxnSpPr>
-          <p:cNvPr id="62" name="Connector 61"/>
+          <p:cNvPr id="67" name="Connector 66"/>
           <p:cNvCxnSpPr/>
           <p:nvPr/>
         </p:nvCxnSpPr>
@@ -6963,7 +7314,7 @@
       </p:cxnSp>
       <p:cxnSp>
         <p:nvCxnSpPr>
-          <p:cNvPr id="63" name="Connector 62"/>
+          <p:cNvPr id="68" name="Connector 67"/>
           <p:cNvCxnSpPr/>
           <p:nvPr/>
         </p:nvCxnSpPr>
@@ -6999,7 +7350,7 @@
       </p:cxnSp>
       <p:cxnSp>
         <p:nvCxnSpPr>
-          <p:cNvPr id="64" name="Connector 63"/>
+          <p:cNvPr id="69" name="Connector 68"/>
           <p:cNvCxnSpPr/>
           <p:nvPr/>
         </p:nvCxnSpPr>
@@ -7035,7 +7386,7 @@
       </p:cxnSp>
       <p:sp>
         <p:nvSpPr>
-          <p:cNvPr id="65" name="Right Arrow 64"/>
+          <p:cNvPr id="70" name="Right Arrow 69"/>
           <p:cNvSpPr/>
           <p:nvPr/>
         </p:nvSpPr>
@@ -7084,7 +7435,7 @@
       </p:sp>
       <p:sp>
         <p:nvSpPr>
-          <p:cNvPr id="66" name="Rectangle 65"/>
+          <p:cNvPr id="71" name="Rectangle 70"/>
           <p:cNvSpPr/>
           <p:nvPr/>
         </p:nvSpPr>
@@ -7133,11 +7484,11 @@
       </p:sp>
       <p:sp>
         <p:nvSpPr>
-          <p:cNvPr id="67" name="TextBox 66"/>
+          <p:cNvPr id="72" name="TextBox 71"/>
           <p:cNvSpPr txBox="1"/>
           <p:nvPr>
             <p:custDataLst>
-              <p:tags r:id="rId29"/>
+              <p:tags r:id="rId34"/>
             </p:custDataLst>
           </p:nvPr>
         </p:nvSpPr>
@@ -7184,11 +7535,11 @@
       </p:sp>
       <p:sp>
         <p:nvSpPr>
-          <p:cNvPr id="68" name="TextBox 67"/>
+          <p:cNvPr id="73" name="TextBox 72"/>
           <p:cNvSpPr txBox="1"/>
           <p:nvPr>
             <p:custDataLst>
-              <p:tags r:id="rId30"/>
+              <p:tags r:id="rId35"/>
             </p:custDataLst>
           </p:nvPr>
         </p:nvSpPr>
@@ -7235,7 +7586,7 @@
       </p:sp>
       <p:sp>
         <p:nvSpPr>
-          <p:cNvPr id="69" name="Right Arrow 68"/>
+          <p:cNvPr id="74" name="Right Arrow 73"/>
           <p:cNvSpPr/>
           <p:nvPr/>
         </p:nvSpPr>
@@ -7284,7 +7635,7 @@
       </p:sp>
       <p:sp>
         <p:nvSpPr>
-          <p:cNvPr id="70" name="Rectangle 69"/>
+          <p:cNvPr id="75" name="Rectangle 74"/>
           <p:cNvSpPr/>
           <p:nvPr/>
         </p:nvSpPr>
@@ -7333,18 +7684,18 @@
       </p:sp>
       <p:sp>
         <p:nvSpPr>
-          <p:cNvPr id="71" name="TextBox 70"/>
+          <p:cNvPr id="76" name="TextBox 75"/>
           <p:cNvSpPr txBox="1"/>
           <p:nvPr>
             <p:custDataLst>
-              <p:tags r:id="rId31"/>
+              <p:tags r:id="rId36"/>
             </p:custDataLst>
           </p:nvPr>
         </p:nvSpPr>
         <p:spPr>
           <a:xfrm>
-            <a:off x="11560250" y="7740000"/>
-            <a:ext cx="2736000" cy="504000"/>
+            <a:off x="11560250" y="7704000"/>
+            <a:ext cx="2736000" cy="360000"/>
           </a:xfrm>
           <a:prstGeom prst="rect">
             <a:avLst/>
@@ -7377,25 +7728,76 @@
                 <a:ea typeface="DFKai-SB"/>
                 <a:cs typeface="Times New Roman"/>
               </a:rPr>
-              <a:t>Top-5證據</a:t>
-            </a:r>
-          </a:p>
-        </p:txBody>
-      </p:sp>
-      <p:sp>
-        <p:nvSpPr>
-          <p:cNvPr id="72" name="TextBox 71"/>
+              <a:t>Top-5訓練案例</a:t>
+            </a:r>
+          </a:p>
+        </p:txBody>
+      </p:sp>
+      <p:sp>
+        <p:nvSpPr>
+          <p:cNvPr id="77" name="Rectangle 76"/>
+          <p:cNvSpPr/>
+          <p:nvPr/>
+        </p:nvSpPr>
+        <p:spPr>
+          <a:xfrm>
+            <a:off x="11664000" y="8136000"/>
+            <a:ext cx="432000" cy="360000"/>
+          </a:xfrm>
+          <a:prstGeom prst="rect">
+            <a:avLst/>
+          </a:prstGeom>
+          <a:solidFill>
+            <a:srgbClr val="EAF0F4"/>
+          </a:solidFill>
+          <a:ln w="10160">
+            <a:solidFill>
+              <a:srgbClr val="D6DDE0"/>
+            </a:solidFill>
+          </a:ln>
+          <a:effectLst/>
+        </p:spPr>
+        <p:style>
+          <a:lnRef idx="1">
+            <a:schemeClr val="accent1"/>
+          </a:lnRef>
+          <a:fillRef idx="3">
+            <a:schemeClr val="accent1"/>
+          </a:fillRef>
+          <a:effectRef idx="2">
+            <a:schemeClr val="accent1"/>
+          </a:effectRef>
+          <a:fontRef idx="minor">
+            <a:schemeClr val="lt1"/>
+          </a:fontRef>
+        </p:style>
+        <p:txBody>
+          <a:bodyPr rtlCol="0" anchor="ctr"/>
+          <a:lstStyle/>
+          <a:p>
+            <a:pPr algn="ctr"/>
+            <a:endParaRPr>
+              <a:latin typeface="Times New Roman"/>
+              <a:ea typeface="DFKai-SB"/>
+              <a:cs typeface="Times New Roman"/>
+            </a:endParaRPr>
+          </a:p>
+        </p:txBody>
+      </p:sp>
+      <p:sp>
+        <p:nvSpPr>
+          <p:cNvPr id="78" name="TextBox 77"/>
           <p:cNvSpPr txBox="1"/>
           <p:nvPr>
             <p:custDataLst>
-              <p:tags r:id="rId32"/>
+              <p:tags r:id="rId37"/>
             </p:custDataLst>
           </p:nvPr>
         </p:nvSpPr>
         <p:spPr>
           <a:xfrm>
-            <a:off x="11569776" y="8190000"/>
-            <a:ext cx="2736000" cy="387000"/>
+            <a:off x="11635425" y="8136000"/>
+            <a:ext cx="432000" cy="360000"/>
           </a:xfrm>
           <a:prstGeom prst="rect">
             <a:avLst/>
@@ -7420,22 +7822,430 @@
               </a:spcAft>
             </a:pPr>
             <a:r>
-              <a:rPr sz="1400" b="0">
+              <a:rPr sz="1800" b="0">
                 <a:solidFill>
-                  <a:srgbClr val="53666E"/>
+                  <a:srgbClr val="105186"/>
                 </a:solidFill>
                 <a:latin typeface="Times New Roman"/>
                 <a:ea typeface="DFKai-SB"/>
                 <a:cs typeface="Times New Roman"/>
               </a:rPr>
-              <a:t>僅檢索訓練案例</a:t>
-            </a:r>
-          </a:p>
-        </p:txBody>
-      </p:sp>
-      <p:sp>
-        <p:nvSpPr>
-          <p:cNvPr id="73" name="Rectangle 72"/>
+              <a:t>1</a:t>
+            </a:r>
+          </a:p>
+        </p:txBody>
+      </p:sp>
+      <p:sp>
+        <p:nvSpPr>
+          <p:cNvPr id="79" name="Rectangle 78"/>
+          <p:cNvSpPr/>
+          <p:nvPr/>
+        </p:nvSpPr>
+        <p:spPr>
+          <a:xfrm>
+            <a:off x="12186000" y="8136000"/>
+            <a:ext cx="432000" cy="360000"/>
+          </a:xfrm>
+          <a:prstGeom prst="rect">
+            <a:avLst/>
+          </a:prstGeom>
+          <a:solidFill>
+            <a:srgbClr val="EAF0F4"/>
+          </a:solidFill>
+          <a:ln w="10160">
+            <a:solidFill>
+              <a:srgbClr val="D6DDE0"/>
+            </a:solidFill>
+          </a:ln>
+          <a:effectLst/>
+        </p:spPr>
+        <p:style>
+          <a:lnRef idx="1">
+            <a:schemeClr val="accent1"/>
+          </a:lnRef>
+          <a:fillRef idx="3">
+            <a:schemeClr val="accent1"/>
+          </a:fillRef>
+          <a:effectRef idx="2">
+            <a:schemeClr val="accent1"/>
+          </a:effectRef>
+          <a:fontRef idx="minor">
+            <a:schemeClr val="lt1"/>
+          </a:fontRef>
+        </p:style>
+        <p:txBody>
+          <a:bodyPr rtlCol="0" anchor="ctr"/>
+          <a:lstStyle/>
+          <a:p>
+            <a:pPr algn="ctr"/>
+            <a:endParaRPr>
+              <a:latin typeface="Times New Roman"/>
+              <a:ea typeface="DFKai-SB"/>
+              <a:cs typeface="Times New Roman"/>
+            </a:endParaRPr>
+          </a:p>
+        </p:txBody>
+      </p:sp>
+      <p:sp>
+        <p:nvSpPr>
+          <p:cNvPr id="80" name="TextBox 79"/>
+          <p:cNvSpPr txBox="1"/>
+          <p:nvPr>
+            <p:custDataLst>
+              <p:tags r:id="rId38"/>
+            </p:custDataLst>
+          </p:nvPr>
+        </p:nvSpPr>
+        <p:spPr>
+          <a:xfrm>
+            <a:off x="12157425" y="8136000"/>
+            <a:ext cx="432000" cy="360000"/>
+          </a:xfrm>
+          <a:prstGeom prst="rect">
+            <a:avLst/>
+          </a:prstGeom>
+          <a:noFill/>
+        </p:spPr>
+        <p:txBody>
+          <a:bodyPr wrap="none" lIns="0" tIns="0" rIns="0" bIns="0" anchor="ctr">
+            <a:spAutoFit/>
+          </a:bodyPr>
+          <a:lstStyle/>
+          <a:p>
+            <a:pPr algn="ctr">
+              <a:lnSpc>
+                <a:spcPct val="110000"/>
+              </a:lnSpc>
+              <a:spcBef>
+                <a:spcPts val="0"/>
+              </a:spcBef>
+              <a:spcAft>
+                <a:spcPts val="0"/>
+              </a:spcAft>
+            </a:pPr>
+            <a:r>
+              <a:rPr sz="1800" b="0">
+                <a:solidFill>
+                  <a:srgbClr val="105186"/>
+                </a:solidFill>
+                <a:latin typeface="Times New Roman"/>
+                <a:ea typeface="DFKai-SB"/>
+                <a:cs typeface="Times New Roman"/>
+              </a:rPr>
+              <a:t>2</a:t>
+            </a:r>
+          </a:p>
+        </p:txBody>
+      </p:sp>
+      <p:sp>
+        <p:nvSpPr>
+          <p:cNvPr id="81" name="Rectangle 80"/>
+          <p:cNvSpPr/>
+          <p:nvPr/>
+        </p:nvSpPr>
+        <p:spPr>
+          <a:xfrm>
+            <a:off x="12708000" y="8136000"/>
+            <a:ext cx="432000" cy="360000"/>
+          </a:xfrm>
+          <a:prstGeom prst="rect">
+            <a:avLst/>
+          </a:prstGeom>
+          <a:solidFill>
+            <a:srgbClr val="EAF0F4"/>
+          </a:solidFill>
+          <a:ln w="10160">
+            <a:solidFill>
+              <a:srgbClr val="D6DDE0"/>
+            </a:solidFill>
+          </a:ln>
+          <a:effectLst/>
+        </p:spPr>
+        <p:style>
+          <a:lnRef idx="1">
+            <a:schemeClr val="accent1"/>
+          </a:lnRef>
+          <a:fillRef idx="3">
+            <a:schemeClr val="accent1"/>
+          </a:fillRef>
+          <a:effectRef idx="2">
+            <a:schemeClr val="accent1"/>
+          </a:effectRef>
+          <a:fontRef idx="minor">
+            <a:schemeClr val="lt1"/>
+          </a:fontRef>
+        </p:style>
+        <p:txBody>
+          <a:bodyPr rtlCol="0" anchor="ctr"/>
+          <a:lstStyle/>
+          <a:p>
+            <a:pPr algn="ctr"/>
+            <a:endParaRPr>
+              <a:latin typeface="Times New Roman"/>
+              <a:ea typeface="DFKai-SB"/>
+              <a:cs typeface="Times New Roman"/>
+            </a:endParaRPr>
+          </a:p>
+        </p:txBody>
+      </p:sp>
+      <p:sp>
+        <p:nvSpPr>
+          <p:cNvPr id="82" name="TextBox 81"/>
+          <p:cNvSpPr txBox="1"/>
+          <p:nvPr>
+            <p:custDataLst>
+              <p:tags r:id="rId39"/>
+            </p:custDataLst>
+          </p:nvPr>
+        </p:nvSpPr>
+        <p:spPr>
+          <a:xfrm>
+            <a:off x="12679425" y="8136000"/>
+            <a:ext cx="432000" cy="360000"/>
+          </a:xfrm>
+          <a:prstGeom prst="rect">
+            <a:avLst/>
+          </a:prstGeom>
+          <a:noFill/>
+        </p:spPr>
+        <p:txBody>
+          <a:bodyPr wrap="none" lIns="0" tIns="0" rIns="0" bIns="0" anchor="ctr">
+            <a:spAutoFit/>
+          </a:bodyPr>
+          <a:lstStyle/>
+          <a:p>
+            <a:pPr algn="ctr">
+              <a:lnSpc>
+                <a:spcPct val="110000"/>
+              </a:lnSpc>
+              <a:spcBef>
+                <a:spcPts val="0"/>
+              </a:spcBef>
+              <a:spcAft>
+                <a:spcPts val="0"/>
+              </a:spcAft>
+            </a:pPr>
+            <a:r>
+              <a:rPr sz="1800" b="0">
+                <a:solidFill>
+                  <a:srgbClr val="105186"/>
+                </a:solidFill>
+                <a:latin typeface="Times New Roman"/>
+                <a:ea typeface="DFKai-SB"/>
+                <a:cs typeface="Times New Roman"/>
+              </a:rPr>
+              <a:t>3</a:t>
+            </a:r>
+          </a:p>
+        </p:txBody>
+      </p:sp>
+      <p:sp>
+        <p:nvSpPr>
+          <p:cNvPr id="83" name="Rectangle 82"/>
+          <p:cNvSpPr/>
+          <p:nvPr/>
+        </p:nvSpPr>
+        <p:spPr>
+          <a:xfrm>
+            <a:off x="13230000" y="8136000"/>
+            <a:ext cx="432000" cy="360000"/>
+          </a:xfrm>
+          <a:prstGeom prst="rect">
+            <a:avLst/>
+          </a:prstGeom>
+          <a:solidFill>
+            <a:srgbClr val="EAF0F4"/>
+          </a:solidFill>
+          <a:ln w="10160">
+            <a:solidFill>
+              <a:srgbClr val="D6DDE0"/>
+            </a:solidFill>
+          </a:ln>
+          <a:effectLst/>
+        </p:spPr>
+        <p:style>
+          <a:lnRef idx="1">
+            <a:schemeClr val="accent1"/>
+          </a:lnRef>
+          <a:fillRef idx="3">
+            <a:schemeClr val="accent1"/>
+          </a:fillRef>
+          <a:effectRef idx="2">
+            <a:schemeClr val="accent1"/>
+          </a:effectRef>
+          <a:fontRef idx="minor">
+            <a:schemeClr val="lt1"/>
+          </a:fontRef>
+        </p:style>
+        <p:txBody>
+          <a:bodyPr rtlCol="0" anchor="ctr"/>
+          <a:lstStyle/>
+          <a:p>
+            <a:pPr algn="ctr"/>
+            <a:endParaRPr>
+              <a:latin typeface="Times New Roman"/>
+              <a:ea typeface="DFKai-SB"/>
+              <a:cs typeface="Times New Roman"/>
+            </a:endParaRPr>
+          </a:p>
+        </p:txBody>
+      </p:sp>
+      <p:sp>
+        <p:nvSpPr>
+          <p:cNvPr id="84" name="TextBox 83"/>
+          <p:cNvSpPr txBox="1"/>
+          <p:nvPr>
+            <p:custDataLst>
+              <p:tags r:id="rId40"/>
+            </p:custDataLst>
+          </p:nvPr>
+        </p:nvSpPr>
+        <p:spPr>
+          <a:xfrm>
+            <a:off x="13201427" y="8136000"/>
+            <a:ext cx="432000" cy="360000"/>
+          </a:xfrm>
+          <a:prstGeom prst="rect">
+            <a:avLst/>
+          </a:prstGeom>
+          <a:noFill/>
+        </p:spPr>
+        <p:txBody>
+          <a:bodyPr wrap="none" lIns="0" tIns="0" rIns="0" bIns="0" anchor="ctr">
+            <a:spAutoFit/>
+          </a:bodyPr>
+          <a:lstStyle/>
+          <a:p>
+            <a:pPr algn="ctr">
+              <a:lnSpc>
+                <a:spcPct val="110000"/>
+              </a:lnSpc>
+              <a:spcBef>
+                <a:spcPts val="0"/>
+              </a:spcBef>
+              <a:spcAft>
+                <a:spcPts val="0"/>
+              </a:spcAft>
+            </a:pPr>
+            <a:r>
+              <a:rPr sz="1800" b="0">
+                <a:solidFill>
+                  <a:srgbClr val="105186"/>
+                </a:solidFill>
+                <a:latin typeface="Times New Roman"/>
+                <a:ea typeface="DFKai-SB"/>
+                <a:cs typeface="Times New Roman"/>
+              </a:rPr>
+              <a:t>4</a:t>
+            </a:r>
+          </a:p>
+        </p:txBody>
+      </p:sp>
+      <p:sp>
+        <p:nvSpPr>
+          <p:cNvPr id="85" name="Rectangle 84"/>
+          <p:cNvSpPr/>
+          <p:nvPr/>
+        </p:nvSpPr>
+        <p:spPr>
+          <a:xfrm>
+            <a:off x="13752000" y="8136000"/>
+            <a:ext cx="432000" cy="360000"/>
+          </a:xfrm>
+          <a:prstGeom prst="rect">
+            <a:avLst/>
+          </a:prstGeom>
+          <a:solidFill>
+            <a:srgbClr val="EAF0F4"/>
+          </a:solidFill>
+          <a:ln w="10160">
+            <a:solidFill>
+              <a:srgbClr val="D6DDE0"/>
+            </a:solidFill>
+          </a:ln>
+          <a:effectLst/>
+        </p:spPr>
+        <p:style>
+          <a:lnRef idx="1">
+            <a:schemeClr val="accent1"/>
+          </a:lnRef>
+          <a:fillRef idx="3">
+            <a:schemeClr val="accent1"/>
+          </a:fillRef>
+          <a:effectRef idx="2">
+            <a:schemeClr val="accent1"/>
+          </a:effectRef>
+          <a:fontRef idx="minor">
+            <a:schemeClr val="lt1"/>
+          </a:fontRef>
+        </p:style>
+        <p:txBody>
+          <a:bodyPr rtlCol="0" anchor="ctr"/>
+          <a:lstStyle/>
+          <a:p>
+            <a:pPr algn="ctr"/>
+            <a:endParaRPr>
+              <a:latin typeface="Times New Roman"/>
+              <a:ea typeface="DFKai-SB"/>
+              <a:cs typeface="Times New Roman"/>
+            </a:endParaRPr>
+          </a:p>
+        </p:txBody>
+      </p:sp>
+      <p:sp>
+        <p:nvSpPr>
+          <p:cNvPr id="86" name="TextBox 85"/>
+          <p:cNvSpPr txBox="1"/>
+          <p:nvPr>
+            <p:custDataLst>
+              <p:tags r:id="rId41"/>
+            </p:custDataLst>
+          </p:nvPr>
+        </p:nvSpPr>
+        <p:spPr>
+          <a:xfrm>
+            <a:off x="13723423" y="8136000"/>
+            <a:ext cx="432000" cy="360000"/>
+          </a:xfrm>
+          <a:prstGeom prst="rect">
+            <a:avLst/>
+          </a:prstGeom>
+          <a:noFill/>
+        </p:spPr>
+        <p:txBody>
+          <a:bodyPr wrap="none" lIns="0" tIns="0" rIns="0" bIns="0" anchor="ctr">
+            <a:spAutoFit/>
+          </a:bodyPr>
+          <a:lstStyle/>
+          <a:p>
+            <a:pPr algn="ctr">
+              <a:lnSpc>
+                <a:spcPct val="110000"/>
+              </a:lnSpc>
+              <a:spcBef>
+                <a:spcPts val="0"/>
+              </a:spcBef>
+              <a:spcAft>
+                <a:spcPts val="0"/>
+              </a:spcAft>
+            </a:pPr>
+            <a:r>
+              <a:rPr sz="1800" b="0">
+                <a:solidFill>
+                  <a:srgbClr val="105186"/>
+                </a:solidFill>
+                <a:latin typeface="Times New Roman"/>
+                <a:ea typeface="DFKai-SB"/>
+                <a:cs typeface="Times New Roman"/>
+              </a:rPr>
+              <a:t>5</a:t>
+            </a:r>
+          </a:p>
+        </p:txBody>
+      </p:sp>
+      <p:sp>
+        <p:nvSpPr>
+          <p:cNvPr id="87" name="Rectangle 86"/>
           <p:cNvSpPr/>
           <p:nvPr/>
         </p:nvSpPr>
@@ -7484,11 +8294,11 @@
       </p:sp>
       <p:sp>
         <p:nvSpPr>
-          <p:cNvPr id="74" name="TextBox 73"/>
+          <p:cNvPr id="88" name="TextBox 87"/>
           <p:cNvSpPr txBox="1"/>
           <p:nvPr>
             <p:custDataLst>
-              <p:tags r:id="rId33"/>
+              <p:tags r:id="rId42"/>
             </p:custDataLst>
           </p:nvPr>
         </p:nvSpPr>
@@ -7535,7 +8345,7 @@
       </p:sp>
       <p:sp>
         <p:nvSpPr>
-          <p:cNvPr id="75" name="Rectangle 74"/>
+          <p:cNvPr id="89" name="Rectangle 88"/>
           <p:cNvSpPr/>
           <p:nvPr/>
         </p:nvSpPr>
@@ -7584,11 +8394,11 @@
       </p:sp>
       <p:sp>
         <p:nvSpPr>
-          <p:cNvPr id="76" name="TextBox 75"/>
+          <p:cNvPr id="90" name="TextBox 89"/>
           <p:cNvSpPr txBox="1"/>
           <p:nvPr>
             <p:custDataLst>
-              <p:tags r:id="rId34"/>
+              <p:tags r:id="rId43"/>
             </p:custDataLst>
           </p:nvPr>
         </p:nvSpPr>
@@ -7635,7 +8445,7 @@
       </p:sp>
       <p:cxnSp>
         <p:nvCxnSpPr>
-          <p:cNvPr id="77" name="Connector 76"/>
+          <p:cNvPr id="91" name="Connector 90"/>
           <p:cNvCxnSpPr/>
           <p:nvPr/>
         </p:nvCxnSpPr>
@@ -7671,7 +8481,7 @@
       </p:cxnSp>
       <p:cxnSp>
         <p:nvCxnSpPr>
-          <p:cNvPr id="78" name="Connector 77"/>
+          <p:cNvPr id="92" name="Connector 91"/>
           <p:cNvCxnSpPr/>
           <p:nvPr/>
         </p:nvCxnSpPr>
@@ -7707,7 +8517,7 @@
       </p:cxnSp>
       <p:cxnSp>
         <p:nvCxnSpPr>
-          <p:cNvPr id="79" name="Connector 78"/>
+          <p:cNvPr id="93" name="Connector 92"/>
           <p:cNvCxnSpPr/>
           <p:nvPr/>
         </p:nvCxnSpPr>
@@ -7743,7 +8553,7 @@
       </p:cxnSp>
       <p:sp>
         <p:nvSpPr>
-          <p:cNvPr id="80" name="Right Arrow 79"/>
+          <p:cNvPr id="94" name="Right Arrow 93"/>
           <p:cNvSpPr/>
           <p:nvPr/>
         </p:nvSpPr>
@@ -7792,7 +8602,7 @@
       </p:sp>
       <p:sp>
         <p:nvSpPr>
-          <p:cNvPr id="81" name="Rectangle 80"/>
+          <p:cNvPr id="95" name="Rectangle 94"/>
           <p:cNvSpPr/>
           <p:nvPr/>
         </p:nvSpPr>
@@ -7841,11 +8651,11 @@
       </p:sp>
       <p:sp>
         <p:nvSpPr>
-          <p:cNvPr id="82" name="TextBox 81"/>
+          <p:cNvPr id="96" name="TextBox 95"/>
           <p:cNvSpPr txBox="1"/>
           <p:nvPr>
             <p:custDataLst>
-              <p:tags r:id="rId35"/>
+              <p:tags r:id="rId44"/>
             </p:custDataLst>
           </p:nvPr>
         </p:nvSpPr>
@@ -7892,11 +8702,11 @@
       </p:sp>
       <p:sp>
         <p:nvSpPr>
-          <p:cNvPr id="83" name="TextBox 82"/>
+          <p:cNvPr id="97" name="TextBox 96"/>
           <p:cNvSpPr txBox="1"/>
           <p:nvPr>
             <p:custDataLst>
-              <p:tags r:id="rId36"/>
+              <p:tags r:id="rId45"/>
             </p:custDataLst>
           </p:nvPr>
         </p:nvSpPr>
@@ -7943,7 +8753,7 @@
       </p:sp>
       <p:sp>
         <p:nvSpPr>
-          <p:cNvPr id="84" name="Right Arrow 83"/>
+          <p:cNvPr id="98" name="Right Arrow 97"/>
           <p:cNvSpPr/>
           <p:nvPr/>
         </p:nvSpPr>
@@ -7992,7 +8802,7 @@
       </p:sp>
       <p:sp>
         <p:nvSpPr>
-          <p:cNvPr id="85" name="Rectangle 84"/>
+          <p:cNvPr id="99" name="Rectangle 98"/>
           <p:cNvSpPr/>
           <p:nvPr/>
         </p:nvSpPr>
@@ -8041,11 +8851,11 @@
       </p:sp>
       <p:sp>
         <p:nvSpPr>
-          <p:cNvPr id="86" name="TextBox 85"/>
+          <p:cNvPr id="100" name="TextBox 99"/>
           <p:cNvSpPr txBox="1"/>
           <p:nvPr>
             <p:custDataLst>
-              <p:tags r:id="rId37"/>
+              <p:tags r:id="rId46"/>
             </p:custDataLst>
           </p:nvPr>
         </p:nvSpPr>
@@ -8092,7 +8902,7 @@
       </p:sp>
       <p:sp>
         <p:nvSpPr>
-          <p:cNvPr id="87" name="Rectangle 86"/>
+          <p:cNvPr id="101" name="Rectangle 100"/>
           <p:cNvSpPr/>
           <p:nvPr/>
         </p:nvSpPr>
@@ -8141,11 +8951,11 @@
       </p:sp>
       <p:sp>
         <p:nvSpPr>
-          <p:cNvPr id="88" name="TextBox 87"/>
+          <p:cNvPr id="102" name="TextBox 101"/>
           <p:cNvSpPr txBox="1"/>
           <p:nvPr>
             <p:custDataLst>
-              <p:tags r:id="rId38"/>
+              <p:tags r:id="rId47"/>
             </p:custDataLst>
           </p:nvPr>
         </p:nvSpPr>
@@ -8192,7 +9002,7 @@
       </p:sp>
       <p:sp>
         <p:nvSpPr>
-          <p:cNvPr id="89" name="Rectangle 88"/>
+          <p:cNvPr id="103" name="Rectangle 102"/>
           <p:cNvSpPr/>
           <p:nvPr/>
         </p:nvSpPr>
@@ -8241,11 +9051,11 @@
       </p:sp>
       <p:sp>
         <p:nvSpPr>
-          <p:cNvPr id="90" name="TextBox 89"/>
+          <p:cNvPr id="104" name="TextBox 103"/>
           <p:cNvSpPr txBox="1"/>
           <p:nvPr>
             <p:custDataLst>
-              <p:tags r:id="rId39"/>
+              <p:tags r:id="rId48"/>
             </p:custDataLst>
           </p:nvPr>
         </p:nvSpPr>
@@ -8292,11 +9102,11 @@
       </p:sp>
       <p:sp>
         <p:nvSpPr>
-          <p:cNvPr id="91" name="TextBox 90"/>
+          <p:cNvPr id="105" name="TextBox 104"/>
           <p:cNvSpPr txBox="1"/>
           <p:nvPr>
             <p:custDataLst>
-              <p:tags r:id="rId40"/>
+              <p:tags r:id="rId49"/>
             </p:custDataLst>
           </p:nvPr>
         </p:nvSpPr>
@@ -8343,7 +9153,7 @@
       </p:sp>
       <p:sp>
         <p:nvSpPr>
-          <p:cNvPr id="92" name="Rectangle 91"/>
+          <p:cNvPr id="106" name="Rectangle 105"/>
           <p:cNvSpPr/>
           <p:nvPr/>
         </p:nvSpPr>
@@ -8392,11 +9202,11 @@
       </p:sp>
       <p:sp>
         <p:nvSpPr>
-          <p:cNvPr id="93" name="TextBox 92"/>
+          <p:cNvPr id="107" name="TextBox 106"/>
           <p:cNvSpPr txBox="1"/>
           <p:nvPr>
             <p:custDataLst>
-              <p:tags r:id="rId41"/>
+              <p:tags r:id="rId50"/>
             </p:custDataLst>
           </p:nvPr>
         </p:nvSpPr>
@@ -8443,7 +9253,7 @@
       </p:sp>
       <p:sp>
         <p:nvSpPr>
-          <p:cNvPr id="94" name="Right Arrow 93"/>
+          <p:cNvPr id="108" name="Right Arrow 107"/>
           <p:cNvSpPr/>
           <p:nvPr/>
         </p:nvSpPr>
@@ -8492,7 +9302,7 @@
       </p:sp>
       <p:sp>
         <p:nvSpPr>
-          <p:cNvPr id="95" name="Rectangle 94"/>
+          <p:cNvPr id="109" name="Rectangle 108"/>
           <p:cNvSpPr/>
           <p:nvPr/>
         </p:nvSpPr>
@@ -8541,11 +9351,11 @@
       </p:sp>
       <p:sp>
         <p:nvSpPr>
-          <p:cNvPr id="96" name="TextBox 95"/>
+          <p:cNvPr id="110" name="TextBox 109"/>
           <p:cNvSpPr txBox="1"/>
           <p:nvPr>
             <p:custDataLst>
-              <p:tags r:id="rId42"/>
+              <p:tags r:id="rId51"/>
             </p:custDataLst>
           </p:nvPr>
         </p:nvSpPr>
@@ -8592,7 +9402,7 @@
       </p:sp>
       <p:sp>
         <p:nvSpPr>
-          <p:cNvPr id="97" name="Right Arrow 96"/>
+          <p:cNvPr id="111" name="Right Arrow 110"/>
           <p:cNvSpPr/>
           <p:nvPr/>
         </p:nvSpPr>
@@ -8641,7 +9451,7 @@
       </p:sp>
       <p:sp>
         <p:nvSpPr>
-          <p:cNvPr id="98" name="Rectangle 97"/>
+          <p:cNvPr id="112" name="Rectangle 111"/>
           <p:cNvSpPr/>
           <p:nvPr/>
         </p:nvSpPr>
@@ -8690,11 +9500,11 @@
       </p:sp>
       <p:sp>
         <p:nvSpPr>
-          <p:cNvPr id="99" name="TextBox 98"/>
+          <p:cNvPr id="113" name="TextBox 112"/>
           <p:cNvSpPr txBox="1"/>
           <p:nvPr>
             <p:custDataLst>
-              <p:tags r:id="rId43"/>
+              <p:tags r:id="rId52"/>
             </p:custDataLst>
           </p:nvPr>
         </p:nvSpPr>
@@ -8741,11 +9551,11 @@
       </p:sp>
       <p:sp>
         <p:nvSpPr>
-          <p:cNvPr id="100" name="TextBox 99"/>
+          <p:cNvPr id="114" name="TextBox 113"/>
           <p:cNvSpPr txBox="1"/>
           <p:nvPr>
             <p:custDataLst>
-              <p:tags r:id="rId44"/>
+              <p:tags r:id="rId53"/>
             </p:custDataLst>
           </p:nvPr>
         </p:nvSpPr>
@@ -8792,7 +9602,7 @@
       </p:sp>
       <p:sp>
         <p:nvSpPr>
-          <p:cNvPr id="101" name="Rectangle 100"/>
+          <p:cNvPr id="115" name="Rectangle 114"/>
           <p:cNvSpPr/>
           <p:nvPr/>
         </p:nvSpPr>
@@ -8841,11 +9651,11 @@
       </p:sp>
       <p:sp>
         <p:nvSpPr>
-          <p:cNvPr id="102" name="TextBox 101"/>
+          <p:cNvPr id="116" name="TextBox 115"/>
           <p:cNvSpPr txBox="1"/>
           <p:nvPr>
             <p:custDataLst>
-              <p:tags r:id="rId45"/>
+              <p:tags r:id="rId54"/>
             </p:custDataLst>
           </p:nvPr>
         </p:nvSpPr>
@@ -8892,11 +9702,11 @@
       </p:sp>
       <p:sp>
         <p:nvSpPr>
-          <p:cNvPr id="103" name="TextBox 102"/>
+          <p:cNvPr id="117" name="TextBox 116"/>
           <p:cNvSpPr txBox="1"/>
           <p:nvPr>
             <p:custDataLst>
-              <p:tags r:id="rId46"/>
+              <p:tags r:id="rId55"/>
             </p:custDataLst>
           </p:nvPr>
         </p:nvSpPr>
@@ -8943,11 +9753,11 @@
       </p:sp>
       <p:sp>
         <p:nvSpPr>
-          <p:cNvPr id="104" name="TextBox 103"/>
+          <p:cNvPr id="118" name="TextBox 117"/>
           <p:cNvSpPr txBox="1"/>
           <p:nvPr>
             <p:custDataLst>
-              <p:tags r:id="rId47"/>
+              <p:tags r:id="rId56"/>
             </p:custDataLst>
           </p:nvPr>
         </p:nvSpPr>
@@ -8987,14 +9797,14 @@
                 <a:ea typeface="DFKai-SB"/>
                 <a:cs typeface="Times New Roman"/>
               </a:rPr>
-              <a:t>三項創新，直接對應可展示成果</a:t>
-            </a:r>
-          </a:p>
-        </p:txBody>
-      </p:sp>
-      <p:sp>
-        <p:nvSpPr>
-          <p:cNvPr id="105" name="Rectangle 104"/>
+              <a:t>三項創新，對應具體事件與產物</a:t>
+            </a:r>
+          </a:p>
+        </p:txBody>
+      </p:sp>
+      <p:sp>
+        <p:nvSpPr>
+          <p:cNvPr id="119" name="Rectangle 118"/>
           <p:cNvSpPr/>
           <p:nvPr/>
         </p:nvSpPr>
@@ -9043,11 +9853,11 @@
       </p:sp>
       <p:sp>
         <p:nvSpPr>
-          <p:cNvPr id="106" name="TextBox 105"/>
+          <p:cNvPr id="120" name="TextBox 119"/>
           <p:cNvSpPr txBox="1"/>
           <p:nvPr>
             <p:custDataLst>
-              <p:tags r:id="rId48"/>
+              <p:tags r:id="rId57"/>
             </p:custDataLst>
           </p:nvPr>
         </p:nvSpPr>
@@ -9094,18 +9904,18 @@
       </p:sp>
       <p:sp>
         <p:nvSpPr>
-          <p:cNvPr id="107" name="TextBox 106"/>
+          <p:cNvPr id="121" name="TextBox 120"/>
           <p:cNvSpPr txBox="1"/>
           <p:nvPr>
             <p:custDataLst>
-              <p:tags r:id="rId49"/>
+              <p:tags r:id="rId58"/>
             </p:custDataLst>
           </p:nvPr>
         </p:nvSpPr>
         <p:spPr>
           <a:xfrm>
-            <a:off x="576000" y="15336000"/>
-            <a:ext cx="4464000" cy="792000"/>
+            <a:off x="576000" y="15300000"/>
+            <a:ext cx="4464000" cy="900000"/>
           </a:xfrm>
           <a:prstGeom prst="rect">
             <a:avLst/>
@@ -9132,13 +9942,13 @@
             <a:r>
               <a:rPr sz="1600" b="0">
                 <a:solidFill>
-                  <a:srgbClr val="53666E"/>
+                  <a:srgbClr val="171C1D"/>
                 </a:solidFill>
                 <a:latin typeface="Times New Roman"/>
                 <a:ea typeface="DFKai-SB"/>
                 <a:cs typeface="Times New Roman"/>
               </a:rPr>
-              <a:t>時序與局部內容共同判斷</a:t>
+              <a:t>CTBM讀取內容、時序與方向</a:t>
             </a:r>
           </a:p>
           <a:p>
@@ -9156,20 +9966,44 @@
             <a:r>
               <a:rPr sz="1600" b="0">
                 <a:solidFill>
-                  <a:srgbClr val="53666E"/>
+                  <a:srgbClr val="171C1D"/>
                 </a:solidFill>
                 <a:latin typeface="Times New Roman"/>
                 <a:ea typeface="DFKai-SB"/>
                 <a:cs typeface="Times New Roman"/>
               </a:rPr>
-              <a:t>校準後形成固定17類分類</a:t>
-            </a:r>
-          </a:p>
-        </p:txBody>
-      </p:sp>
-      <p:sp>
-        <p:nvSpPr>
-          <p:cNvPr id="108" name="Rectangle 107"/>
+              <a:t>PBCNN補充局部位元組模式</a:t>
+            </a:r>
+          </a:p>
+          <a:p>
+            <a:pPr algn="l">
+              <a:lnSpc>
+                <a:spcPct val="110000"/>
+              </a:lnSpc>
+              <a:spcBef>
+                <a:spcPts val="0"/>
+              </a:spcBef>
+              <a:spcAft>
+                <a:spcPts val="0"/>
+              </a:spcAft>
+            </a:pPr>
+            <a:r>
+              <a:rPr sz="1600" b="0">
+                <a:solidFill>
+                  <a:srgbClr val="171C1D"/>
+                </a:solidFill>
+                <a:latin typeface="Times New Roman"/>
+                <a:ea typeface="DFKai-SB"/>
+                <a:cs typeface="Times New Roman"/>
+              </a:rPr>
+              <a:t>校準融合後輸出固定17類</a:t>
+            </a:r>
+          </a:p>
+        </p:txBody>
+      </p:sp>
+      <p:sp>
+        <p:nvSpPr>
+          <p:cNvPr id="122" name="Rectangle 121"/>
           <p:cNvSpPr/>
           <p:nvPr/>
         </p:nvSpPr>
@@ -9218,7 +10052,7 @@
       </p:sp>
       <p:cxnSp>
         <p:nvCxnSpPr>
-          <p:cNvPr id="109" name="Connector 108"/>
+          <p:cNvPr id="123" name="Connector 122"/>
           <p:cNvCxnSpPr/>
           <p:nvPr/>
         </p:nvCxnSpPr>
@@ -9254,11 +10088,11 @@
       </p:cxnSp>
       <p:sp>
         <p:nvSpPr>
-          <p:cNvPr id="110" name="TextBox 109"/>
+          <p:cNvPr id="124" name="TextBox 123"/>
           <p:cNvSpPr txBox="1"/>
           <p:nvPr>
             <p:custDataLst>
-              <p:tags r:id="rId50"/>
+              <p:tags r:id="rId59"/>
             </p:custDataLst>
           </p:nvPr>
         </p:nvSpPr>
@@ -9305,18 +10139,18 @@
       </p:sp>
       <p:sp>
         <p:nvSpPr>
-          <p:cNvPr id="111" name="TextBox 110"/>
+          <p:cNvPr id="125" name="TextBox 124"/>
           <p:cNvSpPr txBox="1"/>
           <p:nvPr>
             <p:custDataLst>
-              <p:tags r:id="rId51"/>
+              <p:tags r:id="rId60"/>
             </p:custDataLst>
           </p:nvPr>
         </p:nvSpPr>
         <p:spPr>
           <a:xfrm>
-            <a:off x="5364000" y="15336000"/>
-            <a:ext cx="4464000" cy="792000"/>
+            <a:off x="5364000" y="15300000"/>
+            <a:ext cx="4464000" cy="900000"/>
           </a:xfrm>
           <a:prstGeom prst="rect">
             <a:avLst/>
@@ -9343,13 +10177,13 @@
             <a:r>
               <a:rPr sz="1600" b="0">
                 <a:solidFill>
-                  <a:srgbClr val="53666E"/>
+                  <a:srgbClr val="171C1D"/>
                 </a:solidFill>
                 <a:latin typeface="Times New Roman"/>
                 <a:ea typeface="DFKai-SB"/>
                 <a:cs typeface="Times New Roman"/>
               </a:rPr>
-              <a:t>表徵與類別機率共同檢索</a:t>
+              <a:t>512維表徵＋17維類別機率</a:t>
             </a:r>
           </a:p>
           <a:p>
@@ -9367,20 +10201,44 @@
             <a:r>
               <a:rPr sz="1600" b="0">
                 <a:solidFill>
-                  <a:srgbClr val="53666E"/>
+                  <a:srgbClr val="171C1D"/>
                 </a:solidFill>
                 <a:latin typeface="Times New Roman"/>
                 <a:ea typeface="DFKai-SB"/>
                 <a:cs typeface="Times New Roman"/>
               </a:rPr>
-              <a:t>為每個事件附上相關案例</a:t>
-            </a:r>
-          </a:p>
-        </p:txBody>
-      </p:sp>
-      <p:sp>
-        <p:nvSpPr>
-          <p:cNvPr id="112" name="Rectangle 111"/>
+              <a:t>529維向量檢索Top-5案例</a:t>
+            </a:r>
+          </a:p>
+          <a:p>
+            <a:pPr algn="l">
+              <a:lnSpc>
+                <a:spcPct val="110000"/>
+              </a:lnSpc>
+              <a:spcBef>
+                <a:spcPts val="0"/>
+              </a:spcBef>
+              <a:spcAft>
+                <a:spcPts val="0"/>
+              </a:spcAft>
+            </a:pPr>
+            <a:r>
+              <a:rPr sz="1600" b="0">
+                <a:solidFill>
+                  <a:srgbClr val="171C1D"/>
+                </a:solidFill>
+                <a:latin typeface="Times New Roman"/>
+                <a:ea typeface="DFKai-SB"/>
+                <a:cs typeface="Times New Roman"/>
+              </a:rPr>
+              <a:t>AI附回支持／複核／不確定</a:t>
+            </a:r>
+          </a:p>
+        </p:txBody>
+      </p:sp>
+      <p:sp>
+        <p:nvSpPr>
+          <p:cNvPr id="126" name="Rectangle 125"/>
           <p:cNvSpPr/>
           <p:nvPr/>
         </p:nvSpPr>
@@ -9429,7 +10287,7 @@
       </p:sp>
       <p:cxnSp>
         <p:nvCxnSpPr>
-          <p:cNvPr id="113" name="Connector 112"/>
+          <p:cNvPr id="127" name="Connector 126"/>
           <p:cNvCxnSpPr/>
           <p:nvPr/>
         </p:nvCxnSpPr>
@@ -9465,11 +10323,11 @@
       </p:cxnSp>
       <p:sp>
         <p:nvSpPr>
-          <p:cNvPr id="114" name="TextBox 113"/>
+          <p:cNvPr id="128" name="TextBox 127"/>
           <p:cNvSpPr txBox="1"/>
           <p:nvPr>
             <p:custDataLst>
-              <p:tags r:id="rId52"/>
+              <p:tags r:id="rId61"/>
             </p:custDataLst>
           </p:nvPr>
         </p:nvSpPr>
@@ -9516,18 +10374,18 @@
       </p:sp>
       <p:sp>
         <p:nvSpPr>
-          <p:cNvPr id="115" name="TextBox 114"/>
+          <p:cNvPr id="129" name="TextBox 128"/>
           <p:cNvSpPr txBox="1"/>
           <p:nvPr>
             <p:custDataLst>
-              <p:tags r:id="rId53"/>
+              <p:tags r:id="rId62"/>
             </p:custDataLst>
           </p:nvPr>
         </p:nvSpPr>
         <p:spPr>
           <a:xfrm>
-            <a:off x="10152000" y="15336000"/>
-            <a:ext cx="4464000" cy="792000"/>
+            <a:off x="10152000" y="15300000"/>
+            <a:ext cx="4464000" cy="900000"/>
           </a:xfrm>
           <a:prstGeom prst="rect">
             <a:avLst/>
@@ -9554,13 +10412,13 @@
             <a:r>
               <a:rPr sz="1600" b="0">
                 <a:solidFill>
-                  <a:srgbClr val="53666E"/>
+                  <a:srgbClr val="171C1D"/>
                 </a:solidFill>
                 <a:latin typeface="Times New Roman"/>
                 <a:ea typeface="DFKai-SB"/>
                 <a:cs typeface="Times New Roman"/>
               </a:rPr>
-              <a:t>稽核附回原事件、策略另檢查</a:t>
+              <a:t>FTP／SSH：登入防護</a:t>
             </a:r>
           </a:p>
           <a:p>
@@ -9578,42 +10436,15 @@
             <a:r>
               <a:rPr sz="1600" b="0">
                 <a:solidFill>
-                  <a:srgbClr val="53666E"/>
+                  <a:srgbClr val="171C1D"/>
                 </a:solidFill>
                 <a:latin typeface="Times New Roman"/>
                 <a:ea typeface="DFKai-SB"/>
                 <a:cs typeface="Times New Roman"/>
               </a:rPr>
-              <a:t>讀回與到期回復留下紀錄</a:t>
-            </a:r>
-          </a:p>
-        </p:txBody>
-      </p:sp>
-      <p:sp>
-        <p:nvSpPr>
-          <p:cNvPr id="116" name="TextBox 115"/>
-          <p:cNvSpPr txBox="1"/>
-          <p:nvPr>
-            <p:custDataLst>
-              <p:tags r:id="rId54"/>
-            </p:custDataLst>
-          </p:nvPr>
-        </p:nvSpPr>
-        <p:spPr>
-          <a:xfrm>
-            <a:off x="576000" y="16380000"/>
-            <a:ext cx="432000" cy="360000"/>
-          </a:xfrm>
-          <a:prstGeom prst="rect">
-            <a:avLst/>
-          </a:prstGeom>
-          <a:noFill/>
-        </p:spPr>
-        <p:txBody>
-          <a:bodyPr wrap="none" lIns="0" tIns="0" rIns="0" bIns="0" anchor="ctr">
-            <a:spAutoFit/>
-          </a:bodyPr>
-          <a:lstStyle/>
+              <a:t>HTTP型DDoS：上游清洗</a:t>
+            </a:r>
+          </a:p>
           <a:p>
             <a:pPr algn="l">
               <a:lnSpc>
@@ -9627,33 +10458,33 @@
               </a:spcAft>
             </a:pPr>
             <a:r>
-              <a:rPr sz="2000" b="1">
+              <a:rPr sz="1600" b="0">
                 <a:solidFill>
-                  <a:srgbClr val="105186"/>
+                  <a:srgbClr val="171C1D"/>
                 </a:solidFill>
                 <a:latin typeface="Times New Roman"/>
                 <a:ea typeface="DFKai-SB"/>
                 <a:cs typeface="Times New Roman"/>
               </a:rPr>
-              <a:t>03</a:t>
-            </a:r>
-          </a:p>
-        </p:txBody>
-      </p:sp>
-      <p:sp>
-        <p:nvSpPr>
-          <p:cNvPr id="117" name="TextBox 116"/>
+              <a:t>Bot限制C2；讀回及到期回復</a:t>
+            </a:r>
+          </a:p>
+        </p:txBody>
+      </p:sp>
+      <p:sp>
+        <p:nvSpPr>
+          <p:cNvPr id="130" name="TextBox 129"/>
           <p:cNvSpPr txBox="1"/>
           <p:nvPr>
             <p:custDataLst>
-              <p:tags r:id="rId55"/>
+              <p:tags r:id="rId63"/>
             </p:custDataLst>
           </p:nvPr>
         </p:nvSpPr>
         <p:spPr>
           <a:xfrm>
-            <a:off x="1116000" y="16380000"/>
-            <a:ext cx="13320000" cy="360000"/>
+            <a:off x="576000" y="16380000"/>
+            <a:ext cx="432000" cy="360000"/>
           </a:xfrm>
           <a:prstGeom prst="rect">
             <a:avLst/>
@@ -9678,33 +10509,33 @@
               </a:spcAft>
             </a:pPr>
             <a:r>
-              <a:rPr sz="2400" b="0">
+              <a:rPr sz="2000" b="1">
                 <a:solidFill>
-                  <a:srgbClr val="092B42"/>
+                  <a:srgbClr val="105186"/>
                 </a:solidFill>
                 <a:latin typeface="Times New Roman"/>
                 <a:ea typeface="DFKai-SB"/>
                 <a:cs typeface="Times New Roman"/>
               </a:rPr>
-              <a:t>以分階段實測呈現效果</a:t>
-            </a:r>
-          </a:p>
-        </p:txBody>
-      </p:sp>
-      <p:sp>
-        <p:nvSpPr>
-          <p:cNvPr id="118" name="TextBox 117"/>
+              <a:t>03</a:t>
+            </a:r>
+          </a:p>
+        </p:txBody>
+      </p:sp>
+      <p:sp>
+        <p:nvSpPr>
+          <p:cNvPr id="131" name="TextBox 130"/>
           <p:cNvSpPr txBox="1"/>
           <p:nvPr>
             <p:custDataLst>
-              <p:tags r:id="rId56"/>
+              <p:tags r:id="rId64"/>
             </p:custDataLst>
           </p:nvPr>
         </p:nvSpPr>
         <p:spPr>
           <a:xfrm>
-            <a:off x="576000" y="16920000"/>
-            <a:ext cx="6624000" cy="360000"/>
+            <a:off x="1116000" y="16380000"/>
+            <a:ext cx="13320000" cy="360000"/>
           </a:xfrm>
           <a:prstGeom prst="rect">
             <a:avLst/>
@@ -9729,33 +10560,33 @@
               </a:spcAft>
             </a:pPr>
             <a:r>
-              <a:rPr sz="1700" b="0">
+              <a:rPr sz="2400" b="0">
                 <a:solidFill>
-                  <a:srgbClr val="171C1D"/>
+                  <a:srgbClr val="092B42"/>
                 </a:solidFill>
                 <a:latin typeface="Times New Roman"/>
                 <a:ea typeface="DFKai-SB"/>
                 <a:cs typeface="Times New Roman"/>
               </a:rPr>
-              <a:t>相同18,998筆測試的 Macro-F1</a:t>
-            </a:r>
-          </a:p>
-        </p:txBody>
-      </p:sp>
-      <p:sp>
-        <p:nvSpPr>
-          <p:cNvPr id="119" name="TextBox 118"/>
+              <a:t>以分階段實測呈現效果</a:t>
+            </a:r>
+          </a:p>
+        </p:txBody>
+      </p:sp>
+      <p:sp>
+        <p:nvSpPr>
+          <p:cNvPr id="132" name="TextBox 131"/>
           <p:cNvSpPr txBox="1"/>
           <p:nvPr>
             <p:custDataLst>
-              <p:tags r:id="rId57"/>
+              <p:tags r:id="rId65"/>
             </p:custDataLst>
           </p:nvPr>
         </p:nvSpPr>
         <p:spPr>
           <a:xfrm>
-            <a:off x="576000" y="17424000"/>
-            <a:ext cx="1584000" cy="360000"/>
+            <a:off x="576000" y="16920000"/>
+            <a:ext cx="6624000" cy="360000"/>
           </a:xfrm>
           <a:prstGeom prst="rect">
             <a:avLst/>
@@ -9780,6 +10611,57 @@
               </a:spcAft>
             </a:pPr>
             <a:r>
+              <a:rPr sz="1700" b="0">
+                <a:solidFill>
+                  <a:srgbClr val="171C1D"/>
+                </a:solidFill>
+                <a:latin typeface="Times New Roman"/>
+                <a:ea typeface="DFKai-SB"/>
+                <a:cs typeface="Times New Roman"/>
+              </a:rPr>
+              <a:t>相同18,998筆測試的 Macro-F1</a:t>
+            </a:r>
+          </a:p>
+        </p:txBody>
+      </p:sp>
+      <p:sp>
+        <p:nvSpPr>
+          <p:cNvPr id="133" name="TextBox 132"/>
+          <p:cNvSpPr txBox="1"/>
+          <p:nvPr>
+            <p:custDataLst>
+              <p:tags r:id="rId66"/>
+            </p:custDataLst>
+          </p:nvPr>
+        </p:nvSpPr>
+        <p:spPr>
+          <a:xfrm>
+            <a:off x="576000" y="17424000"/>
+            <a:ext cx="1584000" cy="360000"/>
+          </a:xfrm>
+          <a:prstGeom prst="rect">
+            <a:avLst/>
+          </a:prstGeom>
+          <a:noFill/>
+        </p:spPr>
+        <p:txBody>
+          <a:bodyPr wrap="none" lIns="0" tIns="0" rIns="0" bIns="0" anchor="ctr">
+            <a:spAutoFit/>
+          </a:bodyPr>
+          <a:lstStyle/>
+          <a:p>
+            <a:pPr algn="l">
+              <a:lnSpc>
+                <a:spcPct val="110000"/>
+              </a:lnSpc>
+              <a:spcBef>
+                <a:spcPts val="0"/>
+              </a:spcBef>
+              <a:spcAft>
+                <a:spcPts val="0"/>
+              </a:spcAft>
+            </a:pPr>
+            <a:r>
               <a:rPr sz="1800" b="0">
                 <a:solidFill>
                   <a:srgbClr val="171C1D"/>
@@ -9795,7 +10677,7 @@
       </p:sp>
       <p:sp>
         <p:nvSpPr>
-          <p:cNvPr id="120" name="Rectangle 119"/>
+          <p:cNvPr id="134" name="Rectangle 133"/>
           <p:cNvSpPr/>
           <p:nvPr/>
         </p:nvSpPr>
@@ -9844,7 +10726,7 @@
       </p:sp>
       <p:sp>
         <p:nvSpPr>
-          <p:cNvPr id="121" name="Rectangle 120"/>
+          <p:cNvPr id="135" name="Rectangle 134"/>
           <p:cNvSpPr/>
           <p:nvPr/>
         </p:nvSpPr>
@@ -9893,11 +10775,11 @@
       </p:sp>
       <p:sp>
         <p:nvSpPr>
-          <p:cNvPr id="122" name="TextBox 121"/>
+          <p:cNvPr id="136" name="TextBox 135"/>
           <p:cNvSpPr txBox="1"/>
           <p:nvPr>
             <p:custDataLst>
-              <p:tags r:id="rId58"/>
+              <p:tags r:id="rId67"/>
             </p:custDataLst>
           </p:nvPr>
         </p:nvSpPr>
@@ -9944,11 +10826,11 @@
       </p:sp>
       <p:sp>
         <p:nvSpPr>
-          <p:cNvPr id="123" name="TextBox 122"/>
+          <p:cNvPr id="137" name="TextBox 136"/>
           <p:cNvSpPr txBox="1"/>
           <p:nvPr>
             <p:custDataLst>
-              <p:tags r:id="rId59"/>
+              <p:tags r:id="rId68"/>
             </p:custDataLst>
           </p:nvPr>
         </p:nvSpPr>
@@ -9995,7 +10877,7 @@
       </p:sp>
       <p:sp>
         <p:nvSpPr>
-          <p:cNvPr id="124" name="Rectangle 123"/>
+          <p:cNvPr id="138" name="Rectangle 137"/>
           <p:cNvSpPr/>
           <p:nvPr/>
         </p:nvSpPr>
@@ -10044,7 +10926,7 @@
       </p:sp>
       <p:sp>
         <p:nvSpPr>
-          <p:cNvPr id="125" name="Rectangle 124"/>
+          <p:cNvPr id="139" name="Rectangle 138"/>
           <p:cNvSpPr/>
           <p:nvPr/>
         </p:nvSpPr>
@@ -10093,11 +10975,11 @@
       </p:sp>
       <p:sp>
         <p:nvSpPr>
-          <p:cNvPr id="126" name="TextBox 125"/>
+          <p:cNvPr id="140" name="TextBox 139"/>
           <p:cNvSpPr txBox="1"/>
           <p:nvPr>
             <p:custDataLst>
-              <p:tags r:id="rId60"/>
+              <p:tags r:id="rId69"/>
             </p:custDataLst>
           </p:nvPr>
         </p:nvSpPr>
@@ -10144,11 +11026,11 @@
       </p:sp>
       <p:sp>
         <p:nvSpPr>
-          <p:cNvPr id="127" name="TextBox 126"/>
+          <p:cNvPr id="141" name="TextBox 140"/>
           <p:cNvSpPr txBox="1"/>
           <p:nvPr>
             <p:custDataLst>
-              <p:tags r:id="rId61"/>
+              <p:tags r:id="rId70"/>
             </p:custDataLst>
           </p:nvPr>
         </p:nvSpPr>
@@ -10195,7 +11077,7 @@
       </p:sp>
       <p:sp>
         <p:nvSpPr>
-          <p:cNvPr id="128" name="Rectangle 127"/>
+          <p:cNvPr id="142" name="Rectangle 141"/>
           <p:cNvSpPr/>
           <p:nvPr/>
         </p:nvSpPr>
@@ -10244,7 +11126,7 @@
       </p:sp>
       <p:sp>
         <p:nvSpPr>
-          <p:cNvPr id="129" name="Rectangle 128"/>
+          <p:cNvPr id="143" name="Rectangle 142"/>
           <p:cNvSpPr/>
           <p:nvPr/>
         </p:nvSpPr>
@@ -10293,11 +11175,11 @@
       </p:sp>
       <p:sp>
         <p:nvSpPr>
-          <p:cNvPr id="130" name="TextBox 129"/>
+          <p:cNvPr id="144" name="TextBox 143"/>
           <p:cNvSpPr txBox="1"/>
           <p:nvPr>
             <p:custDataLst>
-              <p:tags r:id="rId62"/>
+              <p:tags r:id="rId71"/>
             </p:custDataLst>
           </p:nvPr>
         </p:nvSpPr>
@@ -10344,11 +11226,11 @@
       </p:sp>
       <p:sp>
         <p:nvSpPr>
-          <p:cNvPr id="131" name="TextBox 130"/>
+          <p:cNvPr id="145" name="TextBox 144"/>
           <p:cNvSpPr txBox="1"/>
           <p:nvPr>
             <p:custDataLst>
-              <p:tags r:id="rId63"/>
+              <p:tags r:id="rId72"/>
             </p:custDataLst>
           </p:nvPr>
         </p:nvSpPr>
@@ -10395,7 +11277,7 @@
       </p:sp>
       <p:cxnSp>
         <p:nvCxnSpPr>
-          <p:cNvPr id="132" name="Connector 131"/>
+          <p:cNvPr id="146" name="Connector 145"/>
           <p:cNvCxnSpPr/>
           <p:nvPr/>
         </p:nvCxnSpPr>
@@ -10431,11 +11313,11 @@
       </p:cxnSp>
       <p:sp>
         <p:nvSpPr>
-          <p:cNvPr id="133" name="TextBox 132"/>
+          <p:cNvPr id="147" name="TextBox 146"/>
           <p:cNvSpPr txBox="1"/>
           <p:nvPr>
             <p:custDataLst>
-              <p:tags r:id="rId64"/>
+              <p:tags r:id="rId73"/>
             </p:custDataLst>
           </p:nvPr>
         </p:nvSpPr>
@@ -10482,11 +11364,11 @@
       </p:sp>
       <p:sp>
         <p:nvSpPr>
-          <p:cNvPr id="134" name="TextBox 133"/>
+          <p:cNvPr id="148" name="TextBox 147"/>
           <p:cNvSpPr txBox="1"/>
           <p:nvPr>
             <p:custDataLst>
-              <p:tags r:id="rId65"/>
+              <p:tags r:id="rId74"/>
             </p:custDataLst>
           </p:nvPr>
         </p:nvSpPr>
@@ -10533,11 +11415,11 @@
       </p:sp>
       <p:sp>
         <p:nvSpPr>
-          <p:cNvPr id="135" name="TextBox 134"/>
+          <p:cNvPr id="149" name="TextBox 148"/>
           <p:cNvSpPr txBox="1"/>
           <p:nvPr>
             <p:custDataLst>
-              <p:tags r:id="rId66"/>
+              <p:tags r:id="rId75"/>
             </p:custDataLst>
           </p:nvPr>
         </p:nvSpPr>
@@ -10584,11 +11466,11 @@
       </p:sp>
       <p:sp>
         <p:nvSpPr>
-          <p:cNvPr id="136" name="TextBox 135"/>
+          <p:cNvPr id="150" name="TextBox 149"/>
           <p:cNvSpPr txBox="1"/>
           <p:nvPr>
             <p:custDataLst>
-              <p:tags r:id="rId67"/>
+              <p:tags r:id="rId76"/>
             </p:custDataLst>
           </p:nvPr>
         </p:nvSpPr>
@@ -10635,11 +11517,11 @@
       </p:sp>
       <p:sp>
         <p:nvSpPr>
-          <p:cNvPr id="137" name="TextBox 136"/>
+          <p:cNvPr id="151" name="TextBox 150"/>
           <p:cNvSpPr txBox="1"/>
           <p:nvPr>
             <p:custDataLst>
-              <p:tags r:id="rId68"/>
+              <p:tags r:id="rId77"/>
             </p:custDataLst>
           </p:nvPr>
         </p:nvSpPr>
@@ -10686,11 +11568,11 @@
       </p:sp>
       <p:sp>
         <p:nvSpPr>
-          <p:cNvPr id="138" name="TextBox 137"/>
+          <p:cNvPr id="152" name="TextBox 151"/>
           <p:cNvSpPr txBox="1"/>
           <p:nvPr>
             <p:custDataLst>
-              <p:tags r:id="rId69"/>
+              <p:tags r:id="rId78"/>
             </p:custDataLst>
           </p:nvPr>
         </p:nvSpPr>
@@ -10737,11 +11619,11 @@
       </p:sp>
       <p:sp>
         <p:nvSpPr>
-          <p:cNvPr id="139" name="TextBox 138"/>
+          <p:cNvPr id="153" name="TextBox 152"/>
           <p:cNvSpPr txBox="1"/>
           <p:nvPr>
             <p:custDataLst>
-              <p:tags r:id="rId70"/>
+              <p:tags r:id="rId79"/>
             </p:custDataLst>
           </p:nvPr>
         </p:nvSpPr>
@@ -10788,11 +11670,11 @@
       </p:sp>
       <p:sp>
         <p:nvSpPr>
-          <p:cNvPr id="140" name="TextBox 139"/>
+          <p:cNvPr id="154" name="TextBox 153"/>
           <p:cNvSpPr txBox="1"/>
           <p:nvPr>
             <p:custDataLst>
-              <p:tags r:id="rId71"/>
+              <p:tags r:id="rId80"/>
             </p:custDataLst>
           </p:nvPr>
         </p:nvSpPr>
@@ -10839,11 +11721,11 @@
       </p:sp>
       <p:sp>
         <p:nvSpPr>
-          <p:cNvPr id="141" name="TextBox 140"/>
+          <p:cNvPr id="155" name="TextBox 154"/>
           <p:cNvSpPr txBox="1"/>
           <p:nvPr>
             <p:custDataLst>
-              <p:tags r:id="rId72"/>
+              <p:tags r:id="rId81"/>
             </p:custDataLst>
           </p:nvPr>
         </p:nvSpPr>
@@ -10890,11 +11772,11 @@
       </p:sp>
       <p:sp>
         <p:nvSpPr>
-          <p:cNvPr id="142" name="TextBox 141"/>
+          <p:cNvPr id="156" name="TextBox 155"/>
           <p:cNvSpPr txBox="1"/>
           <p:nvPr>
             <p:custDataLst>
-              <p:tags r:id="rId73"/>
+              <p:tags r:id="rId82"/>
             </p:custDataLst>
           </p:nvPr>
         </p:nvSpPr>
@@ -10965,7 +11847,7 @@
       </p:sp>
       <p:cxnSp>
         <p:nvCxnSpPr>
-          <p:cNvPr id="143" name="Connector 142"/>
+          <p:cNvPr id="157" name="Connector 156"/>
           <p:cNvCxnSpPr/>
           <p:nvPr/>
         </p:nvCxnSpPr>
@@ -11001,18 +11883,18 @@
       </p:cxnSp>
       <p:sp>
         <p:nvSpPr>
-          <p:cNvPr id="144" name="TextBox 143"/>
+          <p:cNvPr id="158" name="TextBox 157"/>
           <p:cNvSpPr txBox="1"/>
           <p:nvPr>
             <p:custDataLst>
-              <p:tags r:id="rId74"/>
+              <p:tags r:id="rId83"/>
             </p:custDataLst>
           </p:nvPr>
         </p:nvSpPr>
         <p:spPr>
           <a:xfrm>
             <a:off x="576000" y="19980000"/>
-            <a:ext cx="13968000" cy="288000"/>
+            <a:ext cx="2412000" cy="576000"/>
           </a:xfrm>
           <a:prstGeom prst="rect">
             <a:avLst/>
@@ -11045,36 +11927,9 @@
                 <a:ea typeface="DFKai-SB"/>
                 <a:cs typeface="Times New Roman"/>
               </a:rPr>
-              <a:t>整合驗證：17類真實張量重跑；6種隔離TCP情境，背景保留與回復皆6/6。</a:t>
-            </a:r>
-          </a:p>
-        </p:txBody>
-      </p:sp>
-      <p:sp>
-        <p:nvSpPr>
-          <p:cNvPr id="145" name="TextBox 144"/>
-          <p:cNvSpPr txBox="1"/>
-          <p:nvPr>
-            <p:custDataLst>
-              <p:tags r:id="rId75"/>
-            </p:custDataLst>
-          </p:nvPr>
-        </p:nvSpPr>
-        <p:spPr>
-          <a:xfrm>
-            <a:off x="576000" y="20322000"/>
-            <a:ext cx="13968000" cy="504000"/>
-          </a:xfrm>
-          <a:prstGeom prst="rect">
-            <a:avLst/>
-          </a:prstGeom>
-          <a:noFill/>
-        </p:spPr>
-        <p:txBody>
-          <a:bodyPr wrap="none" lIns="0" tIns="0" rIns="0" bIns="0" anchor="ctr">
-            <a:spAutoFit/>
-          </a:bodyPr>
-          <a:lstStyle/>
+              <a:t>17類本機重跑</a:t>
+            </a:r>
+          </a:p>
           <a:p>
             <a:pPr algn="l">
               <a:lnSpc>
@@ -11090,15 +11945,1035 @@
             <a:r>
               <a:rPr sz="1600" b="0">
                 <a:solidFill>
-                  <a:srgbClr val="53666E"/>
+                  <a:srgbClr val="105186"/>
                 </a:solidFill>
                 <a:latin typeface="Times New Roman"/>
                 <a:ea typeface="DFKai-SB"/>
                 <a:cs typeface="Times New Roman"/>
               </a:rPr>
-              <a:t>6種隔離情境：4種套用規則、2種監測或蒐證。</a:t>
-            </a:r>
-          </a:p>
+              <a:t>6種隔離TCP情境</a:t>
+            </a:r>
+          </a:p>
+        </p:txBody>
+      </p:sp>
+      <p:sp>
+        <p:nvSpPr>
+          <p:cNvPr id="159" name="Rectangle 158"/>
+          <p:cNvSpPr/>
+          <p:nvPr/>
+        </p:nvSpPr>
+        <p:spPr>
+          <a:xfrm>
+            <a:off x="3240000" y="19980000"/>
+            <a:ext cx="1116000" cy="324000"/>
+          </a:xfrm>
+          <a:prstGeom prst="rect">
+            <a:avLst/>
+          </a:prstGeom>
+          <a:solidFill>
+            <a:srgbClr val="F0F2F3"/>
+          </a:solidFill>
+          <a:ln w="10160">
+            <a:solidFill>
+              <a:srgbClr val="D6DDE0"/>
+            </a:solidFill>
+          </a:ln>
+          <a:effectLst/>
+        </p:spPr>
+        <p:style>
+          <a:lnRef idx="1">
+            <a:schemeClr val="accent1"/>
+          </a:lnRef>
+          <a:fillRef idx="3">
+            <a:schemeClr val="accent1"/>
+          </a:fillRef>
+          <a:effectRef idx="2">
+            <a:schemeClr val="accent1"/>
+          </a:effectRef>
+          <a:fontRef idx="minor">
+            <a:schemeClr val="lt1"/>
+          </a:fontRef>
+        </p:style>
+        <p:txBody>
+          <a:bodyPr rtlCol="0" anchor="ctr"/>
+          <a:lstStyle/>
+          <a:p>
+            <a:pPr algn="ctr"/>
+            <a:endParaRPr>
+              <a:latin typeface="Times New Roman"/>
+              <a:ea typeface="DFKai-SB"/>
+              <a:cs typeface="Times New Roman"/>
+            </a:endParaRPr>
+          </a:p>
+        </p:txBody>
+      </p:sp>
+      <p:sp>
+        <p:nvSpPr>
+          <p:cNvPr id="160" name="TextBox 159"/>
+          <p:cNvSpPr txBox="1"/>
+          <p:nvPr>
+            <p:custDataLst>
+              <p:tags r:id="rId84"/>
+            </p:custDataLst>
+          </p:nvPr>
+        </p:nvSpPr>
+        <p:spPr>
+          <a:xfrm>
+            <a:off x="3214600" y="19980000"/>
+            <a:ext cx="1116000" cy="324000"/>
+          </a:xfrm>
+          <a:prstGeom prst="rect">
+            <a:avLst/>
+          </a:prstGeom>
+          <a:noFill/>
+        </p:spPr>
+        <p:txBody>
+          <a:bodyPr wrap="none" lIns="0" tIns="0" rIns="0" bIns="0" anchor="ctr">
+            <a:spAutoFit/>
+          </a:bodyPr>
+          <a:lstStyle/>
+          <a:p>
+            <a:pPr algn="ctr">
+              <a:lnSpc>
+                <a:spcPct val="110000"/>
+              </a:lnSpc>
+              <a:spcBef>
+                <a:spcPts val="0"/>
+              </a:spcBef>
+              <a:spcAft>
+                <a:spcPts val="0"/>
+              </a:spcAft>
+            </a:pPr>
+            <a:r>
+              <a:rPr sz="1600" b="0">
+                <a:solidFill>
+                  <a:srgbClr val="105186"/>
+                </a:solidFill>
+                <a:latin typeface="Times New Roman"/>
+                <a:ea typeface="DFKai-SB"/>
+                <a:cs typeface="Times New Roman"/>
+              </a:rPr>
+              <a:t>正常</a:t>
+            </a:r>
+          </a:p>
+        </p:txBody>
+      </p:sp>
+      <p:sp>
+        <p:nvSpPr>
+          <p:cNvPr id="161" name="TextBox 160"/>
+          <p:cNvSpPr txBox="1"/>
+          <p:nvPr>
+            <p:custDataLst>
+              <p:tags r:id="rId85"/>
+            </p:custDataLst>
+          </p:nvPr>
+        </p:nvSpPr>
+        <p:spPr>
+          <a:xfrm>
+            <a:off x="3217775" y="20304000"/>
+            <a:ext cx="1116000" cy="216000"/>
+          </a:xfrm>
+          <a:prstGeom prst="rect">
+            <a:avLst/>
+          </a:prstGeom>
+          <a:noFill/>
+        </p:spPr>
+        <p:txBody>
+          <a:bodyPr wrap="none" lIns="0" tIns="0" rIns="0" bIns="0" anchor="ctr">
+            <a:spAutoFit/>
+          </a:bodyPr>
+          <a:lstStyle/>
+          <a:p>
+            <a:pPr algn="ctr">
+              <a:lnSpc>
+                <a:spcPct val="110000"/>
+              </a:lnSpc>
+              <a:spcBef>
+                <a:spcPts val="0"/>
+              </a:spcBef>
+              <a:spcAft>
+                <a:spcPts val="0"/>
+              </a:spcAft>
+            </a:pPr>
+            <a:r>
+              <a:rPr sz="1400" b="0">
+                <a:solidFill>
+                  <a:srgbClr val="171C1D"/>
+                </a:solidFill>
+                <a:latin typeface="Times New Roman"/>
+                <a:ea typeface="DFKai-SB"/>
+                <a:cs typeface="Times New Roman"/>
+              </a:rPr>
+              <a:t>監測</a:t>
+            </a:r>
+          </a:p>
+        </p:txBody>
+      </p:sp>
+      <p:sp>
+        <p:nvSpPr>
+          <p:cNvPr id="162" name="Rectangle 161"/>
+          <p:cNvSpPr/>
+          <p:nvPr/>
+        </p:nvSpPr>
+        <p:spPr>
+          <a:xfrm>
+            <a:off x="4500000" y="19980000"/>
+            <a:ext cx="1116000" cy="324000"/>
+          </a:xfrm>
+          <a:prstGeom prst="rect">
+            <a:avLst/>
+          </a:prstGeom>
+          <a:solidFill>
+            <a:srgbClr val="FFF4DD"/>
+          </a:solidFill>
+          <a:ln w="10160">
+            <a:solidFill>
+              <a:srgbClr val="D6DDE0"/>
+            </a:solidFill>
+          </a:ln>
+          <a:effectLst/>
+        </p:spPr>
+        <p:style>
+          <a:lnRef idx="1">
+            <a:schemeClr val="accent1"/>
+          </a:lnRef>
+          <a:fillRef idx="3">
+            <a:schemeClr val="accent1"/>
+          </a:fillRef>
+          <a:effectRef idx="2">
+            <a:schemeClr val="accent1"/>
+          </a:effectRef>
+          <a:fontRef idx="minor">
+            <a:schemeClr val="lt1"/>
+          </a:fontRef>
+        </p:style>
+        <p:txBody>
+          <a:bodyPr rtlCol="0" anchor="ctr"/>
+          <a:lstStyle/>
+          <a:p>
+            <a:pPr algn="ctr"/>
+            <a:endParaRPr>
+              <a:latin typeface="Times New Roman"/>
+              <a:ea typeface="DFKai-SB"/>
+              <a:cs typeface="Times New Roman"/>
+            </a:endParaRPr>
+          </a:p>
+        </p:txBody>
+      </p:sp>
+      <p:sp>
+        <p:nvSpPr>
+          <p:cNvPr id="163" name="TextBox 162"/>
+          <p:cNvSpPr txBox="1"/>
+          <p:nvPr>
+            <p:custDataLst>
+              <p:tags r:id="rId86"/>
+            </p:custDataLst>
+          </p:nvPr>
+        </p:nvSpPr>
+        <p:spPr>
+          <a:xfrm>
+            <a:off x="4474600" y="19980000"/>
+            <a:ext cx="1116000" cy="324000"/>
+          </a:xfrm>
+          <a:prstGeom prst="rect">
+            <a:avLst/>
+          </a:prstGeom>
+          <a:noFill/>
+        </p:spPr>
+        <p:txBody>
+          <a:bodyPr wrap="none" lIns="0" tIns="0" rIns="0" bIns="0" anchor="ctr">
+            <a:spAutoFit/>
+          </a:bodyPr>
+          <a:lstStyle/>
+          <a:p>
+            <a:pPr algn="ctr">
+              <a:lnSpc>
+                <a:spcPct val="110000"/>
+              </a:lnSpc>
+              <a:spcBef>
+                <a:spcPts val="0"/>
+              </a:spcBef>
+              <a:spcAft>
+                <a:spcPts val="0"/>
+              </a:spcAft>
+            </a:pPr>
+            <a:r>
+              <a:rPr sz="1600" b="0">
+                <a:solidFill>
+                  <a:srgbClr val="105186"/>
+                </a:solidFill>
+                <a:latin typeface="Times New Roman"/>
+                <a:ea typeface="DFKai-SB"/>
+                <a:cs typeface="Times New Roman"/>
+              </a:rPr>
+              <a:t>FTP</a:t>
+            </a:r>
+          </a:p>
+        </p:txBody>
+      </p:sp>
+      <p:sp>
+        <p:nvSpPr>
+          <p:cNvPr id="164" name="TextBox 163"/>
+          <p:cNvSpPr txBox="1"/>
+          <p:nvPr>
+            <p:custDataLst>
+              <p:tags r:id="rId87"/>
+            </p:custDataLst>
+          </p:nvPr>
+        </p:nvSpPr>
+        <p:spPr>
+          <a:xfrm>
+            <a:off x="4477775" y="20304000"/>
+            <a:ext cx="1116000" cy="216000"/>
+          </a:xfrm>
+          <a:prstGeom prst="rect">
+            <a:avLst/>
+          </a:prstGeom>
+          <a:noFill/>
+        </p:spPr>
+        <p:txBody>
+          <a:bodyPr wrap="none" lIns="0" tIns="0" rIns="0" bIns="0" anchor="ctr">
+            <a:spAutoFit/>
+          </a:bodyPr>
+          <a:lstStyle/>
+          <a:p>
+            <a:pPr algn="ctr">
+              <a:lnSpc>
+                <a:spcPct val="110000"/>
+              </a:lnSpc>
+              <a:spcBef>
+                <a:spcPts val="0"/>
+              </a:spcBef>
+              <a:spcAft>
+                <a:spcPts val="0"/>
+              </a:spcAft>
+            </a:pPr>
+            <a:r>
+              <a:rPr sz="1400" b="0">
+                <a:solidFill>
+                  <a:srgbClr val="171C1D"/>
+                </a:solidFill>
+                <a:latin typeface="Times New Roman"/>
+                <a:ea typeface="DFKai-SB"/>
+                <a:cs typeface="Times New Roman"/>
+              </a:rPr>
+              <a:t>規則</a:t>
+            </a:r>
+          </a:p>
+        </p:txBody>
+      </p:sp>
+      <p:sp>
+        <p:nvSpPr>
+          <p:cNvPr id="165" name="Rectangle 164"/>
+          <p:cNvSpPr/>
+          <p:nvPr/>
+        </p:nvSpPr>
+        <p:spPr>
+          <a:xfrm>
+            <a:off x="5760000" y="19980000"/>
+            <a:ext cx="1116000" cy="324000"/>
+          </a:xfrm>
+          <a:prstGeom prst="rect">
+            <a:avLst/>
+          </a:prstGeom>
+          <a:solidFill>
+            <a:srgbClr val="FFF4DD"/>
+          </a:solidFill>
+          <a:ln w="10160">
+            <a:solidFill>
+              <a:srgbClr val="D6DDE0"/>
+            </a:solidFill>
+          </a:ln>
+          <a:effectLst/>
+        </p:spPr>
+        <p:style>
+          <a:lnRef idx="1">
+            <a:schemeClr val="accent1"/>
+          </a:lnRef>
+          <a:fillRef idx="3">
+            <a:schemeClr val="accent1"/>
+          </a:fillRef>
+          <a:effectRef idx="2">
+            <a:schemeClr val="accent1"/>
+          </a:effectRef>
+          <a:fontRef idx="minor">
+            <a:schemeClr val="lt1"/>
+          </a:fontRef>
+        </p:style>
+        <p:txBody>
+          <a:bodyPr rtlCol="0" anchor="ctr"/>
+          <a:lstStyle/>
+          <a:p>
+            <a:pPr algn="ctr"/>
+            <a:endParaRPr>
+              <a:latin typeface="Times New Roman"/>
+              <a:ea typeface="DFKai-SB"/>
+              <a:cs typeface="Times New Roman"/>
+            </a:endParaRPr>
+          </a:p>
+        </p:txBody>
+      </p:sp>
+      <p:sp>
+        <p:nvSpPr>
+          <p:cNvPr id="166" name="TextBox 165"/>
+          <p:cNvSpPr txBox="1"/>
+          <p:nvPr>
+            <p:custDataLst>
+              <p:tags r:id="rId88"/>
+            </p:custDataLst>
+          </p:nvPr>
+        </p:nvSpPr>
+        <p:spPr>
+          <a:xfrm>
+            <a:off x="5734600" y="19980000"/>
+            <a:ext cx="1116000" cy="324000"/>
+          </a:xfrm>
+          <a:prstGeom prst="rect">
+            <a:avLst/>
+          </a:prstGeom>
+          <a:noFill/>
+        </p:spPr>
+        <p:txBody>
+          <a:bodyPr wrap="none" lIns="0" tIns="0" rIns="0" bIns="0" anchor="ctr">
+            <a:spAutoFit/>
+          </a:bodyPr>
+          <a:lstStyle/>
+          <a:p>
+            <a:pPr algn="ctr">
+              <a:lnSpc>
+                <a:spcPct val="110000"/>
+              </a:lnSpc>
+              <a:spcBef>
+                <a:spcPts val="0"/>
+              </a:spcBef>
+              <a:spcAft>
+                <a:spcPts val="0"/>
+              </a:spcAft>
+            </a:pPr>
+            <a:r>
+              <a:rPr sz="1600" b="0">
+                <a:solidFill>
+                  <a:srgbClr val="105186"/>
+                </a:solidFill>
+                <a:latin typeface="Times New Roman"/>
+                <a:ea typeface="DFKai-SB"/>
+                <a:cs typeface="Times New Roman"/>
+              </a:rPr>
+              <a:t>SSH</a:t>
+            </a:r>
+          </a:p>
+        </p:txBody>
+      </p:sp>
+      <p:sp>
+        <p:nvSpPr>
+          <p:cNvPr id="167" name="TextBox 166"/>
+          <p:cNvSpPr txBox="1"/>
+          <p:nvPr>
+            <p:custDataLst>
+              <p:tags r:id="rId89"/>
+            </p:custDataLst>
+          </p:nvPr>
+        </p:nvSpPr>
+        <p:spPr>
+          <a:xfrm>
+            <a:off x="5737775" y="20304000"/>
+            <a:ext cx="1116000" cy="216000"/>
+          </a:xfrm>
+          <a:prstGeom prst="rect">
+            <a:avLst/>
+          </a:prstGeom>
+          <a:noFill/>
+        </p:spPr>
+        <p:txBody>
+          <a:bodyPr wrap="none" lIns="0" tIns="0" rIns="0" bIns="0" anchor="ctr">
+            <a:spAutoFit/>
+          </a:bodyPr>
+          <a:lstStyle/>
+          <a:p>
+            <a:pPr algn="ctr">
+              <a:lnSpc>
+                <a:spcPct val="110000"/>
+              </a:lnSpc>
+              <a:spcBef>
+                <a:spcPts val="0"/>
+              </a:spcBef>
+              <a:spcAft>
+                <a:spcPts val="0"/>
+              </a:spcAft>
+            </a:pPr>
+            <a:r>
+              <a:rPr sz="1400" b="0">
+                <a:solidFill>
+                  <a:srgbClr val="171C1D"/>
+                </a:solidFill>
+                <a:latin typeface="Times New Roman"/>
+                <a:ea typeface="DFKai-SB"/>
+                <a:cs typeface="Times New Roman"/>
+              </a:rPr>
+              <a:t>規則</a:t>
+            </a:r>
+          </a:p>
+        </p:txBody>
+      </p:sp>
+      <p:sp>
+        <p:nvSpPr>
+          <p:cNvPr id="168" name="Rectangle 167"/>
+          <p:cNvSpPr/>
+          <p:nvPr/>
+        </p:nvSpPr>
+        <p:spPr>
+          <a:xfrm>
+            <a:off x="7020000" y="19980000"/>
+            <a:ext cx="1116000" cy="324000"/>
+          </a:xfrm>
+          <a:prstGeom prst="rect">
+            <a:avLst/>
+          </a:prstGeom>
+          <a:solidFill>
+            <a:srgbClr val="FFF4DD"/>
+          </a:solidFill>
+          <a:ln w="10160">
+            <a:solidFill>
+              <a:srgbClr val="D6DDE0"/>
+            </a:solidFill>
+          </a:ln>
+          <a:effectLst/>
+        </p:spPr>
+        <p:style>
+          <a:lnRef idx="1">
+            <a:schemeClr val="accent1"/>
+          </a:lnRef>
+          <a:fillRef idx="3">
+            <a:schemeClr val="accent1"/>
+          </a:fillRef>
+          <a:effectRef idx="2">
+            <a:schemeClr val="accent1"/>
+          </a:effectRef>
+          <a:fontRef idx="minor">
+            <a:schemeClr val="lt1"/>
+          </a:fontRef>
+        </p:style>
+        <p:txBody>
+          <a:bodyPr rtlCol="0" anchor="ctr"/>
+          <a:lstStyle/>
+          <a:p>
+            <a:pPr algn="ctr"/>
+            <a:endParaRPr>
+              <a:latin typeface="Times New Roman"/>
+              <a:ea typeface="DFKai-SB"/>
+              <a:cs typeface="Times New Roman"/>
+            </a:endParaRPr>
+          </a:p>
+        </p:txBody>
+      </p:sp>
+      <p:sp>
+        <p:nvSpPr>
+          <p:cNvPr id="169" name="TextBox 168"/>
+          <p:cNvSpPr txBox="1"/>
+          <p:nvPr>
+            <p:custDataLst>
+              <p:tags r:id="rId90"/>
+            </p:custDataLst>
+          </p:nvPr>
+        </p:nvSpPr>
+        <p:spPr>
+          <a:xfrm>
+            <a:off x="6994600" y="19980000"/>
+            <a:ext cx="1116000" cy="324000"/>
+          </a:xfrm>
+          <a:prstGeom prst="rect">
+            <a:avLst/>
+          </a:prstGeom>
+          <a:noFill/>
+        </p:spPr>
+        <p:txBody>
+          <a:bodyPr wrap="none" lIns="0" tIns="0" rIns="0" bIns="0" anchor="ctr">
+            <a:spAutoFit/>
+          </a:bodyPr>
+          <a:lstStyle/>
+          <a:p>
+            <a:pPr algn="ctr">
+              <a:lnSpc>
+                <a:spcPct val="110000"/>
+              </a:lnSpc>
+              <a:spcBef>
+                <a:spcPts val="0"/>
+              </a:spcBef>
+              <a:spcAft>
+                <a:spcPts val="0"/>
+              </a:spcAft>
+            </a:pPr>
+            <a:r>
+              <a:rPr sz="1600" b="0">
+                <a:solidFill>
+                  <a:srgbClr val="105186"/>
+                </a:solidFill>
+                <a:latin typeface="Times New Roman"/>
+                <a:ea typeface="DFKai-SB"/>
+                <a:cs typeface="Times New Roman"/>
+              </a:rPr>
+              <a:t>HTTP</a:t>
+            </a:r>
+          </a:p>
+        </p:txBody>
+      </p:sp>
+      <p:sp>
+        <p:nvSpPr>
+          <p:cNvPr id="170" name="TextBox 169"/>
+          <p:cNvSpPr txBox="1"/>
+          <p:nvPr>
+            <p:custDataLst>
+              <p:tags r:id="rId91"/>
+            </p:custDataLst>
+          </p:nvPr>
+        </p:nvSpPr>
+        <p:spPr>
+          <a:xfrm>
+            <a:off x="6997775" y="20304000"/>
+            <a:ext cx="1116000" cy="216000"/>
+          </a:xfrm>
+          <a:prstGeom prst="rect">
+            <a:avLst/>
+          </a:prstGeom>
+          <a:noFill/>
+        </p:spPr>
+        <p:txBody>
+          <a:bodyPr wrap="none" lIns="0" tIns="0" rIns="0" bIns="0" anchor="ctr">
+            <a:spAutoFit/>
+          </a:bodyPr>
+          <a:lstStyle/>
+          <a:p>
+            <a:pPr algn="ctr">
+              <a:lnSpc>
+                <a:spcPct val="110000"/>
+              </a:lnSpc>
+              <a:spcBef>
+                <a:spcPts val="0"/>
+              </a:spcBef>
+              <a:spcAft>
+                <a:spcPts val="0"/>
+              </a:spcAft>
+            </a:pPr>
+            <a:r>
+              <a:rPr sz="1400" b="0">
+                <a:solidFill>
+                  <a:srgbClr val="171C1D"/>
+                </a:solidFill>
+                <a:latin typeface="Times New Roman"/>
+                <a:ea typeface="DFKai-SB"/>
+                <a:cs typeface="Times New Roman"/>
+              </a:rPr>
+              <a:t>規則</a:t>
+            </a:r>
+          </a:p>
+        </p:txBody>
+      </p:sp>
+      <p:sp>
+        <p:nvSpPr>
+          <p:cNvPr id="171" name="Rectangle 170"/>
+          <p:cNvSpPr/>
+          <p:nvPr/>
+        </p:nvSpPr>
+        <p:spPr>
+          <a:xfrm>
+            <a:off x="8280000" y="19980000"/>
+            <a:ext cx="1116000" cy="324000"/>
+          </a:xfrm>
+          <a:prstGeom prst="rect">
+            <a:avLst/>
+          </a:prstGeom>
+          <a:solidFill>
+            <a:srgbClr val="F0F2F3"/>
+          </a:solidFill>
+          <a:ln w="10160">
+            <a:solidFill>
+              <a:srgbClr val="D6DDE0"/>
+            </a:solidFill>
+          </a:ln>
+          <a:effectLst/>
+        </p:spPr>
+        <p:style>
+          <a:lnRef idx="1">
+            <a:schemeClr val="accent1"/>
+          </a:lnRef>
+          <a:fillRef idx="3">
+            <a:schemeClr val="accent1"/>
+          </a:fillRef>
+          <a:effectRef idx="2">
+            <a:schemeClr val="accent1"/>
+          </a:effectRef>
+          <a:fontRef idx="minor">
+            <a:schemeClr val="lt1"/>
+          </a:fontRef>
+        </p:style>
+        <p:txBody>
+          <a:bodyPr rtlCol="0" anchor="ctr"/>
+          <a:lstStyle/>
+          <a:p>
+            <a:pPr algn="ctr"/>
+            <a:endParaRPr>
+              <a:latin typeface="Times New Roman"/>
+              <a:ea typeface="DFKai-SB"/>
+              <a:cs typeface="Times New Roman"/>
+            </a:endParaRPr>
+          </a:p>
+        </p:txBody>
+      </p:sp>
+      <p:sp>
+        <p:nvSpPr>
+          <p:cNvPr id="172" name="TextBox 171"/>
+          <p:cNvSpPr txBox="1"/>
+          <p:nvPr>
+            <p:custDataLst>
+              <p:tags r:id="rId92"/>
+            </p:custDataLst>
+          </p:nvPr>
+        </p:nvSpPr>
+        <p:spPr>
+          <a:xfrm>
+            <a:off x="8254600" y="19980000"/>
+            <a:ext cx="1116000" cy="324000"/>
+          </a:xfrm>
+          <a:prstGeom prst="rect">
+            <a:avLst/>
+          </a:prstGeom>
+          <a:noFill/>
+        </p:spPr>
+        <p:txBody>
+          <a:bodyPr wrap="none" lIns="0" tIns="0" rIns="0" bIns="0" anchor="ctr">
+            <a:spAutoFit/>
+          </a:bodyPr>
+          <a:lstStyle/>
+          <a:p>
+            <a:pPr algn="ctr">
+              <a:lnSpc>
+                <a:spcPct val="110000"/>
+              </a:lnSpc>
+              <a:spcBef>
+                <a:spcPts val="0"/>
+              </a:spcBef>
+              <a:spcAft>
+                <a:spcPts val="0"/>
+              </a:spcAft>
+            </a:pPr>
+            <a:r>
+              <a:rPr sz="1600" b="0">
+                <a:solidFill>
+                  <a:srgbClr val="105186"/>
+                </a:solidFill>
+                <a:latin typeface="Times New Roman"/>
+                <a:ea typeface="DFKai-SB"/>
+                <a:cs typeface="Times New Roman"/>
+              </a:rPr>
+              <a:t>XSS</a:t>
+            </a:r>
+          </a:p>
+        </p:txBody>
+      </p:sp>
+      <p:sp>
+        <p:nvSpPr>
+          <p:cNvPr id="173" name="TextBox 172"/>
+          <p:cNvSpPr txBox="1"/>
+          <p:nvPr>
+            <p:custDataLst>
+              <p:tags r:id="rId93"/>
+            </p:custDataLst>
+          </p:nvPr>
+        </p:nvSpPr>
+        <p:spPr>
+          <a:xfrm>
+            <a:off x="8257775" y="20304000"/>
+            <a:ext cx="1116000" cy="216000"/>
+          </a:xfrm>
+          <a:prstGeom prst="rect">
+            <a:avLst/>
+          </a:prstGeom>
+          <a:noFill/>
+        </p:spPr>
+        <p:txBody>
+          <a:bodyPr wrap="none" lIns="0" tIns="0" rIns="0" bIns="0" anchor="ctr">
+            <a:spAutoFit/>
+          </a:bodyPr>
+          <a:lstStyle/>
+          <a:p>
+            <a:pPr algn="ctr">
+              <a:lnSpc>
+                <a:spcPct val="110000"/>
+              </a:lnSpc>
+              <a:spcBef>
+                <a:spcPts val="0"/>
+              </a:spcBef>
+              <a:spcAft>
+                <a:spcPts val="0"/>
+              </a:spcAft>
+            </a:pPr>
+            <a:r>
+              <a:rPr sz="1400" b="0">
+                <a:solidFill>
+                  <a:srgbClr val="171C1D"/>
+                </a:solidFill>
+                <a:latin typeface="Times New Roman"/>
+                <a:ea typeface="DFKai-SB"/>
+                <a:cs typeface="Times New Roman"/>
+              </a:rPr>
+              <a:t>蒐證</a:t>
+            </a:r>
+          </a:p>
+        </p:txBody>
+      </p:sp>
+      <p:sp>
+        <p:nvSpPr>
+          <p:cNvPr id="174" name="Rectangle 173"/>
+          <p:cNvSpPr/>
+          <p:nvPr/>
+        </p:nvSpPr>
+        <p:spPr>
+          <a:xfrm>
+            <a:off x="9540000" y="19980000"/>
+            <a:ext cx="1116000" cy="324000"/>
+          </a:xfrm>
+          <a:prstGeom prst="rect">
+            <a:avLst/>
+          </a:prstGeom>
+          <a:solidFill>
+            <a:srgbClr val="FFF4DD"/>
+          </a:solidFill>
+          <a:ln w="10160">
+            <a:solidFill>
+              <a:srgbClr val="D6DDE0"/>
+            </a:solidFill>
+          </a:ln>
+          <a:effectLst/>
+        </p:spPr>
+        <p:style>
+          <a:lnRef idx="1">
+            <a:schemeClr val="accent1"/>
+          </a:lnRef>
+          <a:fillRef idx="3">
+            <a:schemeClr val="accent1"/>
+          </a:fillRef>
+          <a:effectRef idx="2">
+            <a:schemeClr val="accent1"/>
+          </a:effectRef>
+          <a:fontRef idx="minor">
+            <a:schemeClr val="lt1"/>
+          </a:fontRef>
+        </p:style>
+        <p:txBody>
+          <a:bodyPr rtlCol="0" anchor="ctr"/>
+          <a:lstStyle/>
+          <a:p>
+            <a:pPr algn="ctr"/>
+            <a:endParaRPr>
+              <a:latin typeface="Times New Roman"/>
+              <a:ea typeface="DFKai-SB"/>
+              <a:cs typeface="Times New Roman"/>
+            </a:endParaRPr>
+          </a:p>
+        </p:txBody>
+      </p:sp>
+      <p:sp>
+        <p:nvSpPr>
+          <p:cNvPr id="175" name="TextBox 174"/>
+          <p:cNvSpPr txBox="1"/>
+          <p:nvPr>
+            <p:custDataLst>
+              <p:tags r:id="rId94"/>
+            </p:custDataLst>
+          </p:nvPr>
+        </p:nvSpPr>
+        <p:spPr>
+          <a:xfrm>
+            <a:off x="9514600" y="19980000"/>
+            <a:ext cx="1116000" cy="324000"/>
+          </a:xfrm>
+          <a:prstGeom prst="rect">
+            <a:avLst/>
+          </a:prstGeom>
+          <a:noFill/>
+        </p:spPr>
+        <p:txBody>
+          <a:bodyPr wrap="none" lIns="0" tIns="0" rIns="0" bIns="0" anchor="ctr">
+            <a:spAutoFit/>
+          </a:bodyPr>
+          <a:lstStyle/>
+          <a:p>
+            <a:pPr algn="ctr">
+              <a:lnSpc>
+                <a:spcPct val="110000"/>
+              </a:lnSpc>
+              <a:spcBef>
+                <a:spcPts val="0"/>
+              </a:spcBef>
+              <a:spcAft>
+                <a:spcPts val="0"/>
+              </a:spcAft>
+            </a:pPr>
+            <a:r>
+              <a:rPr sz="1600" b="0">
+                <a:solidFill>
+                  <a:srgbClr val="105186"/>
+                </a:solidFill>
+                <a:latin typeface="Times New Roman"/>
+                <a:ea typeface="DFKai-SB"/>
+                <a:cs typeface="Times New Roman"/>
+              </a:rPr>
+              <a:t>Bot</a:t>
+            </a:r>
+          </a:p>
+        </p:txBody>
+      </p:sp>
+      <p:sp>
+        <p:nvSpPr>
+          <p:cNvPr id="176" name="TextBox 175"/>
+          <p:cNvSpPr txBox="1"/>
+          <p:nvPr>
+            <p:custDataLst>
+              <p:tags r:id="rId95"/>
+            </p:custDataLst>
+          </p:nvPr>
+        </p:nvSpPr>
+        <p:spPr>
+          <a:xfrm>
+            <a:off x="9517775" y="20304000"/>
+            <a:ext cx="1116000" cy="216000"/>
+          </a:xfrm>
+          <a:prstGeom prst="rect">
+            <a:avLst/>
+          </a:prstGeom>
+          <a:noFill/>
+        </p:spPr>
+        <p:txBody>
+          <a:bodyPr wrap="none" lIns="0" tIns="0" rIns="0" bIns="0" anchor="ctr">
+            <a:spAutoFit/>
+          </a:bodyPr>
+          <a:lstStyle/>
+          <a:p>
+            <a:pPr algn="ctr">
+              <a:lnSpc>
+                <a:spcPct val="110000"/>
+              </a:lnSpc>
+              <a:spcBef>
+                <a:spcPts val="0"/>
+              </a:spcBef>
+              <a:spcAft>
+                <a:spcPts val="0"/>
+              </a:spcAft>
+            </a:pPr>
+            <a:r>
+              <a:rPr sz="1400" b="0">
+                <a:solidFill>
+                  <a:srgbClr val="171C1D"/>
+                </a:solidFill>
+                <a:latin typeface="Times New Roman"/>
+                <a:ea typeface="DFKai-SB"/>
+                <a:cs typeface="Times New Roman"/>
+              </a:rPr>
+              <a:t>規則</a:t>
+            </a:r>
+          </a:p>
+        </p:txBody>
+      </p:sp>
+      <p:sp>
+        <p:nvSpPr>
+          <p:cNvPr id="177" name="TextBox 176"/>
+          <p:cNvSpPr txBox="1"/>
+          <p:nvPr>
+            <p:custDataLst>
+              <p:tags r:id="rId96"/>
+            </p:custDataLst>
+          </p:nvPr>
+        </p:nvSpPr>
+        <p:spPr>
+          <a:xfrm>
+            <a:off x="11030862" y="19980000"/>
+            <a:ext cx="3456000" cy="576000"/>
+          </a:xfrm>
+          <a:prstGeom prst="rect">
+            <a:avLst/>
+          </a:prstGeom>
+          <a:noFill/>
+        </p:spPr>
+        <p:txBody>
+          <a:bodyPr wrap="none" lIns="0" tIns="0" rIns="0" bIns="0" anchor="ctr">
+            <a:spAutoFit/>
+          </a:bodyPr>
+          <a:lstStyle/>
+          <a:p>
+            <a:pPr algn="r">
+              <a:lnSpc>
+                <a:spcPct val="110000"/>
+              </a:lnSpc>
+              <a:spcBef>
+                <a:spcPts val="0"/>
+              </a:spcBef>
+              <a:spcAft>
+                <a:spcPts val="0"/>
+              </a:spcAft>
+            </a:pPr>
+            <a:r>
+              <a:rPr sz="1800" b="1">
+                <a:solidFill>
+                  <a:srgbClr val="105186"/>
+                </a:solidFill>
+                <a:latin typeface="Times New Roman"/>
+                <a:ea typeface="DFKai-SB"/>
+                <a:cs typeface="Times New Roman"/>
+              </a:rPr>
+              <a:t>背景保留 6/6</a:t>
+            </a:r>
+          </a:p>
+          <a:p>
+            <a:pPr algn="r">
+              <a:lnSpc>
+                <a:spcPct val="110000"/>
+              </a:lnSpc>
+              <a:spcBef>
+                <a:spcPts val="0"/>
+              </a:spcBef>
+              <a:spcAft>
+                <a:spcPts val="0"/>
+              </a:spcAft>
+            </a:pPr>
+            <a:r>
+              <a:rPr sz="1800" b="1">
+                <a:solidFill>
+                  <a:srgbClr val="105186"/>
+                </a:solidFill>
+                <a:latin typeface="Times New Roman"/>
+                <a:ea typeface="DFKai-SB"/>
+                <a:cs typeface="Times New Roman"/>
+              </a:rPr>
+              <a:t>到期回復 6/6</a:t>
+            </a:r>
+          </a:p>
+        </p:txBody>
+      </p:sp>
+      <p:sp>
+        <p:nvSpPr>
+          <p:cNvPr id="178" name="TextBox 177"/>
+          <p:cNvSpPr txBox="1"/>
+          <p:nvPr>
+            <p:custDataLst>
+              <p:tags r:id="rId97"/>
+            </p:custDataLst>
+          </p:nvPr>
+        </p:nvSpPr>
+        <p:spPr>
+          <a:xfrm>
+            <a:off x="576000" y="20592000"/>
+            <a:ext cx="13968000" cy="252000"/>
+          </a:xfrm>
+          <a:prstGeom prst="rect">
+            <a:avLst/>
+          </a:prstGeom>
+          <a:noFill/>
+        </p:spPr>
+        <p:txBody>
+          <a:bodyPr wrap="none" lIns="0" tIns="0" rIns="0" bIns="0" anchor="ctr">
+            <a:spAutoFit/>
+          </a:bodyPr>
+          <a:lstStyle/>
           <a:p>
             <a:pPr algn="l">
               <a:lnSpc>
@@ -11120,7 +12995,7 @@
                 <a:ea typeface="DFKai-SB"/>
                 <a:cs typeface="Times New Roman"/>
               </a:rPr>
-              <a:t>6/6為隔離交易與回復結果，非原生攻擊防禦率。</a:t>
+              <a:t>4種套用規則、2種監測或蒐證；6/6為隔離交易與回復結果，非原生攻擊防禦率。</a:t>
             </a:r>
           </a:p>
         </p:txBody>
@@ -11141,25 +13016,25 @@
 
 <file path=ppt/tags/tag10.xml><?xml version="1.0" encoding="utf-8"?>
 <p:tagLst xmlns:a="http://schemas.openxmlformats.org/drawingml/2006/main" xmlns:r="http://schemas.openxmlformats.org/officeDocument/2006/relationships" xmlns:p="http://schemas.openxmlformats.org/presentationml/2006/main">
-  <p:tag name="ALIGNMENT_TARGET_X" val="65.19685363769531"/>
+  <p:tag name="ALIGNMENT_TARGET_X" val="104.88188934326172"/>
 </p:tagLst>
 </file>
 
 <file path=ppt/tags/tag11.xml><?xml version="1.0" encoding="utf-8"?>
 <p:tagLst xmlns:a="http://schemas.openxmlformats.org/drawingml/2006/main" xmlns:r="http://schemas.openxmlformats.org/officeDocument/2006/relationships" xmlns:p="http://schemas.openxmlformats.org/presentationml/2006/main">
-  <p:tag name="ALIGNMENT_TARGET_X" val="104.88188934326172"/>
+  <p:tag name="ALIGNMENT_TARGET_X" val="147.40158081054688"/>
 </p:tagLst>
 </file>
 
 <file path=ppt/tags/tag12.xml><?xml version="1.0" encoding="utf-8"?>
 <p:tagLst xmlns:a="http://schemas.openxmlformats.org/drawingml/2006/main" xmlns:r="http://schemas.openxmlformats.org/officeDocument/2006/relationships" xmlns:p="http://schemas.openxmlformats.org/presentationml/2006/main">
-  <p:tag name="ALIGNMENT_TARGET_X" val="104.88188934326172"/>
+  <p:tag name="ALIGNMENT_TARGET_X" val="65.19685363769531"/>
 </p:tagLst>
 </file>
 
 <file path=ppt/tags/tag13.xml><?xml version="1.0" encoding="utf-8"?>
 <p:tagLst xmlns:a="http://schemas.openxmlformats.org/drawingml/2006/main" xmlns:r="http://schemas.openxmlformats.org/officeDocument/2006/relationships" xmlns:p="http://schemas.openxmlformats.org/presentationml/2006/main">
-  <p:tag name="ALIGNMENT_TARGET_X" val="65.19685363769531"/>
+  <p:tag name="ALIGNMENT_TARGET_X" val="104.88188934326172"/>
 </p:tagLst>
 </file>
 
@@ -11171,7 +13046,7 @@
 
 <file path=ppt/tags/tag15.xml><?xml version="1.0" encoding="utf-8"?>
 <p:tagLst xmlns:a="http://schemas.openxmlformats.org/drawingml/2006/main" xmlns:r="http://schemas.openxmlformats.org/officeDocument/2006/relationships" xmlns:p="http://schemas.openxmlformats.org/presentationml/2006/main">
-  <p:tag name="ALIGNMENT_TARGET_X" val="104.88188934326172"/>
+  <p:tag name="ALIGNMENT_TARGET_X" val="147.40158081054688"/>
 </p:tagLst>
 </file>
 
@@ -11195,7 +13070,7 @@
 
 <file path=ppt/tags/tag19.xml><?xml version="1.0" encoding="utf-8"?>
 <p:tagLst xmlns:a="http://schemas.openxmlformats.org/drawingml/2006/main" xmlns:r="http://schemas.openxmlformats.org/officeDocument/2006/relationships" xmlns:p="http://schemas.openxmlformats.org/presentationml/2006/main">
-  <p:tag name="ALIGNMENT_TARGET_X" val="450.7086486816406"/>
+  <p:tag name="ALIGNMENT_TARGET_X" val="147.40158081054688"/>
 </p:tagLst>
 </file>
 
@@ -11207,43 +13082,43 @@
 
 <file path=ppt/tags/tag20.xml><?xml version="1.0" encoding="utf-8"?>
 <p:tagLst xmlns:a="http://schemas.openxmlformats.org/drawingml/2006/main" xmlns:r="http://schemas.openxmlformats.org/officeDocument/2006/relationships" xmlns:p="http://schemas.openxmlformats.org/presentationml/2006/main">
-  <p:tag name="ALIGNMENT_TARGET_X" val="450.7086486816406"/>
+  <p:tag name="ALIGNMENT_TARGET_X" val="65.19685363769531"/>
 </p:tagLst>
 </file>
 
 <file path=ppt/tags/tag21.xml><?xml version="1.0" encoding="utf-8"?>
 <p:tagLst xmlns:a="http://schemas.openxmlformats.org/drawingml/2006/main" xmlns:r="http://schemas.openxmlformats.org/officeDocument/2006/relationships" xmlns:p="http://schemas.openxmlformats.org/presentationml/2006/main">
-  <p:tag name="ALIGNMENT_TARGET_X" val="450.7086486816406"/>
+  <p:tag name="ALIGNMENT_TARGET_X" val="104.88188934326172"/>
 </p:tagLst>
 </file>
 
 <file path=ppt/tags/tag22.xml><?xml version="1.0" encoding="utf-8"?>
 <p:tagLst xmlns:a="http://schemas.openxmlformats.org/drawingml/2006/main" xmlns:r="http://schemas.openxmlformats.org/officeDocument/2006/relationships" xmlns:p="http://schemas.openxmlformats.org/presentationml/2006/main">
-  <p:tag name="ALIGNMENT_TARGET_X" val="450.7086486816406"/>
+  <p:tag name="ALIGNMENT_TARGET_X" val="104.88188934326172"/>
 </p:tagLst>
 </file>
 
 <file path=ppt/tags/tag23.xml><?xml version="1.0" encoding="utf-8"?>
 <p:tagLst xmlns:a="http://schemas.openxmlformats.org/drawingml/2006/main" xmlns:r="http://schemas.openxmlformats.org/officeDocument/2006/relationships" xmlns:p="http://schemas.openxmlformats.org/presentationml/2006/main">
-  <p:tag name="ALIGNMENT_TARGET_X" val="738.4252014160156"/>
+  <p:tag name="ALIGNMENT_TARGET_X" val="147.40158081054688"/>
 </p:tagLst>
 </file>
 
 <file path=ppt/tags/tag24.xml><?xml version="1.0" encoding="utf-8"?>
 <p:tagLst xmlns:a="http://schemas.openxmlformats.org/drawingml/2006/main" xmlns:r="http://schemas.openxmlformats.org/officeDocument/2006/relationships" xmlns:p="http://schemas.openxmlformats.org/presentationml/2006/main">
-  <p:tag name="ALIGNMENT_TARGET_X" val="738.4252014160156"/>
+  <p:tag name="ALIGNMENT_TARGET_X" val="450.7086486816406"/>
 </p:tagLst>
 </file>
 
 <file path=ppt/tags/tag25.xml><?xml version="1.0" encoding="utf-8"?>
 <p:tagLst xmlns:a="http://schemas.openxmlformats.org/drawingml/2006/main" xmlns:r="http://schemas.openxmlformats.org/officeDocument/2006/relationships" xmlns:p="http://schemas.openxmlformats.org/presentationml/2006/main">
-  <p:tag name="ALIGNMENT_TARGET_X" val="1020.4724578857422"/>
+  <p:tag name="ALIGNMENT_TARGET_X" val="450.7086486816406"/>
 </p:tagLst>
 </file>
 
 <file path=ppt/tags/tag26.xml><?xml version="1.0" encoding="utf-8"?>
 <p:tagLst xmlns:a="http://schemas.openxmlformats.org/drawingml/2006/main" xmlns:r="http://schemas.openxmlformats.org/officeDocument/2006/relationships" xmlns:p="http://schemas.openxmlformats.org/presentationml/2006/main">
-  <p:tag name="ALIGNMENT_TARGET_X" val="1020.4724578857422"/>
+  <p:tag name="ALIGNMENT_TARGET_X" val="450.7086486816406"/>
 </p:tagLst>
 </file>
 
@@ -11255,7 +13130,7 @@
 
 <file path=ppt/tags/tag28.xml><?xml version="1.0" encoding="utf-8"?>
 <p:tagLst xmlns:a="http://schemas.openxmlformats.org/drawingml/2006/main" xmlns:r="http://schemas.openxmlformats.org/officeDocument/2006/relationships" xmlns:p="http://schemas.openxmlformats.org/presentationml/2006/main">
-  <p:tag name="ALIGNMENT_TARGET_X" val="450.7086486816406"/>
+  <p:tag name="ALIGNMENT_TARGET_X" val="738.4252014160156"/>
 </p:tagLst>
 </file>
 
@@ -11273,7 +13148,7 @@
 
 <file path=ppt/tags/tag30.xml><?xml version="1.0" encoding="utf-8"?>
 <p:tagLst xmlns:a="http://schemas.openxmlformats.org/drawingml/2006/main" xmlns:r="http://schemas.openxmlformats.org/officeDocument/2006/relationships" xmlns:p="http://schemas.openxmlformats.org/presentationml/2006/main">
-  <p:tag name="ALIGNMENT_TARGET_X" val="738.4252014160156"/>
+  <p:tag name="ALIGNMENT_TARGET_X" val="1020.4724578857422"/>
 </p:tagLst>
 </file>
 
@@ -11285,7 +13160,7 @@
 
 <file path=ppt/tags/tag32.xml><?xml version="1.0" encoding="utf-8"?>
 <p:tagLst xmlns:a="http://schemas.openxmlformats.org/drawingml/2006/main" xmlns:r="http://schemas.openxmlformats.org/officeDocument/2006/relationships" xmlns:p="http://schemas.openxmlformats.org/presentationml/2006/main">
-  <p:tag name="ALIGNMENT_TARGET_X" val="1020.4724578857422"/>
+  <p:tag name="ALIGNMENT_TARGET_X" val="450.7086486816406"/>
 </p:tagLst>
 </file>
 
@@ -11297,7 +13172,7 @@
 
 <file path=ppt/tags/tag34.xml><?xml version="1.0" encoding="utf-8"?>
 <p:tagLst xmlns:a="http://schemas.openxmlformats.org/drawingml/2006/main" xmlns:r="http://schemas.openxmlformats.org/officeDocument/2006/relationships" xmlns:p="http://schemas.openxmlformats.org/presentationml/2006/main">
-  <p:tag name="ALIGNMENT_TARGET_X" val="450.7086486816406"/>
+  <p:tag name="ALIGNMENT_TARGET_X" val="738.4252014160156"/>
 </p:tagLst>
 </file>
 
@@ -11309,25 +13184,25 @@
 
 <file path=ppt/tags/tag36.xml><?xml version="1.0" encoding="utf-8"?>
 <p:tagLst xmlns:a="http://schemas.openxmlformats.org/drawingml/2006/main" xmlns:r="http://schemas.openxmlformats.org/officeDocument/2006/relationships" xmlns:p="http://schemas.openxmlformats.org/presentationml/2006/main">
-  <p:tag name="ALIGNMENT_TARGET_X" val="738.4252014160156"/>
+  <p:tag name="ALIGNMENT_TARGET_X" val="1020.4724578857422"/>
 </p:tagLst>
 </file>
 
 <file path=ppt/tags/tag37.xml><?xml version="1.0" encoding="utf-8"?>
 <p:tagLst xmlns:a="http://schemas.openxmlformats.org/drawingml/2006/main" xmlns:r="http://schemas.openxmlformats.org/officeDocument/2006/relationships" xmlns:p="http://schemas.openxmlformats.org/presentationml/2006/main">
-  <p:tag name="ALIGNMENT_TARGET_X" val="1020.4724578857422"/>
+  <p:tag name="ALIGNMENT_TARGET_X" val="935.4330444335938"/>
 </p:tagLst>
 </file>
 
 <file path=ppt/tags/tag38.xml><?xml version="1.0" encoding="utf-8"?>
 <p:tagLst xmlns:a="http://schemas.openxmlformats.org/drawingml/2006/main" xmlns:r="http://schemas.openxmlformats.org/officeDocument/2006/relationships" xmlns:p="http://schemas.openxmlformats.org/presentationml/2006/main">
-  <p:tag name="ALIGNMENT_TARGET_X" val="1020.4724578857422"/>
+  <p:tag name="ALIGNMENT_TARGET_X" val="976.5354614257812"/>
 </p:tagLst>
 </file>
 
 <file path=ppt/tags/tag39.xml><?xml version="1.0" encoding="utf-8"?>
 <p:tagLst xmlns:a="http://schemas.openxmlformats.org/drawingml/2006/main" xmlns:r="http://schemas.openxmlformats.org/officeDocument/2006/relationships" xmlns:p="http://schemas.openxmlformats.org/presentationml/2006/main">
-  <p:tag name="ALIGNMENT_TARGET_X" val="1020.4724578857422"/>
+  <p:tag name="ALIGNMENT_TARGET_X" val="1017.6378173828125"/>
 </p:tagLst>
 </file>
 
@@ -11339,61 +13214,61 @@
 
 <file path=ppt/tags/tag40.xml><?xml version="1.0" encoding="utf-8"?>
 <p:tagLst xmlns:a="http://schemas.openxmlformats.org/drawingml/2006/main" xmlns:r="http://schemas.openxmlformats.org/officeDocument/2006/relationships" xmlns:p="http://schemas.openxmlformats.org/presentationml/2006/main">
-  <p:tag name="ALIGNMENT_TARGET_X" val="340.157470703125"/>
+  <p:tag name="ALIGNMENT_TARGET_X" val="1058.7401733398438"/>
 </p:tagLst>
 </file>
 
 <file path=ppt/tags/tag41.xml><?xml version="1.0" encoding="utf-8"?>
 <p:tagLst xmlns:a="http://schemas.openxmlformats.org/drawingml/2006/main" xmlns:r="http://schemas.openxmlformats.org/officeDocument/2006/relationships" xmlns:p="http://schemas.openxmlformats.org/presentationml/2006/main">
-  <p:tag name="ALIGNMENT_TARGET_X" val="450.7086486816406"/>
+  <p:tag name="ALIGNMENT_TARGET_X" val="1099.8424682617188"/>
 </p:tagLst>
 </file>
 
 <file path=ppt/tags/tag42.xml><?xml version="1.0" encoding="utf-8"?>
 <p:tagLst xmlns:a="http://schemas.openxmlformats.org/drawingml/2006/main" xmlns:r="http://schemas.openxmlformats.org/officeDocument/2006/relationships" xmlns:p="http://schemas.openxmlformats.org/presentationml/2006/main">
-  <p:tag name="ALIGNMENT_TARGET_X" val="728.5039367675781"/>
+  <p:tag name="ALIGNMENT_TARGET_X" val="450.7086486816406"/>
 </p:tagLst>
 </file>
 
 <file path=ppt/tags/tag43.xml><?xml version="1.0" encoding="utf-8"?>
 <p:tagLst xmlns:a="http://schemas.openxmlformats.org/drawingml/2006/main" xmlns:r="http://schemas.openxmlformats.org/officeDocument/2006/relationships" xmlns:p="http://schemas.openxmlformats.org/presentationml/2006/main">
-  <p:tag name="ALIGNMENT_TARGET_X" val="1006.2992248535156"/>
+  <p:tag name="ALIGNMENT_TARGET_X" val="450.7086486816406"/>
 </p:tagLst>
 </file>
 
 <file path=ppt/tags/tag44.xml><?xml version="1.0" encoding="utf-8"?>
 <p:tagLst xmlns:a="http://schemas.openxmlformats.org/drawingml/2006/main" xmlns:r="http://schemas.openxmlformats.org/officeDocument/2006/relationships" xmlns:p="http://schemas.openxmlformats.org/presentationml/2006/main">
-  <p:tag name="ALIGNMENT_TARGET_X" val="340.157470703125"/>
+  <p:tag name="ALIGNMENT_TARGET_X" val="738.4252014160156"/>
 </p:tagLst>
 </file>
 
 <file path=ppt/tags/tag45.xml><?xml version="1.0" encoding="utf-8"?>
 <p:tagLst xmlns:a="http://schemas.openxmlformats.org/drawingml/2006/main" xmlns:r="http://schemas.openxmlformats.org/officeDocument/2006/relationships" xmlns:p="http://schemas.openxmlformats.org/presentationml/2006/main">
-  <p:tag name="ALIGNMENT_TARGET_X" val="595.2756156921387"/>
+  <p:tag name="ALIGNMENT_TARGET_X" val="738.4252014160156"/>
 </p:tagLst>
 </file>
 
 <file path=ppt/tags/tag46.xml><?xml version="1.0" encoding="utf-8"?>
 <p:tagLst xmlns:a="http://schemas.openxmlformats.org/drawingml/2006/main" xmlns:r="http://schemas.openxmlformats.org/officeDocument/2006/relationships" xmlns:p="http://schemas.openxmlformats.org/presentationml/2006/main">
-  <p:tag name="ALIGNMENT_TARGET_X" val="45.354331970214844"/>
+  <p:tag name="ALIGNMENT_TARGET_X" val="1020.4724578857422"/>
 </p:tagLst>
 </file>
 
 <file path=ppt/tags/tag47.xml><?xml version="1.0" encoding="utf-8"?>
 <p:tagLst xmlns:a="http://schemas.openxmlformats.org/drawingml/2006/main" xmlns:r="http://schemas.openxmlformats.org/officeDocument/2006/relationships" xmlns:p="http://schemas.openxmlformats.org/presentationml/2006/main">
-  <p:tag name="ALIGNMENT_TARGET_X" val="87.87401580810547"/>
+  <p:tag name="ALIGNMENT_TARGET_X" val="1020.4724578857422"/>
 </p:tagLst>
 </file>
 
 <file path=ppt/tags/tag48.xml><?xml version="1.0" encoding="utf-8"?>
 <p:tagLst xmlns:a="http://schemas.openxmlformats.org/drawingml/2006/main" xmlns:r="http://schemas.openxmlformats.org/officeDocument/2006/relationships" xmlns:p="http://schemas.openxmlformats.org/presentationml/2006/main">
-  <p:tag name="ALIGNMENT_TARGET_X" val="45.354331970214844"/>
+  <p:tag name="ALIGNMENT_TARGET_X" val="1020.4724578857422"/>
 </p:tagLst>
 </file>
 
 <file path=ppt/tags/tag49.xml><?xml version="1.0" encoding="utf-8"?>
 <p:tagLst xmlns:a="http://schemas.openxmlformats.org/drawingml/2006/main" xmlns:r="http://schemas.openxmlformats.org/officeDocument/2006/relationships" xmlns:p="http://schemas.openxmlformats.org/presentationml/2006/main">
-  <p:tag name="ALIGNMENT_TARGET_X" val="45.354331970214844"/>
+  <p:tag name="ALIGNMENT_TARGET_X" val="340.157470703125"/>
 </p:tagLst>
 </file>
 
@@ -11405,43 +13280,43 @@
 
 <file path=ppt/tags/tag50.xml><?xml version="1.0" encoding="utf-8"?>
 <p:tagLst xmlns:a="http://schemas.openxmlformats.org/drawingml/2006/main" xmlns:r="http://schemas.openxmlformats.org/officeDocument/2006/relationships" xmlns:p="http://schemas.openxmlformats.org/presentationml/2006/main">
-  <p:tag name="ALIGNMENT_TARGET_X" val="422.3622131347656"/>
+  <p:tag name="ALIGNMENT_TARGET_X" val="450.7086486816406"/>
 </p:tagLst>
 </file>
 
 <file path=ppt/tags/tag51.xml><?xml version="1.0" encoding="utf-8"?>
 <p:tagLst xmlns:a="http://schemas.openxmlformats.org/drawingml/2006/main" xmlns:r="http://schemas.openxmlformats.org/officeDocument/2006/relationships" xmlns:p="http://schemas.openxmlformats.org/presentationml/2006/main">
-  <p:tag name="ALIGNMENT_TARGET_X" val="422.3622131347656"/>
+  <p:tag name="ALIGNMENT_TARGET_X" val="728.5039367675781"/>
 </p:tagLst>
 </file>
 
 <file path=ppt/tags/tag52.xml><?xml version="1.0" encoding="utf-8"?>
 <p:tagLst xmlns:a="http://schemas.openxmlformats.org/drawingml/2006/main" xmlns:r="http://schemas.openxmlformats.org/officeDocument/2006/relationships" xmlns:p="http://schemas.openxmlformats.org/presentationml/2006/main">
-  <p:tag name="ALIGNMENT_TARGET_X" val="799.3700561523438"/>
+  <p:tag name="ALIGNMENT_TARGET_X" val="1006.2992248535156"/>
 </p:tagLst>
 </file>
 
 <file path=ppt/tags/tag53.xml><?xml version="1.0" encoding="utf-8"?>
 <p:tagLst xmlns:a="http://schemas.openxmlformats.org/drawingml/2006/main" xmlns:r="http://schemas.openxmlformats.org/officeDocument/2006/relationships" xmlns:p="http://schemas.openxmlformats.org/presentationml/2006/main">
-  <p:tag name="ALIGNMENT_TARGET_X" val="799.3700561523438"/>
+  <p:tag name="ALIGNMENT_TARGET_X" val="340.157470703125"/>
 </p:tagLst>
 </file>
 
 <file path=ppt/tags/tag54.xml><?xml version="1.0" encoding="utf-8"?>
 <p:tagLst xmlns:a="http://schemas.openxmlformats.org/drawingml/2006/main" xmlns:r="http://schemas.openxmlformats.org/officeDocument/2006/relationships" xmlns:p="http://schemas.openxmlformats.org/presentationml/2006/main">
-  <p:tag name="ALIGNMENT_TARGET_X" val="45.354331970214844"/>
+  <p:tag name="ALIGNMENT_TARGET_X" val="595.2756156921387"/>
 </p:tagLst>
 </file>
 
 <file path=ppt/tags/tag55.xml><?xml version="1.0" encoding="utf-8"?>
 <p:tagLst xmlns:a="http://schemas.openxmlformats.org/drawingml/2006/main" xmlns:r="http://schemas.openxmlformats.org/officeDocument/2006/relationships" xmlns:p="http://schemas.openxmlformats.org/presentationml/2006/main">
-  <p:tag name="ALIGNMENT_TARGET_X" val="87.87401580810547"/>
+  <p:tag name="ALIGNMENT_TARGET_X" val="45.354331970214844"/>
 </p:tagLst>
 </file>
 
 <file path=ppt/tags/tag56.xml><?xml version="1.0" encoding="utf-8"?>
 <p:tagLst xmlns:a="http://schemas.openxmlformats.org/drawingml/2006/main" xmlns:r="http://schemas.openxmlformats.org/officeDocument/2006/relationships" xmlns:p="http://schemas.openxmlformats.org/presentationml/2006/main">
-  <p:tag name="ALIGNMENT_TARGET_X" val="45.354331970214844"/>
+  <p:tag name="ALIGNMENT_TARGET_X" val="87.87401580810547"/>
 </p:tagLst>
 </file>
 
@@ -11453,37 +13328,37 @@
 
 <file path=ppt/tags/tag58.xml><?xml version="1.0" encoding="utf-8"?>
 <p:tagLst xmlns:a="http://schemas.openxmlformats.org/drawingml/2006/main" xmlns:r="http://schemas.openxmlformats.org/officeDocument/2006/relationships" xmlns:p="http://schemas.openxmlformats.org/presentationml/2006/main">
-  <p:tag name="ALIGNMENT_TARGET_X" val="566.9291381835938"/>
+  <p:tag name="ALIGNMENT_TARGET_X" val="45.354331970214844"/>
 </p:tagLst>
 </file>
 
 <file path=ppt/tags/tag59.xml><?xml version="1.0" encoding="utf-8"?>
 <p:tagLst xmlns:a="http://schemas.openxmlformats.org/drawingml/2006/main" xmlns:r="http://schemas.openxmlformats.org/officeDocument/2006/relationships" xmlns:p="http://schemas.openxmlformats.org/presentationml/2006/main">
-  <p:tag name="ALIGNMENT_TARGET_X" val="45.354331970214844"/>
+  <p:tag name="ALIGNMENT_TARGET_X" val="422.3622131347656"/>
 </p:tagLst>
 </file>
 
 <file path=ppt/tags/tag6.xml><?xml version="1.0" encoding="utf-8"?>
 <p:tagLst xmlns:a="http://schemas.openxmlformats.org/drawingml/2006/main" xmlns:r="http://schemas.openxmlformats.org/officeDocument/2006/relationships" xmlns:p="http://schemas.openxmlformats.org/presentationml/2006/main">
-  <p:tag name="ALIGNMENT_TARGET_X" val="87.87401580810547"/>
+  <p:tag name="ALIGNMENT_TARGET_X" val="45.354331970214844"/>
 </p:tagLst>
 </file>
 
 <file path=ppt/tags/tag60.xml><?xml version="1.0" encoding="utf-8"?>
 <p:tagLst xmlns:a="http://schemas.openxmlformats.org/drawingml/2006/main" xmlns:r="http://schemas.openxmlformats.org/officeDocument/2006/relationships" xmlns:p="http://schemas.openxmlformats.org/presentationml/2006/main">
-  <p:tag name="ALIGNMENT_TARGET_X" val="566.9291381835938"/>
+  <p:tag name="ALIGNMENT_TARGET_X" val="422.3622131347656"/>
 </p:tagLst>
 </file>
 
 <file path=ppt/tags/tag61.xml><?xml version="1.0" encoding="utf-8"?>
 <p:tagLst xmlns:a="http://schemas.openxmlformats.org/drawingml/2006/main" xmlns:r="http://schemas.openxmlformats.org/officeDocument/2006/relationships" xmlns:p="http://schemas.openxmlformats.org/presentationml/2006/main">
-  <p:tag name="ALIGNMENT_TARGET_X" val="45.354331970214844"/>
+  <p:tag name="ALIGNMENT_TARGET_X" val="799.3700561523438"/>
 </p:tagLst>
 </file>
 
 <file path=ppt/tags/tag62.xml><?xml version="1.0" encoding="utf-8"?>
 <p:tagLst xmlns:a="http://schemas.openxmlformats.org/drawingml/2006/main" xmlns:r="http://schemas.openxmlformats.org/officeDocument/2006/relationships" xmlns:p="http://schemas.openxmlformats.org/presentationml/2006/main">
-  <p:tag name="ALIGNMENT_TARGET_X" val="566.9291381835938"/>
+  <p:tag name="ALIGNMENT_TARGET_X" val="799.3700561523438"/>
 </p:tagLst>
 </file>
 
@@ -11495,61 +13370,61 @@
 
 <file path=ppt/tags/tag64.xml><?xml version="1.0" encoding="utf-8"?>
 <p:tagLst xmlns:a="http://schemas.openxmlformats.org/drawingml/2006/main" xmlns:r="http://schemas.openxmlformats.org/officeDocument/2006/relationships" xmlns:p="http://schemas.openxmlformats.org/presentationml/2006/main">
-  <p:tag name="ALIGNMENT_TARGET_X" val="623.6220703125"/>
+  <p:tag name="ALIGNMENT_TARGET_X" val="87.87401580810547"/>
 </p:tagLst>
 </file>
 
 <file path=ppt/tags/tag65.xml><?xml version="1.0" encoding="utf-8"?>
 <p:tagLst xmlns:a="http://schemas.openxmlformats.org/drawingml/2006/main" xmlns:r="http://schemas.openxmlformats.org/officeDocument/2006/relationships" xmlns:p="http://schemas.openxmlformats.org/presentationml/2006/main">
-  <p:tag name="ALIGNMENT_TARGET_X" val="623.6220703125"/>
+  <p:tag name="ALIGNMENT_TARGET_X" val="45.354331970214844"/>
 </p:tagLst>
 </file>
 
 <file path=ppt/tags/tag66.xml><?xml version="1.0" encoding="utf-8"?>
 <p:tagLst xmlns:a="http://schemas.openxmlformats.org/drawingml/2006/main" xmlns:r="http://schemas.openxmlformats.org/officeDocument/2006/relationships" xmlns:p="http://schemas.openxmlformats.org/presentationml/2006/main">
-  <p:tag name="ALIGNMENT_TARGET_X" val="623.6220703125"/>
+  <p:tag name="ALIGNMENT_TARGET_X" val="45.354331970214844"/>
 </p:tagLst>
 </file>
 
 <file path=ppt/tags/tag67.xml><?xml version="1.0" encoding="utf-8"?>
 <p:tagLst xmlns:a="http://schemas.openxmlformats.org/drawingml/2006/main" xmlns:r="http://schemas.openxmlformats.org/officeDocument/2006/relationships" xmlns:p="http://schemas.openxmlformats.org/presentationml/2006/main">
-  <p:tag name="ALIGNMENT_TARGET_X" val="705.8267974853516"/>
+  <p:tag name="ALIGNMENT_TARGET_X" val="566.9291381835938"/>
 </p:tagLst>
 </file>
 
 <file path=ppt/tags/tag68.xml><?xml version="1.0" encoding="utf-8"?>
 <p:tagLst xmlns:a="http://schemas.openxmlformats.org/drawingml/2006/main" xmlns:r="http://schemas.openxmlformats.org/officeDocument/2006/relationships" xmlns:p="http://schemas.openxmlformats.org/presentationml/2006/main">
-  <p:tag name="ALIGNMENT_TARGET_X" val="705.8267974853516"/>
+  <p:tag name="ALIGNMENT_TARGET_X" val="45.354331970214844"/>
 </p:tagLst>
 </file>
 
 <file path=ppt/tags/tag69.xml><?xml version="1.0" encoding="utf-8"?>
 <p:tagLst xmlns:a="http://schemas.openxmlformats.org/drawingml/2006/main" xmlns:r="http://schemas.openxmlformats.org/officeDocument/2006/relationships" xmlns:p="http://schemas.openxmlformats.org/presentationml/2006/main">
-  <p:tag name="ALIGNMENT_TARGET_X" val="884.4094390869141"/>
+  <p:tag name="ALIGNMENT_TARGET_X" val="566.9291381835938"/>
 </p:tagLst>
 </file>
 
 <file path=ppt/tags/tag7.xml><?xml version="1.0" encoding="utf-8"?>
 <p:tagLst xmlns:a="http://schemas.openxmlformats.org/drawingml/2006/main" xmlns:r="http://schemas.openxmlformats.org/officeDocument/2006/relationships" xmlns:p="http://schemas.openxmlformats.org/presentationml/2006/main">
-  <p:tag name="ALIGNMENT_TARGET_X" val="65.19685363769531"/>
+  <p:tag name="ALIGNMENT_TARGET_X" val="87.87401580810547"/>
 </p:tagLst>
 </file>
 
 <file path=ppt/tags/tag70.xml><?xml version="1.0" encoding="utf-8"?>
 <p:tagLst xmlns:a="http://schemas.openxmlformats.org/drawingml/2006/main" xmlns:r="http://schemas.openxmlformats.org/officeDocument/2006/relationships" xmlns:p="http://schemas.openxmlformats.org/presentationml/2006/main">
-  <p:tag name="ALIGNMENT_TARGET_X" val="884.4094390869141"/>
+  <p:tag name="ALIGNMENT_TARGET_X" val="45.354331970214844"/>
 </p:tagLst>
 </file>
 
 <file path=ppt/tags/tag71.xml><?xml version="1.0" encoding="utf-8"?>
 <p:tagLst xmlns:a="http://schemas.openxmlformats.org/drawingml/2006/main" xmlns:r="http://schemas.openxmlformats.org/officeDocument/2006/relationships" xmlns:p="http://schemas.openxmlformats.org/presentationml/2006/main">
-  <p:tag name="ALIGNMENT_TARGET_X" val="1062.9921417236328"/>
+  <p:tag name="ALIGNMENT_TARGET_X" val="566.9291381835938"/>
 </p:tagLst>
 </file>
 
 <file path=ppt/tags/tag72.xml><?xml version="1.0" encoding="utf-8"?>
 <p:tagLst xmlns:a="http://schemas.openxmlformats.org/drawingml/2006/main" xmlns:r="http://schemas.openxmlformats.org/officeDocument/2006/relationships" xmlns:p="http://schemas.openxmlformats.org/presentationml/2006/main">
-  <p:tag name="ALIGNMENT_TARGET_X" val="1062.9921417236328"/>
+  <p:tag name="ALIGNMENT_TARGET_X" val="45.354331970214844"/>
 </p:tagLst>
 </file>
 
@@ -11561,25 +13436,157 @@
 
 <file path=ppt/tags/tag74.xml><?xml version="1.0" encoding="utf-8"?>
 <p:tagLst xmlns:a="http://schemas.openxmlformats.org/drawingml/2006/main" xmlns:r="http://schemas.openxmlformats.org/officeDocument/2006/relationships" xmlns:p="http://schemas.openxmlformats.org/presentationml/2006/main">
-  <p:tag name="ALIGNMENT_TARGET_X" val="45.354331970214844"/>
+  <p:tag name="ALIGNMENT_TARGET_X" val="623.6220703125"/>
 </p:tagLst>
 </file>
 
 <file path=ppt/tags/tag75.xml><?xml version="1.0" encoding="utf-8"?>
 <p:tagLst xmlns:a="http://schemas.openxmlformats.org/drawingml/2006/main" xmlns:r="http://schemas.openxmlformats.org/officeDocument/2006/relationships" xmlns:p="http://schemas.openxmlformats.org/presentationml/2006/main">
-  <p:tag name="ALIGNMENT_TARGET_X" val="45.354331970214844"/>
+  <p:tag name="ALIGNMENT_TARGET_X" val="623.6220703125"/>
+</p:tagLst>
+</file>
+
+<file path=ppt/tags/tag76.xml><?xml version="1.0" encoding="utf-8"?>
+<p:tagLst xmlns:a="http://schemas.openxmlformats.org/drawingml/2006/main" xmlns:r="http://schemas.openxmlformats.org/officeDocument/2006/relationships" xmlns:p="http://schemas.openxmlformats.org/presentationml/2006/main">
+  <p:tag name="ALIGNMENT_TARGET_X" val="705.8267974853516"/>
+</p:tagLst>
+</file>
+
+<file path=ppt/tags/tag77.xml><?xml version="1.0" encoding="utf-8"?>
+<p:tagLst xmlns:a="http://schemas.openxmlformats.org/drawingml/2006/main" xmlns:r="http://schemas.openxmlformats.org/officeDocument/2006/relationships" xmlns:p="http://schemas.openxmlformats.org/presentationml/2006/main">
+  <p:tag name="ALIGNMENT_TARGET_X" val="705.8267974853516"/>
+</p:tagLst>
+</file>
+
+<file path=ppt/tags/tag78.xml><?xml version="1.0" encoding="utf-8"?>
+<p:tagLst xmlns:a="http://schemas.openxmlformats.org/drawingml/2006/main" xmlns:r="http://schemas.openxmlformats.org/officeDocument/2006/relationships" xmlns:p="http://schemas.openxmlformats.org/presentationml/2006/main">
+  <p:tag name="ALIGNMENT_TARGET_X" val="884.4094390869141"/>
+</p:tagLst>
+</file>
+
+<file path=ppt/tags/tag79.xml><?xml version="1.0" encoding="utf-8"?>
+<p:tagLst xmlns:a="http://schemas.openxmlformats.org/drawingml/2006/main" xmlns:r="http://schemas.openxmlformats.org/officeDocument/2006/relationships" xmlns:p="http://schemas.openxmlformats.org/presentationml/2006/main">
+  <p:tag name="ALIGNMENT_TARGET_X" val="884.4094390869141"/>
 </p:tagLst>
 </file>
 
 <file path=ppt/tags/tag8.xml><?xml version="1.0" encoding="utf-8"?>
 <p:tagLst xmlns:a="http://schemas.openxmlformats.org/drawingml/2006/main" xmlns:r="http://schemas.openxmlformats.org/officeDocument/2006/relationships" xmlns:p="http://schemas.openxmlformats.org/presentationml/2006/main">
-  <p:tag name="ALIGNMENT_TARGET_X" val="104.88188934326172"/>
+  <p:tag name="ALIGNMENT_TARGET_X" val="65.19685363769531"/>
+</p:tagLst>
+</file>
+
+<file path=ppt/tags/tag80.xml><?xml version="1.0" encoding="utf-8"?>
+<p:tagLst xmlns:a="http://schemas.openxmlformats.org/drawingml/2006/main" xmlns:r="http://schemas.openxmlformats.org/officeDocument/2006/relationships" xmlns:p="http://schemas.openxmlformats.org/presentationml/2006/main">
+  <p:tag name="ALIGNMENT_TARGET_X" val="1062.9921417236328"/>
+</p:tagLst>
+</file>
+
+<file path=ppt/tags/tag81.xml><?xml version="1.0" encoding="utf-8"?>
+<p:tagLst xmlns:a="http://schemas.openxmlformats.org/drawingml/2006/main" xmlns:r="http://schemas.openxmlformats.org/officeDocument/2006/relationships" xmlns:p="http://schemas.openxmlformats.org/presentationml/2006/main">
+  <p:tag name="ALIGNMENT_TARGET_X" val="1062.9921417236328"/>
+</p:tagLst>
+</file>
+
+<file path=ppt/tags/tag82.xml><?xml version="1.0" encoding="utf-8"?>
+<p:tagLst xmlns:a="http://schemas.openxmlformats.org/drawingml/2006/main" xmlns:r="http://schemas.openxmlformats.org/officeDocument/2006/relationships" xmlns:p="http://schemas.openxmlformats.org/presentationml/2006/main">
+  <p:tag name="ALIGNMENT_TARGET_X" val="623.6220703125"/>
+</p:tagLst>
+</file>
+
+<file path=ppt/tags/tag83.xml><?xml version="1.0" encoding="utf-8"?>
+<p:tagLst xmlns:a="http://schemas.openxmlformats.org/drawingml/2006/main" xmlns:r="http://schemas.openxmlformats.org/officeDocument/2006/relationships" xmlns:p="http://schemas.openxmlformats.org/presentationml/2006/main">
+  <p:tag name="ALIGNMENT_TARGET_X" val="45.354331970214844"/>
+</p:tagLst>
+</file>
+
+<file path=ppt/tags/tag84.xml><?xml version="1.0" encoding="utf-8"?>
+<p:tagLst xmlns:a="http://schemas.openxmlformats.org/drawingml/2006/main" xmlns:r="http://schemas.openxmlformats.org/officeDocument/2006/relationships" xmlns:p="http://schemas.openxmlformats.org/presentationml/2006/main">
+  <p:tag name="ALIGNMENT_TARGET_X" val="299.0551109313965"/>
+</p:tagLst>
+</file>
+
+<file path=ppt/tags/tag85.xml><?xml version="1.0" encoding="utf-8"?>
+<p:tagLst xmlns:a="http://schemas.openxmlformats.org/drawingml/2006/main" xmlns:r="http://schemas.openxmlformats.org/officeDocument/2006/relationships" xmlns:p="http://schemas.openxmlformats.org/presentationml/2006/main">
+  <p:tag name="ALIGNMENT_TARGET_X" val="299.0551109313965"/>
+</p:tagLst>
+</file>
+
+<file path=ppt/tags/tag86.xml><?xml version="1.0" encoding="utf-8"?>
+<p:tagLst xmlns:a="http://schemas.openxmlformats.org/drawingml/2006/main" xmlns:r="http://schemas.openxmlformats.org/officeDocument/2006/relationships" xmlns:p="http://schemas.openxmlformats.org/presentationml/2006/main">
+  <p:tag name="ALIGNMENT_TARGET_X" val="398.26772689819336"/>
+</p:tagLst>
+</file>
+
+<file path=ppt/tags/tag87.xml><?xml version="1.0" encoding="utf-8"?>
+<p:tagLst xmlns:a="http://schemas.openxmlformats.org/drawingml/2006/main" xmlns:r="http://schemas.openxmlformats.org/officeDocument/2006/relationships" xmlns:p="http://schemas.openxmlformats.org/presentationml/2006/main">
+  <p:tag name="ALIGNMENT_TARGET_X" val="398.26772689819336"/>
+</p:tagLst>
+</file>
+
+<file path=ppt/tags/tag88.xml><?xml version="1.0" encoding="utf-8"?>
+<p:tagLst xmlns:a="http://schemas.openxmlformats.org/drawingml/2006/main" xmlns:r="http://schemas.openxmlformats.org/officeDocument/2006/relationships" xmlns:p="http://schemas.openxmlformats.org/presentationml/2006/main">
+  <p:tag name="ALIGNMENT_TARGET_X" val="497.4803123474121"/>
+</p:tagLst>
+</file>
+
+<file path=ppt/tags/tag89.xml><?xml version="1.0" encoding="utf-8"?>
+<p:tagLst xmlns:a="http://schemas.openxmlformats.org/drawingml/2006/main" xmlns:r="http://schemas.openxmlformats.org/officeDocument/2006/relationships" xmlns:p="http://schemas.openxmlformats.org/presentationml/2006/main">
+  <p:tag name="ALIGNMENT_TARGET_X" val="497.4803123474121"/>
 </p:tagLst>
 </file>
 
 <file path=ppt/tags/tag9.xml><?xml version="1.0" encoding="utf-8"?>
 <p:tagLst xmlns:a="http://schemas.openxmlformats.org/drawingml/2006/main" xmlns:r="http://schemas.openxmlformats.org/officeDocument/2006/relationships" xmlns:p="http://schemas.openxmlformats.org/presentationml/2006/main">
   <p:tag name="ALIGNMENT_TARGET_X" val="104.88188934326172"/>
+</p:tagLst>
+</file>
+
+<file path=ppt/tags/tag90.xml><?xml version="1.0" encoding="utf-8"?>
+<p:tagLst xmlns:a="http://schemas.openxmlformats.org/drawingml/2006/main" xmlns:r="http://schemas.openxmlformats.org/officeDocument/2006/relationships" xmlns:p="http://schemas.openxmlformats.org/presentationml/2006/main">
+  <p:tag name="ALIGNMENT_TARGET_X" val="596.692928314209"/>
+</p:tagLst>
+</file>
+
+<file path=ppt/tags/tag91.xml><?xml version="1.0" encoding="utf-8"?>
+<p:tagLst xmlns:a="http://schemas.openxmlformats.org/drawingml/2006/main" xmlns:r="http://schemas.openxmlformats.org/officeDocument/2006/relationships" xmlns:p="http://schemas.openxmlformats.org/presentationml/2006/main">
+  <p:tag name="ALIGNMENT_TARGET_X" val="596.692928314209"/>
+</p:tagLst>
+</file>
+
+<file path=ppt/tags/tag92.xml><?xml version="1.0" encoding="utf-8"?>
+<p:tagLst xmlns:a="http://schemas.openxmlformats.org/drawingml/2006/main" xmlns:r="http://schemas.openxmlformats.org/officeDocument/2006/relationships" xmlns:p="http://schemas.openxmlformats.org/presentationml/2006/main">
+  <p:tag name="ALIGNMENT_TARGET_X" val="695.9055137634277"/>
+</p:tagLst>
+</file>
+
+<file path=ppt/tags/tag93.xml><?xml version="1.0" encoding="utf-8"?>
+<p:tagLst xmlns:a="http://schemas.openxmlformats.org/drawingml/2006/main" xmlns:r="http://schemas.openxmlformats.org/officeDocument/2006/relationships" xmlns:p="http://schemas.openxmlformats.org/presentationml/2006/main">
+  <p:tag name="ALIGNMENT_TARGET_X" val="695.9055137634277"/>
+</p:tagLst>
+</file>
+
+<file path=ppt/tags/tag94.xml><?xml version="1.0" encoding="utf-8"?>
+<p:tagLst xmlns:a="http://schemas.openxmlformats.org/drawingml/2006/main" xmlns:r="http://schemas.openxmlformats.org/officeDocument/2006/relationships" xmlns:p="http://schemas.openxmlformats.org/presentationml/2006/main">
+  <p:tag name="ALIGNMENT_TARGET_X" val="795.1180992126465"/>
+</p:tagLst>
+</file>
+
+<file path=ppt/tags/tag95.xml><?xml version="1.0" encoding="utf-8"?>
+<p:tagLst xmlns:a="http://schemas.openxmlformats.org/drawingml/2006/main" xmlns:r="http://schemas.openxmlformats.org/officeDocument/2006/relationships" xmlns:p="http://schemas.openxmlformats.org/presentationml/2006/main">
+  <p:tag name="ALIGNMENT_TARGET_X" val="795.1180992126465"/>
+</p:tagLst>
+</file>
+
+<file path=ppt/tags/tag96.xml><?xml version="1.0" encoding="utf-8"?>
+<p:tagLst xmlns:a="http://schemas.openxmlformats.org/drawingml/2006/main" xmlns:r="http://schemas.openxmlformats.org/officeDocument/2006/relationships" xmlns:p="http://schemas.openxmlformats.org/presentationml/2006/main">
+  <p:tag name="ALIGNMENT_TARGET_X" val="1145.1968383789062"/>
+</p:tagLst>
+</file>
+
+<file path=ppt/tags/tag97.xml><?xml version="1.0" encoding="utf-8"?>
+<p:tagLst xmlns:a="http://schemas.openxmlformats.org/drawingml/2006/main" xmlns:r="http://schemas.openxmlformats.org/officeDocument/2006/relationships" xmlns:p="http://schemas.openxmlformats.org/presentationml/2006/main">
+  <p:tag name="ALIGNMENT_TARGET_X" val="45.354331970214844"/>
 </p:tagLst>
 </file>
 

</xml_diff>

<commit_message>
Complete finals runbook, offline operator kit and claim consistency checks
</commit_message>
<xml_diff>
--- a/deliverables/決賽海報_AI資安框架_A2.pptx
+++ b/deliverables/決賽海報_AI資安框架_A2.pptx
@@ -10375,7 +10375,7 @@
       <p:sp>
         <p:nvSpPr>
           <p:cNvPr id="129" name="TextBox 128"/>
-          <p:cNvSpPr txBox="1"/>
+          <p:cNvSpPr/>
           <p:nvPr>
             <p:custDataLst>
               <p:tags r:id="rId62"/>
@@ -10384,33 +10384,30 @@
         </p:nvSpPr>
         <p:spPr>
           <a:xfrm>
-            <a:off x="10152000" y="15300000"/>
-            <a:ext cx="4464000" cy="900000"/>
+            <a:off x="10152031" y="15300008"/>
+            <a:ext cx="4463986" cy="900017"/>
           </a:xfrm>
           <a:prstGeom prst="rect">
             <a:avLst/>
           </a:prstGeom>
           <a:noFill/>
-        </p:spPr>
-        <p:txBody>
-          <a:bodyPr wrap="none" lIns="0" tIns="0" rIns="0" bIns="0" anchor="ctr">
-            <a:spAutoFit/>
+          <a:ln>
+            <a:noFill/>
+          </a:ln>
+        </p:spPr>
+        <p:txBody>
+          <a:bodyPr wrap="none" lIns="0" tIns="47657" rIns="0" bIns="0" anchor="t" anchorCtr="0">
+            <a:noAutofit/>
           </a:bodyPr>
           <a:lstStyle/>
           <a:p>
             <a:pPr algn="l">
               <a:lnSpc>
-                <a:spcPct val="110000"/>
+                <a:spcPts val="2112"/>
               </a:lnSpc>
-              <a:spcBef>
-                <a:spcPts val="0"/>
-              </a:spcBef>
-              <a:spcAft>
-                <a:spcPts val="0"/>
-              </a:spcAft>
             </a:pPr>
             <a:r>
-              <a:rPr sz="1600" b="0">
+              <a:rPr lang="zh-CN" sz="1600" dirty="0">
                 <a:solidFill>
                   <a:srgbClr val="171C1D"/>
                 </a:solidFill>
@@ -10424,17 +10421,11 @@
           <a:p>
             <a:pPr algn="l">
               <a:lnSpc>
-                <a:spcPct val="110000"/>
+                <a:spcPts val="2112"/>
               </a:lnSpc>
-              <a:spcBef>
-                <a:spcPts val="0"/>
-              </a:spcBef>
-              <a:spcAft>
-                <a:spcPts val="0"/>
-              </a:spcAft>
             </a:pPr>
             <a:r>
-              <a:rPr sz="1600" b="0">
+              <a:rPr lang="zh-CN" sz="1600" dirty="0">
                 <a:solidFill>
                   <a:srgbClr val="171C1D"/>
                 </a:solidFill>
@@ -10442,23 +10433,17 @@
                 <a:ea typeface="DFKai-SB"/>
                 <a:cs typeface="Times New Roman"/>
               </a:rPr>
-              <a:t>HTTP型DDoS：上游清洗</a:t>
+              <a:t>HTTP型DDoS：來源限速</a:t>
             </a:r>
           </a:p>
           <a:p>
             <a:pPr algn="l">
               <a:lnSpc>
-                <a:spcPct val="110000"/>
+                <a:spcPts val="2112"/>
               </a:lnSpc>
-              <a:spcBef>
-                <a:spcPts val="0"/>
-              </a:spcBef>
-              <a:spcAft>
-                <a:spcPts val="0"/>
-              </a:spcAft>
             </a:pPr>
             <a:r>
-              <a:rPr sz="1600" b="0">
+              <a:rPr lang="zh-CN" sz="1600" dirty="0">
                 <a:solidFill>
                   <a:srgbClr val="171C1D"/>
                 </a:solidFill>
@@ -13358,7 +13343,7 @@
 
 <file path=ppt/tags/tag62.xml><?xml version="1.0" encoding="utf-8"?>
 <p:tagLst xmlns:a="http://schemas.openxmlformats.org/drawingml/2006/main" xmlns:r="http://schemas.openxmlformats.org/officeDocument/2006/relationships" xmlns:p="http://schemas.openxmlformats.org/presentationml/2006/main">
-  <p:tag name="ALIGNMENT_TARGET_X" val="799.3700561523438"/>
+  <p:tag name="ALIGNMENT_TARGET_X" val="799.3724975585938"/>
 </p:tagLst>
 </file>
 

</xml_diff>

<commit_message>
Refine cross-media visual hierarchy using current design references
</commit_message>
<xml_diff>
--- a/deliverables/決賽海報_AI資安框架_A2.pptx
+++ b/deliverables/決賽海報_AI資安框架_A2.pptx
@@ -345,7 +345,7 @@
                 <a:ea typeface="DFKai-SB"/>
                 <a:cs typeface="Times New Roman"/>
               </a:rPr>
-              <a:t>10/29/2026</a:t>
+              <a:t>10/30/2026</a:t>
             </a:fld>
             <a:endParaRPr lang="en-US">
               <a:latin typeface="Times New Roman"/>
@@ -557,7 +557,7 @@
                 <a:ea typeface="DFKai-SB"/>
                 <a:cs typeface="Times New Roman"/>
               </a:rPr>
-              <a:t>10/29/2026</a:t>
+              <a:t>10/30/2026</a:t>
             </a:fld>
             <a:endParaRPr lang="en-US">
               <a:latin typeface="Times New Roman"/>
@@ -779,7 +779,7 @@
                 <a:ea typeface="DFKai-SB"/>
                 <a:cs typeface="Times New Roman"/>
               </a:rPr>
-              <a:t>10/29/2026</a:t>
+              <a:t>10/30/2026</a:t>
             </a:fld>
             <a:endParaRPr lang="en-US">
               <a:latin typeface="Times New Roman"/>
@@ -991,7 +991,7 @@
                 <a:ea typeface="DFKai-SB"/>
                 <a:cs typeface="Times New Roman"/>
               </a:rPr>
-              <a:t>10/29/2026</a:t>
+              <a:t>10/30/2026</a:t>
             </a:fld>
             <a:endParaRPr lang="en-US">
               <a:latin typeface="Times New Roman"/>
@@ -1295,7 +1295,7 @@
                 <a:ea typeface="DFKai-SB"/>
                 <a:cs typeface="Times New Roman"/>
               </a:rPr>
-              <a:t>10/29/2026</a:t>
+              <a:t>10/30/2026</a:t>
             </a:fld>
             <a:endParaRPr lang="en-US">
               <a:latin typeface="Times New Roman"/>
@@ -1716,7 +1716,7 @@
                 <a:ea typeface="DFKai-SB"/>
                 <a:cs typeface="Times New Roman"/>
               </a:rPr>
-              <a:t>10/29/2026</a:t>
+              <a:t>10/30/2026</a:t>
             </a:fld>
             <a:endParaRPr lang="en-US">
               <a:latin typeface="Times New Roman"/>
@@ -2355,7 +2355,7 @@
                 <a:ea typeface="DFKai-SB"/>
                 <a:cs typeface="Times New Roman"/>
               </a:rPr>
-              <a:t>10/29/2026</a:t>
+              <a:t>10/30/2026</a:t>
             </a:fld>
             <a:endParaRPr lang="en-US">
               <a:latin typeface="Times New Roman"/>
@@ -2496,7 +2496,7 @@
                 <a:ea typeface="DFKai-SB"/>
                 <a:cs typeface="Times New Roman"/>
               </a:rPr>
-              <a:t>10/29/2026</a:t>
+              <a:t>10/30/2026</a:t>
             </a:fld>
             <a:endParaRPr lang="en-US">
               <a:latin typeface="Times New Roman"/>
@@ -2611,7 +2611,7 @@
                 <a:ea typeface="DFKai-SB"/>
                 <a:cs typeface="Times New Roman"/>
               </a:rPr>
-              <a:t>10/29/2026</a:t>
+              <a:t>10/30/2026</a:t>
             </a:fld>
             <a:endParaRPr lang="en-US">
               <a:latin typeface="Times New Roman"/>
@@ -3010,7 +3010,7 @@
                 <a:ea typeface="DFKai-SB"/>
                 <a:cs typeface="Times New Roman"/>
               </a:rPr>
-              <a:t>10/29/2026</a:t>
+              <a:t>10/30/2026</a:t>
             </a:fld>
             <a:endParaRPr lang="en-US">
               <a:latin typeface="Times New Roman"/>
@@ -3370,7 +3370,7 @@
                 <a:ea typeface="DFKai-SB"/>
                 <a:cs typeface="Times New Roman"/>
               </a:rPr>
-              <a:t>10/29/2026</a:t>
+              <a:t>10/30/2026</a:t>
             </a:fld>
             <a:endParaRPr lang="en-US">
               <a:latin typeface="Times New Roman"/>
@@ -3628,7 +3628,7 @@
                 <a:ea typeface="DFKai-SB"/>
                 <a:cs typeface="Times New Roman"/>
               </a:rPr>
-              <a:t>10/29/2026</a:t>
+              <a:t>10/30/2026</a:t>
             </a:fld>
             <a:endParaRPr lang="en-US">
               <a:latin typeface="Times New Roman"/>
@@ -9909,9 +9909,9 @@
           <a:p>
             <a:pPr algn="r"/>
             <a:r>
-              <a:rPr lang="zh-TW" sz="2100" b="1" dirty="0">
-                <a:solidFill>
-                  <a:srgbClr val="245EA8"/>
+              <a:rPr lang="en-US" sz="2100" b="1" dirty="0">
+                <a:solidFill>
+                  <a:srgbClr val="087F8C"/>
                 </a:solidFill>
                 <a:latin typeface="Times New Roman"/>
                 <a:ea typeface="DFKai-SB"/>
@@ -10056,16 +10056,16 @@
           </a:ln>
         </p:spPr>
         <p:txBody>
-          <a:bodyPr wrap="none" lIns="0" tIns="-5974" rIns="0" bIns="0" anchor="t" anchorCtr="0">
+          <a:bodyPr wrap="none" lIns="0" tIns="-56774" rIns="0" bIns="0" anchor="t" anchorCtr="0">
             <a:noAutofit/>
           </a:bodyPr>
           <a:lstStyle/>
           <a:p>
             <a:pPr algn="l"/>
             <a:r>
-              <a:rPr lang="en-US" sz="2800" b="1" dirty="0">
-                <a:solidFill>
-                  <a:srgbClr val="245EA8"/>
+              <a:rPr lang="en-US" sz="3200" b="1" dirty="0">
+                <a:solidFill>
+                  <a:srgbClr val="087F8C"/>
                 </a:solidFill>
                 <a:latin typeface="Times New Roman"/>
                 <a:ea typeface="DFKai-SB"/>

</xml_diff>

<commit_message>
Improve exhibit reading controls and explicit poster chart scale
</commit_message>
<xml_diff>
--- a/deliverables/決賽海報_AI資安框架_A2.pptx
+++ b/deliverables/決賽海報_AI資安框架_A2.pptx
@@ -4736,7 +4736,7 @@
           <p:nvPr/>
         </p:nvPicPr>
         <p:blipFill>
-          <a:blip r:embed="rId92"/>
+          <a:blip r:embed="rId95"/>
           <a:stretch>
             <a:fillRect/>
           </a:stretch>
@@ -5086,7 +5086,7 @@
           <p:nvPr/>
         </p:nvPicPr>
         <p:blipFill>
-          <a:blip r:embed="rId93"/>
+          <a:blip r:embed="rId96"/>
           <a:stretch>
             <a:fillRect/>
           </a:stretch>
@@ -5921,7 +5921,7 @@
           <p:nvPr/>
         </p:nvPicPr>
         <p:blipFill>
-          <a:blip r:embed="rId94"/>
+          <a:blip r:embed="rId97"/>
           <a:stretch>
             <a:fillRect/>
           </a:stretch>
@@ -10942,9 +10942,45 @@
           </a:p>
         </p:txBody>
       </p:sp>
-      <p:sp>
-        <p:nvSpPr>
-          <p:cNvPr id="139" name="TextBox 138"/>
+      <p:cxnSp>
+        <p:nvCxnSpPr>
+          <p:cNvPr id="139" name="Connector 138"/>
+          <p:cNvCxnSpPr/>
+          <p:nvPr/>
+        </p:nvCxnSpPr>
+        <p:spPr>
+          <a:xfrm>
+            <a:off x="2304000" y="19080000"/>
+            <a:ext cx="0" cy="72000"/>
+          </a:xfrm>
+          <a:prstGeom prst="line">
+            <a:avLst/>
+          </a:prstGeom>
+          <a:ln w="7620">
+            <a:solidFill>
+              <a:srgbClr val="D7E1EA"/>
+            </a:solidFill>
+          </a:ln>
+          <a:effectLst/>
+        </p:spPr>
+        <p:style>
+          <a:lnRef idx="2">
+            <a:schemeClr val="accent1"/>
+          </a:lnRef>
+          <a:fillRef idx="0">
+            <a:schemeClr val="accent1"/>
+          </a:fillRef>
+          <a:effectRef idx="1">
+            <a:schemeClr val="accent1"/>
+          </a:effectRef>
+          <a:fontRef idx="minor">
+            <a:schemeClr val="tx1"/>
+          </a:fontRef>
+        </p:style>
+      </p:cxnSp>
+      <p:sp>
+        <p:nvSpPr>
+          <p:cNvPr id="140" name="TextBox 139"/>
           <p:cNvSpPr txBox="1"/>
           <p:nvPr>
             <p:custDataLst>
@@ -10954,8 +10990,8 @@
         </p:nvSpPr>
         <p:spPr>
           <a:xfrm>
-            <a:off x="550600" y="19260000"/>
-            <a:ext cx="6624000" cy="324000"/>
+            <a:off x="1960950" y="19152000"/>
+            <a:ext cx="648000" cy="216000"/>
           </a:xfrm>
           <a:prstGeom prst="rect">
             <a:avLst/>
@@ -10980,6 +11016,231 @@
               </a:spcAft>
             </a:pPr>
             <a:r>
+              <a:rPr sz="1200" b="0">
+                <a:solidFill>
+                  <a:srgbClr val="526477"/>
+                </a:solidFill>
+                <a:latin typeface="Times New Roman"/>
+                <a:ea typeface="DFKai-SB"/>
+                <a:cs typeface="Times New Roman"/>
+              </a:rPr>
+              <a:t>0%</a:t>
+            </a:r>
+          </a:p>
+        </p:txBody>
+      </p:sp>
+      <p:cxnSp>
+        <p:nvCxnSpPr>
+          <p:cNvPr id="141" name="Connector 140"/>
+          <p:cNvCxnSpPr/>
+          <p:nvPr/>
+        </p:nvCxnSpPr>
+        <p:spPr>
+          <a:xfrm>
+            <a:off x="3996000" y="19080000"/>
+            <a:ext cx="0" cy="72000"/>
+          </a:xfrm>
+          <a:prstGeom prst="line">
+            <a:avLst/>
+          </a:prstGeom>
+          <a:ln w="7620">
+            <a:solidFill>
+              <a:srgbClr val="D7E1EA"/>
+            </a:solidFill>
+          </a:ln>
+          <a:effectLst/>
+        </p:spPr>
+        <p:style>
+          <a:lnRef idx="2">
+            <a:schemeClr val="accent1"/>
+          </a:lnRef>
+          <a:fillRef idx="0">
+            <a:schemeClr val="accent1"/>
+          </a:fillRef>
+          <a:effectRef idx="1">
+            <a:schemeClr val="accent1"/>
+          </a:effectRef>
+          <a:fontRef idx="minor">
+            <a:schemeClr val="tx1"/>
+          </a:fontRef>
+        </p:style>
+      </p:cxnSp>
+      <p:sp>
+        <p:nvSpPr>
+          <p:cNvPr id="142" name="TextBox 141"/>
+          <p:cNvSpPr txBox="1"/>
+          <p:nvPr>
+            <p:custDataLst>
+              <p:tags r:id="rId66"/>
+            </p:custDataLst>
+          </p:nvPr>
+        </p:nvSpPr>
+        <p:spPr>
+          <a:xfrm>
+            <a:off x="3652950" y="19152000"/>
+            <a:ext cx="648000" cy="216000"/>
+          </a:xfrm>
+          <a:prstGeom prst="rect">
+            <a:avLst/>
+          </a:prstGeom>
+          <a:noFill/>
+        </p:spPr>
+        <p:txBody>
+          <a:bodyPr wrap="none" lIns="0" tIns="0" rIns="0" bIns="0" anchor="ctr">
+            <a:spAutoFit/>
+          </a:bodyPr>
+          <a:lstStyle/>
+          <a:p>
+            <a:pPr algn="ctr">
+              <a:lnSpc>
+                <a:spcPct val="110000"/>
+              </a:lnSpc>
+              <a:spcBef>
+                <a:spcPts val="0"/>
+              </a:spcBef>
+              <a:spcAft>
+                <a:spcPts val="0"/>
+              </a:spcAft>
+            </a:pPr>
+            <a:r>
+              <a:rPr sz="1200" b="0">
+                <a:solidFill>
+                  <a:srgbClr val="526477"/>
+                </a:solidFill>
+                <a:latin typeface="Times New Roman"/>
+                <a:ea typeface="DFKai-SB"/>
+                <a:cs typeface="Times New Roman"/>
+              </a:rPr>
+              <a:t>50%</a:t>
+            </a:r>
+          </a:p>
+        </p:txBody>
+      </p:sp>
+      <p:cxnSp>
+        <p:nvCxnSpPr>
+          <p:cNvPr id="143" name="Connector 142"/>
+          <p:cNvCxnSpPr/>
+          <p:nvPr/>
+        </p:nvCxnSpPr>
+        <p:spPr>
+          <a:xfrm>
+            <a:off x="5688000" y="19080000"/>
+            <a:ext cx="0" cy="72000"/>
+          </a:xfrm>
+          <a:prstGeom prst="line">
+            <a:avLst/>
+          </a:prstGeom>
+          <a:ln w="7620">
+            <a:solidFill>
+              <a:srgbClr val="D7E1EA"/>
+            </a:solidFill>
+          </a:ln>
+          <a:effectLst/>
+        </p:spPr>
+        <p:style>
+          <a:lnRef idx="2">
+            <a:schemeClr val="accent1"/>
+          </a:lnRef>
+          <a:fillRef idx="0">
+            <a:schemeClr val="accent1"/>
+          </a:fillRef>
+          <a:effectRef idx="1">
+            <a:schemeClr val="accent1"/>
+          </a:effectRef>
+          <a:fontRef idx="minor">
+            <a:schemeClr val="tx1"/>
+          </a:fontRef>
+        </p:style>
+      </p:cxnSp>
+      <p:sp>
+        <p:nvSpPr>
+          <p:cNvPr id="144" name="TextBox 143"/>
+          <p:cNvSpPr txBox="1"/>
+          <p:nvPr>
+            <p:custDataLst>
+              <p:tags r:id="rId67"/>
+            </p:custDataLst>
+          </p:nvPr>
+        </p:nvSpPr>
+        <p:spPr>
+          <a:xfrm>
+            <a:off x="5344950" y="19152000"/>
+            <a:ext cx="648000" cy="216000"/>
+          </a:xfrm>
+          <a:prstGeom prst="rect">
+            <a:avLst/>
+          </a:prstGeom>
+          <a:noFill/>
+        </p:spPr>
+        <p:txBody>
+          <a:bodyPr wrap="none" lIns="0" tIns="0" rIns="0" bIns="0" anchor="ctr">
+            <a:spAutoFit/>
+          </a:bodyPr>
+          <a:lstStyle/>
+          <a:p>
+            <a:pPr algn="ctr">
+              <a:lnSpc>
+                <a:spcPct val="110000"/>
+              </a:lnSpc>
+              <a:spcBef>
+                <a:spcPts val="0"/>
+              </a:spcBef>
+              <a:spcAft>
+                <a:spcPts val="0"/>
+              </a:spcAft>
+            </a:pPr>
+            <a:r>
+              <a:rPr sz="1200" b="0">
+                <a:solidFill>
+                  <a:srgbClr val="526477"/>
+                </a:solidFill>
+                <a:latin typeface="Times New Roman"/>
+                <a:ea typeface="DFKai-SB"/>
+                <a:cs typeface="Times New Roman"/>
+              </a:rPr>
+              <a:t>100%</a:t>
+            </a:r>
+          </a:p>
+        </p:txBody>
+      </p:sp>
+      <p:sp>
+        <p:nvSpPr>
+          <p:cNvPr id="145" name="TextBox 144"/>
+          <p:cNvSpPr txBox="1"/>
+          <p:nvPr>
+            <p:custDataLst>
+              <p:tags r:id="rId68"/>
+            </p:custDataLst>
+          </p:nvPr>
+        </p:nvSpPr>
+        <p:spPr>
+          <a:xfrm>
+            <a:off x="550600" y="19440000"/>
+            <a:ext cx="6624000" cy="324000"/>
+          </a:xfrm>
+          <a:prstGeom prst="rect">
+            <a:avLst/>
+          </a:prstGeom>
+          <a:noFill/>
+        </p:spPr>
+        <p:txBody>
+          <a:bodyPr wrap="none" lIns="0" tIns="0" rIns="0" bIns="0" anchor="ctr">
+            <a:spAutoFit/>
+          </a:bodyPr>
+          <a:lstStyle/>
+          <a:p>
+            <a:pPr algn="ctr">
+              <a:lnSpc>
+                <a:spcPct val="110000"/>
+              </a:lnSpc>
+              <a:spcBef>
+                <a:spcPts val="0"/>
+              </a:spcBef>
+              <a:spcAft>
+                <a:spcPts val="0"/>
+              </a:spcAft>
+            </a:pPr>
+            <a:r>
               <a:rPr sz="1600" b="0">
                 <a:solidFill>
                   <a:srgbClr val="526477"/>
@@ -10995,7 +11256,7 @@
       </p:sp>
       <p:cxnSp>
         <p:nvCxnSpPr>
-          <p:cNvPr id="140" name="Connector 139"/>
+          <p:cNvPr id="146" name="Connector 145"/>
           <p:cNvCxnSpPr/>
           <p:nvPr/>
         </p:nvCxnSpPr>
@@ -11031,11 +11292,11 @@
       </p:cxnSp>
       <p:sp>
         <p:nvSpPr>
-          <p:cNvPr id="141" name="TextBox 140"/>
+          <p:cNvPr id="147" name="TextBox 146"/>
           <p:cNvSpPr txBox="1"/>
           <p:nvPr>
             <p:custDataLst>
-              <p:tags r:id="rId66"/>
+              <p:tags r:id="rId69"/>
             </p:custDataLst>
           </p:nvPr>
         </p:nvSpPr>
@@ -11082,11 +11343,11 @@
       </p:sp>
       <p:sp>
         <p:nvSpPr>
-          <p:cNvPr id="142" name="TextBox 141"/>
+          <p:cNvPr id="148" name="TextBox 147"/>
           <p:cNvSpPr txBox="1"/>
           <p:nvPr>
             <p:custDataLst>
-              <p:tags r:id="rId67"/>
+              <p:tags r:id="rId70"/>
             </p:custDataLst>
           </p:nvPr>
         </p:nvSpPr>
@@ -11133,11 +11394,11 @@
       </p:sp>
       <p:sp>
         <p:nvSpPr>
-          <p:cNvPr id="143" name="TextBox 142"/>
+          <p:cNvPr id="149" name="TextBox 148"/>
           <p:cNvSpPr txBox="1"/>
           <p:nvPr>
             <p:custDataLst>
-              <p:tags r:id="rId68"/>
+              <p:tags r:id="rId71"/>
             </p:custDataLst>
           </p:nvPr>
         </p:nvSpPr>
@@ -11184,11 +11445,11 @@
       </p:sp>
       <p:sp>
         <p:nvSpPr>
-          <p:cNvPr id="144" name="TextBox 143"/>
+          <p:cNvPr id="150" name="TextBox 149"/>
           <p:cNvSpPr txBox="1"/>
           <p:nvPr>
             <p:custDataLst>
-              <p:tags r:id="rId69"/>
+              <p:tags r:id="rId72"/>
             </p:custDataLst>
           </p:nvPr>
         </p:nvSpPr>
@@ -11235,11 +11496,11 @@
       </p:sp>
       <p:sp>
         <p:nvSpPr>
-          <p:cNvPr id="145" name="TextBox 144"/>
+          <p:cNvPr id="151" name="TextBox 150"/>
           <p:cNvSpPr txBox="1"/>
           <p:nvPr>
             <p:custDataLst>
-              <p:tags r:id="rId70"/>
+              <p:tags r:id="rId73"/>
             </p:custDataLst>
           </p:nvPr>
         </p:nvSpPr>
@@ -11286,11 +11547,11 @@
       </p:sp>
       <p:sp>
         <p:nvSpPr>
-          <p:cNvPr id="146" name="TextBox 145"/>
+          <p:cNvPr id="152" name="TextBox 151"/>
           <p:cNvSpPr txBox="1"/>
           <p:nvPr>
             <p:custDataLst>
-              <p:tags r:id="rId71"/>
+              <p:tags r:id="rId74"/>
             </p:custDataLst>
           </p:nvPr>
         </p:nvSpPr>
@@ -11337,11 +11598,11 @@
       </p:sp>
       <p:sp>
         <p:nvSpPr>
-          <p:cNvPr id="147" name="TextBox 146"/>
+          <p:cNvPr id="153" name="TextBox 152"/>
           <p:cNvSpPr txBox="1"/>
           <p:nvPr>
             <p:custDataLst>
-              <p:tags r:id="rId72"/>
+              <p:tags r:id="rId75"/>
             </p:custDataLst>
           </p:nvPr>
         </p:nvSpPr>
@@ -11388,11 +11649,11 @@
       </p:sp>
       <p:sp>
         <p:nvSpPr>
-          <p:cNvPr id="148" name="TextBox 147"/>
+          <p:cNvPr id="154" name="TextBox 153"/>
           <p:cNvSpPr txBox="1"/>
           <p:nvPr>
             <p:custDataLst>
-              <p:tags r:id="rId73"/>
+              <p:tags r:id="rId76"/>
             </p:custDataLst>
           </p:nvPr>
         </p:nvSpPr>
@@ -11439,11 +11700,11 @@
       </p:sp>
       <p:sp>
         <p:nvSpPr>
-          <p:cNvPr id="149" name="TextBox 148"/>
+          <p:cNvPr id="155" name="TextBox 154"/>
           <p:cNvSpPr txBox="1"/>
           <p:nvPr>
             <p:custDataLst>
-              <p:tags r:id="rId74"/>
+              <p:tags r:id="rId77"/>
             </p:custDataLst>
           </p:nvPr>
         </p:nvSpPr>
@@ -11490,11 +11751,11 @@
       </p:sp>
       <p:sp>
         <p:nvSpPr>
-          <p:cNvPr id="150" name="TextBox 149"/>
+          <p:cNvPr id="156" name="TextBox 155"/>
           <p:cNvSpPr txBox="1"/>
           <p:nvPr>
             <p:custDataLst>
-              <p:tags r:id="rId75"/>
+              <p:tags r:id="rId78"/>
             </p:custDataLst>
           </p:nvPr>
         </p:nvSpPr>
@@ -11565,7 +11826,7 @@
       </p:sp>
       <p:cxnSp>
         <p:nvCxnSpPr>
-          <p:cNvPr id="151" name="Connector 150"/>
+          <p:cNvPr id="157" name="Connector 156"/>
           <p:cNvCxnSpPr/>
           <p:nvPr/>
         </p:nvCxnSpPr>
@@ -11601,11 +11862,11 @@
       </p:cxnSp>
       <p:sp>
         <p:nvSpPr>
-          <p:cNvPr id="152" name="TextBox 151"/>
+          <p:cNvPr id="158" name="TextBox 157"/>
           <p:cNvSpPr txBox="1"/>
           <p:nvPr>
             <p:custDataLst>
-              <p:tags r:id="rId76"/>
+              <p:tags r:id="rId79"/>
             </p:custDataLst>
           </p:nvPr>
         </p:nvSpPr>
@@ -11676,7 +11937,7 @@
       </p:sp>
       <p:sp>
         <p:nvSpPr>
-          <p:cNvPr id="153" name="Rectangle 152"/>
+          <p:cNvPr id="159" name="Rectangle 158"/>
           <p:cNvSpPr/>
           <p:nvPr/>
         </p:nvSpPr>
@@ -11727,11 +11988,11 @@
       </p:sp>
       <p:sp>
         <p:nvSpPr>
-          <p:cNvPr id="154" name="TextBox 153"/>
+          <p:cNvPr id="160" name="TextBox 159"/>
           <p:cNvSpPr txBox="1"/>
           <p:nvPr>
             <p:custDataLst>
-              <p:tags r:id="rId77"/>
+              <p:tags r:id="rId80"/>
             </p:custDataLst>
           </p:nvPr>
         </p:nvSpPr>
@@ -11778,11 +12039,11 @@
       </p:sp>
       <p:sp>
         <p:nvSpPr>
-          <p:cNvPr id="155" name="TextBox 154"/>
+          <p:cNvPr id="161" name="TextBox 160"/>
           <p:cNvSpPr txBox="1"/>
           <p:nvPr>
             <p:custDataLst>
-              <p:tags r:id="rId78"/>
+              <p:tags r:id="rId81"/>
             </p:custDataLst>
           </p:nvPr>
         </p:nvSpPr>
@@ -11829,7 +12090,7 @@
       </p:sp>
       <p:sp>
         <p:nvSpPr>
-          <p:cNvPr id="156" name="Rectangle 155"/>
+          <p:cNvPr id="162" name="Rectangle 161"/>
           <p:cNvSpPr/>
           <p:nvPr/>
         </p:nvSpPr>
@@ -11880,11 +12141,11 @@
       </p:sp>
       <p:sp>
         <p:nvSpPr>
-          <p:cNvPr id="157" name="TextBox 156"/>
+          <p:cNvPr id="163" name="TextBox 162"/>
           <p:cNvSpPr txBox="1"/>
           <p:nvPr>
             <p:custDataLst>
-              <p:tags r:id="rId79"/>
+              <p:tags r:id="rId82"/>
             </p:custDataLst>
           </p:nvPr>
         </p:nvSpPr>
@@ -11931,11 +12192,11 @@
       </p:sp>
       <p:sp>
         <p:nvSpPr>
-          <p:cNvPr id="158" name="TextBox 157"/>
+          <p:cNvPr id="164" name="TextBox 163"/>
           <p:cNvSpPr txBox="1"/>
           <p:nvPr>
             <p:custDataLst>
-              <p:tags r:id="rId80"/>
+              <p:tags r:id="rId83"/>
             </p:custDataLst>
           </p:nvPr>
         </p:nvSpPr>
@@ -11982,7 +12243,7 @@
       </p:sp>
       <p:sp>
         <p:nvSpPr>
-          <p:cNvPr id="159" name="Rectangle 158"/>
+          <p:cNvPr id="165" name="Rectangle 164"/>
           <p:cNvSpPr/>
           <p:nvPr/>
         </p:nvSpPr>
@@ -12033,11 +12294,11 @@
       </p:sp>
       <p:sp>
         <p:nvSpPr>
-          <p:cNvPr id="160" name="TextBox 159"/>
+          <p:cNvPr id="166" name="TextBox 165"/>
           <p:cNvSpPr txBox="1"/>
           <p:nvPr>
             <p:custDataLst>
-              <p:tags r:id="rId81"/>
+              <p:tags r:id="rId84"/>
             </p:custDataLst>
           </p:nvPr>
         </p:nvSpPr>
@@ -12084,11 +12345,11 @@
       </p:sp>
       <p:sp>
         <p:nvSpPr>
-          <p:cNvPr id="161" name="TextBox 160"/>
+          <p:cNvPr id="167" name="TextBox 166"/>
           <p:cNvSpPr txBox="1"/>
           <p:nvPr>
             <p:custDataLst>
-              <p:tags r:id="rId82"/>
+              <p:tags r:id="rId85"/>
             </p:custDataLst>
           </p:nvPr>
         </p:nvSpPr>
@@ -12135,7 +12396,7 @@
       </p:sp>
       <p:sp>
         <p:nvSpPr>
-          <p:cNvPr id="162" name="Rectangle 161"/>
+          <p:cNvPr id="168" name="Rectangle 167"/>
           <p:cNvSpPr/>
           <p:nvPr/>
         </p:nvSpPr>
@@ -12186,11 +12447,11 @@
       </p:sp>
       <p:sp>
         <p:nvSpPr>
-          <p:cNvPr id="163" name="TextBox 162"/>
+          <p:cNvPr id="169" name="TextBox 168"/>
           <p:cNvSpPr txBox="1"/>
           <p:nvPr>
             <p:custDataLst>
-              <p:tags r:id="rId83"/>
+              <p:tags r:id="rId86"/>
             </p:custDataLst>
           </p:nvPr>
         </p:nvSpPr>
@@ -12237,11 +12498,11 @@
       </p:sp>
       <p:sp>
         <p:nvSpPr>
-          <p:cNvPr id="164" name="TextBox 163"/>
+          <p:cNvPr id="170" name="TextBox 169"/>
           <p:cNvSpPr txBox="1"/>
           <p:nvPr>
             <p:custDataLst>
-              <p:tags r:id="rId84"/>
+              <p:tags r:id="rId87"/>
             </p:custDataLst>
           </p:nvPr>
         </p:nvSpPr>
@@ -12288,7 +12549,7 @@
       </p:sp>
       <p:sp>
         <p:nvSpPr>
-          <p:cNvPr id="165" name="Rectangle 164"/>
+          <p:cNvPr id="171" name="Rectangle 170"/>
           <p:cNvSpPr/>
           <p:nvPr/>
         </p:nvSpPr>
@@ -12339,11 +12600,11 @@
       </p:sp>
       <p:sp>
         <p:nvSpPr>
-          <p:cNvPr id="166" name="TextBox 165"/>
+          <p:cNvPr id="172" name="TextBox 171"/>
           <p:cNvSpPr txBox="1"/>
           <p:nvPr>
             <p:custDataLst>
-              <p:tags r:id="rId85"/>
+              <p:tags r:id="rId88"/>
             </p:custDataLst>
           </p:nvPr>
         </p:nvSpPr>
@@ -12390,11 +12651,11 @@
       </p:sp>
       <p:sp>
         <p:nvSpPr>
-          <p:cNvPr id="167" name="TextBox 166"/>
+          <p:cNvPr id="173" name="TextBox 172"/>
           <p:cNvSpPr txBox="1"/>
           <p:nvPr>
             <p:custDataLst>
-              <p:tags r:id="rId86"/>
+              <p:tags r:id="rId89"/>
             </p:custDataLst>
           </p:nvPr>
         </p:nvSpPr>
@@ -12441,7 +12702,7 @@
       </p:sp>
       <p:sp>
         <p:nvSpPr>
-          <p:cNvPr id="168" name="Rectangle 167"/>
+          <p:cNvPr id="174" name="Rectangle 173"/>
           <p:cNvSpPr/>
           <p:nvPr/>
         </p:nvSpPr>
@@ -12492,11 +12753,11 @@
       </p:sp>
       <p:sp>
         <p:nvSpPr>
-          <p:cNvPr id="169" name="TextBox 168"/>
+          <p:cNvPr id="175" name="TextBox 174"/>
           <p:cNvSpPr txBox="1"/>
           <p:nvPr>
             <p:custDataLst>
-              <p:tags r:id="rId87"/>
+              <p:tags r:id="rId90"/>
             </p:custDataLst>
           </p:nvPr>
         </p:nvSpPr>
@@ -12543,11 +12804,11 @@
       </p:sp>
       <p:sp>
         <p:nvSpPr>
-          <p:cNvPr id="170" name="TextBox 169"/>
+          <p:cNvPr id="176" name="TextBox 175"/>
           <p:cNvSpPr txBox="1"/>
           <p:nvPr>
             <p:custDataLst>
-              <p:tags r:id="rId88"/>
+              <p:tags r:id="rId91"/>
             </p:custDataLst>
           </p:nvPr>
         </p:nvSpPr>
@@ -12594,11 +12855,11 @@
       </p:sp>
       <p:sp>
         <p:nvSpPr>
-          <p:cNvPr id="171" name="TextBox 170"/>
+          <p:cNvPr id="177" name="TextBox 176"/>
           <p:cNvSpPr txBox="1"/>
           <p:nvPr>
             <p:custDataLst>
-              <p:tags r:id="rId89"/>
+              <p:tags r:id="rId92"/>
             </p:custDataLst>
           </p:nvPr>
         </p:nvSpPr>
@@ -12669,11 +12930,11 @@
       </p:sp>
       <p:sp>
         <p:nvSpPr>
-          <p:cNvPr id="172" name="TextBox 171"/>
+          <p:cNvPr id="178" name="TextBox 177"/>
           <p:cNvSpPr txBox="1"/>
           <p:nvPr>
             <p:custDataLst>
-              <p:tags r:id="rId90"/>
+              <p:tags r:id="rId93"/>
             </p:custDataLst>
           </p:nvPr>
         </p:nvSpPr>
@@ -13094,31 +13355,31 @@
 
 <file path=ppt/tags/tag65.xml><?xml version="1.0" encoding="utf-8"?>
 <p:tagLst xmlns:a="http://schemas.openxmlformats.org/drawingml/2006/main" xmlns:r="http://schemas.openxmlformats.org/officeDocument/2006/relationships" xmlns:p="http://schemas.openxmlformats.org/presentationml/2006/main">
-  <p:tag name="ALIGNMENT_TARGET_X" val="306.1417465209961"/>
+  <p:tag name="ALIGNMENT_TARGET_X" val="181.41732788085938"/>
 </p:tagLst>
 </file>
 
 <file path=ppt/tags/tag66.xml><?xml version="1.0" encoding="utf-8"?>
 <p:tagLst xmlns:a="http://schemas.openxmlformats.org/drawingml/2006/main" xmlns:r="http://schemas.openxmlformats.org/officeDocument/2006/relationships" xmlns:p="http://schemas.openxmlformats.org/presentationml/2006/main">
-  <p:tag name="ALIGNMENT_TARGET_X" val="884.4094848632812"/>
+  <p:tag name="ALIGNMENT_TARGET_X" val="314.6456604003906"/>
 </p:tagLst>
 </file>
 
 <file path=ppt/tags/tag67.xml><?xml version="1.0" encoding="utf-8"?>
 <p:tagLst xmlns:a="http://schemas.openxmlformats.org/drawingml/2006/main" xmlns:r="http://schemas.openxmlformats.org/officeDocument/2006/relationships" xmlns:p="http://schemas.openxmlformats.org/presentationml/2006/main">
-  <p:tag name="ALIGNMENT_TARGET_X" val="884.4094848632812"/>
+  <p:tag name="ALIGNMENT_TARGET_X" val="447.8740234375"/>
 </p:tagLst>
 </file>
 
 <file path=ppt/tags/tag68.xml><?xml version="1.0" encoding="utf-8"?>
 <p:tagLst xmlns:a="http://schemas.openxmlformats.org/drawingml/2006/main" xmlns:r="http://schemas.openxmlformats.org/officeDocument/2006/relationships" xmlns:p="http://schemas.openxmlformats.org/presentationml/2006/main">
-  <p:tag name="ALIGNMENT_TARGET_X" val="884.4094848632812"/>
+  <p:tag name="ALIGNMENT_TARGET_X" val="306.1417465209961"/>
 </p:tagLst>
 </file>
 
 <file path=ppt/tags/tag69.xml><?xml version="1.0" encoding="utf-8"?>
 <p:tagLst xmlns:a="http://schemas.openxmlformats.org/drawingml/2006/main" xmlns:r="http://schemas.openxmlformats.org/officeDocument/2006/relationships" xmlns:p="http://schemas.openxmlformats.org/presentationml/2006/main">
-  <p:tag name="ALIGNMENT_TARGET_X" val="705.8267974853516"/>
+  <p:tag name="ALIGNMENT_TARGET_X" val="884.4094848632812"/>
 </p:tagLst>
 </file>
 
@@ -13130,61 +13391,61 @@
 
 <file path=ppt/tags/tag70.xml><?xml version="1.0" encoding="utf-8"?>
 <p:tagLst xmlns:a="http://schemas.openxmlformats.org/drawingml/2006/main" xmlns:r="http://schemas.openxmlformats.org/officeDocument/2006/relationships" xmlns:p="http://schemas.openxmlformats.org/presentationml/2006/main">
-  <p:tag name="ALIGNMENT_TARGET_X" val="705.8267974853516"/>
+  <p:tag name="ALIGNMENT_TARGET_X" val="884.4094848632812"/>
 </p:tagLst>
 </file>
 
 <file path=ppt/tags/tag71.xml><?xml version="1.0" encoding="utf-8"?>
 <p:tagLst xmlns:a="http://schemas.openxmlformats.org/drawingml/2006/main" xmlns:r="http://schemas.openxmlformats.org/officeDocument/2006/relationships" xmlns:p="http://schemas.openxmlformats.org/presentationml/2006/main">
-  <p:tag name="ALIGNMENT_TARGET_X" val="884.4094390869141"/>
+  <p:tag name="ALIGNMENT_TARGET_X" val="884.4094848632812"/>
 </p:tagLst>
 </file>
 
 <file path=ppt/tags/tag72.xml><?xml version="1.0" encoding="utf-8"?>
 <p:tagLst xmlns:a="http://schemas.openxmlformats.org/drawingml/2006/main" xmlns:r="http://schemas.openxmlformats.org/officeDocument/2006/relationships" xmlns:p="http://schemas.openxmlformats.org/presentationml/2006/main">
-  <p:tag name="ALIGNMENT_TARGET_X" val="884.4094390869141"/>
+  <p:tag name="ALIGNMENT_TARGET_X" val="705.8267974853516"/>
 </p:tagLst>
 </file>
 
 <file path=ppt/tags/tag73.xml><?xml version="1.0" encoding="utf-8"?>
 <p:tagLst xmlns:a="http://schemas.openxmlformats.org/drawingml/2006/main" xmlns:r="http://schemas.openxmlformats.org/officeDocument/2006/relationships" xmlns:p="http://schemas.openxmlformats.org/presentationml/2006/main">
-  <p:tag name="ALIGNMENT_TARGET_X" val="1062.9921417236328"/>
+  <p:tag name="ALIGNMENT_TARGET_X" val="705.8267974853516"/>
 </p:tagLst>
 </file>
 
 <file path=ppt/tags/tag74.xml><?xml version="1.0" encoding="utf-8"?>
 <p:tagLst xmlns:a="http://schemas.openxmlformats.org/drawingml/2006/main" xmlns:r="http://schemas.openxmlformats.org/officeDocument/2006/relationships" xmlns:p="http://schemas.openxmlformats.org/presentationml/2006/main">
-  <p:tag name="ALIGNMENT_TARGET_X" val="1062.9921417236328"/>
+  <p:tag name="ALIGNMENT_TARGET_X" val="884.4094390869141"/>
 </p:tagLst>
 </file>
 
 <file path=ppt/tags/tag75.xml><?xml version="1.0" encoding="utf-8"?>
 <p:tagLst xmlns:a="http://schemas.openxmlformats.org/drawingml/2006/main" xmlns:r="http://schemas.openxmlformats.org/officeDocument/2006/relationships" xmlns:p="http://schemas.openxmlformats.org/presentationml/2006/main">
-  <p:tag name="ALIGNMENT_TARGET_X" val="884.4094848632812"/>
+  <p:tag name="ALIGNMENT_TARGET_X" val="884.4094390869141"/>
 </p:tagLst>
 </file>
 
 <file path=ppt/tags/tag76.xml><?xml version="1.0" encoding="utf-8"?>
 <p:tagLst xmlns:a="http://schemas.openxmlformats.org/drawingml/2006/main" xmlns:r="http://schemas.openxmlformats.org/officeDocument/2006/relationships" xmlns:p="http://schemas.openxmlformats.org/presentationml/2006/main">
-  <p:tag name="ALIGNMENT_TARGET_X" val="140.3149642944336"/>
+  <p:tag name="ALIGNMENT_TARGET_X" val="1062.9921417236328"/>
 </p:tagLst>
 </file>
 
 <file path=ppt/tags/tag77.xml><?xml version="1.0" encoding="utf-8"?>
 <p:tagLst xmlns:a="http://schemas.openxmlformats.org/drawingml/2006/main" xmlns:r="http://schemas.openxmlformats.org/officeDocument/2006/relationships" xmlns:p="http://schemas.openxmlformats.org/presentationml/2006/main">
-  <p:tag name="ALIGNMENT_TARGET_X" val="299.0551109313965"/>
+  <p:tag name="ALIGNMENT_TARGET_X" val="1062.9921417236328"/>
 </p:tagLst>
 </file>
 
 <file path=ppt/tags/tag78.xml><?xml version="1.0" encoding="utf-8"?>
 <p:tagLst xmlns:a="http://schemas.openxmlformats.org/drawingml/2006/main" xmlns:r="http://schemas.openxmlformats.org/officeDocument/2006/relationships" xmlns:p="http://schemas.openxmlformats.org/presentationml/2006/main">
-  <p:tag name="ALIGNMENT_TARGET_X" val="299.0551109313965"/>
+  <p:tag name="ALIGNMENT_TARGET_X" val="884.4094848632812"/>
 </p:tagLst>
 </file>
 
 <file path=ppt/tags/tag79.xml><?xml version="1.0" encoding="utf-8"?>
 <p:tagLst xmlns:a="http://schemas.openxmlformats.org/drawingml/2006/main" xmlns:r="http://schemas.openxmlformats.org/officeDocument/2006/relationships" xmlns:p="http://schemas.openxmlformats.org/presentationml/2006/main">
-  <p:tag name="ALIGNMENT_TARGET_X" val="398.26772689819336"/>
+  <p:tag name="ALIGNMENT_TARGET_X" val="140.3149642944336"/>
 </p:tagLst>
 </file>
 
@@ -13196,61 +13457,61 @@
 
 <file path=ppt/tags/tag80.xml><?xml version="1.0" encoding="utf-8"?>
 <p:tagLst xmlns:a="http://schemas.openxmlformats.org/drawingml/2006/main" xmlns:r="http://schemas.openxmlformats.org/officeDocument/2006/relationships" xmlns:p="http://schemas.openxmlformats.org/presentationml/2006/main">
-  <p:tag name="ALIGNMENT_TARGET_X" val="398.26772689819336"/>
+  <p:tag name="ALIGNMENT_TARGET_X" val="299.0551109313965"/>
 </p:tagLst>
 </file>
 
 <file path=ppt/tags/tag81.xml><?xml version="1.0" encoding="utf-8"?>
 <p:tagLst xmlns:a="http://schemas.openxmlformats.org/drawingml/2006/main" xmlns:r="http://schemas.openxmlformats.org/officeDocument/2006/relationships" xmlns:p="http://schemas.openxmlformats.org/presentationml/2006/main">
-  <p:tag name="ALIGNMENT_TARGET_X" val="497.4803123474121"/>
+  <p:tag name="ALIGNMENT_TARGET_X" val="299.0551109313965"/>
 </p:tagLst>
 </file>
 
 <file path=ppt/tags/tag82.xml><?xml version="1.0" encoding="utf-8"?>
 <p:tagLst xmlns:a="http://schemas.openxmlformats.org/drawingml/2006/main" xmlns:r="http://schemas.openxmlformats.org/officeDocument/2006/relationships" xmlns:p="http://schemas.openxmlformats.org/presentationml/2006/main">
-  <p:tag name="ALIGNMENT_TARGET_X" val="497.4803123474121"/>
+  <p:tag name="ALIGNMENT_TARGET_X" val="398.26772689819336"/>
 </p:tagLst>
 </file>
 
 <file path=ppt/tags/tag83.xml><?xml version="1.0" encoding="utf-8"?>
 <p:tagLst xmlns:a="http://schemas.openxmlformats.org/drawingml/2006/main" xmlns:r="http://schemas.openxmlformats.org/officeDocument/2006/relationships" xmlns:p="http://schemas.openxmlformats.org/presentationml/2006/main">
-  <p:tag name="ALIGNMENT_TARGET_X" val="596.692928314209"/>
+  <p:tag name="ALIGNMENT_TARGET_X" val="398.26772689819336"/>
 </p:tagLst>
 </file>
 
 <file path=ppt/tags/tag84.xml><?xml version="1.0" encoding="utf-8"?>
 <p:tagLst xmlns:a="http://schemas.openxmlformats.org/drawingml/2006/main" xmlns:r="http://schemas.openxmlformats.org/officeDocument/2006/relationships" xmlns:p="http://schemas.openxmlformats.org/presentationml/2006/main">
-  <p:tag name="ALIGNMENT_TARGET_X" val="596.692928314209"/>
+  <p:tag name="ALIGNMENT_TARGET_X" val="497.4803123474121"/>
 </p:tagLst>
 </file>
 
 <file path=ppt/tags/tag85.xml><?xml version="1.0" encoding="utf-8"?>
 <p:tagLst xmlns:a="http://schemas.openxmlformats.org/drawingml/2006/main" xmlns:r="http://schemas.openxmlformats.org/officeDocument/2006/relationships" xmlns:p="http://schemas.openxmlformats.org/presentationml/2006/main">
-  <p:tag name="ALIGNMENT_TARGET_X" val="695.9055137634277"/>
+  <p:tag name="ALIGNMENT_TARGET_X" val="497.4803123474121"/>
 </p:tagLst>
 </file>
 
 <file path=ppt/tags/tag86.xml><?xml version="1.0" encoding="utf-8"?>
 <p:tagLst xmlns:a="http://schemas.openxmlformats.org/drawingml/2006/main" xmlns:r="http://schemas.openxmlformats.org/officeDocument/2006/relationships" xmlns:p="http://schemas.openxmlformats.org/presentationml/2006/main">
-  <p:tag name="ALIGNMENT_TARGET_X" val="695.9055137634277"/>
+  <p:tag name="ALIGNMENT_TARGET_X" val="596.692928314209"/>
 </p:tagLst>
 </file>
 
 <file path=ppt/tags/tag87.xml><?xml version="1.0" encoding="utf-8"?>
 <p:tagLst xmlns:a="http://schemas.openxmlformats.org/drawingml/2006/main" xmlns:r="http://schemas.openxmlformats.org/officeDocument/2006/relationships" xmlns:p="http://schemas.openxmlformats.org/presentationml/2006/main">
-  <p:tag name="ALIGNMENT_TARGET_X" val="795.1180992126465"/>
+  <p:tag name="ALIGNMENT_TARGET_X" val="596.692928314209"/>
 </p:tagLst>
 </file>
 
 <file path=ppt/tags/tag88.xml><?xml version="1.0" encoding="utf-8"?>
 <p:tagLst xmlns:a="http://schemas.openxmlformats.org/drawingml/2006/main" xmlns:r="http://schemas.openxmlformats.org/officeDocument/2006/relationships" xmlns:p="http://schemas.openxmlformats.org/presentationml/2006/main">
-  <p:tag name="ALIGNMENT_TARGET_X" val="795.1180992126465"/>
+  <p:tag name="ALIGNMENT_TARGET_X" val="695.9055137634277"/>
 </p:tagLst>
 </file>
 
 <file path=ppt/tags/tag89.xml><?xml version="1.0" encoding="utf-8"?>
 <p:tagLst xmlns:a="http://schemas.openxmlformats.org/drawingml/2006/main" xmlns:r="http://schemas.openxmlformats.org/officeDocument/2006/relationships" xmlns:p="http://schemas.openxmlformats.org/presentationml/2006/main">
-  <p:tag name="ALIGNMENT_TARGET_X" val="1145.1968383789062"/>
+  <p:tag name="ALIGNMENT_TARGET_X" val="695.9055137634277"/>
 </p:tagLst>
 </file>
 
@@ -13261,6 +13522,24 @@
 </file>
 
 <file path=ppt/tags/tag90.xml><?xml version="1.0" encoding="utf-8"?>
+<p:tagLst xmlns:a="http://schemas.openxmlformats.org/drawingml/2006/main" xmlns:r="http://schemas.openxmlformats.org/officeDocument/2006/relationships" xmlns:p="http://schemas.openxmlformats.org/presentationml/2006/main">
+  <p:tag name="ALIGNMENT_TARGET_X" val="795.1180992126465"/>
+</p:tagLst>
+</file>
+
+<file path=ppt/tags/tag91.xml><?xml version="1.0" encoding="utf-8"?>
+<p:tagLst xmlns:a="http://schemas.openxmlformats.org/drawingml/2006/main" xmlns:r="http://schemas.openxmlformats.org/officeDocument/2006/relationships" xmlns:p="http://schemas.openxmlformats.org/presentationml/2006/main">
+  <p:tag name="ALIGNMENT_TARGET_X" val="795.1180992126465"/>
+</p:tagLst>
+</file>
+
+<file path=ppt/tags/tag92.xml><?xml version="1.0" encoding="utf-8"?>
+<p:tagLst xmlns:a="http://schemas.openxmlformats.org/drawingml/2006/main" xmlns:r="http://schemas.openxmlformats.org/officeDocument/2006/relationships" xmlns:p="http://schemas.openxmlformats.org/presentationml/2006/main">
+  <p:tag name="ALIGNMENT_TARGET_X" val="1145.1968383789062"/>
+</p:tagLst>
+</file>
+
+<file path=ppt/tags/tag93.xml><?xml version="1.0" encoding="utf-8"?>
 <p:tagLst xmlns:a="http://schemas.openxmlformats.org/drawingml/2006/main" xmlns:r="http://schemas.openxmlformats.org/officeDocument/2006/relationships" xmlns:p="http://schemas.openxmlformats.org/presentationml/2006/main">
   <p:tag name="ALIGNMENT_TARGET_X" val="595.2755966186523"/>
 </p:tagLst>

</xml_diff>

<commit_message>
Group poster outcomes and distinguish Q&A evidence summaries
</commit_message>
<xml_diff>
--- a/deliverables/決賽海報_AI資安框架_A2.pptx
+++ b/deliverables/決賽海報_AI資安框架_A2.pptx
@@ -11445,7 +11445,56 @@
       </p:sp>
       <p:sp>
         <p:nvSpPr>
-          <p:cNvPr id="150" name="TextBox 149"/>
+          <p:cNvPr id="150" name="Rectangle 149"/>
+          <p:cNvSpPr/>
+          <p:nvPr/>
+        </p:nvSpPr>
+        <p:spPr>
+          <a:xfrm>
+            <a:off x="7920000" y="18324000"/>
+            <a:ext cx="2088000" cy="864000"/>
+          </a:xfrm>
+          <a:prstGeom prst="rect">
+            <a:avLst/>
+          </a:prstGeom>
+          <a:solidFill>
+            <a:srgbClr val="E9F5F3"/>
+          </a:solidFill>
+          <a:ln>
+            <a:noFill/>
+          </a:ln>
+          <a:effectLst/>
+        </p:spPr>
+        <p:style>
+          <a:lnRef idx="1">
+            <a:schemeClr val="accent1"/>
+          </a:lnRef>
+          <a:fillRef idx="3">
+            <a:schemeClr val="accent1"/>
+          </a:fillRef>
+          <a:effectRef idx="2">
+            <a:schemeClr val="accent1"/>
+          </a:effectRef>
+          <a:fontRef idx="minor">
+            <a:schemeClr val="lt1"/>
+          </a:fontRef>
+        </p:style>
+        <p:txBody>
+          <a:bodyPr rtlCol="0" anchor="ctr"/>
+          <a:lstStyle/>
+          <a:p>
+            <a:pPr algn="ctr"/>
+            <a:endParaRPr>
+              <a:latin typeface="Times New Roman"/>
+              <a:ea typeface="DFKai-SB"/>
+              <a:cs typeface="Times New Roman"/>
+            </a:endParaRPr>
+          </a:p>
+        </p:txBody>
+      </p:sp>
+      <p:sp>
+        <p:nvSpPr>
+          <p:cNvPr id="151" name="TextBox 150"/>
           <p:cNvSpPr txBox="1"/>
           <p:nvPr>
             <p:custDataLst>
@@ -11483,7 +11532,7 @@
             <a:r>
               <a:rPr sz="2600" b="0">
                 <a:solidFill>
-                  <a:srgbClr val="245EA8"/>
+                  <a:srgbClr val="087F8C"/>
                 </a:solidFill>
                 <a:latin typeface="Times New Roman"/>
                 <a:ea typeface="DFKai-SB"/>
@@ -11496,7 +11545,7 @@
       </p:sp>
       <p:sp>
         <p:nvSpPr>
-          <p:cNvPr id="151" name="TextBox 150"/>
+          <p:cNvPr id="152" name="TextBox 151"/>
           <p:cNvSpPr txBox="1"/>
           <p:nvPr>
             <p:custDataLst>
@@ -11547,7 +11596,56 @@
       </p:sp>
       <p:sp>
         <p:nvSpPr>
-          <p:cNvPr id="152" name="TextBox 151"/>
+          <p:cNvPr id="153" name="Rectangle 152"/>
+          <p:cNvSpPr/>
+          <p:nvPr/>
+        </p:nvSpPr>
+        <p:spPr>
+          <a:xfrm>
+            <a:off x="10188000" y="18324000"/>
+            <a:ext cx="2088000" cy="864000"/>
+          </a:xfrm>
+          <a:prstGeom prst="rect">
+            <a:avLst/>
+          </a:prstGeom>
+          <a:solidFill>
+            <a:srgbClr val="F4F7FA"/>
+          </a:solidFill>
+          <a:ln>
+            <a:noFill/>
+          </a:ln>
+          <a:effectLst/>
+        </p:spPr>
+        <p:style>
+          <a:lnRef idx="1">
+            <a:schemeClr val="accent1"/>
+          </a:lnRef>
+          <a:fillRef idx="3">
+            <a:schemeClr val="accent1"/>
+          </a:fillRef>
+          <a:effectRef idx="2">
+            <a:schemeClr val="accent1"/>
+          </a:effectRef>
+          <a:fontRef idx="minor">
+            <a:schemeClr val="lt1"/>
+          </a:fontRef>
+        </p:style>
+        <p:txBody>
+          <a:bodyPr rtlCol="0" anchor="ctr"/>
+          <a:lstStyle/>
+          <a:p>
+            <a:pPr algn="ctr"/>
+            <a:endParaRPr>
+              <a:latin typeface="Times New Roman"/>
+              <a:ea typeface="DFKai-SB"/>
+              <a:cs typeface="Times New Roman"/>
+            </a:endParaRPr>
+          </a:p>
+        </p:txBody>
+      </p:sp>
+      <p:sp>
+        <p:nvSpPr>
+          <p:cNvPr id="154" name="TextBox 153"/>
           <p:cNvSpPr txBox="1"/>
           <p:nvPr>
             <p:custDataLst>
@@ -11598,7 +11696,7 @@
       </p:sp>
       <p:sp>
         <p:nvSpPr>
-          <p:cNvPr id="153" name="TextBox 152"/>
+          <p:cNvPr id="155" name="TextBox 154"/>
           <p:cNvSpPr txBox="1"/>
           <p:nvPr>
             <p:custDataLst>
@@ -11649,7 +11747,56 @@
       </p:sp>
       <p:sp>
         <p:nvSpPr>
-          <p:cNvPr id="154" name="TextBox 153"/>
+          <p:cNvPr id="156" name="Rectangle 155"/>
+          <p:cNvSpPr/>
+          <p:nvPr/>
+        </p:nvSpPr>
+        <p:spPr>
+          <a:xfrm>
+            <a:off x="12456000" y="18324000"/>
+            <a:ext cx="2088000" cy="864000"/>
+          </a:xfrm>
+          <a:prstGeom prst="rect">
+            <a:avLst/>
+          </a:prstGeom>
+          <a:solidFill>
+            <a:srgbClr val="F4F7FA"/>
+          </a:solidFill>
+          <a:ln>
+            <a:noFill/>
+          </a:ln>
+          <a:effectLst/>
+        </p:spPr>
+        <p:style>
+          <a:lnRef idx="1">
+            <a:schemeClr val="accent1"/>
+          </a:lnRef>
+          <a:fillRef idx="3">
+            <a:schemeClr val="accent1"/>
+          </a:fillRef>
+          <a:effectRef idx="2">
+            <a:schemeClr val="accent1"/>
+          </a:effectRef>
+          <a:fontRef idx="minor">
+            <a:schemeClr val="lt1"/>
+          </a:fontRef>
+        </p:style>
+        <p:txBody>
+          <a:bodyPr rtlCol="0" anchor="ctr"/>
+          <a:lstStyle/>
+          <a:p>
+            <a:pPr algn="ctr"/>
+            <a:endParaRPr>
+              <a:latin typeface="Times New Roman"/>
+              <a:ea typeface="DFKai-SB"/>
+              <a:cs typeface="Times New Roman"/>
+            </a:endParaRPr>
+          </a:p>
+        </p:txBody>
+      </p:sp>
+      <p:sp>
+        <p:nvSpPr>
+          <p:cNvPr id="157" name="TextBox 156"/>
           <p:cNvSpPr txBox="1"/>
           <p:nvPr>
             <p:custDataLst>
@@ -11700,7 +11847,7 @@
       </p:sp>
       <p:sp>
         <p:nvSpPr>
-          <p:cNvPr id="155" name="TextBox 154"/>
+          <p:cNvPr id="158" name="TextBox 157"/>
           <p:cNvSpPr txBox="1"/>
           <p:nvPr>
             <p:custDataLst>
@@ -11751,7 +11898,7 @@
       </p:sp>
       <p:sp>
         <p:nvSpPr>
-          <p:cNvPr id="156" name="TextBox 155"/>
+          <p:cNvPr id="159" name="TextBox 158"/>
           <p:cNvSpPr txBox="1"/>
           <p:nvPr>
             <p:custDataLst>
@@ -11826,7 +11973,7 @@
       </p:sp>
       <p:cxnSp>
         <p:nvCxnSpPr>
-          <p:cNvPr id="157" name="Connector 156"/>
+          <p:cNvPr id="160" name="Connector 159"/>
           <p:cNvCxnSpPr/>
           <p:nvPr/>
         </p:nvCxnSpPr>
@@ -11862,7 +12009,7 @@
       </p:cxnSp>
       <p:sp>
         <p:nvSpPr>
-          <p:cNvPr id="158" name="TextBox 157"/>
+          <p:cNvPr id="161" name="TextBox 160"/>
           <p:cNvSpPr txBox="1"/>
           <p:nvPr>
             <p:custDataLst>
@@ -11937,7 +12084,7 @@
       </p:sp>
       <p:sp>
         <p:nvSpPr>
-          <p:cNvPr id="159" name="Rectangle 158"/>
+          <p:cNvPr id="162" name="Rectangle 161"/>
           <p:cNvSpPr/>
           <p:nvPr/>
         </p:nvSpPr>
@@ -11988,7 +12135,7 @@
       </p:sp>
       <p:sp>
         <p:nvSpPr>
-          <p:cNvPr id="160" name="TextBox 159"/>
+          <p:cNvPr id="163" name="TextBox 162"/>
           <p:cNvSpPr txBox="1"/>
           <p:nvPr>
             <p:custDataLst>
@@ -12039,7 +12186,7 @@
       </p:sp>
       <p:sp>
         <p:nvSpPr>
-          <p:cNvPr id="161" name="TextBox 160"/>
+          <p:cNvPr id="164" name="TextBox 163"/>
           <p:cNvSpPr txBox="1"/>
           <p:nvPr>
             <p:custDataLst>
@@ -12090,7 +12237,7 @@
       </p:sp>
       <p:sp>
         <p:nvSpPr>
-          <p:cNvPr id="162" name="Rectangle 161"/>
+          <p:cNvPr id="165" name="Rectangle 164"/>
           <p:cNvSpPr/>
           <p:nvPr/>
         </p:nvSpPr>
@@ -12141,7 +12288,7 @@
       </p:sp>
       <p:sp>
         <p:nvSpPr>
-          <p:cNvPr id="163" name="TextBox 162"/>
+          <p:cNvPr id="166" name="TextBox 165"/>
           <p:cNvSpPr txBox="1"/>
           <p:nvPr>
             <p:custDataLst>
@@ -12192,7 +12339,7 @@
       </p:sp>
       <p:sp>
         <p:nvSpPr>
-          <p:cNvPr id="164" name="TextBox 163"/>
+          <p:cNvPr id="167" name="TextBox 166"/>
           <p:cNvSpPr txBox="1"/>
           <p:nvPr>
             <p:custDataLst>
@@ -12243,7 +12390,7 @@
       </p:sp>
       <p:sp>
         <p:nvSpPr>
-          <p:cNvPr id="165" name="Rectangle 164"/>
+          <p:cNvPr id="168" name="Rectangle 167"/>
           <p:cNvSpPr/>
           <p:nvPr/>
         </p:nvSpPr>
@@ -12294,7 +12441,7 @@
       </p:sp>
       <p:sp>
         <p:nvSpPr>
-          <p:cNvPr id="166" name="TextBox 165"/>
+          <p:cNvPr id="169" name="TextBox 168"/>
           <p:cNvSpPr txBox="1"/>
           <p:nvPr>
             <p:custDataLst>
@@ -12345,7 +12492,7 @@
       </p:sp>
       <p:sp>
         <p:nvSpPr>
-          <p:cNvPr id="167" name="TextBox 166"/>
+          <p:cNvPr id="170" name="TextBox 169"/>
           <p:cNvSpPr txBox="1"/>
           <p:nvPr>
             <p:custDataLst>
@@ -12396,7 +12543,7 @@
       </p:sp>
       <p:sp>
         <p:nvSpPr>
-          <p:cNvPr id="168" name="Rectangle 167"/>
+          <p:cNvPr id="171" name="Rectangle 170"/>
           <p:cNvSpPr/>
           <p:nvPr/>
         </p:nvSpPr>
@@ -12447,7 +12594,7 @@
       </p:sp>
       <p:sp>
         <p:nvSpPr>
-          <p:cNvPr id="169" name="TextBox 168"/>
+          <p:cNvPr id="172" name="TextBox 171"/>
           <p:cNvSpPr txBox="1"/>
           <p:nvPr>
             <p:custDataLst>
@@ -12498,7 +12645,7 @@
       </p:sp>
       <p:sp>
         <p:nvSpPr>
-          <p:cNvPr id="170" name="TextBox 169"/>
+          <p:cNvPr id="173" name="TextBox 172"/>
           <p:cNvSpPr txBox="1"/>
           <p:nvPr>
             <p:custDataLst>
@@ -12549,7 +12696,7 @@
       </p:sp>
       <p:sp>
         <p:nvSpPr>
-          <p:cNvPr id="171" name="Rectangle 170"/>
+          <p:cNvPr id="174" name="Rectangle 173"/>
           <p:cNvSpPr/>
           <p:nvPr/>
         </p:nvSpPr>
@@ -12600,7 +12747,7 @@
       </p:sp>
       <p:sp>
         <p:nvSpPr>
-          <p:cNvPr id="172" name="TextBox 171"/>
+          <p:cNvPr id="175" name="TextBox 174"/>
           <p:cNvSpPr txBox="1"/>
           <p:nvPr>
             <p:custDataLst>
@@ -12651,7 +12798,7 @@
       </p:sp>
       <p:sp>
         <p:nvSpPr>
-          <p:cNvPr id="173" name="TextBox 172"/>
+          <p:cNvPr id="176" name="TextBox 175"/>
           <p:cNvSpPr txBox="1"/>
           <p:nvPr>
             <p:custDataLst>
@@ -12702,7 +12849,7 @@
       </p:sp>
       <p:sp>
         <p:nvSpPr>
-          <p:cNvPr id="174" name="Rectangle 173"/>
+          <p:cNvPr id="177" name="Rectangle 176"/>
           <p:cNvSpPr/>
           <p:nvPr/>
         </p:nvSpPr>
@@ -12753,7 +12900,7 @@
       </p:sp>
       <p:sp>
         <p:nvSpPr>
-          <p:cNvPr id="175" name="TextBox 174"/>
+          <p:cNvPr id="178" name="TextBox 177"/>
           <p:cNvSpPr txBox="1"/>
           <p:nvPr>
             <p:custDataLst>
@@ -12804,7 +12951,7 @@
       </p:sp>
       <p:sp>
         <p:nvSpPr>
-          <p:cNvPr id="176" name="TextBox 175"/>
+          <p:cNvPr id="179" name="TextBox 178"/>
           <p:cNvSpPr txBox="1"/>
           <p:nvPr>
             <p:custDataLst>
@@ -12855,7 +13002,7 @@
       </p:sp>
       <p:sp>
         <p:nvSpPr>
-          <p:cNvPr id="177" name="TextBox 176"/>
+          <p:cNvPr id="180" name="TextBox 179"/>
           <p:cNvSpPr txBox="1"/>
           <p:nvPr>
             <p:custDataLst>
@@ -12930,7 +13077,7 @@
       </p:sp>
       <p:sp>
         <p:nvSpPr>
-          <p:cNvPr id="178" name="TextBox 177"/>
+          <p:cNvPr id="181" name="TextBox 180"/>
           <p:cNvSpPr txBox="1"/>
           <p:nvPr>
             <p:custDataLst>

</xml_diff>

<commit_message>
Move the deck cover and ending onto the light canvas
Slides 1 and 9 now use the film's light gray canvas with navy headings,
a blue last title line and closing line, and the light evidence chain,
so the whole deck and film read light with no colour jump into slide 2.
Text, order, notes and metrics are unchanged. Slides re-authored and
re-exported through the full pipeline; slide SVG sources, previews,
zip and manifests regenerated. The page-background test now expects a
light canvas on every slide.

Co-Authored-By: Claude Opus 5.5 <noreply@anthropic.com>
</commit_message>
<xml_diff>
--- a/deliverables/決賽海報_AI資安框架_A2.pptx
+++ b/deliverables/決賽海報_AI資安框架_A2.pptx
@@ -345,7 +345,7 @@
                 <a:ea typeface="Microsoft JhengHei"/>
                 <a:cs typeface="Segoe UI"/>
               </a:rPr>
-              <a:t>10/30/2026</a:t>
+              <a:t>10/31/2026</a:t>
             </a:fld>
             <a:endParaRPr lang="en-US">
               <a:latin typeface="Segoe UI"/>
@@ -557,7 +557,7 @@
                 <a:ea typeface="Microsoft JhengHei"/>
                 <a:cs typeface="Segoe UI"/>
               </a:rPr>
-              <a:t>10/30/2026</a:t>
+              <a:t>10/31/2026</a:t>
             </a:fld>
             <a:endParaRPr lang="en-US">
               <a:latin typeface="Segoe UI"/>
@@ -779,7 +779,7 @@
                 <a:ea typeface="Microsoft JhengHei"/>
                 <a:cs typeface="Segoe UI"/>
               </a:rPr>
-              <a:t>10/30/2026</a:t>
+              <a:t>10/31/2026</a:t>
             </a:fld>
             <a:endParaRPr lang="en-US">
               <a:latin typeface="Segoe UI"/>
@@ -991,7 +991,7 @@
                 <a:ea typeface="Microsoft JhengHei"/>
                 <a:cs typeface="Segoe UI"/>
               </a:rPr>
-              <a:t>10/30/2026</a:t>
+              <a:t>10/31/2026</a:t>
             </a:fld>
             <a:endParaRPr lang="en-US">
               <a:latin typeface="Segoe UI"/>
@@ -1295,7 +1295,7 @@
                 <a:ea typeface="Microsoft JhengHei"/>
                 <a:cs typeface="Segoe UI"/>
               </a:rPr>
-              <a:t>10/30/2026</a:t>
+              <a:t>10/31/2026</a:t>
             </a:fld>
             <a:endParaRPr lang="en-US">
               <a:latin typeface="Segoe UI"/>
@@ -1716,7 +1716,7 @@
                 <a:ea typeface="Microsoft JhengHei"/>
                 <a:cs typeface="Segoe UI"/>
               </a:rPr>
-              <a:t>10/30/2026</a:t>
+              <a:t>10/31/2026</a:t>
             </a:fld>
             <a:endParaRPr lang="en-US">
               <a:latin typeface="Segoe UI"/>
@@ -2355,7 +2355,7 @@
                 <a:ea typeface="Microsoft JhengHei"/>
                 <a:cs typeface="Segoe UI"/>
               </a:rPr>
-              <a:t>10/30/2026</a:t>
+              <a:t>10/31/2026</a:t>
             </a:fld>
             <a:endParaRPr lang="en-US">
               <a:latin typeface="Segoe UI"/>
@@ -2496,7 +2496,7 @@
                 <a:ea typeface="Microsoft JhengHei"/>
                 <a:cs typeface="Segoe UI"/>
               </a:rPr>
-              <a:t>10/30/2026</a:t>
+              <a:t>10/31/2026</a:t>
             </a:fld>
             <a:endParaRPr lang="en-US">
               <a:latin typeface="Segoe UI"/>
@@ -2611,7 +2611,7 @@
                 <a:ea typeface="Microsoft JhengHei"/>
                 <a:cs typeface="Segoe UI"/>
               </a:rPr>
-              <a:t>10/30/2026</a:t>
+              <a:t>10/31/2026</a:t>
             </a:fld>
             <a:endParaRPr lang="en-US">
               <a:latin typeface="Segoe UI"/>
@@ -3010,7 +3010,7 @@
                 <a:ea typeface="Microsoft JhengHei"/>
                 <a:cs typeface="Segoe UI"/>
               </a:rPr>
-              <a:t>10/30/2026</a:t>
+              <a:t>10/31/2026</a:t>
             </a:fld>
             <a:endParaRPr lang="en-US">
               <a:latin typeface="Segoe UI"/>
@@ -3370,7 +3370,7 @@
                 <a:ea typeface="Microsoft JhengHei"/>
                 <a:cs typeface="Segoe UI"/>
               </a:rPr>
-              <a:t>10/30/2026</a:t>
+              <a:t>10/31/2026</a:t>
             </a:fld>
             <a:endParaRPr lang="en-US">
               <a:latin typeface="Segoe UI"/>
@@ -3628,7 +3628,7 @@
                 <a:ea typeface="Microsoft JhengHei"/>
                 <a:cs typeface="Segoe UI"/>
               </a:rPr>
-              <a:t>10/30/2026</a:t>
+              <a:t>10/31/2026</a:t>
             </a:fld>
             <a:endParaRPr lang="en-US">
               <a:latin typeface="Segoe UI"/>

</xml_diff>

<commit_message>
Lighten the A2 poster masthead
The masthead now uses the light gray canvas of the deck cover with a
hairline below it: navy title, blue takeaway, muted note, and the
evidence chain as white discs with blue outlines. Layout, sizes, text
and figures are unchanged. Poster rebuilt, overflow-checked, aligned
and re-exported; previews, zip and manifests regenerated.

Co-Authored-By: Claude Opus 5.5 <noreply@anthropic.com>
</commit_message>
<xml_diff>
--- a/deliverables/決賽海報_AI資安框架_A2.pptx
+++ b/deliverables/決賽海報_AI資安框架_A2.pptx
@@ -4052,7 +4052,7 @@
             <a:avLst/>
           </a:prstGeom>
           <a:solidFill>
-            <a:srgbClr val="0B1B2E"/>
+            <a:srgbClr val="F3F6FA"/>
           </a:solidFill>
           <a:ln>
             <a:noFill/>
@@ -4086,9 +4086,45 @@
           </a:p>
         </p:txBody>
       </p:sp>
-      <p:sp>
-        <p:nvSpPr>
-          <p:cNvPr id="3" name="TextBox 2"/>
+      <p:cxnSp>
+        <p:nvCxnSpPr>
+          <p:cNvPr id="3" name="Connector 2"/>
+          <p:cNvCxnSpPr/>
+          <p:nvPr/>
+        </p:nvCxnSpPr>
+        <p:spPr>
+          <a:xfrm>
+            <a:off x="0" y="5832000"/>
+            <a:ext cx="15120000" cy="0"/>
+          </a:xfrm>
+          <a:prstGeom prst="line">
+            <a:avLst/>
+          </a:prstGeom>
+          <a:ln w="19050">
+            <a:solidFill>
+              <a:srgbClr val="DCE3EC"/>
+            </a:solidFill>
+          </a:ln>
+          <a:effectLst/>
+        </p:spPr>
+        <p:style>
+          <a:lnRef idx="2">
+            <a:schemeClr val="accent1"/>
+          </a:lnRef>
+          <a:fillRef idx="0">
+            <a:schemeClr val="accent1"/>
+          </a:fillRef>
+          <a:effectRef idx="1">
+            <a:schemeClr val="accent1"/>
+          </a:effectRef>
+          <a:fontRef idx="minor">
+            <a:schemeClr val="tx1"/>
+          </a:fontRef>
+        </p:style>
+      </p:cxnSp>
+      <p:sp>
+        <p:nvSpPr>
+          <p:cNvPr id="4" name="TextBox 3"/>
           <p:cNvSpPr txBox="1"/>
           <p:nvPr>
             <p:custDataLst>
@@ -4126,7 +4162,7 @@
             <a:r>
               <a:rPr sz="1800" b="1">
                 <a:solidFill>
-                  <a:srgbClr val="5EEAD4"/>
+                  <a:srgbClr val="0F766E"/>
                 </a:solidFill>
                 <a:latin typeface="Segoe UI"/>
                 <a:ea typeface="Microsoft JhengHei"/>
@@ -4139,7 +4175,7 @@
       </p:sp>
       <p:sp>
         <p:nvSpPr>
-          <p:cNvPr id="4" name="PosterTitle_Masthead"/>
+          <p:cNvPr id="5" name="PosterTitle_Masthead"/>
           <p:cNvSpPr txBox="1"/>
           <p:nvPr>
             <p:custDataLst>
@@ -4177,7 +4213,7 @@
             <a:r>
               <a:rPr sz="4600" b="1">
                 <a:solidFill>
-                  <a:srgbClr val="FFFFFF"/>
+                  <a:srgbClr val="0B1B2E"/>
                 </a:solidFill>
                 <a:latin typeface="Segoe UI"/>
                 <a:ea typeface="Microsoft JhengHei"/>
@@ -4201,7 +4237,7 @@
             <a:r>
               <a:rPr sz="4600" b="1">
                 <a:solidFill>
-                  <a:srgbClr val="FFFFFF"/>
+                  <a:srgbClr val="0B1B2E"/>
                 </a:solidFill>
                 <a:latin typeface="Segoe UI"/>
                 <a:ea typeface="Microsoft JhengHei"/>
@@ -4225,7 +4261,7 @@
             <a:r>
               <a:rPr sz="4600" b="1">
                 <a:solidFill>
-                  <a:srgbClr val="FFFFFF"/>
+                  <a:srgbClr val="0B1B2E"/>
                 </a:solidFill>
                 <a:latin typeface="Segoe UI"/>
                 <a:ea typeface="Microsoft JhengHei"/>
@@ -4238,7 +4274,7 @@
       </p:sp>
       <p:sp>
         <p:nvSpPr>
-          <p:cNvPr id="5" name="Rectangle 4"/>
+          <p:cNvPr id="6" name="Rectangle 5"/>
           <p:cNvSpPr/>
           <p:nvPr/>
         </p:nvSpPr>
@@ -4287,7 +4323,7 @@
       </p:sp>
       <p:sp>
         <p:nvSpPr>
-          <p:cNvPr id="6" name="TextBox 5"/>
+          <p:cNvPr id="7" name="TextBox 6"/>
           <p:cNvSpPr txBox="1"/>
           <p:nvPr>
             <p:custDataLst>
@@ -4325,7 +4361,7 @@
             <a:r>
               <a:rPr sz="2700" b="1">
                 <a:solidFill>
-                  <a:srgbClr val="FFFFFF"/>
+                  <a:srgbClr val="1D4ED8"/>
                 </a:solidFill>
                 <a:latin typeface="Segoe UI"/>
                 <a:ea typeface="Microsoft JhengHei"/>
@@ -4338,7 +4374,7 @@
       </p:sp>
       <p:sp>
         <p:nvSpPr>
-          <p:cNvPr id="7" name="TextBox 6"/>
+          <p:cNvPr id="8" name="TextBox 7"/>
           <p:cNvSpPr txBox="1"/>
           <p:nvPr>
             <p:custDataLst>
@@ -4376,7 +4412,7 @@
             <a:r>
               <a:rPr sz="1800" b="0">
                 <a:solidFill>
-                  <a:srgbClr val="A8B8CC"/>
+                  <a:srgbClr val="52637A"/>
                 </a:solidFill>
                 <a:latin typeface="Segoe UI"/>
                 <a:ea typeface="Microsoft JhengHei"/>
@@ -4389,7 +4425,7 @@
       </p:sp>
       <p:cxnSp>
         <p:nvCxnSpPr>
-          <p:cNvPr id="8" name="Connector 7"/>
+          <p:cNvPr id="9" name="Connector 8"/>
           <p:cNvCxnSpPr/>
           <p:nvPr/>
         </p:nvCxnSpPr>
@@ -4403,7 +4439,7 @@
           </a:prstGeom>
           <a:ln w="25400">
             <a:solidFill>
-              <a:srgbClr val="2A4260"/>
+              <a:srgbClr val="DCE3EC"/>
             </a:solidFill>
           </a:ln>
           <a:effectLst/>
@@ -4425,7 +4461,7 @@
       </p:cxnSp>
       <p:sp>
         <p:nvSpPr>
-          <p:cNvPr id="9" name="Oval 8"/>
+          <p:cNvPr id="10" name="Oval 9"/>
           <p:cNvSpPr/>
           <p:nvPr/>
         </p:nvSpPr>
@@ -4442,7 +4478,7 @@
           </a:solidFill>
           <a:ln w="10160">
             <a:solidFill>
-              <a:srgbClr val="5EEAD4"/>
+              <a:srgbClr val="1D4ED8"/>
             </a:solidFill>
           </a:ln>
           <a:effectLst/>
@@ -4476,7 +4512,7 @@
       </p:sp>
       <p:pic>
         <p:nvPicPr>
-          <p:cNvPr id="10" name="Picture 9" descr="flat-icon-2.png"/>
+          <p:cNvPr id="11" name="Picture 10" descr="flat-icon-2.png"/>
           <p:cNvPicPr>
             <a:picLocks noChangeAspect="1"/>
           </p:cNvPicPr>
@@ -4500,7 +4536,7 @@
       </p:pic>
       <p:sp>
         <p:nvSpPr>
-          <p:cNvPr id="11" name="TextBox 10"/>
+          <p:cNvPr id="12" name="TextBox 11"/>
           <p:cNvSpPr txBox="1"/>
           <p:nvPr>
             <p:custDataLst>
@@ -4538,7 +4574,7 @@
             <a:r>
               <a:rPr sz="2000" b="1">
                 <a:solidFill>
-                  <a:srgbClr val="FFFFFF"/>
+                  <a:srgbClr val="0B1B2E"/>
                 </a:solidFill>
                 <a:latin typeface="Segoe UI"/>
                 <a:ea typeface="Microsoft JhengHei"/>
@@ -4551,7 +4587,7 @@
       </p:sp>
       <p:sp>
         <p:nvSpPr>
-          <p:cNvPr id="12" name="Oval 11"/>
+          <p:cNvPr id="13" name="Oval 12"/>
           <p:cNvSpPr/>
           <p:nvPr/>
         </p:nvSpPr>
@@ -4568,7 +4604,7 @@
           </a:solidFill>
           <a:ln w="10160">
             <a:solidFill>
-              <a:srgbClr val="5EEAD4"/>
+              <a:srgbClr val="1D4ED8"/>
             </a:solidFill>
           </a:ln>
           <a:effectLst/>
@@ -4602,7 +4638,7 @@
       </p:sp>
       <p:pic>
         <p:nvPicPr>
-          <p:cNvPr id="13" name="Picture 12" descr="flat-icon-3.png"/>
+          <p:cNvPr id="14" name="Picture 13" descr="flat-icon-3.png"/>
           <p:cNvPicPr>
             <a:picLocks noChangeAspect="1"/>
           </p:cNvPicPr>
@@ -4626,7 +4662,7 @@
       </p:pic>
       <p:sp>
         <p:nvSpPr>
-          <p:cNvPr id="14" name="TextBox 13"/>
+          <p:cNvPr id="15" name="TextBox 14"/>
           <p:cNvSpPr txBox="1"/>
           <p:nvPr>
             <p:custDataLst>
@@ -4664,7 +4700,7 @@
             <a:r>
               <a:rPr sz="2000" b="1">
                 <a:solidFill>
-                  <a:srgbClr val="FFFFFF"/>
+                  <a:srgbClr val="0B1B2E"/>
                 </a:solidFill>
                 <a:latin typeface="Segoe UI"/>
                 <a:ea typeface="Microsoft JhengHei"/>
@@ -4677,7 +4713,7 @@
       </p:sp>
       <p:sp>
         <p:nvSpPr>
-          <p:cNvPr id="15" name="Oval 14"/>
+          <p:cNvPr id="16" name="Oval 15"/>
           <p:cNvSpPr/>
           <p:nvPr/>
         </p:nvSpPr>
@@ -4687,57 +4723,6 @@
             <a:ext cx="576000" cy="576000"/>
           </a:xfrm>
           <a:prstGeom prst="ellipse">
-            <a:avLst/>
-          </a:prstGeom>
-          <a:solidFill>
-            <a:srgbClr val="FFFFFF"/>
-          </a:solidFill>
-          <a:ln w="10160">
-            <a:solidFill>
-              <a:srgbClr val="5EEAD4"/>
-            </a:solidFill>
-          </a:ln>
-          <a:effectLst/>
-        </p:spPr>
-        <p:style>
-          <a:lnRef idx="1">
-            <a:schemeClr val="accent1"/>
-          </a:lnRef>
-          <a:fillRef idx="3">
-            <a:schemeClr val="accent1"/>
-          </a:fillRef>
-          <a:effectRef idx="2">
-            <a:schemeClr val="accent1"/>
-          </a:effectRef>
-          <a:fontRef idx="minor">
-            <a:schemeClr val="lt1"/>
-          </a:fontRef>
-        </p:style>
-        <p:txBody>
-          <a:bodyPr rtlCol="0" anchor="ctr"/>
-          <a:lstStyle/>
-          <a:p>
-            <a:pPr algn="ctr"/>
-            <a:endParaRPr>
-              <a:latin typeface="Segoe UI"/>
-              <a:ea typeface="Microsoft JhengHei"/>
-              <a:cs typeface="Segoe UI"/>
-            </a:endParaRPr>
-          </a:p>
-        </p:txBody>
-      </p:sp>
-      <p:sp>
-        <p:nvSpPr>
-          <p:cNvPr id="16" name="Rectangle 15"/>
-          <p:cNvSpPr/>
-          <p:nvPr/>
-        </p:nvSpPr>
-        <p:spPr>
-          <a:xfrm>
-            <a:off x="9295200" y="4716000"/>
-            <a:ext cx="230400" cy="360000"/>
-          </a:xfrm>
-          <a:prstGeom prst="rect">
             <a:avLst/>
           </a:prstGeom>
           <a:solidFill>
@@ -4777,20 +4762,23 @@
           </a:p>
         </p:txBody>
       </p:sp>
-      <p:cxnSp>
-        <p:nvCxnSpPr>
-          <p:cNvPr id="17" name="Connector 16"/>
-          <p:cNvCxnSpPr/>
+      <p:sp>
+        <p:nvSpPr>
+          <p:cNvPr id="17" name="Rectangle 16"/>
+          <p:cNvSpPr/>
           <p:nvPr/>
-        </p:nvCxnSpPr>
-        <p:spPr>
-          <a:xfrm>
-            <a:off x="9345888" y="4806000"/>
-            <a:ext cx="129024" cy="0"/>
-          </a:xfrm>
-          <a:prstGeom prst="line">
-            <a:avLst/>
-          </a:prstGeom>
+        </p:nvSpPr>
+        <p:spPr>
+          <a:xfrm>
+            <a:off x="9295200" y="4716000"/>
+            <a:ext cx="230400" cy="360000"/>
+          </a:xfrm>
+          <a:prstGeom prst="rect">
+            <a:avLst/>
+          </a:prstGeom>
+          <a:solidFill>
+            <a:srgbClr val="FFFFFF"/>
+          </a:solidFill>
           <a:ln w="10160">
             <a:solidFill>
               <a:srgbClr val="1D4ED8"/>
@@ -4799,20 +4787,32 @@
           <a:effectLst/>
         </p:spPr>
         <p:style>
-          <a:lnRef idx="2">
+          <a:lnRef idx="1">
             <a:schemeClr val="accent1"/>
           </a:lnRef>
-          <a:fillRef idx="0">
+          <a:fillRef idx="3">
             <a:schemeClr val="accent1"/>
           </a:fillRef>
-          <a:effectRef idx="1">
+          <a:effectRef idx="2">
             <a:schemeClr val="accent1"/>
           </a:effectRef>
           <a:fontRef idx="minor">
-            <a:schemeClr val="tx1"/>
+            <a:schemeClr val="lt1"/>
           </a:fontRef>
         </p:style>
-      </p:cxnSp>
+        <p:txBody>
+          <a:bodyPr rtlCol="0" anchor="ctr"/>
+          <a:lstStyle/>
+          <a:p>
+            <a:pPr algn="ctr"/>
+            <a:endParaRPr>
+              <a:latin typeface="Segoe UI"/>
+              <a:ea typeface="Microsoft JhengHei"/>
+              <a:cs typeface="Segoe UI"/>
+            </a:endParaRPr>
+          </a:p>
+        </p:txBody>
+      </p:sp>
       <p:cxnSp>
         <p:nvCxnSpPr>
           <p:cNvPr id="18" name="Connector 17"/>
@@ -4821,7 +4821,7 @@
         </p:nvCxnSpPr>
         <p:spPr>
           <a:xfrm>
-            <a:off x="9345888" y="4896000"/>
+            <a:off x="9345888" y="4806000"/>
             <a:ext cx="129024" cy="0"/>
           </a:xfrm>
           <a:prstGeom prst="line">
@@ -4857,7 +4857,7 @@
         </p:nvCxnSpPr>
         <p:spPr>
           <a:xfrm>
-            <a:off x="9345888" y="4986000"/>
+            <a:off x="9345888" y="4896000"/>
             <a:ext cx="129024" cy="0"/>
           </a:xfrm>
           <a:prstGeom prst="line">
@@ -4885,9 +4885,45 @@
           </a:fontRef>
         </p:style>
       </p:cxnSp>
-      <p:sp>
-        <p:nvSpPr>
-          <p:cNvPr id="20" name="TextBox 19"/>
+      <p:cxnSp>
+        <p:nvCxnSpPr>
+          <p:cNvPr id="20" name="Connector 19"/>
+          <p:cNvCxnSpPr/>
+          <p:nvPr/>
+        </p:nvCxnSpPr>
+        <p:spPr>
+          <a:xfrm>
+            <a:off x="9345888" y="4986000"/>
+            <a:ext cx="129024" cy="0"/>
+          </a:xfrm>
+          <a:prstGeom prst="line">
+            <a:avLst/>
+          </a:prstGeom>
+          <a:ln w="10160">
+            <a:solidFill>
+              <a:srgbClr val="1D4ED8"/>
+            </a:solidFill>
+          </a:ln>
+          <a:effectLst/>
+        </p:spPr>
+        <p:style>
+          <a:lnRef idx="2">
+            <a:schemeClr val="accent1"/>
+          </a:lnRef>
+          <a:fillRef idx="0">
+            <a:schemeClr val="accent1"/>
+          </a:fillRef>
+          <a:effectRef idx="1">
+            <a:schemeClr val="accent1"/>
+          </a:effectRef>
+          <a:fontRef idx="minor">
+            <a:schemeClr val="tx1"/>
+          </a:fontRef>
+        </p:style>
+      </p:cxnSp>
+      <p:sp>
+        <p:nvSpPr>
+          <p:cNvPr id="21" name="TextBox 20"/>
           <p:cNvSpPr txBox="1"/>
           <p:nvPr>
             <p:custDataLst>
@@ -4925,7 +4961,7 @@
             <a:r>
               <a:rPr sz="2000" b="1">
                 <a:solidFill>
-                  <a:srgbClr val="FFFFFF"/>
+                  <a:srgbClr val="0B1B2E"/>
                 </a:solidFill>
                 <a:latin typeface="Segoe UI"/>
                 <a:ea typeface="Microsoft JhengHei"/>
@@ -4938,7 +4974,7 @@
       </p:sp>
       <p:sp>
         <p:nvSpPr>
-          <p:cNvPr id="21" name="Oval 20"/>
+          <p:cNvPr id="22" name="Oval 21"/>
           <p:cNvSpPr/>
           <p:nvPr/>
         </p:nvSpPr>
@@ -4955,7 +4991,7 @@
           </a:solidFill>
           <a:ln w="10160">
             <a:solidFill>
-              <a:srgbClr val="5EEAD4"/>
+              <a:srgbClr val="1D4ED8"/>
             </a:solidFill>
           </a:ln>
           <a:effectLst/>
@@ -4989,7 +5025,7 @@
       </p:sp>
       <p:pic>
         <p:nvPicPr>
-          <p:cNvPr id="22" name="Picture 21" descr="flat-icon-4.png"/>
+          <p:cNvPr id="23" name="Picture 22" descr="flat-icon-4.png"/>
           <p:cNvPicPr>
             <a:picLocks noChangeAspect="1"/>
           </p:cNvPicPr>
@@ -5013,7 +5049,7 @@
       </p:pic>
       <p:sp>
         <p:nvSpPr>
-          <p:cNvPr id="23" name="TextBox 22"/>
+          <p:cNvPr id="24" name="TextBox 23"/>
           <p:cNvSpPr txBox="1"/>
           <p:nvPr>
             <p:custDataLst>
@@ -5051,7 +5087,7 @@
             <a:r>
               <a:rPr sz="2000" b="1">
                 <a:solidFill>
-                  <a:srgbClr val="FFFFFF"/>
+                  <a:srgbClr val="0B1B2E"/>
                 </a:solidFill>
                 <a:latin typeface="Segoe UI"/>
                 <a:ea typeface="Microsoft JhengHei"/>
@@ -5064,7 +5100,7 @@
       </p:sp>
       <p:sp>
         <p:nvSpPr>
-          <p:cNvPr id="24" name="TextBox 23"/>
+          <p:cNvPr id="25" name="TextBox 24"/>
           <p:cNvSpPr txBox="1"/>
           <p:nvPr>
             <p:custDataLst>
@@ -5115,7 +5151,7 @@
       </p:sp>
       <p:sp>
         <p:nvSpPr>
-          <p:cNvPr id="25" name="TextBox 24"/>
+          <p:cNvPr id="26" name="TextBox 25"/>
           <p:cNvSpPr txBox="1"/>
           <p:nvPr>
             <p:custDataLst>
@@ -5166,7 +5202,7 @@
       </p:sp>
       <p:cxnSp>
         <p:nvCxnSpPr>
-          <p:cNvPr id="26" name="Connector 25"/>
+          <p:cNvPr id="27" name="Connector 26"/>
           <p:cNvCxnSpPr/>
           <p:nvPr/>
         </p:nvCxnSpPr>
@@ -5202,7 +5238,7 @@
       </p:cxnSp>
       <p:sp>
         <p:nvSpPr>
-          <p:cNvPr id="27" name="Rounded Rectangle 26"/>
+          <p:cNvPr id="28" name="Rounded Rectangle 27"/>
           <p:cNvSpPr/>
           <p:nvPr/>
         </p:nvSpPr>
@@ -5253,7 +5289,7 @@
       </p:sp>
       <p:pic>
         <p:nvPicPr>
-          <p:cNvPr id="28" name="Picture 27" descr="flat-icon-2.png"/>
+          <p:cNvPr id="29" name="Picture 28" descr="flat-icon-2.png"/>
           <p:cNvPicPr>
             <a:picLocks noChangeAspect="1"/>
           </p:cNvPicPr>
@@ -5277,7 +5313,7 @@
       </p:pic>
       <p:sp>
         <p:nvSpPr>
-          <p:cNvPr id="29" name="TextBox 28"/>
+          <p:cNvPr id="30" name="TextBox 29"/>
           <p:cNvSpPr txBox="1"/>
           <p:nvPr>
             <p:custDataLst>
@@ -5328,7 +5364,7 @@
       </p:sp>
       <p:sp>
         <p:nvSpPr>
-          <p:cNvPr id="30" name="TextBox 29"/>
+          <p:cNvPr id="31" name="TextBox 30"/>
           <p:cNvSpPr txBox="1"/>
           <p:nvPr>
             <p:custDataLst>
@@ -5379,7 +5415,7 @@
       </p:sp>
       <p:sp>
         <p:nvSpPr>
-          <p:cNvPr id="31" name="TextBox 30"/>
+          <p:cNvPr id="32" name="TextBox 31"/>
           <p:cNvSpPr txBox="1"/>
           <p:nvPr>
             <p:custDataLst>
@@ -5454,7 +5490,7 @@
       </p:sp>
       <p:sp>
         <p:nvSpPr>
-          <p:cNvPr id="32" name="Down Arrow 31"/>
+          <p:cNvPr id="33" name="Down Arrow 32"/>
           <p:cNvSpPr/>
           <p:nvPr/>
         </p:nvSpPr>
@@ -5503,7 +5539,7 @@
       </p:sp>
       <p:sp>
         <p:nvSpPr>
-          <p:cNvPr id="33" name="Rounded Rectangle 32"/>
+          <p:cNvPr id="34" name="Rounded Rectangle 33"/>
           <p:cNvSpPr/>
           <p:nvPr/>
         </p:nvSpPr>
@@ -5554,7 +5590,7 @@
       </p:sp>
       <p:pic>
         <p:nvPicPr>
-          <p:cNvPr id="34" name="Picture 33" descr="flat-icon-3.png"/>
+          <p:cNvPr id="35" name="Picture 34" descr="flat-icon-3.png"/>
           <p:cNvPicPr>
             <a:picLocks noChangeAspect="1"/>
           </p:cNvPicPr>
@@ -5578,7 +5614,7 @@
       </p:pic>
       <p:sp>
         <p:nvSpPr>
-          <p:cNvPr id="35" name="TextBox 34"/>
+          <p:cNvPr id="36" name="TextBox 35"/>
           <p:cNvSpPr txBox="1"/>
           <p:nvPr>
             <p:custDataLst>
@@ -5629,7 +5665,7 @@
       </p:sp>
       <p:sp>
         <p:nvSpPr>
-          <p:cNvPr id="36" name="TextBox 35"/>
+          <p:cNvPr id="37" name="TextBox 36"/>
           <p:cNvSpPr txBox="1"/>
           <p:nvPr>
             <p:custDataLst>
@@ -5680,7 +5716,7 @@
       </p:sp>
       <p:sp>
         <p:nvSpPr>
-          <p:cNvPr id="37" name="TextBox 36"/>
+          <p:cNvPr id="38" name="TextBox 37"/>
           <p:cNvSpPr txBox="1"/>
           <p:nvPr>
             <p:custDataLst>
@@ -5755,7 +5791,7 @@
       </p:sp>
       <p:sp>
         <p:nvSpPr>
-          <p:cNvPr id="38" name="Down Arrow 37"/>
+          <p:cNvPr id="39" name="Down Arrow 38"/>
           <p:cNvSpPr/>
           <p:nvPr/>
         </p:nvSpPr>
@@ -5804,7 +5840,7 @@
       </p:sp>
       <p:sp>
         <p:nvSpPr>
-          <p:cNvPr id="39" name="Rounded Rectangle 38"/>
+          <p:cNvPr id="40" name="Rounded Rectangle 39"/>
           <p:cNvSpPr/>
           <p:nvPr/>
         </p:nvSpPr>
@@ -5855,7 +5891,7 @@
       </p:sp>
       <p:sp>
         <p:nvSpPr>
-          <p:cNvPr id="40" name="Rectangle 39"/>
+          <p:cNvPr id="41" name="Rectangle 40"/>
           <p:cNvSpPr/>
           <p:nvPr/>
         </p:nvSpPr>
@@ -5906,49 +5942,13 @@
       </p:sp>
       <p:cxnSp>
         <p:nvCxnSpPr>
-          <p:cNvPr id="41" name="Connector 40"/>
-          <p:cNvCxnSpPr/>
-          <p:nvPr/>
-        </p:nvCxnSpPr>
-        <p:spPr>
-          <a:xfrm>
-            <a:off x="1187280" y="10440000"/>
-            <a:ext cx="181440" cy="0"/>
-          </a:xfrm>
-          <a:prstGeom prst="line">
-            <a:avLst/>
-          </a:prstGeom>
-          <a:ln w="10160">
-            <a:solidFill>
-              <a:srgbClr val="1D4ED8"/>
-            </a:solidFill>
-          </a:ln>
-          <a:effectLst/>
-        </p:spPr>
-        <p:style>
-          <a:lnRef idx="2">
-            <a:schemeClr val="accent1"/>
-          </a:lnRef>
-          <a:fillRef idx="0">
-            <a:schemeClr val="accent1"/>
-          </a:fillRef>
-          <a:effectRef idx="1">
-            <a:schemeClr val="accent1"/>
-          </a:effectRef>
-          <a:fontRef idx="minor">
-            <a:schemeClr val="tx1"/>
-          </a:fontRef>
-        </p:style>
-      </p:cxnSp>
-      <p:cxnSp>
-        <p:nvCxnSpPr>
           <p:cNvPr id="42" name="Connector 41"/>
           <p:cNvCxnSpPr/>
           <p:nvPr/>
         </p:nvCxnSpPr>
         <p:spPr>
           <a:xfrm>
-            <a:off x="1187280" y="10548000"/>
+            <a:off x="1187280" y="10440000"/>
             <a:ext cx="181440" cy="0"/>
           </a:xfrm>
           <a:prstGeom prst="line">
@@ -5984,7 +5984,7 @@
         </p:nvCxnSpPr>
         <p:spPr>
           <a:xfrm>
-            <a:off x="1187280" y="10656000"/>
+            <a:off x="1187280" y="10548000"/>
             <a:ext cx="181440" cy="0"/>
           </a:xfrm>
           <a:prstGeom prst="line">
@@ -6012,9 +6012,45 @@
           </a:fontRef>
         </p:style>
       </p:cxnSp>
-      <p:sp>
-        <p:nvSpPr>
-          <p:cNvPr id="44" name="TextBox 43"/>
+      <p:cxnSp>
+        <p:nvCxnSpPr>
+          <p:cNvPr id="44" name="Connector 43"/>
+          <p:cNvCxnSpPr/>
+          <p:nvPr/>
+        </p:nvCxnSpPr>
+        <p:spPr>
+          <a:xfrm>
+            <a:off x="1187280" y="10656000"/>
+            <a:ext cx="181440" cy="0"/>
+          </a:xfrm>
+          <a:prstGeom prst="line">
+            <a:avLst/>
+          </a:prstGeom>
+          <a:ln w="10160">
+            <a:solidFill>
+              <a:srgbClr val="1D4ED8"/>
+            </a:solidFill>
+          </a:ln>
+          <a:effectLst/>
+        </p:spPr>
+        <p:style>
+          <a:lnRef idx="2">
+            <a:schemeClr val="accent1"/>
+          </a:lnRef>
+          <a:fillRef idx="0">
+            <a:schemeClr val="accent1"/>
+          </a:fillRef>
+          <a:effectRef idx="1">
+            <a:schemeClr val="accent1"/>
+          </a:effectRef>
+          <a:fontRef idx="minor">
+            <a:schemeClr val="tx1"/>
+          </a:fontRef>
+        </p:style>
+      </p:cxnSp>
+      <p:sp>
+        <p:nvSpPr>
+          <p:cNvPr id="45" name="TextBox 44"/>
           <p:cNvSpPr txBox="1"/>
           <p:nvPr>
             <p:custDataLst>
@@ -6065,7 +6101,7 @@
       </p:sp>
       <p:sp>
         <p:nvSpPr>
-          <p:cNvPr id="45" name="TextBox 44"/>
+          <p:cNvPr id="46" name="TextBox 45"/>
           <p:cNvSpPr txBox="1"/>
           <p:nvPr>
             <p:custDataLst>
@@ -6116,7 +6152,7 @@
       </p:sp>
       <p:sp>
         <p:nvSpPr>
-          <p:cNvPr id="46" name="TextBox 45"/>
+          <p:cNvPr id="47" name="TextBox 46"/>
           <p:cNvSpPr txBox="1"/>
           <p:nvPr>
             <p:custDataLst>
@@ -6191,7 +6227,7 @@
       </p:sp>
       <p:sp>
         <p:nvSpPr>
-          <p:cNvPr id="47" name="Down Arrow 46"/>
+          <p:cNvPr id="48" name="Down Arrow 47"/>
           <p:cNvSpPr/>
           <p:nvPr/>
         </p:nvSpPr>
@@ -6240,7 +6276,7 @@
       </p:sp>
       <p:sp>
         <p:nvSpPr>
-          <p:cNvPr id="48" name="Rounded Rectangle 47"/>
+          <p:cNvPr id="49" name="Rounded Rectangle 48"/>
           <p:cNvSpPr/>
           <p:nvPr/>
         </p:nvSpPr>
@@ -6291,7 +6327,7 @@
       </p:sp>
       <p:pic>
         <p:nvPicPr>
-          <p:cNvPr id="49" name="Picture 48" descr="flat-icon-4.png"/>
+          <p:cNvPr id="50" name="Picture 49" descr="flat-icon-4.png"/>
           <p:cNvPicPr>
             <a:picLocks noChangeAspect="1"/>
           </p:cNvPicPr>
@@ -6315,7 +6351,7 @@
       </p:pic>
       <p:sp>
         <p:nvSpPr>
-          <p:cNvPr id="50" name="TextBox 49"/>
+          <p:cNvPr id="51" name="TextBox 50"/>
           <p:cNvSpPr txBox="1"/>
           <p:nvPr>
             <p:custDataLst>
@@ -6366,7 +6402,7 @@
       </p:sp>
       <p:sp>
         <p:nvSpPr>
-          <p:cNvPr id="51" name="TextBox 50"/>
+          <p:cNvPr id="52" name="TextBox 51"/>
           <p:cNvSpPr txBox="1"/>
           <p:nvPr>
             <p:custDataLst>
@@ -6417,7 +6453,7 @@
       </p:sp>
       <p:sp>
         <p:nvSpPr>
-          <p:cNvPr id="52" name="TextBox 51"/>
+          <p:cNvPr id="53" name="TextBox 52"/>
           <p:cNvSpPr txBox="1"/>
           <p:nvPr>
             <p:custDataLst>
@@ -6492,7 +6528,7 @@
       </p:sp>
       <p:sp>
         <p:nvSpPr>
-          <p:cNvPr id="53" name="Rounded Rectangle 52"/>
+          <p:cNvPr id="54" name="Rounded Rectangle 53"/>
           <p:cNvSpPr/>
           <p:nvPr/>
         </p:nvSpPr>
@@ -6545,7 +6581,7 @@
       </p:sp>
       <p:sp>
         <p:nvSpPr>
-          <p:cNvPr id="54" name="TextBox 53"/>
+          <p:cNvPr id="55" name="TextBox 54"/>
           <p:cNvSpPr txBox="1"/>
           <p:nvPr>
             <p:custDataLst>
@@ -6596,7 +6632,7 @@
       </p:sp>
       <p:sp>
         <p:nvSpPr>
-          <p:cNvPr id="55" name="TextBox 54"/>
+          <p:cNvPr id="56" name="TextBox 55"/>
           <p:cNvSpPr txBox="1"/>
           <p:nvPr>
             <p:custDataLst>
@@ -6647,7 +6683,7 @@
       </p:sp>
       <p:sp>
         <p:nvSpPr>
-          <p:cNvPr id="56" name="Rounded Rectangle 55"/>
+          <p:cNvPr id="57" name="Rounded Rectangle 56"/>
           <p:cNvSpPr/>
           <p:nvPr/>
         </p:nvSpPr>
@@ -6700,7 +6736,7 @@
       </p:sp>
       <p:sp>
         <p:nvSpPr>
-          <p:cNvPr id="57" name="TextBox 56"/>
+          <p:cNvPr id="58" name="TextBox 57"/>
           <p:cNvSpPr txBox="1"/>
           <p:nvPr>
             <p:custDataLst>
@@ -6751,7 +6787,7 @@
       </p:sp>
       <p:sp>
         <p:nvSpPr>
-          <p:cNvPr id="58" name="TextBox 57"/>
+          <p:cNvPr id="59" name="TextBox 58"/>
           <p:cNvSpPr txBox="1"/>
           <p:nvPr>
             <p:custDataLst>
@@ -6800,42 +6836,6 @@
           </a:p>
         </p:txBody>
       </p:sp>
-      <p:cxnSp>
-        <p:nvCxnSpPr>
-          <p:cNvPr id="59" name="Connector 58"/>
-          <p:cNvCxnSpPr/>
-          <p:nvPr/>
-        </p:nvCxnSpPr>
-        <p:spPr>
-          <a:xfrm>
-            <a:off x="7344000" y="7164000"/>
-            <a:ext cx="288000" cy="0"/>
-          </a:xfrm>
-          <a:prstGeom prst="line">
-            <a:avLst/>
-          </a:prstGeom>
-          <a:ln w="15240">
-            <a:solidFill>
-              <a:srgbClr val="1D4ED8"/>
-            </a:solidFill>
-          </a:ln>
-          <a:effectLst/>
-        </p:spPr>
-        <p:style>
-          <a:lnRef idx="2">
-            <a:schemeClr val="accent1"/>
-          </a:lnRef>
-          <a:fillRef idx="0">
-            <a:schemeClr val="accent1"/>
-          </a:fillRef>
-          <a:effectRef idx="1">
-            <a:schemeClr val="accent1"/>
-          </a:effectRef>
-          <a:fontRef idx="minor">
-            <a:schemeClr val="tx1"/>
-          </a:fontRef>
-        </p:style>
-      </p:cxnSp>
       <p:cxnSp>
         <p:nvCxnSpPr>
           <p:cNvPr id="60" name="Connector 59"/>
@@ -6844,7 +6844,7 @@
         </p:nvCxnSpPr>
         <p:spPr>
           <a:xfrm>
-            <a:off x="7344000" y="7884000"/>
+            <a:off x="7344000" y="7164000"/>
             <a:ext cx="288000" cy="0"/>
           </a:xfrm>
           <a:prstGeom prst="line">
@@ -6880,8 +6880,8 @@
         </p:nvCxnSpPr>
         <p:spPr>
           <a:xfrm>
-            <a:off x="7632000" y="7164000"/>
-            <a:ext cx="0" cy="720000"/>
+            <a:off x="7344000" y="7884000"/>
+            <a:ext cx="288000" cy="0"/>
           </a:xfrm>
           <a:prstGeom prst="line">
             <a:avLst/>
@@ -6908,9 +6908,45 @@
           </a:fontRef>
         </p:style>
       </p:cxnSp>
-      <p:sp>
-        <p:nvSpPr>
-          <p:cNvPr id="62" name="Right Arrow 61"/>
+      <p:cxnSp>
+        <p:nvCxnSpPr>
+          <p:cNvPr id="62" name="Connector 61"/>
+          <p:cNvCxnSpPr/>
+          <p:nvPr/>
+        </p:nvCxnSpPr>
+        <p:spPr>
+          <a:xfrm>
+            <a:off x="7632000" y="7164000"/>
+            <a:ext cx="0" cy="720000"/>
+          </a:xfrm>
+          <a:prstGeom prst="line">
+            <a:avLst/>
+          </a:prstGeom>
+          <a:ln w="15240">
+            <a:solidFill>
+              <a:srgbClr val="1D4ED8"/>
+            </a:solidFill>
+          </a:ln>
+          <a:effectLst/>
+        </p:spPr>
+        <p:style>
+          <a:lnRef idx="2">
+            <a:schemeClr val="accent1"/>
+          </a:lnRef>
+          <a:fillRef idx="0">
+            <a:schemeClr val="accent1"/>
+          </a:fillRef>
+          <a:effectRef idx="1">
+            <a:schemeClr val="accent1"/>
+          </a:effectRef>
+          <a:fontRef idx="minor">
+            <a:schemeClr val="tx1"/>
+          </a:fontRef>
+        </p:style>
+      </p:cxnSp>
+      <p:sp>
+        <p:nvSpPr>
+          <p:cNvPr id="63" name="Right Arrow 62"/>
           <p:cNvSpPr/>
           <p:nvPr/>
         </p:nvSpPr>
@@ -6959,7 +6995,7 @@
       </p:sp>
       <p:sp>
         <p:nvSpPr>
-          <p:cNvPr id="63" name="Rounded Rectangle 62"/>
+          <p:cNvPr id="64" name="Rounded Rectangle 63"/>
           <p:cNvSpPr/>
           <p:nvPr/>
         </p:nvSpPr>
@@ -7010,7 +7046,7 @@
       </p:sp>
       <p:sp>
         <p:nvSpPr>
-          <p:cNvPr id="64" name="TextBox 63"/>
+          <p:cNvPr id="65" name="TextBox 64"/>
           <p:cNvSpPr txBox="1"/>
           <p:nvPr>
             <p:custDataLst>
@@ -7061,7 +7097,7 @@
       </p:sp>
       <p:sp>
         <p:nvSpPr>
-          <p:cNvPr id="65" name="TextBox 64"/>
+          <p:cNvPr id="66" name="TextBox 65"/>
           <p:cNvSpPr txBox="1"/>
           <p:nvPr>
             <p:custDataLst>
@@ -7112,7 +7148,7 @@
       </p:sp>
       <p:sp>
         <p:nvSpPr>
-          <p:cNvPr id="66" name="Right Arrow 65"/>
+          <p:cNvPr id="67" name="Right Arrow 66"/>
           <p:cNvSpPr/>
           <p:nvPr/>
         </p:nvSpPr>
@@ -7161,7 +7197,7 @@
       </p:sp>
       <p:sp>
         <p:nvSpPr>
-          <p:cNvPr id="67" name="Rounded Rectangle 66"/>
+          <p:cNvPr id="68" name="Rounded Rectangle 67"/>
           <p:cNvSpPr/>
           <p:nvPr/>
         </p:nvSpPr>
@@ -7212,7 +7248,7 @@
       </p:sp>
       <p:sp>
         <p:nvSpPr>
-          <p:cNvPr id="68" name="TextBox 67"/>
+          <p:cNvPr id="69" name="TextBox 68"/>
           <p:cNvSpPr txBox="1"/>
           <p:nvPr>
             <p:custDataLst>
@@ -7263,7 +7299,7 @@
       </p:sp>
       <p:sp>
         <p:nvSpPr>
-          <p:cNvPr id="69" name="TextBox 68"/>
+          <p:cNvPr id="70" name="TextBox 69"/>
           <p:cNvSpPr txBox="1"/>
           <p:nvPr>
             <p:custDataLst>
@@ -7314,7 +7350,7 @@
       </p:sp>
       <p:sp>
         <p:nvSpPr>
-          <p:cNvPr id="70" name="Rounded Rectangle 69"/>
+          <p:cNvPr id="71" name="Rounded Rectangle 70"/>
           <p:cNvSpPr/>
           <p:nvPr/>
         </p:nvSpPr>
@@ -7367,7 +7403,7 @@
       </p:sp>
       <p:sp>
         <p:nvSpPr>
-          <p:cNvPr id="71" name="TextBox 70"/>
+          <p:cNvPr id="72" name="TextBox 71"/>
           <p:cNvSpPr txBox="1"/>
           <p:nvPr>
             <p:custDataLst>
@@ -7418,7 +7454,7 @@
       </p:sp>
       <p:sp>
         <p:nvSpPr>
-          <p:cNvPr id="72" name="Rounded Rectangle 71"/>
+          <p:cNvPr id="73" name="Rounded Rectangle 72"/>
           <p:cNvSpPr/>
           <p:nvPr/>
         </p:nvSpPr>
@@ -7471,7 +7507,7 @@
       </p:sp>
       <p:sp>
         <p:nvSpPr>
-          <p:cNvPr id="73" name="TextBox 72"/>
+          <p:cNvPr id="74" name="TextBox 73"/>
           <p:cNvSpPr txBox="1"/>
           <p:nvPr>
             <p:custDataLst>
@@ -7520,42 +7556,6 @@
           </a:p>
         </p:txBody>
       </p:sp>
-      <p:cxnSp>
-        <p:nvCxnSpPr>
-          <p:cNvPr id="74" name="Connector 73"/>
-          <p:cNvCxnSpPr/>
-          <p:nvPr/>
-        </p:nvCxnSpPr>
-        <p:spPr>
-          <a:xfrm>
-            <a:off x="7344000" y="8856000"/>
-            <a:ext cx="288000" cy="0"/>
-          </a:xfrm>
-          <a:prstGeom prst="line">
-            <a:avLst/>
-          </a:prstGeom>
-          <a:ln w="15240">
-            <a:solidFill>
-              <a:srgbClr val="1D4ED8"/>
-            </a:solidFill>
-          </a:ln>
-          <a:effectLst/>
-        </p:spPr>
-        <p:style>
-          <a:lnRef idx="2">
-            <a:schemeClr val="accent1"/>
-          </a:lnRef>
-          <a:fillRef idx="0">
-            <a:schemeClr val="accent1"/>
-          </a:fillRef>
-          <a:effectRef idx="1">
-            <a:schemeClr val="accent1"/>
-          </a:effectRef>
-          <a:fontRef idx="minor">
-            <a:schemeClr val="tx1"/>
-          </a:fontRef>
-        </p:style>
-      </p:cxnSp>
       <p:cxnSp>
         <p:nvCxnSpPr>
           <p:cNvPr id="75" name="Connector 74"/>
@@ -7564,7 +7564,7 @@
         </p:nvCxnSpPr>
         <p:spPr>
           <a:xfrm>
-            <a:off x="7344000" y="9576000"/>
+            <a:off x="7344000" y="8856000"/>
             <a:ext cx="288000" cy="0"/>
           </a:xfrm>
           <a:prstGeom prst="line">
@@ -7600,8 +7600,8 @@
         </p:nvCxnSpPr>
         <p:spPr>
           <a:xfrm>
-            <a:off x="7632000" y="8856000"/>
-            <a:ext cx="0" cy="720000"/>
+            <a:off x="7344000" y="9576000"/>
+            <a:ext cx="288000" cy="0"/>
           </a:xfrm>
           <a:prstGeom prst="line">
             <a:avLst/>
@@ -7628,9 +7628,45 @@
           </a:fontRef>
         </p:style>
       </p:cxnSp>
-      <p:sp>
-        <p:nvSpPr>
-          <p:cNvPr id="77" name="Right Arrow 76"/>
+      <p:cxnSp>
+        <p:nvCxnSpPr>
+          <p:cNvPr id="77" name="Connector 76"/>
+          <p:cNvCxnSpPr/>
+          <p:nvPr/>
+        </p:nvCxnSpPr>
+        <p:spPr>
+          <a:xfrm>
+            <a:off x="7632000" y="8856000"/>
+            <a:ext cx="0" cy="720000"/>
+          </a:xfrm>
+          <a:prstGeom prst="line">
+            <a:avLst/>
+          </a:prstGeom>
+          <a:ln w="15240">
+            <a:solidFill>
+              <a:srgbClr val="1D4ED8"/>
+            </a:solidFill>
+          </a:ln>
+          <a:effectLst/>
+        </p:spPr>
+        <p:style>
+          <a:lnRef idx="2">
+            <a:schemeClr val="accent1"/>
+          </a:lnRef>
+          <a:fillRef idx="0">
+            <a:schemeClr val="accent1"/>
+          </a:fillRef>
+          <a:effectRef idx="1">
+            <a:schemeClr val="accent1"/>
+          </a:effectRef>
+          <a:fontRef idx="minor">
+            <a:schemeClr val="tx1"/>
+          </a:fontRef>
+        </p:style>
+      </p:cxnSp>
+      <p:sp>
+        <p:nvSpPr>
+          <p:cNvPr id="78" name="Right Arrow 77"/>
           <p:cNvSpPr/>
           <p:nvPr/>
         </p:nvSpPr>
@@ -7679,7 +7715,7 @@
       </p:sp>
       <p:sp>
         <p:nvSpPr>
-          <p:cNvPr id="78" name="Rounded Rectangle 77"/>
+          <p:cNvPr id="79" name="Rounded Rectangle 78"/>
           <p:cNvSpPr/>
           <p:nvPr/>
         </p:nvSpPr>
@@ -7730,7 +7766,7 @@
       </p:sp>
       <p:sp>
         <p:nvSpPr>
-          <p:cNvPr id="79" name="TextBox 78"/>
+          <p:cNvPr id="80" name="TextBox 79"/>
           <p:cNvSpPr txBox="1"/>
           <p:nvPr>
             <p:custDataLst>
@@ -7781,7 +7817,7 @@
       </p:sp>
       <p:sp>
         <p:nvSpPr>
-          <p:cNvPr id="80" name="TextBox 79"/>
+          <p:cNvPr id="81" name="TextBox 80"/>
           <p:cNvSpPr txBox="1"/>
           <p:nvPr>
             <p:custDataLst>
@@ -7832,7 +7868,7 @@
       </p:sp>
       <p:sp>
         <p:nvSpPr>
-          <p:cNvPr id="81" name="Right Arrow 80"/>
+          <p:cNvPr id="82" name="Right Arrow 81"/>
           <p:cNvSpPr/>
           <p:nvPr/>
         </p:nvSpPr>
@@ -7881,7 +7917,7 @@
       </p:sp>
       <p:sp>
         <p:nvSpPr>
-          <p:cNvPr id="82" name="Rounded Rectangle 81"/>
+          <p:cNvPr id="83" name="Rounded Rectangle 82"/>
           <p:cNvSpPr/>
           <p:nvPr/>
         </p:nvSpPr>
@@ -7932,7 +7968,7 @@
       </p:sp>
       <p:sp>
         <p:nvSpPr>
-          <p:cNvPr id="83" name="TextBox 82"/>
+          <p:cNvPr id="84" name="TextBox 83"/>
           <p:cNvSpPr txBox="1"/>
           <p:nvPr>
             <p:custDataLst>
@@ -7983,7 +8019,7 @@
       </p:sp>
       <p:sp>
         <p:nvSpPr>
-          <p:cNvPr id="84" name="Rounded Rectangle 83"/>
+          <p:cNvPr id="85" name="Rounded Rectangle 84"/>
           <p:cNvSpPr/>
           <p:nvPr/>
         </p:nvSpPr>
@@ -8034,7 +8070,7 @@
       </p:sp>
       <p:sp>
         <p:nvSpPr>
-          <p:cNvPr id="85" name="TextBox 84"/>
+          <p:cNvPr id="86" name="TextBox 85"/>
           <p:cNvSpPr txBox="1"/>
           <p:nvPr>
             <p:custDataLst>
@@ -8085,7 +8121,7 @@
       </p:sp>
       <p:sp>
         <p:nvSpPr>
-          <p:cNvPr id="86" name="Rounded Rectangle 85"/>
+          <p:cNvPr id="87" name="Rounded Rectangle 86"/>
           <p:cNvSpPr/>
           <p:nvPr/>
         </p:nvSpPr>
@@ -8136,7 +8172,7 @@
       </p:sp>
       <p:sp>
         <p:nvSpPr>
-          <p:cNvPr id="87" name="TextBox 86"/>
+          <p:cNvPr id="88" name="TextBox 87"/>
           <p:cNvSpPr txBox="1"/>
           <p:nvPr>
             <p:custDataLst>
@@ -8187,7 +8223,7 @@
       </p:sp>
       <p:sp>
         <p:nvSpPr>
-          <p:cNvPr id="88" name="Rounded Rectangle 87"/>
+          <p:cNvPr id="89" name="Rounded Rectangle 88"/>
           <p:cNvSpPr/>
           <p:nvPr/>
         </p:nvSpPr>
@@ -8238,7 +8274,7 @@
       </p:sp>
       <p:sp>
         <p:nvSpPr>
-          <p:cNvPr id="89" name="TextBox 88"/>
+          <p:cNvPr id="90" name="TextBox 89"/>
           <p:cNvSpPr txBox="1"/>
           <p:nvPr>
             <p:custDataLst>
@@ -8289,7 +8325,7 @@
       </p:sp>
       <p:sp>
         <p:nvSpPr>
-          <p:cNvPr id="90" name="Rounded Rectangle 89"/>
+          <p:cNvPr id="91" name="Rounded Rectangle 90"/>
           <p:cNvSpPr/>
           <p:nvPr/>
         </p:nvSpPr>
@@ -8340,7 +8376,7 @@
       </p:sp>
       <p:sp>
         <p:nvSpPr>
-          <p:cNvPr id="91" name="TextBox 90"/>
+          <p:cNvPr id="92" name="TextBox 91"/>
           <p:cNvSpPr txBox="1"/>
           <p:nvPr>
             <p:custDataLst>
@@ -8391,7 +8427,7 @@
       </p:sp>
       <p:sp>
         <p:nvSpPr>
-          <p:cNvPr id="92" name="Rounded Rectangle 91"/>
+          <p:cNvPr id="93" name="Rounded Rectangle 92"/>
           <p:cNvSpPr/>
           <p:nvPr/>
         </p:nvSpPr>
@@ -8442,7 +8478,7 @@
       </p:sp>
       <p:sp>
         <p:nvSpPr>
-          <p:cNvPr id="93" name="TextBox 92"/>
+          <p:cNvPr id="94" name="TextBox 93"/>
           <p:cNvSpPr txBox="1"/>
           <p:nvPr>
             <p:custDataLst>
@@ -8493,7 +8529,7 @@
       </p:sp>
       <p:sp>
         <p:nvSpPr>
-          <p:cNvPr id="94" name="Rounded Rectangle 93"/>
+          <p:cNvPr id="95" name="Rounded Rectangle 94"/>
           <p:cNvSpPr/>
           <p:nvPr/>
         </p:nvSpPr>
@@ -8546,7 +8582,7 @@
       </p:sp>
       <p:sp>
         <p:nvSpPr>
-          <p:cNvPr id="95" name="TextBox 94"/>
+          <p:cNvPr id="96" name="TextBox 95"/>
           <p:cNvSpPr txBox="1"/>
           <p:nvPr>
             <p:custDataLst>
@@ -8597,7 +8633,7 @@
       </p:sp>
       <p:sp>
         <p:nvSpPr>
-          <p:cNvPr id="96" name="Rounded Rectangle 95"/>
+          <p:cNvPr id="97" name="Rounded Rectangle 96"/>
           <p:cNvSpPr/>
           <p:nvPr/>
         </p:nvSpPr>
@@ -8650,7 +8686,7 @@
       </p:sp>
       <p:sp>
         <p:nvSpPr>
-          <p:cNvPr id="97" name="TextBox 96"/>
+          <p:cNvPr id="98" name="TextBox 97"/>
           <p:cNvSpPr txBox="1"/>
           <p:nvPr>
             <p:custDataLst>
@@ -8699,42 +8735,6 @@
           </a:p>
         </p:txBody>
       </p:sp>
-      <p:cxnSp>
-        <p:nvCxnSpPr>
-          <p:cNvPr id="98" name="Connector 97"/>
-          <p:cNvCxnSpPr/>
-          <p:nvPr/>
-        </p:nvCxnSpPr>
-        <p:spPr>
-          <a:xfrm>
-            <a:off x="7344000" y="10548000"/>
-            <a:ext cx="288000" cy="0"/>
-          </a:xfrm>
-          <a:prstGeom prst="line">
-            <a:avLst/>
-          </a:prstGeom>
-          <a:ln w="15240">
-            <a:solidFill>
-              <a:srgbClr val="1D4ED8"/>
-            </a:solidFill>
-          </a:ln>
-          <a:effectLst/>
-        </p:spPr>
-        <p:style>
-          <a:lnRef idx="2">
-            <a:schemeClr val="accent1"/>
-          </a:lnRef>
-          <a:fillRef idx="0">
-            <a:schemeClr val="accent1"/>
-          </a:fillRef>
-          <a:effectRef idx="1">
-            <a:schemeClr val="accent1"/>
-          </a:effectRef>
-          <a:fontRef idx="minor">
-            <a:schemeClr val="tx1"/>
-          </a:fontRef>
-        </p:style>
-      </p:cxnSp>
       <p:cxnSp>
         <p:nvCxnSpPr>
           <p:cNvPr id="99" name="Connector 98"/>
@@ -8743,7 +8743,7 @@
         </p:nvCxnSpPr>
         <p:spPr>
           <a:xfrm>
-            <a:off x="7344000" y="11268000"/>
+            <a:off x="7344000" y="10548000"/>
             <a:ext cx="288000" cy="0"/>
           </a:xfrm>
           <a:prstGeom prst="line">
@@ -8779,8 +8779,8 @@
         </p:nvCxnSpPr>
         <p:spPr>
           <a:xfrm>
-            <a:off x="7632000" y="10548000"/>
-            <a:ext cx="0" cy="720000"/>
+            <a:off x="7344000" y="11268000"/>
+            <a:ext cx="288000" cy="0"/>
           </a:xfrm>
           <a:prstGeom prst="line">
             <a:avLst/>
@@ -8807,9 +8807,45 @@
           </a:fontRef>
         </p:style>
       </p:cxnSp>
-      <p:sp>
-        <p:nvSpPr>
-          <p:cNvPr id="101" name="Right Arrow 100"/>
+      <p:cxnSp>
+        <p:nvCxnSpPr>
+          <p:cNvPr id="101" name="Connector 100"/>
+          <p:cNvCxnSpPr/>
+          <p:nvPr/>
+        </p:nvCxnSpPr>
+        <p:spPr>
+          <a:xfrm>
+            <a:off x="7632000" y="10548000"/>
+            <a:ext cx="0" cy="720000"/>
+          </a:xfrm>
+          <a:prstGeom prst="line">
+            <a:avLst/>
+          </a:prstGeom>
+          <a:ln w="15240">
+            <a:solidFill>
+              <a:srgbClr val="1D4ED8"/>
+            </a:solidFill>
+          </a:ln>
+          <a:effectLst/>
+        </p:spPr>
+        <p:style>
+          <a:lnRef idx="2">
+            <a:schemeClr val="accent1"/>
+          </a:lnRef>
+          <a:fillRef idx="0">
+            <a:schemeClr val="accent1"/>
+          </a:fillRef>
+          <a:effectRef idx="1">
+            <a:schemeClr val="accent1"/>
+          </a:effectRef>
+          <a:fontRef idx="minor">
+            <a:schemeClr val="tx1"/>
+          </a:fontRef>
+        </p:style>
+      </p:cxnSp>
+      <p:sp>
+        <p:nvSpPr>
+          <p:cNvPr id="102" name="Right Arrow 101"/>
           <p:cNvSpPr/>
           <p:nvPr/>
         </p:nvSpPr>
@@ -8858,7 +8894,7 @@
       </p:sp>
       <p:sp>
         <p:nvSpPr>
-          <p:cNvPr id="102" name="Rounded Rectangle 101"/>
+          <p:cNvPr id="103" name="Rounded Rectangle 102"/>
           <p:cNvSpPr/>
           <p:nvPr/>
         </p:nvSpPr>
@@ -8909,7 +8945,7 @@
       </p:sp>
       <p:sp>
         <p:nvSpPr>
-          <p:cNvPr id="103" name="TextBox 102"/>
+          <p:cNvPr id="104" name="TextBox 103"/>
           <p:cNvSpPr txBox="1"/>
           <p:nvPr>
             <p:custDataLst>
@@ -8960,7 +8996,7 @@
       </p:sp>
       <p:sp>
         <p:nvSpPr>
-          <p:cNvPr id="104" name="TextBox 103"/>
+          <p:cNvPr id="105" name="TextBox 104"/>
           <p:cNvSpPr txBox="1"/>
           <p:nvPr>
             <p:custDataLst>
@@ -9011,7 +9047,7 @@
       </p:sp>
       <p:sp>
         <p:nvSpPr>
-          <p:cNvPr id="105" name="Right Arrow 104"/>
+          <p:cNvPr id="106" name="Right Arrow 105"/>
           <p:cNvSpPr/>
           <p:nvPr/>
         </p:nvSpPr>
@@ -9060,7 +9096,7 @@
       </p:sp>
       <p:sp>
         <p:nvSpPr>
-          <p:cNvPr id="106" name="Rounded Rectangle 105"/>
+          <p:cNvPr id="107" name="Rounded Rectangle 106"/>
           <p:cNvSpPr/>
           <p:nvPr/>
         </p:nvSpPr>
@@ -9111,7 +9147,7 @@
       </p:sp>
       <p:sp>
         <p:nvSpPr>
-          <p:cNvPr id="107" name="TextBox 106"/>
+          <p:cNvPr id="108" name="TextBox 107"/>
           <p:cNvSpPr txBox="1"/>
           <p:nvPr>
             <p:custDataLst>
@@ -9162,7 +9198,7 @@
       </p:sp>
       <p:sp>
         <p:nvSpPr>
-          <p:cNvPr id="108" name="Rounded Rectangle 107"/>
+          <p:cNvPr id="109" name="Rounded Rectangle 108"/>
           <p:cNvSpPr/>
           <p:nvPr/>
         </p:nvSpPr>
@@ -9213,7 +9249,7 @@
       </p:sp>
       <p:sp>
         <p:nvSpPr>
-          <p:cNvPr id="109" name="TextBox 108"/>
+          <p:cNvPr id="110" name="TextBox 109"/>
           <p:cNvSpPr txBox="1"/>
           <p:nvPr>
             <p:custDataLst>
@@ -9264,7 +9300,7 @@
       </p:sp>
       <p:sp>
         <p:nvSpPr>
-          <p:cNvPr id="110" name="Rounded Rectangle 109"/>
+          <p:cNvPr id="111" name="Rounded Rectangle 110"/>
           <p:cNvSpPr/>
           <p:nvPr/>
         </p:nvSpPr>
@@ -9315,7 +9351,7 @@
       </p:sp>
       <p:sp>
         <p:nvSpPr>
-          <p:cNvPr id="111" name="TextBox 110"/>
+          <p:cNvPr id="112" name="TextBox 111"/>
           <p:cNvSpPr txBox="1"/>
           <p:nvPr>
             <p:custDataLst>
@@ -9366,7 +9402,7 @@
       </p:sp>
       <p:sp>
         <p:nvSpPr>
-          <p:cNvPr id="112" name="TextBox 111"/>
+          <p:cNvPr id="113" name="TextBox 112"/>
           <p:cNvSpPr txBox="1"/>
           <p:nvPr>
             <p:custDataLst>
@@ -9417,7 +9453,7 @@
       </p:sp>
       <p:sp>
         <p:nvSpPr>
-          <p:cNvPr id="113" name="Rounded Rectangle 112"/>
+          <p:cNvPr id="114" name="Rounded Rectangle 113"/>
           <p:cNvSpPr/>
           <p:nvPr/>
         </p:nvSpPr>
@@ -9470,7 +9506,7 @@
       </p:sp>
       <p:sp>
         <p:nvSpPr>
-          <p:cNvPr id="114" name="TextBox 113"/>
+          <p:cNvPr id="115" name="TextBox 114"/>
           <p:cNvSpPr txBox="1"/>
           <p:nvPr>
             <p:custDataLst>
@@ -9521,7 +9557,7 @@
       </p:sp>
       <p:sp>
         <p:nvSpPr>
-          <p:cNvPr id="115" name="Right Arrow 114"/>
+          <p:cNvPr id="116" name="Right Arrow 115"/>
           <p:cNvSpPr/>
           <p:nvPr/>
         </p:nvSpPr>
@@ -9570,7 +9606,7 @@
       </p:sp>
       <p:sp>
         <p:nvSpPr>
-          <p:cNvPr id="116" name="Rounded Rectangle 115"/>
+          <p:cNvPr id="117" name="Rounded Rectangle 116"/>
           <p:cNvSpPr/>
           <p:nvPr/>
         </p:nvSpPr>
@@ -9623,7 +9659,7 @@
       </p:sp>
       <p:sp>
         <p:nvSpPr>
-          <p:cNvPr id="117" name="TextBox 116"/>
+          <p:cNvPr id="118" name="TextBox 117"/>
           <p:cNvSpPr txBox="1"/>
           <p:nvPr>
             <p:custDataLst>
@@ -9674,7 +9710,7 @@
       </p:sp>
       <p:sp>
         <p:nvSpPr>
-          <p:cNvPr id="118" name="Right Arrow 117"/>
+          <p:cNvPr id="119" name="Right Arrow 118"/>
           <p:cNvSpPr/>
           <p:nvPr/>
         </p:nvSpPr>
@@ -9723,7 +9759,7 @@
       </p:sp>
       <p:sp>
         <p:nvSpPr>
-          <p:cNvPr id="119" name="Rounded Rectangle 118"/>
+          <p:cNvPr id="120" name="Rounded Rectangle 119"/>
           <p:cNvSpPr/>
           <p:nvPr/>
         </p:nvSpPr>
@@ -9774,7 +9810,7 @@
       </p:sp>
       <p:sp>
         <p:nvSpPr>
-          <p:cNvPr id="120" name="TextBox 119"/>
+          <p:cNvPr id="121" name="TextBox 120"/>
           <p:cNvSpPr txBox="1"/>
           <p:nvPr>
             <p:custDataLst>
@@ -9825,7 +9861,7 @@
       </p:sp>
       <p:sp>
         <p:nvSpPr>
-          <p:cNvPr id="121" name="TextBox 120"/>
+          <p:cNvPr id="122" name="TextBox 121"/>
           <p:cNvSpPr txBox="1"/>
           <p:nvPr>
             <p:custDataLst>
@@ -9876,7 +9912,7 @@
       </p:sp>
       <p:sp>
         <p:nvSpPr>
-          <p:cNvPr id="122" name="Rounded Rectangle 121"/>
+          <p:cNvPr id="123" name="Rounded Rectangle 122"/>
           <p:cNvSpPr/>
           <p:nvPr/>
         </p:nvSpPr>
@@ -9927,7 +9963,7 @@
       </p:sp>
       <p:sp>
         <p:nvSpPr>
-          <p:cNvPr id="123" name="Oval 122"/>
+          <p:cNvPr id="124" name="Oval 123"/>
           <p:cNvSpPr/>
           <p:nvPr/>
         </p:nvSpPr>
@@ -9976,7 +10012,7 @@
       </p:sp>
       <p:sp>
         <p:nvSpPr>
-          <p:cNvPr id="124" name="Oval 123"/>
+          <p:cNvPr id="125" name="Oval 124"/>
           <p:cNvSpPr/>
           <p:nvPr/>
         </p:nvSpPr>
@@ -10025,7 +10061,7 @@
       </p:sp>
       <p:sp>
         <p:nvSpPr>
-          <p:cNvPr id="125" name="Oval 124"/>
+          <p:cNvPr id="126" name="Oval 125"/>
           <p:cNvSpPr/>
           <p:nvPr/>
         </p:nvSpPr>
@@ -10074,7 +10110,7 @@
       </p:sp>
       <p:sp>
         <p:nvSpPr>
-          <p:cNvPr id="126" name="Oval 125"/>
+          <p:cNvPr id="127" name="Oval 126"/>
           <p:cNvSpPr/>
           <p:nvPr/>
         </p:nvSpPr>
@@ -10123,7 +10159,7 @@
       </p:sp>
       <p:sp>
         <p:nvSpPr>
-          <p:cNvPr id="127" name="TextBox 126"/>
+          <p:cNvPr id="128" name="TextBox 127"/>
           <p:cNvSpPr txBox="1"/>
           <p:nvPr>
             <p:custDataLst>
@@ -10174,7 +10210,7 @@
       </p:sp>
       <p:sp>
         <p:nvSpPr>
-          <p:cNvPr id="128" name="TextBox 127"/>
+          <p:cNvPr id="129" name="TextBox 128"/>
           <p:cNvSpPr txBox="1"/>
           <p:nvPr>
             <p:custDataLst>
@@ -10225,7 +10261,7 @@
       </p:sp>
       <p:sp>
         <p:nvSpPr>
-          <p:cNvPr id="129" name="TextBox 128"/>
+          <p:cNvPr id="130" name="TextBox 129"/>
           <p:cNvSpPr txBox="1"/>
           <p:nvPr>
             <p:custDataLst>
@@ -10276,7 +10312,7 @@
       </p:sp>
       <p:cxnSp>
         <p:nvCxnSpPr>
-          <p:cNvPr id="130" name="Connector 129"/>
+          <p:cNvPr id="131" name="Connector 130"/>
           <p:cNvCxnSpPr/>
           <p:nvPr/>
         </p:nvCxnSpPr>
@@ -10312,7 +10348,7 @@
       </p:cxnSp>
       <p:sp>
         <p:nvSpPr>
-          <p:cNvPr id="131" name="Rounded Rectangle 130"/>
+          <p:cNvPr id="132" name="Rounded Rectangle 131"/>
           <p:cNvSpPr/>
           <p:nvPr/>
         </p:nvSpPr>
@@ -10365,7 +10401,7 @@
       </p:sp>
       <p:sp>
         <p:nvSpPr>
-          <p:cNvPr id="132" name="Rectangle 131"/>
+          <p:cNvPr id="133" name="Rectangle 132"/>
           <p:cNvSpPr/>
           <p:nvPr/>
         </p:nvSpPr>
@@ -10414,7 +10450,7 @@
       </p:sp>
       <p:sp>
         <p:nvSpPr>
-          <p:cNvPr id="133" name="TextBox 132"/>
+          <p:cNvPr id="134" name="TextBox 133"/>
           <p:cNvSpPr txBox="1"/>
           <p:nvPr>
             <p:custDataLst>
@@ -10465,7 +10501,7 @@
       </p:sp>
       <p:sp>
         <p:nvSpPr>
-          <p:cNvPr id="134" name="TextBox 133"/>
+          <p:cNvPr id="135" name="TextBox 134"/>
           <p:cNvSpPr txBox="1"/>
           <p:nvPr>
             <p:custDataLst>
@@ -10564,7 +10600,7 @@
       </p:sp>
       <p:sp>
         <p:nvSpPr>
-          <p:cNvPr id="135" name="Rounded Rectangle 134"/>
+          <p:cNvPr id="136" name="Rounded Rectangle 135"/>
           <p:cNvSpPr/>
           <p:nvPr/>
         </p:nvSpPr>
@@ -10617,7 +10653,7 @@
       </p:sp>
       <p:sp>
         <p:nvSpPr>
-          <p:cNvPr id="136" name="Rectangle 135"/>
+          <p:cNvPr id="137" name="Rectangle 136"/>
           <p:cNvSpPr/>
           <p:nvPr/>
         </p:nvSpPr>
@@ -10666,7 +10702,7 @@
       </p:sp>
       <p:sp>
         <p:nvSpPr>
-          <p:cNvPr id="137" name="TextBox 136"/>
+          <p:cNvPr id="138" name="TextBox 137"/>
           <p:cNvSpPr txBox="1"/>
           <p:nvPr>
             <p:custDataLst>
@@ -10717,7 +10753,7 @@
       </p:sp>
       <p:sp>
         <p:nvSpPr>
-          <p:cNvPr id="138" name="TextBox 137"/>
+          <p:cNvPr id="139" name="TextBox 138"/>
           <p:cNvSpPr txBox="1"/>
           <p:nvPr>
             <p:custDataLst>
@@ -10816,7 +10852,7 @@
       </p:sp>
       <p:sp>
         <p:nvSpPr>
-          <p:cNvPr id="139" name="Rounded Rectangle 138"/>
+          <p:cNvPr id="140" name="Rounded Rectangle 139"/>
           <p:cNvSpPr/>
           <p:nvPr/>
         </p:nvSpPr>
@@ -10869,7 +10905,7 @@
       </p:sp>
       <p:sp>
         <p:nvSpPr>
-          <p:cNvPr id="140" name="Rectangle 139"/>
+          <p:cNvPr id="141" name="Rectangle 140"/>
           <p:cNvSpPr/>
           <p:nvPr/>
         </p:nvSpPr>
@@ -10918,7 +10954,7 @@
       </p:sp>
       <p:sp>
         <p:nvSpPr>
-          <p:cNvPr id="141" name="TextBox 140"/>
+          <p:cNvPr id="142" name="TextBox 141"/>
           <p:cNvSpPr txBox="1"/>
           <p:nvPr>
             <p:custDataLst>
@@ -10969,7 +11005,7 @@
       </p:sp>
       <p:sp>
         <p:nvSpPr>
-          <p:cNvPr id="142" name="TextBox 141"/>
+          <p:cNvPr id="143" name="TextBox 142"/>
           <p:cNvSpPr txBox="1"/>
           <p:nvPr>
             <p:custDataLst>
@@ -11068,7 +11104,7 @@
       </p:sp>
       <p:sp>
         <p:nvSpPr>
-          <p:cNvPr id="143" name="TextBox 142"/>
+          <p:cNvPr id="144" name="TextBox 143"/>
           <p:cNvSpPr txBox="1"/>
           <p:nvPr>
             <p:custDataLst>
@@ -11119,7 +11155,7 @@
       </p:sp>
       <p:sp>
         <p:nvSpPr>
-          <p:cNvPr id="144" name="TextBox 143"/>
+          <p:cNvPr id="145" name="TextBox 144"/>
           <p:cNvSpPr txBox="1"/>
           <p:nvPr>
             <p:custDataLst>
@@ -11170,7 +11206,7 @@
       </p:sp>
       <p:cxnSp>
         <p:nvCxnSpPr>
-          <p:cNvPr id="145" name="Connector 144"/>
+          <p:cNvPr id="146" name="Connector 145"/>
           <p:cNvCxnSpPr/>
           <p:nvPr/>
         </p:nvCxnSpPr>
@@ -11206,7 +11242,7 @@
       </p:cxnSp>
       <p:sp>
         <p:nvSpPr>
-          <p:cNvPr id="146" name="TextBox 145"/>
+          <p:cNvPr id="147" name="TextBox 146"/>
           <p:cNvSpPr txBox="1"/>
           <p:nvPr>
             <p:custDataLst>
@@ -11257,7 +11293,7 @@
       </p:sp>
       <p:sp>
         <p:nvSpPr>
-          <p:cNvPr id="147" name="TextBox 146"/>
+          <p:cNvPr id="148" name="TextBox 147"/>
           <p:cNvSpPr txBox="1"/>
           <p:nvPr>
             <p:custDataLst>
@@ -11308,7 +11344,7 @@
       </p:sp>
       <p:sp>
         <p:nvSpPr>
-          <p:cNvPr id="148" name="Rectangle 147"/>
+          <p:cNvPr id="149" name="Rectangle 148"/>
           <p:cNvSpPr/>
           <p:nvPr/>
         </p:nvSpPr>
@@ -11357,7 +11393,7 @@
       </p:sp>
       <p:sp>
         <p:nvSpPr>
-          <p:cNvPr id="149" name="Rectangle 148"/>
+          <p:cNvPr id="150" name="Rectangle 149"/>
           <p:cNvSpPr/>
           <p:nvPr/>
         </p:nvSpPr>
@@ -11406,7 +11442,7 @@
       </p:sp>
       <p:sp>
         <p:nvSpPr>
-          <p:cNvPr id="150" name="TextBox 149"/>
+          <p:cNvPr id="151" name="TextBox 150"/>
           <p:cNvSpPr txBox="1"/>
           <p:nvPr>
             <p:custDataLst>
@@ -11457,7 +11493,7 @@
       </p:sp>
       <p:sp>
         <p:nvSpPr>
-          <p:cNvPr id="151" name="TextBox 150"/>
+          <p:cNvPr id="152" name="TextBox 151"/>
           <p:cNvSpPr txBox="1"/>
           <p:nvPr>
             <p:custDataLst>
@@ -11508,7 +11544,7 @@
       </p:sp>
       <p:sp>
         <p:nvSpPr>
-          <p:cNvPr id="152" name="Rectangle 151"/>
+          <p:cNvPr id="153" name="Rectangle 152"/>
           <p:cNvSpPr/>
           <p:nvPr/>
         </p:nvSpPr>
@@ -11557,7 +11593,7 @@
       </p:sp>
       <p:sp>
         <p:nvSpPr>
-          <p:cNvPr id="153" name="Rectangle 152"/>
+          <p:cNvPr id="154" name="Rectangle 153"/>
           <p:cNvSpPr/>
           <p:nvPr/>
         </p:nvSpPr>
@@ -11606,7 +11642,7 @@
       </p:sp>
       <p:sp>
         <p:nvSpPr>
-          <p:cNvPr id="154" name="TextBox 153"/>
+          <p:cNvPr id="155" name="TextBox 154"/>
           <p:cNvSpPr txBox="1"/>
           <p:nvPr>
             <p:custDataLst>
@@ -11657,7 +11693,7 @@
       </p:sp>
       <p:sp>
         <p:nvSpPr>
-          <p:cNvPr id="155" name="TextBox 154"/>
+          <p:cNvPr id="156" name="TextBox 155"/>
           <p:cNvSpPr txBox="1"/>
           <p:nvPr>
             <p:custDataLst>
@@ -11708,7 +11744,7 @@
       </p:sp>
       <p:sp>
         <p:nvSpPr>
-          <p:cNvPr id="156" name="Rectangle 155"/>
+          <p:cNvPr id="157" name="Rectangle 156"/>
           <p:cNvSpPr/>
           <p:nvPr/>
         </p:nvSpPr>
@@ -11757,7 +11793,7 @@
       </p:sp>
       <p:sp>
         <p:nvSpPr>
-          <p:cNvPr id="157" name="Rectangle 156"/>
+          <p:cNvPr id="158" name="Rectangle 157"/>
           <p:cNvSpPr/>
           <p:nvPr/>
         </p:nvSpPr>
@@ -11806,7 +11842,7 @@
       </p:sp>
       <p:sp>
         <p:nvSpPr>
-          <p:cNvPr id="158" name="TextBox 157"/>
+          <p:cNvPr id="159" name="TextBox 158"/>
           <p:cNvSpPr txBox="1"/>
           <p:nvPr>
             <p:custDataLst>
@@ -11857,7 +11893,7 @@
       </p:sp>
       <p:cxnSp>
         <p:nvCxnSpPr>
-          <p:cNvPr id="159" name="Connector 158"/>
+          <p:cNvPr id="160" name="Connector 159"/>
           <p:cNvCxnSpPr/>
           <p:nvPr/>
         </p:nvCxnSpPr>
@@ -11893,7 +11929,7 @@
       </p:cxnSp>
       <p:sp>
         <p:nvSpPr>
-          <p:cNvPr id="160" name="TextBox 159"/>
+          <p:cNvPr id="161" name="TextBox 160"/>
           <p:cNvSpPr txBox="1"/>
           <p:nvPr>
             <p:custDataLst>
@@ -11944,7 +11980,7 @@
       </p:sp>
       <p:cxnSp>
         <p:nvCxnSpPr>
-          <p:cNvPr id="161" name="Connector 160"/>
+          <p:cNvPr id="162" name="Connector 161"/>
           <p:cNvCxnSpPr/>
           <p:nvPr/>
         </p:nvCxnSpPr>
@@ -11980,7 +12016,7 @@
       </p:cxnSp>
       <p:sp>
         <p:nvSpPr>
-          <p:cNvPr id="162" name="TextBox 161"/>
+          <p:cNvPr id="163" name="TextBox 162"/>
           <p:cNvSpPr txBox="1"/>
           <p:nvPr>
             <p:custDataLst>
@@ -12031,7 +12067,7 @@
       </p:sp>
       <p:cxnSp>
         <p:nvCxnSpPr>
-          <p:cNvPr id="163" name="Connector 162"/>
+          <p:cNvPr id="164" name="Connector 163"/>
           <p:cNvCxnSpPr/>
           <p:nvPr/>
         </p:nvCxnSpPr>
@@ -12067,7 +12103,7 @@
       </p:cxnSp>
       <p:sp>
         <p:nvSpPr>
-          <p:cNvPr id="164" name="TextBox 163"/>
+          <p:cNvPr id="165" name="TextBox 164"/>
           <p:cNvSpPr txBox="1"/>
           <p:nvPr>
             <p:custDataLst>
@@ -12118,7 +12154,7 @@
       </p:sp>
       <p:sp>
         <p:nvSpPr>
-          <p:cNvPr id="165" name="TextBox 164"/>
+          <p:cNvPr id="166" name="TextBox 165"/>
           <p:cNvSpPr txBox="1"/>
           <p:nvPr>
             <p:custDataLst>
@@ -12169,7 +12205,7 @@
       </p:sp>
       <p:cxnSp>
         <p:nvCxnSpPr>
-          <p:cNvPr id="166" name="Connector 165"/>
+          <p:cNvPr id="167" name="Connector 166"/>
           <p:cNvCxnSpPr/>
           <p:nvPr/>
         </p:nvCxnSpPr>
@@ -12205,7 +12241,7 @@
       </p:cxnSp>
       <p:sp>
         <p:nvSpPr>
-          <p:cNvPr id="167" name="TextBox 166"/>
+          <p:cNvPr id="168" name="TextBox 167"/>
           <p:cNvSpPr txBox="1"/>
           <p:nvPr>
             <p:custDataLst>
@@ -12256,7 +12292,7 @@
       </p:sp>
       <p:sp>
         <p:nvSpPr>
-          <p:cNvPr id="168" name="TextBox 167"/>
+          <p:cNvPr id="169" name="TextBox 168"/>
           <p:cNvSpPr txBox="1"/>
           <p:nvPr>
             <p:custDataLst>
@@ -12307,7 +12343,7 @@
       </p:sp>
       <p:sp>
         <p:nvSpPr>
-          <p:cNvPr id="169" name="TextBox 168"/>
+          <p:cNvPr id="170" name="TextBox 169"/>
           <p:cNvSpPr txBox="1"/>
           <p:nvPr>
             <p:custDataLst>
@@ -12358,7 +12394,7 @@
       </p:sp>
       <p:sp>
         <p:nvSpPr>
-          <p:cNvPr id="170" name="Rounded Rectangle 169"/>
+          <p:cNvPr id="171" name="Rounded Rectangle 170"/>
           <p:cNvSpPr/>
           <p:nvPr/>
         </p:nvSpPr>
@@ -12409,7 +12445,7 @@
       </p:sp>
       <p:sp>
         <p:nvSpPr>
-          <p:cNvPr id="171" name="TextBox 170"/>
+          <p:cNvPr id="172" name="TextBox 171"/>
           <p:cNvSpPr txBox="1"/>
           <p:nvPr>
             <p:custDataLst>
@@ -12460,7 +12496,7 @@
       </p:sp>
       <p:sp>
         <p:nvSpPr>
-          <p:cNvPr id="172" name="TextBox 171"/>
+          <p:cNvPr id="173" name="TextBox 172"/>
           <p:cNvSpPr txBox="1"/>
           <p:nvPr>
             <p:custDataLst>
@@ -12511,7 +12547,7 @@
       </p:sp>
       <p:sp>
         <p:nvSpPr>
-          <p:cNvPr id="173" name="Rounded Rectangle 172"/>
+          <p:cNvPr id="174" name="Rounded Rectangle 173"/>
           <p:cNvSpPr/>
           <p:nvPr/>
         </p:nvSpPr>
@@ -12562,7 +12598,7 @@
       </p:sp>
       <p:sp>
         <p:nvSpPr>
-          <p:cNvPr id="174" name="TextBox 173"/>
+          <p:cNvPr id="175" name="TextBox 174"/>
           <p:cNvSpPr txBox="1"/>
           <p:nvPr>
             <p:custDataLst>
@@ -12613,7 +12649,7 @@
       </p:sp>
       <p:sp>
         <p:nvSpPr>
-          <p:cNvPr id="175" name="TextBox 174"/>
+          <p:cNvPr id="176" name="TextBox 175"/>
           <p:cNvSpPr txBox="1"/>
           <p:nvPr>
             <p:custDataLst>
@@ -12664,7 +12700,7 @@
       </p:sp>
       <p:sp>
         <p:nvSpPr>
-          <p:cNvPr id="176" name="Rounded Rectangle 175"/>
+          <p:cNvPr id="177" name="Rounded Rectangle 176"/>
           <p:cNvSpPr/>
           <p:nvPr/>
         </p:nvSpPr>
@@ -12715,7 +12751,7 @@
       </p:sp>
       <p:sp>
         <p:nvSpPr>
-          <p:cNvPr id="177" name="TextBox 176"/>
+          <p:cNvPr id="178" name="TextBox 177"/>
           <p:cNvSpPr txBox="1"/>
           <p:nvPr>
             <p:custDataLst>
@@ -12766,7 +12802,7 @@
       </p:sp>
       <p:sp>
         <p:nvSpPr>
-          <p:cNvPr id="178" name="TextBox 177"/>
+          <p:cNvPr id="179" name="TextBox 178"/>
           <p:cNvSpPr txBox="1"/>
           <p:nvPr>
             <p:custDataLst>
@@ -12817,7 +12853,7 @@
       </p:sp>
       <p:sp>
         <p:nvSpPr>
-          <p:cNvPr id="179" name="TextBox 178"/>
+          <p:cNvPr id="180" name="TextBox 179"/>
           <p:cNvSpPr txBox="1"/>
           <p:nvPr>
             <p:custDataLst>
@@ -12868,7 +12904,7 @@
       </p:sp>
       <p:sp>
         <p:nvSpPr>
-          <p:cNvPr id="180" name="Rounded Rectangle 179"/>
+          <p:cNvPr id="181" name="Rounded Rectangle 180"/>
           <p:cNvSpPr/>
           <p:nvPr/>
         </p:nvSpPr>
@@ -12919,7 +12955,7 @@
       </p:sp>
       <p:sp>
         <p:nvSpPr>
-          <p:cNvPr id="181" name="TextBox 180"/>
+          <p:cNvPr id="182" name="TextBox 181"/>
           <p:cNvSpPr txBox="1"/>
           <p:nvPr>
             <p:custDataLst>
@@ -12994,7 +13030,7 @@
       </p:sp>
       <p:sp>
         <p:nvSpPr>
-          <p:cNvPr id="182" name="Rounded Rectangle 181"/>
+          <p:cNvPr id="183" name="Rounded Rectangle 182"/>
           <p:cNvSpPr/>
           <p:nvPr/>
         </p:nvSpPr>
@@ -13047,7 +13083,7 @@
       </p:sp>
       <p:sp>
         <p:nvSpPr>
-          <p:cNvPr id="183" name="TextBox 182"/>
+          <p:cNvPr id="184" name="TextBox 183"/>
           <p:cNvSpPr txBox="1"/>
           <p:nvPr>
             <p:custDataLst>
@@ -13098,7 +13134,7 @@
       </p:sp>
       <p:sp>
         <p:nvSpPr>
-          <p:cNvPr id="184" name="TextBox 183"/>
+          <p:cNvPr id="185" name="TextBox 184"/>
           <p:cNvSpPr txBox="1"/>
           <p:nvPr>
             <p:custDataLst>
@@ -13149,7 +13185,7 @@
       </p:sp>
       <p:sp>
         <p:nvSpPr>
-          <p:cNvPr id="185" name="Rounded Rectangle 184"/>
+          <p:cNvPr id="186" name="Rounded Rectangle 185"/>
           <p:cNvSpPr/>
           <p:nvPr/>
         </p:nvSpPr>
@@ -13200,7 +13236,7 @@
       </p:sp>
       <p:sp>
         <p:nvSpPr>
-          <p:cNvPr id="186" name="TextBox 185"/>
+          <p:cNvPr id="187" name="TextBox 186"/>
           <p:cNvSpPr txBox="1"/>
           <p:nvPr>
             <p:custDataLst>
@@ -13251,7 +13287,7 @@
       </p:sp>
       <p:sp>
         <p:nvSpPr>
-          <p:cNvPr id="187" name="TextBox 186"/>
+          <p:cNvPr id="188" name="TextBox 187"/>
           <p:cNvSpPr txBox="1"/>
           <p:nvPr>
             <p:custDataLst>
@@ -13302,7 +13338,7 @@
       </p:sp>
       <p:sp>
         <p:nvSpPr>
-          <p:cNvPr id="188" name="Rounded Rectangle 187"/>
+          <p:cNvPr id="189" name="Rounded Rectangle 188"/>
           <p:cNvSpPr/>
           <p:nvPr/>
         </p:nvSpPr>
@@ -13353,7 +13389,7 @@
       </p:sp>
       <p:sp>
         <p:nvSpPr>
-          <p:cNvPr id="189" name="TextBox 188"/>
+          <p:cNvPr id="190" name="TextBox 189"/>
           <p:cNvSpPr txBox="1"/>
           <p:nvPr>
             <p:custDataLst>
@@ -13404,7 +13440,7 @@
       </p:sp>
       <p:sp>
         <p:nvSpPr>
-          <p:cNvPr id="190" name="TextBox 189"/>
+          <p:cNvPr id="191" name="TextBox 190"/>
           <p:cNvSpPr txBox="1"/>
           <p:nvPr>
             <p:custDataLst>
@@ -13455,7 +13491,7 @@
       </p:sp>
       <p:sp>
         <p:nvSpPr>
-          <p:cNvPr id="191" name="Rounded Rectangle 190"/>
+          <p:cNvPr id="192" name="Rounded Rectangle 191"/>
           <p:cNvSpPr/>
           <p:nvPr/>
         </p:nvSpPr>
@@ -13506,7 +13542,7 @@
       </p:sp>
       <p:sp>
         <p:nvSpPr>
-          <p:cNvPr id="192" name="TextBox 191"/>
+          <p:cNvPr id="193" name="TextBox 192"/>
           <p:cNvSpPr txBox="1"/>
           <p:nvPr>
             <p:custDataLst>
@@ -13557,7 +13593,7 @@
       </p:sp>
       <p:sp>
         <p:nvSpPr>
-          <p:cNvPr id="193" name="TextBox 192"/>
+          <p:cNvPr id="194" name="TextBox 193"/>
           <p:cNvSpPr txBox="1"/>
           <p:nvPr>
             <p:custDataLst>
@@ -13608,7 +13644,7 @@
       </p:sp>
       <p:sp>
         <p:nvSpPr>
-          <p:cNvPr id="194" name="Rounded Rectangle 193"/>
+          <p:cNvPr id="195" name="Rounded Rectangle 194"/>
           <p:cNvSpPr/>
           <p:nvPr/>
         </p:nvSpPr>
@@ -13661,7 +13697,7 @@
       </p:sp>
       <p:sp>
         <p:nvSpPr>
-          <p:cNvPr id="195" name="TextBox 194"/>
+          <p:cNvPr id="196" name="TextBox 195"/>
           <p:cNvSpPr txBox="1"/>
           <p:nvPr>
             <p:custDataLst>
@@ -13712,7 +13748,7 @@
       </p:sp>
       <p:sp>
         <p:nvSpPr>
-          <p:cNvPr id="196" name="TextBox 195"/>
+          <p:cNvPr id="197" name="TextBox 196"/>
           <p:cNvSpPr txBox="1"/>
           <p:nvPr>
             <p:custDataLst>
@@ -13763,7 +13799,7 @@
       </p:sp>
       <p:sp>
         <p:nvSpPr>
-          <p:cNvPr id="197" name="Rounded Rectangle 196"/>
+          <p:cNvPr id="198" name="Rounded Rectangle 197"/>
           <p:cNvSpPr/>
           <p:nvPr/>
         </p:nvSpPr>
@@ -13814,7 +13850,7 @@
       </p:sp>
       <p:sp>
         <p:nvSpPr>
-          <p:cNvPr id="198" name="TextBox 197"/>
+          <p:cNvPr id="199" name="TextBox 198"/>
           <p:cNvSpPr txBox="1"/>
           <p:nvPr>
             <p:custDataLst>
@@ -13865,7 +13901,7 @@
       </p:sp>
       <p:sp>
         <p:nvSpPr>
-          <p:cNvPr id="199" name="TextBox 198"/>
+          <p:cNvPr id="200" name="TextBox 199"/>
           <p:cNvSpPr txBox="1"/>
           <p:nvPr>
             <p:custDataLst>
@@ -13916,7 +13952,7 @@
       </p:sp>
       <p:sp>
         <p:nvSpPr>
-          <p:cNvPr id="200" name="TextBox 199"/>
+          <p:cNvPr id="201" name="TextBox 200"/>
           <p:cNvSpPr txBox="1"/>
           <p:nvPr>
             <p:custDataLst>
@@ -13991,7 +14027,7 @@
       </p:sp>
       <p:sp>
         <p:nvSpPr>
-          <p:cNvPr id="201" name="TextBox 200"/>
+          <p:cNvPr id="202" name="TextBox 201"/>
           <p:cNvSpPr txBox="1"/>
           <p:nvPr>
             <p:custDataLst>

</xml_diff>

<commit_message>
Centre the A2 poster layout
The masthead stack, section headings (number and title in one centred
line), stage label column, policy notes, advantage cards and results
captions now align to their block centres. Stage rows drop their small
icons; the evidence-chain icons stay in the masthead. Row 04 nodes are
spaced at 94 mm so the last node ends with the other rows. The bar
chart keeps its zero-based axis and left category labels. Text and
figures are unchanged.

Co-Authored-By: Claude Opus 5.5 <noreply@anthropic.com>
</commit_message>
<xml_diff>
--- a/deliverables/決賽海報_AI資安框架_A2.pptx
+++ b/deliverables/決賽海報_AI資安框架_A2.pptx
@@ -4134,8 +4134,8 @@
         </p:nvSpPr>
         <p:spPr>
           <a:xfrm>
-            <a:off x="864000" y="432000"/>
-            <a:ext cx="10800000" cy="288000"/>
+            <a:off x="832250" y="432000"/>
+            <a:ext cx="13392000" cy="288000"/>
           </a:xfrm>
           <a:prstGeom prst="rect">
             <a:avLst/>
@@ -4148,7 +4148,7 @@
           </a:bodyPr>
           <a:lstStyle/>
           <a:p>
-            <a:pPr algn="l">
+            <a:pPr algn="ctr">
               <a:lnSpc>
                 <a:spcPct val="110000"/>
               </a:lnSpc>
@@ -4185,7 +4185,7 @@
         </p:nvSpPr>
         <p:spPr>
           <a:xfrm>
-            <a:off x="864000" y="720000"/>
+            <a:off x="783037" y="720000"/>
             <a:ext cx="13392000" cy="2556000"/>
           </a:xfrm>
           <a:prstGeom prst="rect">
@@ -4199,7 +4199,7 @@
           </a:bodyPr>
           <a:lstStyle/>
           <a:p>
-            <a:pPr algn="l">
+            <a:pPr algn="ctr">
               <a:lnSpc>
                 <a:spcPct val="110000"/>
               </a:lnSpc>
@@ -4223,7 +4223,7 @@
             </a:r>
           </a:p>
           <a:p>
-            <a:pPr algn="l">
+            <a:pPr algn="ctr">
               <a:lnSpc>
                 <a:spcPct val="110000"/>
               </a:lnSpc>
@@ -4247,7 +4247,7 @@
             </a:r>
           </a:p>
           <a:p>
-            <a:pPr algn="l">
+            <a:pPr algn="ctr">
               <a:lnSpc>
                 <a:spcPct val="110000"/>
               </a:lnSpc>
@@ -4280,7 +4280,7 @@
         </p:nvSpPr>
         <p:spPr>
           <a:xfrm>
-            <a:off x="864000" y="3384000"/>
+            <a:off x="7128000" y="3384000"/>
             <a:ext cx="864000" cy="57600"/>
           </a:xfrm>
           <a:prstGeom prst="rect">
@@ -4333,7 +4333,7 @@
         </p:nvSpPr>
         <p:spPr>
           <a:xfrm>
-            <a:off x="864000" y="3492000"/>
+            <a:off x="816375" y="3492000"/>
             <a:ext cx="13392000" cy="396000"/>
           </a:xfrm>
           <a:prstGeom prst="rect">
@@ -4347,7 +4347,7 @@
           </a:bodyPr>
           <a:lstStyle/>
           <a:p>
-            <a:pPr algn="l">
+            <a:pPr algn="ctr">
               <a:lnSpc>
                 <a:spcPct val="110000"/>
               </a:lnSpc>
@@ -4384,7 +4384,7 @@
         </p:nvSpPr>
         <p:spPr>
           <a:xfrm>
-            <a:off x="864000" y="3924000"/>
+            <a:off x="833044" y="3924000"/>
             <a:ext cx="13392000" cy="288000"/>
           </a:xfrm>
           <a:prstGeom prst="rect">
@@ -4398,7 +4398,7 @@
           </a:bodyPr>
           <a:lstStyle/>
           <a:p>
-            <a:pPr algn="l">
+            <a:pPr algn="ctr">
               <a:lnSpc>
                 <a:spcPct val="110000"/>
               </a:lnSpc>
@@ -4519,7 +4519,7 @@
           <p:nvPr/>
         </p:nvPicPr>
         <p:blipFill>
-          <a:blip r:embed="rId101"/>
+          <a:blip r:embed="rId98"/>
           <a:stretch>
             <a:fillRect/>
           </a:stretch>
@@ -4645,7 +4645,7 @@
           <p:nvPr/>
         </p:nvPicPr>
         <p:blipFill>
-          <a:blip r:embed="rId102"/>
+          <a:blip r:embed="rId99"/>
           <a:stretch>
             <a:fillRect/>
           </a:stretch>
@@ -5032,7 +5032,7 @@
           <p:nvPr/>
         </p:nvPicPr>
         <p:blipFill>
-          <a:blip r:embed="rId103"/>
+          <a:blip r:embed="rId100"/>
           <a:stretch>
             <a:fillRect/>
           </a:stretch>
@@ -5110,8 +5110,8 @@
         </p:nvSpPr>
         <p:spPr>
           <a:xfrm>
-            <a:off x="864000" y="6030000"/>
-            <a:ext cx="576000" cy="468000"/>
+            <a:off x="818756" y="6030000"/>
+            <a:ext cx="13392000" cy="468000"/>
           </a:xfrm>
           <a:prstGeom prst="rect">
             <a:avLst/>
@@ -5124,7 +5124,7 @@
           </a:bodyPr>
           <a:lstStyle/>
           <a:p>
-            <a:pPr algn="l">
+            <a:pPr algn="ctr">
               <a:lnSpc>
                 <a:spcPct val="110000"/>
               </a:lnSpc>
@@ -5136,7 +5136,7 @@
               </a:spcAft>
             </a:pPr>
             <a:r>
-              <a:rPr sz="2200" b="1">
+              <a:rPr sz="2600" b="1">
                 <a:solidFill>
                   <a:srgbClr val="0F766E"/>
                 </a:solidFill>
@@ -5144,48 +5144,8 @@
                 <a:ea typeface="Microsoft JhengHei"/>
                 <a:cs typeface="Segoe UI"/>
               </a:rPr>
-              <a:t>01</a:t>
-            </a:r>
-          </a:p>
-        </p:txBody>
-      </p:sp>
-      <p:sp>
-        <p:nvSpPr>
-          <p:cNvPr id="26" name="TextBox 25"/>
-          <p:cNvSpPr txBox="1"/>
-          <p:nvPr>
-            <p:custDataLst>
-              <p:tags r:id="rId10"/>
-            </p:custDataLst>
-          </p:nvPr>
-        </p:nvSpPr>
-        <p:spPr>
-          <a:xfrm>
-            <a:off x="1476000" y="6030000"/>
-            <a:ext cx="10800000" cy="468000"/>
-          </a:xfrm>
-          <a:prstGeom prst="rect">
-            <a:avLst/>
-          </a:prstGeom>
-          <a:noFill/>
-        </p:spPr>
-        <p:txBody>
-          <a:bodyPr wrap="none" lIns="0" tIns="0" rIns="0" bIns="0" anchor="ctr">
-            <a:spAutoFit/>
-          </a:bodyPr>
-          <a:lstStyle/>
-          <a:p>
-            <a:pPr algn="l">
-              <a:lnSpc>
-                <a:spcPct val="110000"/>
-              </a:lnSpc>
-              <a:spcBef>
-                <a:spcPts val="0"/>
-              </a:spcBef>
-              <a:spcAft>
-                <a:spcPts val="0"/>
-              </a:spcAft>
-            </a:pPr>
+              <a:t>01　</a:t>
+            </a:r>
             <a:r>
               <a:rPr sz="2600" b="1">
                 <a:solidFill>
@@ -5202,7 +5162,7 @@
       </p:sp>
       <p:cxnSp>
         <p:nvCxnSpPr>
-          <p:cNvPr id="27" name="Connector 26"/>
+          <p:cNvPr id="26" name="Connector 25"/>
           <p:cNvCxnSpPr/>
           <p:nvPr/>
         </p:nvCxnSpPr>
@@ -5238,7 +5198,7 @@
       </p:cxnSp>
       <p:sp>
         <p:nvSpPr>
-          <p:cNvPr id="28" name="Rounded Rectangle 27"/>
+          <p:cNvPr id="27" name="Rounded Rectangle 26"/>
           <p:cNvSpPr/>
           <p:nvPr/>
         </p:nvSpPr>
@@ -5287,44 +5247,20 @@
           </a:p>
         </p:txBody>
       </p:sp>
-      <p:pic>
-        <p:nvPicPr>
-          <p:cNvPr id="29" name="Picture 28" descr="flat-icon-2.png"/>
-          <p:cNvPicPr>
-            <a:picLocks noChangeAspect="1"/>
-          </p:cNvPicPr>
-          <p:nvPr/>
-        </p:nvPicPr>
-        <p:blipFill>
-          <a:blip r:embed="rId101"/>
-          <a:stretch>
-            <a:fillRect/>
-          </a:stretch>
-        </p:blipFill>
-        <p:spPr>
-          <a:xfrm>
-            <a:off x="1044000" y="6912000"/>
-            <a:ext cx="468000" cy="468000"/>
-          </a:xfrm>
-          <a:prstGeom prst="rect">
-            <a:avLst/>
-          </a:prstGeom>
-        </p:spPr>
-      </p:pic>
-      <p:sp>
-        <p:nvSpPr>
-          <p:cNvPr id="30" name="TextBox 29"/>
+      <p:sp>
+        <p:nvSpPr>
+          <p:cNvPr id="28" name="TextBox 27"/>
           <p:cNvSpPr txBox="1"/>
           <p:nvPr>
             <p:custDataLst>
-              <p:tags r:id="rId11"/>
+              <p:tags r:id="rId10"/>
             </p:custDataLst>
           </p:nvPr>
         </p:nvSpPr>
         <p:spPr>
           <a:xfrm>
-            <a:off x="1656000" y="6876000"/>
-            <a:ext cx="2592000" cy="324000"/>
+            <a:off x="897106" y="6876000"/>
+            <a:ext cx="3456000" cy="324000"/>
           </a:xfrm>
           <a:prstGeom prst="rect">
             <a:avLst/>
@@ -5337,7 +5273,7 @@
           </a:bodyPr>
           <a:lstStyle/>
           <a:p>
-            <a:pPr algn="l">
+            <a:pPr algn="ctr">
               <a:lnSpc>
                 <a:spcPct val="110000"/>
               </a:lnSpc>
@@ -5351,31 +5287,42 @@
             <a:r>
               <a:rPr sz="2200" b="1">
                 <a:solidFill>
+                  <a:srgbClr val="0F766E"/>
+                </a:solidFill>
+                <a:latin typeface="Segoe UI"/>
+                <a:ea typeface="Microsoft JhengHei"/>
+                <a:cs typeface="Segoe UI"/>
+              </a:rPr>
+              <a:t>01 </a:t>
+            </a:r>
+            <a:r>
+              <a:rPr sz="2200" b="1">
+                <a:solidFill>
                   <a:srgbClr val="0B1B2E"/>
                 </a:solidFill>
                 <a:latin typeface="Segoe UI"/>
                 <a:ea typeface="Microsoft JhengHei"/>
                 <a:cs typeface="Segoe UI"/>
               </a:rPr>
-              <a:t>01  互補判定</a:t>
-            </a:r>
-          </a:p>
-        </p:txBody>
-      </p:sp>
-      <p:sp>
-        <p:nvSpPr>
-          <p:cNvPr id="31" name="TextBox 30"/>
+              <a:t>互補判定</a:t>
+            </a:r>
+          </a:p>
+        </p:txBody>
+      </p:sp>
+      <p:sp>
+        <p:nvSpPr>
+          <p:cNvPr id="29" name="TextBox 28"/>
           <p:cNvSpPr txBox="1"/>
           <p:nvPr>
             <p:custDataLst>
-              <p:tags r:id="rId12"/>
+              <p:tags r:id="rId11"/>
             </p:custDataLst>
           </p:nvPr>
         </p:nvSpPr>
         <p:spPr>
           <a:xfrm>
-            <a:off x="1656000" y="7200000"/>
-            <a:ext cx="2592000" cy="216000"/>
+            <a:off x="911394" y="7200000"/>
+            <a:ext cx="3456000" cy="216000"/>
           </a:xfrm>
           <a:prstGeom prst="rect">
             <a:avLst/>
@@ -5388,7 +5335,7 @@
           </a:bodyPr>
           <a:lstStyle/>
           <a:p>
-            <a:pPr algn="l">
+            <a:pPr algn="ctr">
               <a:lnSpc>
                 <a:spcPct val="110000"/>
               </a:lnSpc>
@@ -5415,18 +5362,18 @@
       </p:sp>
       <p:sp>
         <p:nvSpPr>
-          <p:cNvPr id="32" name="TextBox 31"/>
+          <p:cNvPr id="30" name="TextBox 29"/>
           <p:cNvSpPr txBox="1"/>
           <p:nvPr>
             <p:custDataLst>
-              <p:tags r:id="rId13"/>
+              <p:tags r:id="rId12"/>
             </p:custDataLst>
           </p:nvPr>
         </p:nvSpPr>
         <p:spPr>
           <a:xfrm>
-            <a:off x="1080000" y="7560000"/>
-            <a:ext cx="3240000" cy="540000"/>
+            <a:off x="909806" y="7524000"/>
+            <a:ext cx="3456000" cy="540000"/>
           </a:xfrm>
           <a:prstGeom prst="rect">
             <a:avLst/>
@@ -5439,7 +5386,7 @@
           </a:bodyPr>
           <a:lstStyle/>
           <a:p>
-            <a:pPr algn="l">
+            <a:pPr algn="ctr">
               <a:lnSpc>
                 <a:spcPct val="110000"/>
               </a:lnSpc>
@@ -5463,7 +5410,7 @@
             </a:r>
           </a:p>
           <a:p>
-            <a:pPr algn="l">
+            <a:pPr algn="ctr">
               <a:lnSpc>
                 <a:spcPct val="110000"/>
               </a:lnSpc>
@@ -5490,7 +5437,7 @@
       </p:sp>
       <p:sp>
         <p:nvSpPr>
-          <p:cNvPr id="33" name="Down Arrow 32"/>
+          <p:cNvPr id="31" name="Down Arrow 30"/>
           <p:cNvSpPr/>
           <p:nvPr/>
         </p:nvSpPr>
@@ -5539,7 +5486,7 @@
       </p:sp>
       <p:sp>
         <p:nvSpPr>
-          <p:cNvPr id="34" name="Rounded Rectangle 33"/>
+          <p:cNvPr id="32" name="Rounded Rectangle 31"/>
           <p:cNvSpPr/>
           <p:nvPr/>
         </p:nvSpPr>
@@ -5588,44 +5535,20 @@
           </a:p>
         </p:txBody>
       </p:sp>
-      <p:pic>
-        <p:nvPicPr>
-          <p:cNvPr id="35" name="Picture 34" descr="flat-icon-3.png"/>
-          <p:cNvPicPr>
-            <a:picLocks noChangeAspect="1"/>
-          </p:cNvPicPr>
-          <p:nvPr/>
-        </p:nvPicPr>
-        <p:blipFill>
-          <a:blip r:embed="rId102"/>
-          <a:stretch>
-            <a:fillRect/>
-          </a:stretch>
-        </p:blipFill>
-        <p:spPr>
-          <a:xfrm>
-            <a:off x="1044000" y="8604000"/>
-            <a:ext cx="468000" cy="468000"/>
-          </a:xfrm>
-          <a:prstGeom prst="rect">
-            <a:avLst/>
-          </a:prstGeom>
-        </p:spPr>
-      </p:pic>
-      <p:sp>
-        <p:nvSpPr>
-          <p:cNvPr id="36" name="TextBox 35"/>
+      <p:sp>
+        <p:nvSpPr>
+          <p:cNvPr id="33" name="TextBox 32"/>
           <p:cNvSpPr txBox="1"/>
           <p:nvPr>
             <p:custDataLst>
-              <p:tags r:id="rId14"/>
+              <p:tags r:id="rId13"/>
             </p:custDataLst>
           </p:nvPr>
         </p:nvSpPr>
         <p:spPr>
           <a:xfrm>
-            <a:off x="1656000" y="8568000"/>
-            <a:ext cx="2592000" cy="324000"/>
+            <a:off x="897106" y="8568000"/>
+            <a:ext cx="3456000" cy="324000"/>
           </a:xfrm>
           <a:prstGeom prst="rect">
             <a:avLst/>
@@ -5638,7 +5561,7 @@
           </a:bodyPr>
           <a:lstStyle/>
           <a:p>
-            <a:pPr algn="l">
+            <a:pPr algn="ctr">
               <a:lnSpc>
                 <a:spcPct val="110000"/>
               </a:lnSpc>
@@ -5652,31 +5575,42 @@
             <a:r>
               <a:rPr sz="2200" b="1">
                 <a:solidFill>
+                  <a:srgbClr val="0F766E"/>
+                </a:solidFill>
+                <a:latin typeface="Segoe UI"/>
+                <a:ea typeface="Microsoft JhengHei"/>
+                <a:cs typeface="Segoe UI"/>
+              </a:rPr>
+              <a:t>02 </a:t>
+            </a:r>
+            <a:r>
+              <a:rPr sz="2200" b="1">
+                <a:solidFill>
                   <a:srgbClr val="0B1B2E"/>
                 </a:solidFill>
                 <a:latin typeface="Segoe UI"/>
                 <a:ea typeface="Microsoft JhengHei"/>
                 <a:cs typeface="Segoe UI"/>
               </a:rPr>
-              <a:t>02  任務檢索</a:t>
-            </a:r>
-          </a:p>
-        </p:txBody>
-      </p:sp>
-      <p:sp>
-        <p:nvSpPr>
-          <p:cNvPr id="37" name="TextBox 36"/>
+              <a:t>任務檢索</a:t>
+            </a:r>
+          </a:p>
+        </p:txBody>
+      </p:sp>
+      <p:sp>
+        <p:nvSpPr>
+          <p:cNvPr id="34" name="TextBox 33"/>
           <p:cNvSpPr txBox="1"/>
           <p:nvPr>
             <p:custDataLst>
-              <p:tags r:id="rId15"/>
+              <p:tags r:id="rId14"/>
             </p:custDataLst>
           </p:nvPr>
         </p:nvSpPr>
         <p:spPr>
           <a:xfrm>
-            <a:off x="1656000" y="8892000"/>
-            <a:ext cx="2592000" cy="216000"/>
+            <a:off x="911394" y="8892000"/>
+            <a:ext cx="3456000" cy="216000"/>
           </a:xfrm>
           <a:prstGeom prst="rect">
             <a:avLst/>
@@ -5689,7 +5623,7 @@
           </a:bodyPr>
           <a:lstStyle/>
           <a:p>
-            <a:pPr algn="l">
+            <a:pPr algn="ctr">
               <a:lnSpc>
                 <a:spcPct val="110000"/>
               </a:lnSpc>
@@ -5716,18 +5650,18 @@
       </p:sp>
       <p:sp>
         <p:nvSpPr>
-          <p:cNvPr id="38" name="TextBox 37"/>
+          <p:cNvPr id="35" name="TextBox 34"/>
           <p:cNvSpPr txBox="1"/>
           <p:nvPr>
             <p:custDataLst>
-              <p:tags r:id="rId16"/>
+              <p:tags r:id="rId15"/>
             </p:custDataLst>
           </p:nvPr>
         </p:nvSpPr>
         <p:spPr>
           <a:xfrm>
-            <a:off x="1080000" y="9252000"/>
-            <a:ext cx="3240000" cy="540000"/>
+            <a:off x="909806" y="9216000"/>
+            <a:ext cx="3456000" cy="540000"/>
           </a:xfrm>
           <a:prstGeom prst="rect">
             <a:avLst/>
@@ -5740,7 +5674,7 @@
           </a:bodyPr>
           <a:lstStyle/>
           <a:p>
-            <a:pPr algn="l">
+            <a:pPr algn="ctr">
               <a:lnSpc>
                 <a:spcPct val="110000"/>
               </a:lnSpc>
@@ -5764,7 +5698,7 @@
             </a:r>
           </a:p>
           <a:p>
-            <a:pPr algn="l">
+            <a:pPr algn="ctr">
               <a:lnSpc>
                 <a:spcPct val="110000"/>
               </a:lnSpc>
@@ -5791,7 +5725,7 @@
       </p:sp>
       <p:sp>
         <p:nvSpPr>
-          <p:cNvPr id="39" name="Down Arrow 38"/>
+          <p:cNvPr id="36" name="Down Arrow 35"/>
           <p:cNvSpPr/>
           <p:nvPr/>
         </p:nvSpPr>
@@ -5840,7 +5774,7 @@
       </p:sp>
       <p:sp>
         <p:nvSpPr>
-          <p:cNvPr id="40" name="Rounded Rectangle 39"/>
+          <p:cNvPr id="37" name="Rounded Rectangle 36"/>
           <p:cNvSpPr/>
           <p:nvPr/>
         </p:nvSpPr>
@@ -5891,177 +5825,18 @@
       </p:sp>
       <p:sp>
         <p:nvSpPr>
-          <p:cNvPr id="41" name="Rectangle 40"/>
-          <p:cNvSpPr/>
-          <p:nvPr/>
-        </p:nvSpPr>
-        <p:spPr>
-          <a:xfrm>
-            <a:off x="1116000" y="10332000"/>
-            <a:ext cx="324000" cy="432000"/>
-          </a:xfrm>
-          <a:prstGeom prst="rect">
-            <a:avLst/>
-          </a:prstGeom>
-          <a:solidFill>
-            <a:srgbClr val="FFFFFF"/>
-          </a:solidFill>
-          <a:ln w="10160">
-            <a:solidFill>
-              <a:srgbClr val="1D4ED8"/>
-            </a:solidFill>
-          </a:ln>
-          <a:effectLst/>
-        </p:spPr>
-        <p:style>
-          <a:lnRef idx="1">
-            <a:schemeClr val="accent1"/>
-          </a:lnRef>
-          <a:fillRef idx="3">
-            <a:schemeClr val="accent1"/>
-          </a:fillRef>
-          <a:effectRef idx="2">
-            <a:schemeClr val="accent1"/>
-          </a:effectRef>
-          <a:fontRef idx="minor">
-            <a:schemeClr val="lt1"/>
-          </a:fontRef>
-        </p:style>
-        <p:txBody>
-          <a:bodyPr rtlCol="0" anchor="ctr"/>
-          <a:lstStyle/>
-          <a:p>
-            <a:pPr algn="ctr"/>
-            <a:endParaRPr>
-              <a:latin typeface="Segoe UI"/>
-              <a:ea typeface="Microsoft JhengHei"/>
-              <a:cs typeface="Segoe UI"/>
-            </a:endParaRPr>
-          </a:p>
-        </p:txBody>
-      </p:sp>
-      <p:cxnSp>
-        <p:nvCxnSpPr>
-          <p:cNvPr id="42" name="Connector 41"/>
-          <p:cNvCxnSpPr/>
-          <p:nvPr/>
-        </p:nvCxnSpPr>
-        <p:spPr>
-          <a:xfrm>
-            <a:off x="1187280" y="10440000"/>
-            <a:ext cx="181440" cy="0"/>
-          </a:xfrm>
-          <a:prstGeom prst="line">
-            <a:avLst/>
-          </a:prstGeom>
-          <a:ln w="10160">
-            <a:solidFill>
-              <a:srgbClr val="1D4ED8"/>
-            </a:solidFill>
-          </a:ln>
-          <a:effectLst/>
-        </p:spPr>
-        <p:style>
-          <a:lnRef idx="2">
-            <a:schemeClr val="accent1"/>
-          </a:lnRef>
-          <a:fillRef idx="0">
-            <a:schemeClr val="accent1"/>
-          </a:fillRef>
-          <a:effectRef idx="1">
-            <a:schemeClr val="accent1"/>
-          </a:effectRef>
-          <a:fontRef idx="minor">
-            <a:schemeClr val="tx1"/>
-          </a:fontRef>
-        </p:style>
-      </p:cxnSp>
-      <p:cxnSp>
-        <p:nvCxnSpPr>
-          <p:cNvPr id="43" name="Connector 42"/>
-          <p:cNvCxnSpPr/>
-          <p:nvPr/>
-        </p:nvCxnSpPr>
-        <p:spPr>
-          <a:xfrm>
-            <a:off x="1187280" y="10548000"/>
-            <a:ext cx="181440" cy="0"/>
-          </a:xfrm>
-          <a:prstGeom prst="line">
-            <a:avLst/>
-          </a:prstGeom>
-          <a:ln w="10160">
-            <a:solidFill>
-              <a:srgbClr val="1D4ED8"/>
-            </a:solidFill>
-          </a:ln>
-          <a:effectLst/>
-        </p:spPr>
-        <p:style>
-          <a:lnRef idx="2">
-            <a:schemeClr val="accent1"/>
-          </a:lnRef>
-          <a:fillRef idx="0">
-            <a:schemeClr val="accent1"/>
-          </a:fillRef>
-          <a:effectRef idx="1">
-            <a:schemeClr val="accent1"/>
-          </a:effectRef>
-          <a:fontRef idx="minor">
-            <a:schemeClr val="tx1"/>
-          </a:fontRef>
-        </p:style>
-      </p:cxnSp>
-      <p:cxnSp>
-        <p:nvCxnSpPr>
-          <p:cNvPr id="44" name="Connector 43"/>
-          <p:cNvCxnSpPr/>
-          <p:nvPr/>
-        </p:nvCxnSpPr>
-        <p:spPr>
-          <a:xfrm>
-            <a:off x="1187280" y="10656000"/>
-            <a:ext cx="181440" cy="0"/>
-          </a:xfrm>
-          <a:prstGeom prst="line">
-            <a:avLst/>
-          </a:prstGeom>
-          <a:ln w="10160">
-            <a:solidFill>
-              <a:srgbClr val="1D4ED8"/>
-            </a:solidFill>
-          </a:ln>
-          <a:effectLst/>
-        </p:spPr>
-        <p:style>
-          <a:lnRef idx="2">
-            <a:schemeClr val="accent1"/>
-          </a:lnRef>
-          <a:fillRef idx="0">
-            <a:schemeClr val="accent1"/>
-          </a:fillRef>
-          <a:effectRef idx="1">
-            <a:schemeClr val="accent1"/>
-          </a:effectRef>
-          <a:fontRef idx="minor">
-            <a:schemeClr val="tx1"/>
-          </a:fontRef>
-        </p:style>
-      </p:cxnSp>
-      <p:sp>
-        <p:nvSpPr>
-          <p:cNvPr id="45" name="TextBox 44"/>
+          <p:cNvPr id="38" name="TextBox 37"/>
           <p:cNvSpPr txBox="1"/>
           <p:nvPr>
             <p:custDataLst>
-              <p:tags r:id="rId17"/>
+              <p:tags r:id="rId16"/>
             </p:custDataLst>
           </p:nvPr>
         </p:nvSpPr>
         <p:spPr>
           <a:xfrm>
-            <a:off x="1656000" y="10260000"/>
-            <a:ext cx="2592000" cy="324000"/>
+            <a:off x="897106" y="10260000"/>
+            <a:ext cx="3456000" cy="324000"/>
           </a:xfrm>
           <a:prstGeom prst="rect">
             <a:avLst/>
@@ -6074,7 +5849,7 @@
           </a:bodyPr>
           <a:lstStyle/>
           <a:p>
-            <a:pPr algn="l">
+            <a:pPr algn="ctr">
               <a:lnSpc>
                 <a:spcPct val="110000"/>
               </a:lnSpc>
@@ -6088,31 +5863,42 @@
             <a:r>
               <a:rPr sz="2200" b="1">
                 <a:solidFill>
+                  <a:srgbClr val="0F766E"/>
+                </a:solidFill>
+                <a:latin typeface="Segoe UI"/>
+                <a:ea typeface="Microsoft JhengHei"/>
+                <a:cs typeface="Segoe UI"/>
+              </a:rPr>
+              <a:t>03 </a:t>
+            </a:r>
+            <a:r>
+              <a:rPr sz="2200" b="1">
+                <a:solidFill>
                   <a:srgbClr val="0B1B2E"/>
                 </a:solidFill>
                 <a:latin typeface="Segoe UI"/>
                 <a:ea typeface="Microsoft JhengHei"/>
                 <a:cs typeface="Segoe UI"/>
               </a:rPr>
-              <a:t>03  證據稽核</a:t>
-            </a:r>
-          </a:p>
-        </p:txBody>
-      </p:sp>
-      <p:sp>
-        <p:nvSpPr>
-          <p:cNvPr id="46" name="TextBox 45"/>
+              <a:t>證據稽核</a:t>
+            </a:r>
+          </a:p>
+        </p:txBody>
+      </p:sp>
+      <p:sp>
+        <p:nvSpPr>
+          <p:cNvPr id="39" name="TextBox 38"/>
           <p:cNvSpPr txBox="1"/>
           <p:nvPr>
             <p:custDataLst>
-              <p:tags r:id="rId18"/>
+              <p:tags r:id="rId17"/>
             </p:custDataLst>
           </p:nvPr>
         </p:nvSpPr>
         <p:spPr>
           <a:xfrm>
-            <a:off x="1656000" y="10584000"/>
-            <a:ext cx="2592000" cy="216000"/>
+            <a:off x="911394" y="10584000"/>
+            <a:ext cx="3456000" cy="216000"/>
           </a:xfrm>
           <a:prstGeom prst="rect">
             <a:avLst/>
@@ -6125,7 +5911,7 @@
           </a:bodyPr>
           <a:lstStyle/>
           <a:p>
-            <a:pPr algn="l">
+            <a:pPr algn="ctr">
               <a:lnSpc>
                 <a:spcPct val="110000"/>
               </a:lnSpc>
@@ -6152,18 +5938,18 @@
       </p:sp>
       <p:sp>
         <p:nvSpPr>
-          <p:cNvPr id="47" name="TextBox 46"/>
+          <p:cNvPr id="40" name="TextBox 39"/>
           <p:cNvSpPr txBox="1"/>
           <p:nvPr>
             <p:custDataLst>
-              <p:tags r:id="rId19"/>
+              <p:tags r:id="rId18"/>
             </p:custDataLst>
           </p:nvPr>
         </p:nvSpPr>
         <p:spPr>
           <a:xfrm>
-            <a:off x="1080000" y="10944000"/>
-            <a:ext cx="3240000" cy="540000"/>
+            <a:off x="909806" y="10908000"/>
+            <a:ext cx="3456000" cy="540000"/>
           </a:xfrm>
           <a:prstGeom prst="rect">
             <a:avLst/>
@@ -6176,7 +5962,7 @@
           </a:bodyPr>
           <a:lstStyle/>
           <a:p>
-            <a:pPr algn="l">
+            <a:pPr algn="ctr">
               <a:lnSpc>
                 <a:spcPct val="110000"/>
               </a:lnSpc>
@@ -6200,7 +5986,7 @@
             </a:r>
           </a:p>
           <a:p>
-            <a:pPr algn="l">
+            <a:pPr algn="ctr">
               <a:lnSpc>
                 <a:spcPct val="110000"/>
               </a:lnSpc>
@@ -6227,7 +6013,7 @@
       </p:sp>
       <p:sp>
         <p:nvSpPr>
-          <p:cNvPr id="48" name="Down Arrow 47"/>
+          <p:cNvPr id="41" name="Down Arrow 40"/>
           <p:cNvSpPr/>
           <p:nvPr/>
         </p:nvSpPr>
@@ -6276,7 +6062,7 @@
       </p:sp>
       <p:sp>
         <p:nvSpPr>
-          <p:cNvPr id="49" name="Rounded Rectangle 48"/>
+          <p:cNvPr id="42" name="Rounded Rectangle 41"/>
           <p:cNvSpPr/>
           <p:nvPr/>
         </p:nvSpPr>
@@ -6325,44 +6111,20 @@
           </a:p>
         </p:txBody>
       </p:sp>
-      <p:pic>
-        <p:nvPicPr>
-          <p:cNvPr id="50" name="Picture 49" descr="flat-icon-4.png"/>
-          <p:cNvPicPr>
-            <a:picLocks noChangeAspect="1"/>
-          </p:cNvPicPr>
-          <p:nvPr/>
-        </p:nvPicPr>
-        <p:blipFill>
-          <a:blip r:embed="rId103"/>
-          <a:stretch>
-            <a:fillRect/>
-          </a:stretch>
-        </p:blipFill>
-        <p:spPr>
-          <a:xfrm>
-            <a:off x="1044000" y="11988000"/>
-            <a:ext cx="468000" cy="468000"/>
-          </a:xfrm>
-          <a:prstGeom prst="rect">
-            <a:avLst/>
-          </a:prstGeom>
-        </p:spPr>
-      </p:pic>
-      <p:sp>
-        <p:nvSpPr>
-          <p:cNvPr id="51" name="TextBox 50"/>
+      <p:sp>
+        <p:nvSpPr>
+          <p:cNvPr id="43" name="TextBox 42"/>
           <p:cNvSpPr txBox="1"/>
           <p:nvPr>
             <p:custDataLst>
-              <p:tags r:id="rId20"/>
+              <p:tags r:id="rId19"/>
             </p:custDataLst>
           </p:nvPr>
         </p:nvSpPr>
         <p:spPr>
           <a:xfrm>
-            <a:off x="1656000" y="11952000"/>
-            <a:ext cx="2592000" cy="324000"/>
+            <a:off x="897106" y="11952000"/>
+            <a:ext cx="3456000" cy="324000"/>
           </a:xfrm>
           <a:prstGeom prst="rect">
             <a:avLst/>
@@ -6375,7 +6137,7 @@
           </a:bodyPr>
           <a:lstStyle/>
           <a:p>
-            <a:pPr algn="l">
+            <a:pPr algn="ctr">
               <a:lnSpc>
                 <a:spcPct val="110000"/>
               </a:lnSpc>
@@ -6389,31 +6151,42 @@
             <a:r>
               <a:rPr sz="2200" b="1">
                 <a:solidFill>
+                  <a:srgbClr val="0F766E"/>
+                </a:solidFill>
+                <a:latin typeface="Segoe UI"/>
+                <a:ea typeface="Microsoft JhengHei"/>
+                <a:cs typeface="Segoe UI"/>
+              </a:rPr>
+              <a:t>04 </a:t>
+            </a:r>
+            <a:r>
+              <a:rPr sz="2200" b="1">
+                <a:solidFill>
                   <a:srgbClr val="0B1B2E"/>
                 </a:solidFill>
                 <a:latin typeface="Segoe UI"/>
                 <a:ea typeface="Microsoft JhengHei"/>
                 <a:cs typeface="Segoe UI"/>
               </a:rPr>
-              <a:t>04  受控回復</a:t>
-            </a:r>
-          </a:p>
-        </p:txBody>
-      </p:sp>
-      <p:sp>
-        <p:nvSpPr>
-          <p:cNvPr id="52" name="TextBox 51"/>
+              <a:t>受控回復</a:t>
+            </a:r>
+          </a:p>
+        </p:txBody>
+      </p:sp>
+      <p:sp>
+        <p:nvSpPr>
+          <p:cNvPr id="44" name="TextBox 43"/>
           <p:cNvSpPr txBox="1"/>
           <p:nvPr>
             <p:custDataLst>
-              <p:tags r:id="rId21"/>
+              <p:tags r:id="rId20"/>
             </p:custDataLst>
           </p:nvPr>
         </p:nvSpPr>
         <p:spPr>
           <a:xfrm>
-            <a:off x="1656000" y="12276000"/>
-            <a:ext cx="2592000" cy="216000"/>
+            <a:off x="911394" y="12276000"/>
+            <a:ext cx="3456000" cy="216000"/>
           </a:xfrm>
           <a:prstGeom prst="rect">
             <a:avLst/>
@@ -6426,7 +6199,7 @@
           </a:bodyPr>
           <a:lstStyle/>
           <a:p>
-            <a:pPr algn="l">
+            <a:pPr algn="ctr">
               <a:lnSpc>
                 <a:spcPct val="110000"/>
               </a:lnSpc>
@@ -6453,18 +6226,18 @@
       </p:sp>
       <p:sp>
         <p:nvSpPr>
-          <p:cNvPr id="53" name="TextBox 52"/>
+          <p:cNvPr id="45" name="TextBox 44"/>
           <p:cNvSpPr txBox="1"/>
           <p:nvPr>
             <p:custDataLst>
-              <p:tags r:id="rId22"/>
+              <p:tags r:id="rId21"/>
             </p:custDataLst>
           </p:nvPr>
         </p:nvSpPr>
         <p:spPr>
           <a:xfrm>
-            <a:off x="1080000" y="12636000"/>
-            <a:ext cx="3240000" cy="540000"/>
+            <a:off x="909806" y="12600000"/>
+            <a:ext cx="3456000" cy="540000"/>
           </a:xfrm>
           <a:prstGeom prst="rect">
             <a:avLst/>
@@ -6477,7 +6250,7 @@
           </a:bodyPr>
           <a:lstStyle/>
           <a:p>
-            <a:pPr algn="l">
+            <a:pPr algn="ctr">
               <a:lnSpc>
                 <a:spcPct val="110000"/>
               </a:lnSpc>
@@ -6501,7 +6274,7 @@
             </a:r>
           </a:p>
           <a:p>
-            <a:pPr algn="l">
+            <a:pPr algn="ctr">
               <a:lnSpc>
                 <a:spcPct val="110000"/>
               </a:lnSpc>
@@ -6528,7 +6301,7 @@
       </p:sp>
       <p:sp>
         <p:nvSpPr>
-          <p:cNvPr id="54" name="Rounded Rectangle 53"/>
+          <p:cNvPr id="46" name="Rounded Rectangle 45"/>
           <p:cNvSpPr/>
           <p:nvPr/>
         </p:nvSpPr>
@@ -6581,11 +6354,11 @@
       </p:sp>
       <p:sp>
         <p:nvSpPr>
-          <p:cNvPr id="55" name="TextBox 54"/>
+          <p:cNvPr id="47" name="TextBox 46"/>
           <p:cNvSpPr txBox="1"/>
           <p:nvPr>
             <p:custDataLst>
-              <p:tags r:id="rId23"/>
+              <p:tags r:id="rId22"/>
             </p:custDataLst>
           </p:nvPr>
         </p:nvSpPr>
@@ -6632,11 +6405,11 @@
       </p:sp>
       <p:sp>
         <p:nvSpPr>
-          <p:cNvPr id="56" name="TextBox 55"/>
+          <p:cNvPr id="48" name="TextBox 47"/>
           <p:cNvSpPr txBox="1"/>
           <p:nvPr>
             <p:custDataLst>
-              <p:tags r:id="rId24"/>
+              <p:tags r:id="rId23"/>
             </p:custDataLst>
           </p:nvPr>
         </p:nvSpPr>
@@ -6683,7 +6456,7 @@
       </p:sp>
       <p:sp>
         <p:nvSpPr>
-          <p:cNvPr id="57" name="Rounded Rectangle 56"/>
+          <p:cNvPr id="49" name="Rounded Rectangle 48"/>
           <p:cNvSpPr/>
           <p:nvPr/>
         </p:nvSpPr>
@@ -6736,11 +6509,11 @@
       </p:sp>
       <p:sp>
         <p:nvSpPr>
-          <p:cNvPr id="58" name="TextBox 57"/>
+          <p:cNvPr id="50" name="TextBox 49"/>
           <p:cNvSpPr txBox="1"/>
           <p:nvPr>
             <p:custDataLst>
-              <p:tags r:id="rId25"/>
+              <p:tags r:id="rId24"/>
             </p:custDataLst>
           </p:nvPr>
         </p:nvSpPr>
@@ -6787,11 +6560,11 @@
       </p:sp>
       <p:sp>
         <p:nvSpPr>
-          <p:cNvPr id="59" name="TextBox 58"/>
+          <p:cNvPr id="51" name="TextBox 50"/>
           <p:cNvSpPr txBox="1"/>
           <p:nvPr>
             <p:custDataLst>
-              <p:tags r:id="rId26"/>
+              <p:tags r:id="rId25"/>
             </p:custDataLst>
           </p:nvPr>
         </p:nvSpPr>
@@ -6838,7 +6611,7 @@
       </p:sp>
       <p:cxnSp>
         <p:nvCxnSpPr>
-          <p:cNvPr id="60" name="Connector 59"/>
+          <p:cNvPr id="52" name="Connector 51"/>
           <p:cNvCxnSpPr/>
           <p:nvPr/>
         </p:nvCxnSpPr>
@@ -6874,7 +6647,7 @@
       </p:cxnSp>
       <p:cxnSp>
         <p:nvCxnSpPr>
-          <p:cNvPr id="61" name="Connector 60"/>
+          <p:cNvPr id="53" name="Connector 52"/>
           <p:cNvCxnSpPr/>
           <p:nvPr/>
         </p:nvCxnSpPr>
@@ -6910,7 +6683,7 @@
       </p:cxnSp>
       <p:cxnSp>
         <p:nvCxnSpPr>
-          <p:cNvPr id="62" name="Connector 61"/>
+          <p:cNvPr id="54" name="Connector 53"/>
           <p:cNvCxnSpPr/>
           <p:nvPr/>
         </p:nvCxnSpPr>
@@ -6946,7 +6719,7 @@
       </p:cxnSp>
       <p:sp>
         <p:nvSpPr>
-          <p:cNvPr id="63" name="Right Arrow 62"/>
+          <p:cNvPr id="55" name="Right Arrow 54"/>
           <p:cNvSpPr/>
           <p:nvPr/>
         </p:nvSpPr>
@@ -6995,7 +6768,7 @@
       </p:sp>
       <p:sp>
         <p:nvSpPr>
-          <p:cNvPr id="64" name="Rounded Rectangle 63"/>
+          <p:cNvPr id="56" name="Rounded Rectangle 55"/>
           <p:cNvSpPr/>
           <p:nvPr/>
         </p:nvSpPr>
@@ -7046,11 +6819,11 @@
       </p:sp>
       <p:sp>
         <p:nvSpPr>
-          <p:cNvPr id="65" name="TextBox 64"/>
+          <p:cNvPr id="57" name="TextBox 56"/>
           <p:cNvSpPr txBox="1"/>
           <p:nvPr>
             <p:custDataLst>
-              <p:tags r:id="rId27"/>
+              <p:tags r:id="rId26"/>
             </p:custDataLst>
           </p:nvPr>
         </p:nvSpPr>
@@ -7097,11 +6870,11 @@
       </p:sp>
       <p:sp>
         <p:nvSpPr>
-          <p:cNvPr id="66" name="TextBox 65"/>
+          <p:cNvPr id="58" name="TextBox 57"/>
           <p:cNvSpPr txBox="1"/>
           <p:nvPr>
             <p:custDataLst>
-              <p:tags r:id="rId28"/>
+              <p:tags r:id="rId27"/>
             </p:custDataLst>
           </p:nvPr>
         </p:nvSpPr>
@@ -7148,7 +6921,7 @@
       </p:sp>
       <p:sp>
         <p:nvSpPr>
-          <p:cNvPr id="67" name="Right Arrow 66"/>
+          <p:cNvPr id="59" name="Right Arrow 58"/>
           <p:cNvSpPr/>
           <p:nvPr/>
         </p:nvSpPr>
@@ -7197,7 +6970,7 @@
       </p:sp>
       <p:sp>
         <p:nvSpPr>
-          <p:cNvPr id="68" name="Rounded Rectangle 67"/>
+          <p:cNvPr id="60" name="Rounded Rectangle 59"/>
           <p:cNvSpPr/>
           <p:nvPr/>
         </p:nvSpPr>
@@ -7248,11 +7021,11 @@
       </p:sp>
       <p:sp>
         <p:nvSpPr>
-          <p:cNvPr id="69" name="TextBox 68"/>
+          <p:cNvPr id="61" name="TextBox 60"/>
           <p:cNvSpPr txBox="1"/>
           <p:nvPr>
             <p:custDataLst>
-              <p:tags r:id="rId29"/>
+              <p:tags r:id="rId28"/>
             </p:custDataLst>
           </p:nvPr>
         </p:nvSpPr>
@@ -7299,11 +7072,11 @@
       </p:sp>
       <p:sp>
         <p:nvSpPr>
-          <p:cNvPr id="70" name="TextBox 69"/>
+          <p:cNvPr id="62" name="TextBox 61"/>
           <p:cNvSpPr txBox="1"/>
           <p:nvPr>
             <p:custDataLst>
-              <p:tags r:id="rId30"/>
+              <p:tags r:id="rId29"/>
             </p:custDataLst>
           </p:nvPr>
         </p:nvSpPr>
@@ -7350,7 +7123,7 @@
       </p:sp>
       <p:sp>
         <p:nvSpPr>
-          <p:cNvPr id="71" name="Rounded Rectangle 70"/>
+          <p:cNvPr id="63" name="Rounded Rectangle 62"/>
           <p:cNvSpPr/>
           <p:nvPr/>
         </p:nvSpPr>
@@ -7403,11 +7176,11 @@
       </p:sp>
       <p:sp>
         <p:nvSpPr>
-          <p:cNvPr id="72" name="TextBox 71"/>
+          <p:cNvPr id="64" name="TextBox 63"/>
           <p:cNvSpPr txBox="1"/>
           <p:nvPr>
             <p:custDataLst>
-              <p:tags r:id="rId31"/>
+              <p:tags r:id="rId30"/>
             </p:custDataLst>
           </p:nvPr>
         </p:nvSpPr>
@@ -7454,7 +7227,7 @@
       </p:sp>
       <p:sp>
         <p:nvSpPr>
-          <p:cNvPr id="73" name="Rounded Rectangle 72"/>
+          <p:cNvPr id="65" name="Rounded Rectangle 64"/>
           <p:cNvSpPr/>
           <p:nvPr/>
         </p:nvSpPr>
@@ -7507,11 +7280,11 @@
       </p:sp>
       <p:sp>
         <p:nvSpPr>
-          <p:cNvPr id="74" name="TextBox 73"/>
+          <p:cNvPr id="66" name="TextBox 65"/>
           <p:cNvSpPr txBox="1"/>
           <p:nvPr>
             <p:custDataLst>
-              <p:tags r:id="rId32"/>
+              <p:tags r:id="rId31"/>
             </p:custDataLst>
           </p:nvPr>
         </p:nvSpPr>
@@ -7558,7 +7331,7 @@
       </p:sp>
       <p:cxnSp>
         <p:nvCxnSpPr>
-          <p:cNvPr id="75" name="Connector 74"/>
+          <p:cNvPr id="67" name="Connector 66"/>
           <p:cNvCxnSpPr/>
           <p:nvPr/>
         </p:nvCxnSpPr>
@@ -7594,7 +7367,7 @@
       </p:cxnSp>
       <p:cxnSp>
         <p:nvCxnSpPr>
-          <p:cNvPr id="76" name="Connector 75"/>
+          <p:cNvPr id="68" name="Connector 67"/>
           <p:cNvCxnSpPr/>
           <p:nvPr/>
         </p:nvCxnSpPr>
@@ -7630,7 +7403,7 @@
       </p:cxnSp>
       <p:cxnSp>
         <p:nvCxnSpPr>
-          <p:cNvPr id="77" name="Connector 76"/>
+          <p:cNvPr id="69" name="Connector 68"/>
           <p:cNvCxnSpPr/>
           <p:nvPr/>
         </p:nvCxnSpPr>
@@ -7666,7 +7439,7 @@
       </p:cxnSp>
       <p:sp>
         <p:nvSpPr>
-          <p:cNvPr id="78" name="Right Arrow 77"/>
+          <p:cNvPr id="70" name="Right Arrow 69"/>
           <p:cNvSpPr/>
           <p:nvPr/>
         </p:nvSpPr>
@@ -7715,7 +7488,7 @@
       </p:sp>
       <p:sp>
         <p:nvSpPr>
-          <p:cNvPr id="79" name="Rounded Rectangle 78"/>
+          <p:cNvPr id="71" name="Rounded Rectangle 70"/>
           <p:cNvSpPr/>
           <p:nvPr/>
         </p:nvSpPr>
@@ -7766,11 +7539,11 @@
       </p:sp>
       <p:sp>
         <p:nvSpPr>
-          <p:cNvPr id="80" name="TextBox 79"/>
+          <p:cNvPr id="72" name="TextBox 71"/>
           <p:cNvSpPr txBox="1"/>
           <p:nvPr>
             <p:custDataLst>
-              <p:tags r:id="rId33"/>
+              <p:tags r:id="rId32"/>
             </p:custDataLst>
           </p:nvPr>
         </p:nvSpPr>
@@ -7817,11 +7590,11 @@
       </p:sp>
       <p:sp>
         <p:nvSpPr>
-          <p:cNvPr id="81" name="TextBox 80"/>
+          <p:cNvPr id="73" name="TextBox 72"/>
           <p:cNvSpPr txBox="1"/>
           <p:nvPr>
             <p:custDataLst>
-              <p:tags r:id="rId34"/>
+              <p:tags r:id="rId33"/>
             </p:custDataLst>
           </p:nvPr>
         </p:nvSpPr>
@@ -7868,7 +7641,7 @@
       </p:sp>
       <p:sp>
         <p:nvSpPr>
-          <p:cNvPr id="82" name="Right Arrow 81"/>
+          <p:cNvPr id="74" name="Right Arrow 73"/>
           <p:cNvSpPr/>
           <p:nvPr/>
         </p:nvSpPr>
@@ -7917,7 +7690,7 @@
       </p:sp>
       <p:sp>
         <p:nvSpPr>
-          <p:cNvPr id="83" name="Rounded Rectangle 82"/>
+          <p:cNvPr id="75" name="Rounded Rectangle 74"/>
           <p:cNvSpPr/>
           <p:nvPr/>
         </p:nvSpPr>
@@ -7968,11 +7741,11 @@
       </p:sp>
       <p:sp>
         <p:nvSpPr>
-          <p:cNvPr id="84" name="TextBox 83"/>
+          <p:cNvPr id="76" name="TextBox 75"/>
           <p:cNvSpPr txBox="1"/>
           <p:nvPr>
             <p:custDataLst>
-              <p:tags r:id="rId35"/>
+              <p:tags r:id="rId34"/>
             </p:custDataLst>
           </p:nvPr>
         </p:nvSpPr>
@@ -8019,7 +7792,7 @@
       </p:sp>
       <p:sp>
         <p:nvSpPr>
-          <p:cNvPr id="85" name="Rounded Rectangle 84"/>
+          <p:cNvPr id="77" name="Rounded Rectangle 76"/>
           <p:cNvSpPr/>
           <p:nvPr/>
         </p:nvSpPr>
@@ -8070,11 +7843,11 @@
       </p:sp>
       <p:sp>
         <p:nvSpPr>
-          <p:cNvPr id="86" name="TextBox 85"/>
+          <p:cNvPr id="78" name="TextBox 77"/>
           <p:cNvSpPr txBox="1"/>
           <p:nvPr>
             <p:custDataLst>
-              <p:tags r:id="rId36"/>
+              <p:tags r:id="rId35"/>
             </p:custDataLst>
           </p:nvPr>
         </p:nvSpPr>
@@ -8121,7 +7894,7 @@
       </p:sp>
       <p:sp>
         <p:nvSpPr>
-          <p:cNvPr id="87" name="Rounded Rectangle 86"/>
+          <p:cNvPr id="79" name="Rounded Rectangle 78"/>
           <p:cNvSpPr/>
           <p:nvPr/>
         </p:nvSpPr>
@@ -8172,11 +7945,11 @@
       </p:sp>
       <p:sp>
         <p:nvSpPr>
-          <p:cNvPr id="88" name="TextBox 87"/>
+          <p:cNvPr id="80" name="TextBox 79"/>
           <p:cNvSpPr txBox="1"/>
           <p:nvPr>
             <p:custDataLst>
-              <p:tags r:id="rId37"/>
+              <p:tags r:id="rId36"/>
             </p:custDataLst>
           </p:nvPr>
         </p:nvSpPr>
@@ -8223,7 +7996,7 @@
       </p:sp>
       <p:sp>
         <p:nvSpPr>
-          <p:cNvPr id="89" name="Rounded Rectangle 88"/>
+          <p:cNvPr id="81" name="Rounded Rectangle 80"/>
           <p:cNvSpPr/>
           <p:nvPr/>
         </p:nvSpPr>
@@ -8274,11 +8047,11 @@
       </p:sp>
       <p:sp>
         <p:nvSpPr>
-          <p:cNvPr id="90" name="TextBox 89"/>
+          <p:cNvPr id="82" name="TextBox 81"/>
           <p:cNvSpPr txBox="1"/>
           <p:nvPr>
             <p:custDataLst>
-              <p:tags r:id="rId38"/>
+              <p:tags r:id="rId37"/>
             </p:custDataLst>
           </p:nvPr>
         </p:nvSpPr>
@@ -8325,7 +8098,7 @@
       </p:sp>
       <p:sp>
         <p:nvSpPr>
-          <p:cNvPr id="91" name="Rounded Rectangle 90"/>
+          <p:cNvPr id="83" name="Rounded Rectangle 82"/>
           <p:cNvSpPr/>
           <p:nvPr/>
         </p:nvSpPr>
@@ -8376,11 +8149,11 @@
       </p:sp>
       <p:sp>
         <p:nvSpPr>
-          <p:cNvPr id="92" name="TextBox 91"/>
+          <p:cNvPr id="84" name="TextBox 83"/>
           <p:cNvSpPr txBox="1"/>
           <p:nvPr>
             <p:custDataLst>
-              <p:tags r:id="rId39"/>
+              <p:tags r:id="rId38"/>
             </p:custDataLst>
           </p:nvPr>
         </p:nvSpPr>
@@ -8427,7 +8200,7 @@
       </p:sp>
       <p:sp>
         <p:nvSpPr>
-          <p:cNvPr id="93" name="Rounded Rectangle 92"/>
+          <p:cNvPr id="85" name="Rounded Rectangle 84"/>
           <p:cNvSpPr/>
           <p:nvPr/>
         </p:nvSpPr>
@@ -8478,11 +8251,11 @@
       </p:sp>
       <p:sp>
         <p:nvSpPr>
-          <p:cNvPr id="94" name="TextBox 93"/>
+          <p:cNvPr id="86" name="TextBox 85"/>
           <p:cNvSpPr txBox="1"/>
           <p:nvPr>
             <p:custDataLst>
-              <p:tags r:id="rId40"/>
+              <p:tags r:id="rId39"/>
             </p:custDataLst>
           </p:nvPr>
         </p:nvSpPr>
@@ -8529,7 +8302,7 @@
       </p:sp>
       <p:sp>
         <p:nvSpPr>
-          <p:cNvPr id="95" name="Rounded Rectangle 94"/>
+          <p:cNvPr id="87" name="Rounded Rectangle 86"/>
           <p:cNvSpPr/>
           <p:nvPr/>
         </p:nvSpPr>
@@ -8582,11 +8355,11 @@
       </p:sp>
       <p:sp>
         <p:nvSpPr>
-          <p:cNvPr id="96" name="TextBox 95"/>
+          <p:cNvPr id="88" name="TextBox 87"/>
           <p:cNvSpPr txBox="1"/>
           <p:nvPr>
             <p:custDataLst>
-              <p:tags r:id="rId41"/>
+              <p:tags r:id="rId40"/>
             </p:custDataLst>
           </p:nvPr>
         </p:nvSpPr>
@@ -8633,7 +8406,7 @@
       </p:sp>
       <p:sp>
         <p:nvSpPr>
-          <p:cNvPr id="97" name="Rounded Rectangle 96"/>
+          <p:cNvPr id="89" name="Rounded Rectangle 88"/>
           <p:cNvSpPr/>
           <p:nvPr/>
         </p:nvSpPr>
@@ -8686,11 +8459,11 @@
       </p:sp>
       <p:sp>
         <p:nvSpPr>
-          <p:cNvPr id="98" name="TextBox 97"/>
+          <p:cNvPr id="90" name="TextBox 89"/>
           <p:cNvSpPr txBox="1"/>
           <p:nvPr>
             <p:custDataLst>
-              <p:tags r:id="rId42"/>
+              <p:tags r:id="rId41"/>
             </p:custDataLst>
           </p:nvPr>
         </p:nvSpPr>
@@ -8737,7 +8510,7 @@
       </p:sp>
       <p:cxnSp>
         <p:nvCxnSpPr>
-          <p:cNvPr id="99" name="Connector 98"/>
+          <p:cNvPr id="91" name="Connector 90"/>
           <p:cNvCxnSpPr/>
           <p:nvPr/>
         </p:nvCxnSpPr>
@@ -8773,7 +8546,7 @@
       </p:cxnSp>
       <p:cxnSp>
         <p:nvCxnSpPr>
-          <p:cNvPr id="100" name="Connector 99"/>
+          <p:cNvPr id="92" name="Connector 91"/>
           <p:cNvCxnSpPr/>
           <p:nvPr/>
         </p:nvCxnSpPr>
@@ -8809,7 +8582,7 @@
       </p:cxnSp>
       <p:cxnSp>
         <p:nvCxnSpPr>
-          <p:cNvPr id="101" name="Connector 100"/>
+          <p:cNvPr id="93" name="Connector 92"/>
           <p:cNvCxnSpPr/>
           <p:nvPr/>
         </p:nvCxnSpPr>
@@ -8845,7 +8618,7 @@
       </p:cxnSp>
       <p:sp>
         <p:nvSpPr>
-          <p:cNvPr id="102" name="Right Arrow 101"/>
+          <p:cNvPr id="94" name="Right Arrow 93"/>
           <p:cNvSpPr/>
           <p:nvPr/>
         </p:nvSpPr>
@@ -8894,7 +8667,7 @@
       </p:sp>
       <p:sp>
         <p:nvSpPr>
-          <p:cNvPr id="103" name="Rounded Rectangle 102"/>
+          <p:cNvPr id="95" name="Rounded Rectangle 94"/>
           <p:cNvSpPr/>
           <p:nvPr/>
         </p:nvSpPr>
@@ -8945,11 +8718,11 @@
       </p:sp>
       <p:sp>
         <p:nvSpPr>
-          <p:cNvPr id="104" name="TextBox 103"/>
+          <p:cNvPr id="96" name="TextBox 95"/>
           <p:cNvSpPr txBox="1"/>
           <p:nvPr>
             <p:custDataLst>
-              <p:tags r:id="rId43"/>
+              <p:tags r:id="rId42"/>
             </p:custDataLst>
           </p:nvPr>
         </p:nvSpPr>
@@ -8996,11 +8769,11 @@
       </p:sp>
       <p:sp>
         <p:nvSpPr>
-          <p:cNvPr id="105" name="TextBox 104"/>
+          <p:cNvPr id="97" name="TextBox 96"/>
           <p:cNvSpPr txBox="1"/>
           <p:nvPr>
             <p:custDataLst>
-              <p:tags r:id="rId44"/>
+              <p:tags r:id="rId43"/>
             </p:custDataLst>
           </p:nvPr>
         </p:nvSpPr>
@@ -9047,7 +8820,7 @@
       </p:sp>
       <p:sp>
         <p:nvSpPr>
-          <p:cNvPr id="106" name="Right Arrow 105"/>
+          <p:cNvPr id="98" name="Right Arrow 97"/>
           <p:cNvSpPr/>
           <p:nvPr/>
         </p:nvSpPr>
@@ -9096,7 +8869,7 @@
       </p:sp>
       <p:sp>
         <p:nvSpPr>
-          <p:cNvPr id="107" name="Rounded Rectangle 106"/>
+          <p:cNvPr id="99" name="Rounded Rectangle 98"/>
           <p:cNvSpPr/>
           <p:nvPr/>
         </p:nvSpPr>
@@ -9147,11 +8920,11 @@
       </p:sp>
       <p:sp>
         <p:nvSpPr>
-          <p:cNvPr id="108" name="TextBox 107"/>
+          <p:cNvPr id="100" name="TextBox 99"/>
           <p:cNvSpPr txBox="1"/>
           <p:nvPr>
             <p:custDataLst>
-              <p:tags r:id="rId45"/>
+              <p:tags r:id="rId44"/>
             </p:custDataLst>
           </p:nvPr>
         </p:nvSpPr>
@@ -9198,7 +8971,7 @@
       </p:sp>
       <p:sp>
         <p:nvSpPr>
-          <p:cNvPr id="109" name="Rounded Rectangle 108"/>
+          <p:cNvPr id="101" name="Rounded Rectangle 100"/>
           <p:cNvSpPr/>
           <p:nvPr/>
         </p:nvSpPr>
@@ -9249,11 +9022,11 @@
       </p:sp>
       <p:sp>
         <p:nvSpPr>
-          <p:cNvPr id="110" name="TextBox 109"/>
+          <p:cNvPr id="102" name="TextBox 101"/>
           <p:cNvSpPr txBox="1"/>
           <p:nvPr>
             <p:custDataLst>
-              <p:tags r:id="rId46"/>
+              <p:tags r:id="rId45"/>
             </p:custDataLst>
           </p:nvPr>
         </p:nvSpPr>
@@ -9300,7 +9073,7 @@
       </p:sp>
       <p:sp>
         <p:nvSpPr>
-          <p:cNvPr id="111" name="Rounded Rectangle 110"/>
+          <p:cNvPr id="103" name="Rounded Rectangle 102"/>
           <p:cNvSpPr/>
           <p:nvPr/>
         </p:nvSpPr>
@@ -9351,11 +9124,11 @@
       </p:sp>
       <p:sp>
         <p:nvSpPr>
-          <p:cNvPr id="112" name="TextBox 111"/>
+          <p:cNvPr id="104" name="TextBox 103"/>
           <p:cNvSpPr txBox="1"/>
           <p:nvPr>
             <p:custDataLst>
-              <p:tags r:id="rId47"/>
+              <p:tags r:id="rId46"/>
             </p:custDataLst>
           </p:nvPr>
         </p:nvSpPr>
@@ -9402,17 +9175,17 @@
       </p:sp>
       <p:sp>
         <p:nvSpPr>
-          <p:cNvPr id="113" name="TextBox 112"/>
+          <p:cNvPr id="105" name="TextBox 104"/>
           <p:cNvSpPr txBox="1"/>
           <p:nvPr>
             <p:custDataLst>
-              <p:tags r:id="rId48"/>
+              <p:tags r:id="rId47"/>
             </p:custDataLst>
           </p:nvPr>
         </p:nvSpPr>
         <p:spPr>
           <a:xfrm>
-            <a:off x="4536000" y="11880000"/>
+            <a:off x="4508219" y="11880000"/>
             <a:ext cx="9576000" cy="288000"/>
           </a:xfrm>
           <a:prstGeom prst="rect">
@@ -9426,7 +9199,7 @@
           </a:bodyPr>
           <a:lstStyle/>
           <a:p>
-            <a:pPr algn="l">
+            <a:pPr algn="ctr">
               <a:lnSpc>
                 <a:spcPct val="110000"/>
               </a:lnSpc>
@@ -9453,7 +9226,7 @@
       </p:sp>
       <p:sp>
         <p:nvSpPr>
-          <p:cNvPr id="114" name="Rounded Rectangle 113"/>
+          <p:cNvPr id="106" name="Rounded Rectangle 105"/>
           <p:cNvSpPr/>
           <p:nvPr/>
         </p:nvSpPr>
@@ -9506,11 +9279,11 @@
       </p:sp>
       <p:sp>
         <p:nvSpPr>
-          <p:cNvPr id="115" name="TextBox 114"/>
+          <p:cNvPr id="107" name="TextBox 106"/>
           <p:cNvSpPr txBox="1"/>
           <p:nvPr>
             <p:custDataLst>
-              <p:tags r:id="rId49"/>
+              <p:tags r:id="rId48"/>
             </p:custDataLst>
           </p:nvPr>
         </p:nvSpPr>
@@ -9557,14 +9330,14 @@
       </p:sp>
       <p:sp>
         <p:nvSpPr>
-          <p:cNvPr id="116" name="Right Arrow 115"/>
+          <p:cNvPr id="108" name="Right Arrow 107"/>
           <p:cNvSpPr/>
           <p:nvPr/>
         </p:nvSpPr>
         <p:spPr>
           <a:xfrm>
-            <a:off x="7452000" y="12402000"/>
-            <a:ext cx="432000" cy="180000"/>
+            <a:off x="7434000" y="12402000"/>
+            <a:ext cx="396000" cy="180000"/>
           </a:xfrm>
           <a:prstGeom prst="rightArrow">
             <a:avLst/>
@@ -9606,13 +9379,13 @@
       </p:sp>
       <p:sp>
         <p:nvSpPr>
-          <p:cNvPr id="117" name="Rounded Rectangle 116"/>
+          <p:cNvPr id="109" name="Rounded Rectangle 108"/>
           <p:cNvSpPr/>
           <p:nvPr/>
         </p:nvSpPr>
         <p:spPr>
           <a:xfrm>
-            <a:off x="7992000" y="12240000"/>
+            <a:off x="7920000" y="12240000"/>
             <a:ext cx="2808000" cy="504000"/>
           </a:xfrm>
           <a:prstGeom prst="roundRect">
@@ -9659,17 +9432,17 @@
       </p:sp>
       <p:sp>
         <p:nvSpPr>
-          <p:cNvPr id="118" name="TextBox 117"/>
+          <p:cNvPr id="110" name="TextBox 109"/>
           <p:cNvSpPr txBox="1"/>
           <p:nvPr>
             <p:custDataLst>
-              <p:tags r:id="rId50"/>
+              <p:tags r:id="rId49"/>
             </p:custDataLst>
           </p:nvPr>
         </p:nvSpPr>
         <p:spPr>
           <a:xfrm>
-            <a:off x="7958661" y="12240000"/>
+            <a:off x="7886663" y="12240000"/>
             <a:ext cx="2808000" cy="504000"/>
           </a:xfrm>
           <a:prstGeom prst="rect">
@@ -9710,14 +9483,14 @@
       </p:sp>
       <p:sp>
         <p:nvSpPr>
-          <p:cNvPr id="119" name="Right Arrow 118"/>
+          <p:cNvPr id="111" name="Right Arrow 110"/>
           <p:cNvSpPr/>
           <p:nvPr/>
         </p:nvSpPr>
         <p:spPr>
           <a:xfrm>
-            <a:off x="10908000" y="12402000"/>
-            <a:ext cx="432000" cy="180000"/>
+            <a:off x="10818000" y="12402000"/>
+            <a:ext cx="396000" cy="180000"/>
           </a:xfrm>
           <a:prstGeom prst="rightArrow">
             <a:avLst/>
@@ -9759,13 +9532,13 @@
       </p:sp>
       <p:sp>
         <p:nvSpPr>
-          <p:cNvPr id="120" name="Rounded Rectangle 119"/>
+          <p:cNvPr id="112" name="Rounded Rectangle 111"/>
           <p:cNvSpPr/>
           <p:nvPr/>
         </p:nvSpPr>
         <p:spPr>
           <a:xfrm>
-            <a:off x="11448000" y="12240000"/>
+            <a:off x="11304000" y="12240000"/>
             <a:ext cx="2808000" cy="504000"/>
           </a:xfrm>
           <a:prstGeom prst="roundRect">
@@ -9810,17 +9583,17 @@
       </p:sp>
       <p:sp>
         <p:nvSpPr>
-          <p:cNvPr id="121" name="TextBox 120"/>
+          <p:cNvPr id="113" name="TextBox 112"/>
           <p:cNvSpPr txBox="1"/>
           <p:nvPr>
             <p:custDataLst>
-              <p:tags r:id="rId51"/>
+              <p:tags r:id="rId50"/>
             </p:custDataLst>
           </p:nvPr>
         </p:nvSpPr>
         <p:spPr>
           <a:xfrm>
-            <a:off x="11414661" y="12240000"/>
+            <a:off x="11270662" y="12240000"/>
             <a:ext cx="2808000" cy="504000"/>
           </a:xfrm>
           <a:prstGeom prst="rect">
@@ -9861,17 +9634,17 @@
       </p:sp>
       <p:sp>
         <p:nvSpPr>
-          <p:cNvPr id="122" name="TextBox 121"/>
+          <p:cNvPr id="114" name="TextBox 113"/>
           <p:cNvSpPr txBox="1"/>
           <p:nvPr>
             <p:custDataLst>
-              <p:tags r:id="rId52"/>
+              <p:tags r:id="rId51"/>
             </p:custDataLst>
           </p:nvPr>
         </p:nvSpPr>
         <p:spPr>
           <a:xfrm>
-            <a:off x="4536000" y="12816000"/>
+            <a:off x="4511394" y="12816000"/>
             <a:ext cx="9576000" cy="252000"/>
           </a:xfrm>
           <a:prstGeom prst="rect">
@@ -9885,7 +9658,7 @@
           </a:bodyPr>
           <a:lstStyle/>
           <a:p>
-            <a:pPr algn="l">
+            <a:pPr algn="ctr">
               <a:lnSpc>
                 <a:spcPct val="110000"/>
               </a:lnSpc>
@@ -9912,7 +9685,7 @@
       </p:sp>
       <p:sp>
         <p:nvSpPr>
-          <p:cNvPr id="123" name="Rounded Rectangle 122"/>
+          <p:cNvPr id="115" name="Rounded Rectangle 114"/>
           <p:cNvSpPr/>
           <p:nvPr/>
         </p:nvSpPr>
@@ -9963,7 +9736,7 @@
       </p:sp>
       <p:sp>
         <p:nvSpPr>
-          <p:cNvPr id="124" name="Oval 123"/>
+          <p:cNvPr id="116" name="Oval 115"/>
           <p:cNvSpPr/>
           <p:nvPr/>
         </p:nvSpPr>
@@ -10012,7 +9785,7 @@
       </p:sp>
       <p:sp>
         <p:nvSpPr>
-          <p:cNvPr id="125" name="Oval 124"/>
+          <p:cNvPr id="117" name="Oval 116"/>
           <p:cNvSpPr/>
           <p:nvPr/>
         </p:nvSpPr>
@@ -10061,7 +9834,7 @@
       </p:sp>
       <p:sp>
         <p:nvSpPr>
-          <p:cNvPr id="126" name="Oval 125"/>
+          <p:cNvPr id="118" name="Oval 117"/>
           <p:cNvSpPr/>
           <p:nvPr/>
         </p:nvSpPr>
@@ -10110,7 +9883,7 @@
       </p:sp>
       <p:sp>
         <p:nvSpPr>
-          <p:cNvPr id="127" name="Oval 126"/>
+          <p:cNvPr id="119" name="Oval 118"/>
           <p:cNvSpPr/>
           <p:nvPr/>
         </p:nvSpPr>
@@ -10159,11 +9932,11 @@
       </p:sp>
       <p:sp>
         <p:nvSpPr>
-          <p:cNvPr id="128" name="TextBox 127"/>
+          <p:cNvPr id="120" name="TextBox 119"/>
           <p:cNvSpPr txBox="1"/>
           <p:nvPr>
             <p:custDataLst>
-              <p:tags r:id="rId53"/>
+              <p:tags r:id="rId52"/>
             </p:custDataLst>
           </p:nvPr>
         </p:nvSpPr>
@@ -10210,18 +9983,18 @@
       </p:sp>
       <p:sp>
         <p:nvSpPr>
-          <p:cNvPr id="129" name="TextBox 128"/>
+          <p:cNvPr id="121" name="TextBox 120"/>
           <p:cNvSpPr txBox="1"/>
           <p:nvPr>
             <p:custDataLst>
-              <p:tags r:id="rId54"/>
+              <p:tags r:id="rId53"/>
             </p:custDataLst>
           </p:nvPr>
         </p:nvSpPr>
         <p:spPr>
           <a:xfrm>
-            <a:off x="864000" y="14274000"/>
-            <a:ext cx="576000" cy="468000"/>
+            <a:off x="818756" y="14274000"/>
+            <a:ext cx="13392000" cy="468000"/>
           </a:xfrm>
           <a:prstGeom prst="rect">
             <a:avLst/>
@@ -10234,7 +10007,7 @@
           </a:bodyPr>
           <a:lstStyle/>
           <a:p>
-            <a:pPr algn="l">
+            <a:pPr algn="ctr">
               <a:lnSpc>
                 <a:spcPct val="110000"/>
               </a:lnSpc>
@@ -10246,7 +10019,7 @@
               </a:spcAft>
             </a:pPr>
             <a:r>
-              <a:rPr sz="2200" b="1">
+              <a:rPr sz="2600" b="1">
                 <a:solidFill>
                   <a:srgbClr val="0F766E"/>
                 </a:solidFill>
@@ -10254,48 +10027,8 @@
                 <a:ea typeface="Microsoft JhengHei"/>
                 <a:cs typeface="Segoe UI"/>
               </a:rPr>
-              <a:t>02</a:t>
-            </a:r>
-          </a:p>
-        </p:txBody>
-      </p:sp>
-      <p:sp>
-        <p:nvSpPr>
-          <p:cNvPr id="130" name="TextBox 129"/>
-          <p:cNvSpPr txBox="1"/>
-          <p:nvPr>
-            <p:custDataLst>
-              <p:tags r:id="rId55"/>
-            </p:custDataLst>
-          </p:nvPr>
-        </p:nvSpPr>
-        <p:spPr>
-          <a:xfrm>
-            <a:off x="1476000" y="14274000"/>
-            <a:ext cx="10800000" cy="468000"/>
-          </a:xfrm>
-          <a:prstGeom prst="rect">
-            <a:avLst/>
-          </a:prstGeom>
-          <a:noFill/>
-        </p:spPr>
-        <p:txBody>
-          <a:bodyPr wrap="none" lIns="0" tIns="0" rIns="0" bIns="0" anchor="ctr">
-            <a:spAutoFit/>
-          </a:bodyPr>
-          <a:lstStyle/>
-          <a:p>
-            <a:pPr algn="l">
-              <a:lnSpc>
-                <a:spcPct val="110000"/>
-              </a:lnSpc>
-              <a:spcBef>
-                <a:spcPts val="0"/>
-              </a:spcBef>
-              <a:spcAft>
-                <a:spcPts val="0"/>
-              </a:spcAft>
-            </a:pPr>
+              <a:t>02　</a:t>
+            </a:r>
             <a:r>
               <a:rPr sz="2600" b="1">
                 <a:solidFill>
@@ -10312,7 +10045,7 @@
       </p:sp>
       <p:cxnSp>
         <p:nvCxnSpPr>
-          <p:cNvPr id="131" name="Connector 130"/>
+          <p:cNvPr id="122" name="Connector 121"/>
           <p:cNvCxnSpPr/>
           <p:nvPr/>
         </p:nvCxnSpPr>
@@ -10348,7 +10081,7 @@
       </p:cxnSp>
       <p:sp>
         <p:nvSpPr>
-          <p:cNvPr id="132" name="Rounded Rectangle 131"/>
+          <p:cNvPr id="123" name="Rounded Rectangle 122"/>
           <p:cNvSpPr/>
           <p:nvPr/>
         </p:nvSpPr>
@@ -10401,13 +10134,13 @@
       </p:sp>
       <p:sp>
         <p:nvSpPr>
-          <p:cNvPr id="133" name="Rectangle 132"/>
+          <p:cNvPr id="124" name="Rectangle 123"/>
           <p:cNvSpPr/>
           <p:nvPr/>
         </p:nvSpPr>
         <p:spPr>
           <a:xfrm>
-            <a:off x="1080000" y="15120000"/>
+            <a:off x="2772000" y="15120000"/>
             <a:ext cx="504000" cy="50400"/>
           </a:xfrm>
           <a:prstGeom prst="rect">
@@ -10450,18 +10183,18 @@
       </p:sp>
       <p:sp>
         <p:nvSpPr>
-          <p:cNvPr id="134" name="TextBox 133"/>
+          <p:cNvPr id="125" name="TextBox 124"/>
           <p:cNvSpPr txBox="1"/>
           <p:nvPr>
             <p:custDataLst>
-              <p:tags r:id="rId56"/>
+              <p:tags r:id="rId54"/>
             </p:custDataLst>
           </p:nvPr>
         </p:nvSpPr>
         <p:spPr>
           <a:xfrm>
-            <a:off x="1080000" y="15228000"/>
-            <a:ext cx="3888000" cy="360000"/>
+            <a:off x="969107" y="15228000"/>
+            <a:ext cx="4032000" cy="360000"/>
           </a:xfrm>
           <a:prstGeom prst="rect">
             <a:avLst/>
@@ -10474,7 +10207,7 @@
           </a:bodyPr>
           <a:lstStyle/>
           <a:p>
-            <a:pPr algn="l">
+            <a:pPr algn="ctr">
               <a:lnSpc>
                 <a:spcPct val="110000"/>
               </a:lnSpc>
@@ -10501,18 +10234,18 @@
       </p:sp>
       <p:sp>
         <p:nvSpPr>
-          <p:cNvPr id="135" name="TextBox 134"/>
+          <p:cNvPr id="126" name="TextBox 125"/>
           <p:cNvSpPr txBox="1"/>
           <p:nvPr>
             <p:custDataLst>
-              <p:tags r:id="rId57"/>
+              <p:tags r:id="rId55"/>
             </p:custDataLst>
           </p:nvPr>
         </p:nvSpPr>
         <p:spPr>
           <a:xfrm>
-            <a:off x="1080000" y="15624000"/>
-            <a:ext cx="3960000" cy="828000"/>
+            <a:off x="981806" y="15624000"/>
+            <a:ext cx="4032000" cy="828000"/>
           </a:xfrm>
           <a:prstGeom prst="rect">
             <a:avLst/>
@@ -10525,7 +10258,7 @@
           </a:bodyPr>
           <a:lstStyle/>
           <a:p>
-            <a:pPr algn="l">
+            <a:pPr algn="ctr">
               <a:lnSpc>
                 <a:spcPct val="110000"/>
               </a:lnSpc>
@@ -10549,7 +10282,7 @@
             </a:r>
           </a:p>
           <a:p>
-            <a:pPr algn="l">
+            <a:pPr algn="ctr">
               <a:lnSpc>
                 <a:spcPct val="110000"/>
               </a:lnSpc>
@@ -10573,7 +10306,7 @@
             </a:r>
           </a:p>
           <a:p>
-            <a:pPr algn="l">
+            <a:pPr algn="ctr">
               <a:lnSpc>
                 <a:spcPct val="110000"/>
               </a:lnSpc>
@@ -10600,7 +10333,7 @@
       </p:sp>
       <p:sp>
         <p:nvSpPr>
-          <p:cNvPr id="136" name="Rounded Rectangle 135"/>
+          <p:cNvPr id="127" name="Rounded Rectangle 126"/>
           <p:cNvSpPr/>
           <p:nvPr/>
         </p:nvSpPr>
@@ -10653,13 +10386,13 @@
       </p:sp>
       <p:sp>
         <p:nvSpPr>
-          <p:cNvPr id="137" name="Rectangle 136"/>
+          <p:cNvPr id="128" name="Rectangle 127"/>
           <p:cNvSpPr/>
           <p:nvPr/>
         </p:nvSpPr>
         <p:spPr>
           <a:xfrm>
-            <a:off x="5616000" y="15120000"/>
+            <a:off x="7308000" y="15120000"/>
             <a:ext cx="504000" cy="50400"/>
           </a:xfrm>
           <a:prstGeom prst="rect">
@@ -10702,18 +10435,18 @@
       </p:sp>
       <p:sp>
         <p:nvSpPr>
-          <p:cNvPr id="138" name="TextBox 137"/>
+          <p:cNvPr id="129" name="TextBox 128"/>
           <p:cNvSpPr txBox="1"/>
           <p:nvPr>
             <p:custDataLst>
-              <p:tags r:id="rId58"/>
+              <p:tags r:id="rId56"/>
             </p:custDataLst>
           </p:nvPr>
         </p:nvSpPr>
         <p:spPr>
           <a:xfrm>
-            <a:off x="5616000" y="15228000"/>
-            <a:ext cx="3888000" cy="360000"/>
+            <a:off x="5505107" y="15228000"/>
+            <a:ext cx="4032000" cy="360000"/>
           </a:xfrm>
           <a:prstGeom prst="rect">
             <a:avLst/>
@@ -10726,7 +10459,7 @@
           </a:bodyPr>
           <a:lstStyle/>
           <a:p>
-            <a:pPr algn="l">
+            <a:pPr algn="ctr">
               <a:lnSpc>
                 <a:spcPct val="110000"/>
               </a:lnSpc>
@@ -10753,18 +10486,18 @@
       </p:sp>
       <p:sp>
         <p:nvSpPr>
-          <p:cNvPr id="139" name="TextBox 138"/>
+          <p:cNvPr id="130" name="TextBox 129"/>
           <p:cNvSpPr txBox="1"/>
           <p:nvPr>
             <p:custDataLst>
-              <p:tags r:id="rId59"/>
+              <p:tags r:id="rId57"/>
             </p:custDataLst>
           </p:nvPr>
         </p:nvSpPr>
         <p:spPr>
           <a:xfrm>
-            <a:off x="5616000" y="15624000"/>
-            <a:ext cx="3960000" cy="828000"/>
+            <a:off x="5517807" y="15624000"/>
+            <a:ext cx="4032000" cy="828000"/>
           </a:xfrm>
           <a:prstGeom prst="rect">
             <a:avLst/>
@@ -10777,7 +10510,7 @@
           </a:bodyPr>
           <a:lstStyle/>
           <a:p>
-            <a:pPr algn="l">
+            <a:pPr algn="ctr">
               <a:lnSpc>
                 <a:spcPct val="110000"/>
               </a:lnSpc>
@@ -10801,7 +10534,7 @@
             </a:r>
           </a:p>
           <a:p>
-            <a:pPr algn="l">
+            <a:pPr algn="ctr">
               <a:lnSpc>
                 <a:spcPct val="110000"/>
               </a:lnSpc>
@@ -10825,7 +10558,7 @@
             </a:r>
           </a:p>
           <a:p>
-            <a:pPr algn="l">
+            <a:pPr algn="ctr">
               <a:lnSpc>
                 <a:spcPct val="110000"/>
               </a:lnSpc>
@@ -10852,7 +10585,7 @@
       </p:sp>
       <p:sp>
         <p:nvSpPr>
-          <p:cNvPr id="140" name="Rounded Rectangle 139"/>
+          <p:cNvPr id="131" name="Rounded Rectangle 130"/>
           <p:cNvSpPr/>
           <p:nvPr/>
         </p:nvSpPr>
@@ -10905,13 +10638,13 @@
       </p:sp>
       <p:sp>
         <p:nvSpPr>
-          <p:cNvPr id="141" name="Rectangle 140"/>
+          <p:cNvPr id="132" name="Rectangle 131"/>
           <p:cNvSpPr/>
           <p:nvPr/>
         </p:nvSpPr>
         <p:spPr>
           <a:xfrm>
-            <a:off x="10152000" y="15120000"/>
+            <a:off x="11844000" y="15120000"/>
             <a:ext cx="504000" cy="50400"/>
           </a:xfrm>
           <a:prstGeom prst="rect">
@@ -10954,18 +10687,18 @@
       </p:sp>
       <p:sp>
         <p:nvSpPr>
-          <p:cNvPr id="142" name="TextBox 141"/>
+          <p:cNvPr id="133" name="TextBox 132"/>
           <p:cNvSpPr txBox="1"/>
           <p:nvPr>
             <p:custDataLst>
-              <p:tags r:id="rId60"/>
+              <p:tags r:id="rId58"/>
             </p:custDataLst>
           </p:nvPr>
         </p:nvSpPr>
         <p:spPr>
           <a:xfrm>
-            <a:off x="10152000" y="15228000"/>
-            <a:ext cx="3888000" cy="360000"/>
+            <a:off x="10041107" y="15228000"/>
+            <a:ext cx="4032000" cy="360000"/>
           </a:xfrm>
           <a:prstGeom prst="rect">
             <a:avLst/>
@@ -10978,7 +10711,7 @@
           </a:bodyPr>
           <a:lstStyle/>
           <a:p>
-            <a:pPr algn="l">
+            <a:pPr algn="ctr">
               <a:lnSpc>
                 <a:spcPct val="110000"/>
               </a:lnSpc>
@@ -11005,18 +10738,18 @@
       </p:sp>
       <p:sp>
         <p:nvSpPr>
-          <p:cNvPr id="143" name="TextBox 142"/>
+          <p:cNvPr id="134" name="TextBox 133"/>
           <p:cNvSpPr txBox="1"/>
           <p:nvPr>
             <p:custDataLst>
-              <p:tags r:id="rId61"/>
+              <p:tags r:id="rId59"/>
             </p:custDataLst>
           </p:nvPr>
         </p:nvSpPr>
         <p:spPr>
           <a:xfrm>
-            <a:off x="10152000" y="15624000"/>
-            <a:ext cx="3960000" cy="828000"/>
+            <a:off x="10053807" y="15624000"/>
+            <a:ext cx="4032000" cy="828000"/>
           </a:xfrm>
           <a:prstGeom prst="rect">
             <a:avLst/>
@@ -11029,7 +10762,7 @@
           </a:bodyPr>
           <a:lstStyle/>
           <a:p>
-            <a:pPr algn="l">
+            <a:pPr algn="ctr">
               <a:lnSpc>
                 <a:spcPct val="110000"/>
               </a:lnSpc>
@@ -11053,7 +10786,7 @@
             </a:r>
           </a:p>
           <a:p>
-            <a:pPr algn="l">
+            <a:pPr algn="ctr">
               <a:lnSpc>
                 <a:spcPct val="110000"/>
               </a:lnSpc>
@@ -11077,7 +10810,7 @@
             </a:r>
           </a:p>
           <a:p>
-            <a:pPr algn="l">
+            <a:pPr algn="ctr">
               <a:lnSpc>
                 <a:spcPct val="110000"/>
               </a:lnSpc>
@@ -11104,18 +10837,18 @@
       </p:sp>
       <p:sp>
         <p:nvSpPr>
-          <p:cNvPr id="144" name="TextBox 143"/>
+          <p:cNvPr id="135" name="TextBox 134"/>
           <p:cNvSpPr txBox="1"/>
           <p:nvPr>
             <p:custDataLst>
-              <p:tags r:id="rId62"/>
+              <p:tags r:id="rId60"/>
             </p:custDataLst>
           </p:nvPr>
         </p:nvSpPr>
         <p:spPr>
           <a:xfrm>
-            <a:off x="864000" y="16794000"/>
-            <a:ext cx="576000" cy="468000"/>
+            <a:off x="818756" y="16794000"/>
+            <a:ext cx="13392000" cy="468000"/>
           </a:xfrm>
           <a:prstGeom prst="rect">
             <a:avLst/>
@@ -11128,7 +10861,7 @@
           </a:bodyPr>
           <a:lstStyle/>
           <a:p>
-            <a:pPr algn="l">
+            <a:pPr algn="ctr">
               <a:lnSpc>
                 <a:spcPct val="110000"/>
               </a:lnSpc>
@@ -11140,7 +10873,7 @@
               </a:spcAft>
             </a:pPr>
             <a:r>
-              <a:rPr sz="2200" b="1">
+              <a:rPr sz="2600" b="1">
                 <a:solidFill>
                   <a:srgbClr val="0F766E"/>
                 </a:solidFill>
@@ -11148,48 +10881,8 @@
                 <a:ea typeface="Microsoft JhengHei"/>
                 <a:cs typeface="Segoe UI"/>
               </a:rPr>
-              <a:t>03</a:t>
-            </a:r>
-          </a:p>
-        </p:txBody>
-      </p:sp>
-      <p:sp>
-        <p:nvSpPr>
-          <p:cNvPr id="145" name="TextBox 144"/>
-          <p:cNvSpPr txBox="1"/>
-          <p:nvPr>
-            <p:custDataLst>
-              <p:tags r:id="rId63"/>
-            </p:custDataLst>
-          </p:nvPr>
-        </p:nvSpPr>
-        <p:spPr>
-          <a:xfrm>
-            <a:off x="1476000" y="16794000"/>
-            <a:ext cx="10800000" cy="468000"/>
-          </a:xfrm>
-          <a:prstGeom prst="rect">
-            <a:avLst/>
-          </a:prstGeom>
-          <a:noFill/>
-        </p:spPr>
-        <p:txBody>
-          <a:bodyPr wrap="none" lIns="0" tIns="0" rIns="0" bIns="0" anchor="ctr">
-            <a:spAutoFit/>
-          </a:bodyPr>
-          <a:lstStyle/>
-          <a:p>
-            <a:pPr algn="l">
-              <a:lnSpc>
-                <a:spcPct val="110000"/>
-              </a:lnSpc>
-              <a:spcBef>
-                <a:spcPts val="0"/>
-              </a:spcBef>
-              <a:spcAft>
-                <a:spcPts val="0"/>
-              </a:spcAft>
-            </a:pPr>
+              <a:t>03　</a:t>
+            </a:r>
             <a:r>
               <a:rPr sz="2600" b="1">
                 <a:solidFill>
@@ -11206,7 +10899,7 @@
       </p:sp>
       <p:cxnSp>
         <p:nvCxnSpPr>
-          <p:cNvPr id="146" name="Connector 145"/>
+          <p:cNvPr id="136" name="Connector 135"/>
           <p:cNvCxnSpPr/>
           <p:nvPr/>
         </p:nvCxnSpPr>
@@ -11242,18 +10935,69 @@
       </p:cxnSp>
       <p:sp>
         <p:nvSpPr>
-          <p:cNvPr id="147" name="TextBox 146"/>
+          <p:cNvPr id="137" name="TextBox 136"/>
           <p:cNvSpPr txBox="1"/>
           <p:nvPr>
             <p:custDataLst>
-              <p:tags r:id="rId64"/>
+              <p:tags r:id="rId61"/>
             </p:custDataLst>
           </p:nvPr>
         </p:nvSpPr>
         <p:spPr>
           <a:xfrm>
-            <a:off x="864000" y="17460000"/>
+            <a:off x="837806" y="17460000"/>
             <a:ext cx="6624000" cy="252000"/>
+          </a:xfrm>
+          <a:prstGeom prst="rect">
+            <a:avLst/>
+          </a:prstGeom>
+          <a:noFill/>
+        </p:spPr>
+        <p:txBody>
+          <a:bodyPr wrap="none" lIns="0" tIns="0" rIns="0" bIns="0" anchor="ctr">
+            <a:spAutoFit/>
+          </a:bodyPr>
+          <a:lstStyle/>
+          <a:p>
+            <a:pPr algn="ctr">
+              <a:lnSpc>
+                <a:spcPct val="110000"/>
+              </a:lnSpc>
+              <a:spcBef>
+                <a:spcPts val="0"/>
+              </a:spcBef>
+              <a:spcAft>
+                <a:spcPts val="0"/>
+              </a:spcAft>
+            </a:pPr>
+            <a:r>
+              <a:rPr sz="1500" b="0">
+                <a:solidFill>
+                  <a:srgbClr val="52637A"/>
+                </a:solidFill>
+                <a:latin typeface="Segoe UI"/>
+                <a:ea typeface="Microsoft JhengHei"/>
+                <a:cs typeface="Segoe UI"/>
+              </a:rPr>
+              <a:t>相同18,998筆測試的 Macro-F1</a:t>
+            </a:r>
+          </a:p>
+        </p:txBody>
+      </p:sp>
+      <p:sp>
+        <p:nvSpPr>
+          <p:cNvPr id="138" name="TextBox 137"/>
+          <p:cNvSpPr txBox="1"/>
+          <p:nvPr>
+            <p:custDataLst>
+              <p:tags r:id="rId62"/>
+            </p:custDataLst>
+          </p:nvPr>
+        </p:nvSpPr>
+        <p:spPr>
+          <a:xfrm>
+            <a:off x="864000" y="17784000"/>
+            <a:ext cx="1440000" cy="288000"/>
           </a:xfrm>
           <a:prstGeom prst="rect">
             <a:avLst/>
@@ -11278,57 +11022,6 @@
               </a:spcAft>
             </a:pPr>
             <a:r>
-              <a:rPr sz="1500" b="0">
-                <a:solidFill>
-                  <a:srgbClr val="52637A"/>
-                </a:solidFill>
-                <a:latin typeface="Segoe UI"/>
-                <a:ea typeface="Microsoft JhengHei"/>
-                <a:cs typeface="Segoe UI"/>
-              </a:rPr>
-              <a:t>相同18,998筆測試的 Macro-F1</a:t>
-            </a:r>
-          </a:p>
-        </p:txBody>
-      </p:sp>
-      <p:sp>
-        <p:nvSpPr>
-          <p:cNvPr id="148" name="TextBox 147"/>
-          <p:cNvSpPr txBox="1"/>
-          <p:nvPr>
-            <p:custDataLst>
-              <p:tags r:id="rId65"/>
-            </p:custDataLst>
-          </p:nvPr>
-        </p:nvSpPr>
-        <p:spPr>
-          <a:xfrm>
-            <a:off x="864000" y="17784000"/>
-            <a:ext cx="1440000" cy="288000"/>
-          </a:xfrm>
-          <a:prstGeom prst="rect">
-            <a:avLst/>
-          </a:prstGeom>
-          <a:noFill/>
-        </p:spPr>
-        <p:txBody>
-          <a:bodyPr wrap="none" lIns="0" tIns="0" rIns="0" bIns="0" anchor="ctr">
-            <a:spAutoFit/>
-          </a:bodyPr>
-          <a:lstStyle/>
-          <a:p>
-            <a:pPr algn="l">
-              <a:lnSpc>
-                <a:spcPct val="110000"/>
-              </a:lnSpc>
-              <a:spcBef>
-                <a:spcPts val="0"/>
-              </a:spcBef>
-              <a:spcAft>
-                <a:spcPts val="0"/>
-              </a:spcAft>
-            </a:pPr>
-            <a:r>
               <a:rPr sz="1700" b="1">
                 <a:solidFill>
                   <a:srgbClr val="15233A"/>
@@ -11344,7 +11037,7 @@
       </p:sp>
       <p:sp>
         <p:nvSpPr>
-          <p:cNvPr id="149" name="Rectangle 148"/>
+          <p:cNvPr id="139" name="Rectangle 138"/>
           <p:cNvSpPr/>
           <p:nvPr/>
         </p:nvSpPr>
@@ -11393,7 +11086,7 @@
       </p:sp>
       <p:sp>
         <p:nvSpPr>
-          <p:cNvPr id="150" name="Rectangle 149"/>
+          <p:cNvPr id="140" name="Rectangle 139"/>
           <p:cNvSpPr/>
           <p:nvPr/>
         </p:nvSpPr>
@@ -11442,11 +11135,11 @@
       </p:sp>
       <p:sp>
         <p:nvSpPr>
-          <p:cNvPr id="151" name="TextBox 150"/>
+          <p:cNvPr id="141" name="TextBox 140"/>
           <p:cNvSpPr txBox="1"/>
           <p:nvPr>
             <p:custDataLst>
-              <p:tags r:id="rId66"/>
+              <p:tags r:id="rId63"/>
             </p:custDataLst>
           </p:nvPr>
         </p:nvSpPr>
@@ -11493,11 +11186,11 @@
       </p:sp>
       <p:sp>
         <p:nvSpPr>
-          <p:cNvPr id="152" name="TextBox 151"/>
+          <p:cNvPr id="142" name="TextBox 141"/>
           <p:cNvSpPr txBox="1"/>
           <p:nvPr>
             <p:custDataLst>
-              <p:tags r:id="rId67"/>
+              <p:tags r:id="rId64"/>
             </p:custDataLst>
           </p:nvPr>
         </p:nvSpPr>
@@ -11544,7 +11237,7 @@
       </p:sp>
       <p:sp>
         <p:nvSpPr>
-          <p:cNvPr id="153" name="Rectangle 152"/>
+          <p:cNvPr id="143" name="Rectangle 142"/>
           <p:cNvSpPr/>
           <p:nvPr/>
         </p:nvSpPr>
@@ -11593,7 +11286,7 @@
       </p:sp>
       <p:sp>
         <p:nvSpPr>
-          <p:cNvPr id="154" name="Rectangle 153"/>
+          <p:cNvPr id="144" name="Rectangle 143"/>
           <p:cNvSpPr/>
           <p:nvPr/>
         </p:nvSpPr>
@@ -11642,11 +11335,11 @@
       </p:sp>
       <p:sp>
         <p:nvSpPr>
-          <p:cNvPr id="155" name="TextBox 154"/>
+          <p:cNvPr id="145" name="TextBox 144"/>
           <p:cNvSpPr txBox="1"/>
           <p:nvPr>
             <p:custDataLst>
-              <p:tags r:id="rId68"/>
+              <p:tags r:id="rId65"/>
             </p:custDataLst>
           </p:nvPr>
         </p:nvSpPr>
@@ -11693,11 +11386,11 @@
       </p:sp>
       <p:sp>
         <p:nvSpPr>
-          <p:cNvPr id="156" name="TextBox 155"/>
+          <p:cNvPr id="146" name="TextBox 145"/>
           <p:cNvSpPr txBox="1"/>
           <p:nvPr>
             <p:custDataLst>
-              <p:tags r:id="rId69"/>
+              <p:tags r:id="rId66"/>
             </p:custDataLst>
           </p:nvPr>
         </p:nvSpPr>
@@ -11744,7 +11437,7 @@
       </p:sp>
       <p:sp>
         <p:nvSpPr>
-          <p:cNvPr id="157" name="Rectangle 156"/>
+          <p:cNvPr id="147" name="Rectangle 146"/>
           <p:cNvSpPr/>
           <p:nvPr/>
         </p:nvSpPr>
@@ -11793,7 +11486,7 @@
       </p:sp>
       <p:sp>
         <p:nvSpPr>
-          <p:cNvPr id="158" name="Rectangle 157"/>
+          <p:cNvPr id="148" name="Rectangle 147"/>
           <p:cNvSpPr/>
           <p:nvPr/>
         </p:nvSpPr>
@@ -11842,11 +11535,11 @@
       </p:sp>
       <p:sp>
         <p:nvSpPr>
-          <p:cNvPr id="159" name="TextBox 158"/>
+          <p:cNvPr id="149" name="TextBox 148"/>
           <p:cNvSpPr txBox="1"/>
           <p:nvPr>
             <p:custDataLst>
-              <p:tags r:id="rId70"/>
+              <p:tags r:id="rId67"/>
             </p:custDataLst>
           </p:nvPr>
         </p:nvSpPr>
@@ -11893,7 +11586,7 @@
       </p:sp>
       <p:cxnSp>
         <p:nvCxnSpPr>
-          <p:cNvPr id="160" name="Connector 159"/>
+          <p:cNvPr id="150" name="Connector 149"/>
           <p:cNvCxnSpPr/>
           <p:nvPr/>
         </p:nvCxnSpPr>
@@ -11929,11 +11622,11 @@
       </p:cxnSp>
       <p:sp>
         <p:nvSpPr>
-          <p:cNvPr id="161" name="TextBox 160"/>
+          <p:cNvPr id="151" name="TextBox 150"/>
           <p:cNvSpPr txBox="1"/>
           <p:nvPr>
             <p:custDataLst>
-              <p:tags r:id="rId71"/>
+              <p:tags r:id="rId68"/>
             </p:custDataLst>
           </p:nvPr>
         </p:nvSpPr>
@@ -11980,7 +11673,7 @@
       </p:sp>
       <p:cxnSp>
         <p:nvCxnSpPr>
-          <p:cNvPr id="162" name="Connector 161"/>
+          <p:cNvPr id="152" name="Connector 151"/>
           <p:cNvCxnSpPr/>
           <p:nvPr/>
         </p:nvCxnSpPr>
@@ -12016,11 +11709,11 @@
       </p:cxnSp>
       <p:sp>
         <p:nvSpPr>
-          <p:cNvPr id="163" name="TextBox 162"/>
+          <p:cNvPr id="153" name="TextBox 152"/>
           <p:cNvSpPr txBox="1"/>
           <p:nvPr>
             <p:custDataLst>
-              <p:tags r:id="rId72"/>
+              <p:tags r:id="rId69"/>
             </p:custDataLst>
           </p:nvPr>
         </p:nvSpPr>
@@ -12067,7 +11760,7 @@
       </p:sp>
       <p:cxnSp>
         <p:nvCxnSpPr>
-          <p:cNvPr id="164" name="Connector 163"/>
+          <p:cNvPr id="154" name="Connector 153"/>
           <p:cNvCxnSpPr/>
           <p:nvPr/>
         </p:nvCxnSpPr>
@@ -12103,11 +11796,11 @@
       </p:cxnSp>
       <p:sp>
         <p:nvSpPr>
-          <p:cNvPr id="165" name="TextBox 164"/>
+          <p:cNvPr id="155" name="TextBox 154"/>
           <p:cNvSpPr txBox="1"/>
           <p:nvPr>
             <p:custDataLst>
-              <p:tags r:id="rId73"/>
+              <p:tags r:id="rId70"/>
             </p:custDataLst>
           </p:nvPr>
         </p:nvSpPr>
@@ -12154,17 +11847,17 @@
       </p:sp>
       <p:sp>
         <p:nvSpPr>
-          <p:cNvPr id="166" name="TextBox 165"/>
+          <p:cNvPr id="156" name="TextBox 155"/>
           <p:cNvSpPr txBox="1"/>
           <p:nvPr>
             <p:custDataLst>
-              <p:tags r:id="rId74"/>
+              <p:tags r:id="rId71"/>
             </p:custDataLst>
           </p:nvPr>
         </p:nvSpPr>
         <p:spPr>
           <a:xfrm>
-            <a:off x="864000" y="19404000"/>
+            <a:off x="837806" y="19404000"/>
             <a:ext cx="6624000" cy="252000"/>
           </a:xfrm>
           <a:prstGeom prst="rect">
@@ -12178,7 +11871,7 @@
           </a:bodyPr>
           <a:lstStyle/>
           <a:p>
-            <a:pPr algn="l">
+            <a:pPr algn="ctr">
               <a:lnSpc>
                 <a:spcPct val="110000"/>
               </a:lnSpc>
@@ -12205,7 +11898,7 @@
       </p:sp>
       <p:cxnSp>
         <p:nvCxnSpPr>
-          <p:cNvPr id="167" name="Connector 166"/>
+          <p:cNvPr id="157" name="Connector 156"/>
           <p:cNvCxnSpPr/>
           <p:nvPr/>
         </p:nvCxnSpPr>
@@ -12241,17 +11934,17 @@
       </p:cxnSp>
       <p:sp>
         <p:nvSpPr>
-          <p:cNvPr id="168" name="TextBox 167"/>
+          <p:cNvPr id="158" name="TextBox 157"/>
           <p:cNvSpPr txBox="1"/>
           <p:nvPr>
             <p:custDataLst>
-              <p:tags r:id="rId75"/>
+              <p:tags r:id="rId72"/>
             </p:custDataLst>
           </p:nvPr>
         </p:nvSpPr>
         <p:spPr>
           <a:xfrm>
-            <a:off x="7920000" y="17460000"/>
+            <a:off x="7893807" y="17460000"/>
             <a:ext cx="6336000" cy="252000"/>
           </a:xfrm>
           <a:prstGeom prst="rect">
@@ -12265,7 +11958,7 @@
           </a:bodyPr>
           <a:lstStyle/>
           <a:p>
-            <a:pPr algn="l">
+            <a:pPr algn="ctr">
               <a:lnSpc>
                 <a:spcPct val="110000"/>
               </a:lnSpc>
@@ -12292,17 +11985,17 @@
       </p:sp>
       <p:sp>
         <p:nvSpPr>
-          <p:cNvPr id="169" name="TextBox 168"/>
+          <p:cNvPr id="159" name="TextBox 158"/>
           <p:cNvSpPr txBox="1"/>
           <p:nvPr>
             <p:custDataLst>
-              <p:tags r:id="rId76"/>
+              <p:tags r:id="rId73"/>
             </p:custDataLst>
           </p:nvPr>
         </p:nvSpPr>
         <p:spPr>
           <a:xfrm>
-            <a:off x="7920000" y="17712000"/>
+            <a:off x="7860469" y="17712000"/>
             <a:ext cx="6336000" cy="504000"/>
           </a:xfrm>
           <a:prstGeom prst="rect">
@@ -12316,7 +12009,7 @@
           </a:bodyPr>
           <a:lstStyle/>
           <a:p>
-            <a:pPr algn="l">
+            <a:pPr algn="ctr">
               <a:lnSpc>
                 <a:spcPct val="110000"/>
               </a:lnSpc>
@@ -12343,17 +12036,17 @@
       </p:sp>
       <p:sp>
         <p:nvSpPr>
-          <p:cNvPr id="170" name="TextBox 169"/>
+          <p:cNvPr id="160" name="TextBox 159"/>
           <p:cNvSpPr txBox="1"/>
           <p:nvPr>
             <p:custDataLst>
-              <p:tags r:id="rId77"/>
+              <p:tags r:id="rId74"/>
             </p:custDataLst>
           </p:nvPr>
         </p:nvSpPr>
         <p:spPr>
           <a:xfrm>
-            <a:off x="7920000" y="18216000"/>
+            <a:off x="7895395" y="18216000"/>
             <a:ext cx="6336000" cy="252000"/>
           </a:xfrm>
           <a:prstGeom prst="rect">
@@ -12367,7 +12060,7 @@
           </a:bodyPr>
           <a:lstStyle/>
           <a:p>
-            <a:pPr algn="l">
+            <a:pPr algn="ctr">
               <a:lnSpc>
                 <a:spcPct val="110000"/>
               </a:lnSpc>
@@ -12394,7 +12087,7 @@
       </p:sp>
       <p:sp>
         <p:nvSpPr>
-          <p:cNvPr id="171" name="Rounded Rectangle 170"/>
+          <p:cNvPr id="161" name="Rounded Rectangle 160"/>
           <p:cNvSpPr/>
           <p:nvPr/>
         </p:nvSpPr>
@@ -12445,11 +12138,11 @@
       </p:sp>
       <p:sp>
         <p:nvSpPr>
-          <p:cNvPr id="172" name="TextBox 171"/>
+          <p:cNvPr id="162" name="TextBox 161"/>
           <p:cNvSpPr txBox="1"/>
           <p:nvPr>
             <p:custDataLst>
-              <p:tags r:id="rId78"/>
+              <p:tags r:id="rId75"/>
             </p:custDataLst>
           </p:nvPr>
         </p:nvSpPr>
@@ -12496,11 +12189,11 @@
       </p:sp>
       <p:sp>
         <p:nvSpPr>
-          <p:cNvPr id="173" name="TextBox 172"/>
+          <p:cNvPr id="163" name="TextBox 162"/>
           <p:cNvSpPr txBox="1"/>
           <p:nvPr>
             <p:custDataLst>
-              <p:tags r:id="rId79"/>
+              <p:tags r:id="rId76"/>
             </p:custDataLst>
           </p:nvPr>
         </p:nvSpPr>
@@ -12547,7 +12240,7 @@
       </p:sp>
       <p:sp>
         <p:nvSpPr>
-          <p:cNvPr id="174" name="Rounded Rectangle 173"/>
+          <p:cNvPr id="164" name="Rounded Rectangle 163"/>
           <p:cNvSpPr/>
           <p:nvPr/>
         </p:nvSpPr>
@@ -12598,11 +12291,11 @@
       </p:sp>
       <p:sp>
         <p:nvSpPr>
-          <p:cNvPr id="175" name="TextBox 174"/>
+          <p:cNvPr id="165" name="TextBox 164"/>
           <p:cNvSpPr txBox="1"/>
           <p:nvPr>
             <p:custDataLst>
-              <p:tags r:id="rId80"/>
+              <p:tags r:id="rId77"/>
             </p:custDataLst>
           </p:nvPr>
         </p:nvSpPr>
@@ -12649,11 +12342,11 @@
       </p:sp>
       <p:sp>
         <p:nvSpPr>
-          <p:cNvPr id="176" name="TextBox 175"/>
+          <p:cNvPr id="166" name="TextBox 165"/>
           <p:cNvSpPr txBox="1"/>
           <p:nvPr>
             <p:custDataLst>
-              <p:tags r:id="rId81"/>
+              <p:tags r:id="rId78"/>
             </p:custDataLst>
           </p:nvPr>
         </p:nvSpPr>
@@ -12700,7 +12393,7 @@
       </p:sp>
       <p:sp>
         <p:nvSpPr>
-          <p:cNvPr id="177" name="Rounded Rectangle 176"/>
+          <p:cNvPr id="167" name="Rounded Rectangle 166"/>
           <p:cNvSpPr/>
           <p:nvPr/>
         </p:nvSpPr>
@@ -12751,11 +12444,11 @@
       </p:sp>
       <p:sp>
         <p:nvSpPr>
-          <p:cNvPr id="178" name="TextBox 177"/>
+          <p:cNvPr id="168" name="TextBox 167"/>
           <p:cNvSpPr txBox="1"/>
           <p:nvPr>
             <p:custDataLst>
-              <p:tags r:id="rId82"/>
+              <p:tags r:id="rId79"/>
             </p:custDataLst>
           </p:nvPr>
         </p:nvSpPr>
@@ -12802,11 +12495,11 @@
       </p:sp>
       <p:sp>
         <p:nvSpPr>
-          <p:cNvPr id="179" name="TextBox 178"/>
+          <p:cNvPr id="169" name="TextBox 168"/>
           <p:cNvSpPr txBox="1"/>
           <p:nvPr>
             <p:custDataLst>
-              <p:tags r:id="rId83"/>
+              <p:tags r:id="rId80"/>
             </p:custDataLst>
           </p:nvPr>
         </p:nvSpPr>
@@ -12853,17 +12546,17 @@
       </p:sp>
       <p:sp>
         <p:nvSpPr>
-          <p:cNvPr id="180" name="TextBox 179"/>
+          <p:cNvPr id="170" name="TextBox 169"/>
           <p:cNvSpPr txBox="1"/>
           <p:nvPr>
             <p:custDataLst>
-              <p:tags r:id="rId84"/>
+              <p:tags r:id="rId81"/>
             </p:custDataLst>
           </p:nvPr>
         </p:nvSpPr>
         <p:spPr>
           <a:xfrm>
-            <a:off x="7920000" y="19404000"/>
+            <a:off x="7896188" y="19404000"/>
             <a:ext cx="6336000" cy="252000"/>
           </a:xfrm>
           <a:prstGeom prst="rect">
@@ -12877,7 +12570,7 @@
           </a:bodyPr>
           <a:lstStyle/>
           <a:p>
-            <a:pPr algn="l">
+            <a:pPr algn="ctr">
               <a:lnSpc>
                 <a:spcPct val="110000"/>
               </a:lnSpc>
@@ -12904,7 +12597,7 @@
       </p:sp>
       <p:sp>
         <p:nvSpPr>
-          <p:cNvPr id="181" name="Rounded Rectangle 180"/>
+          <p:cNvPr id="171" name="Rounded Rectangle 170"/>
           <p:cNvSpPr/>
           <p:nvPr/>
         </p:nvSpPr>
@@ -12955,17 +12648,17 @@
       </p:sp>
       <p:sp>
         <p:nvSpPr>
-          <p:cNvPr id="182" name="TextBox 181"/>
+          <p:cNvPr id="172" name="TextBox 171"/>
           <p:cNvSpPr txBox="1"/>
           <p:nvPr>
             <p:custDataLst>
-              <p:tags r:id="rId85"/>
+              <p:tags r:id="rId82"/>
             </p:custDataLst>
           </p:nvPr>
         </p:nvSpPr>
         <p:spPr>
           <a:xfrm>
-            <a:off x="1008000" y="19836000"/>
+            <a:off x="981807" y="19836000"/>
             <a:ext cx="2304000" cy="720000"/>
           </a:xfrm>
           <a:prstGeom prst="rect">
@@ -12979,7 +12672,7 @@
           </a:bodyPr>
           <a:lstStyle/>
           <a:p>
-            <a:pPr algn="l">
+            <a:pPr algn="ctr">
               <a:lnSpc>
                 <a:spcPct val="110000"/>
               </a:lnSpc>
@@ -13003,7 +12696,7 @@
             </a:r>
           </a:p>
           <a:p>
-            <a:pPr algn="l">
+            <a:pPr algn="ctr">
               <a:lnSpc>
                 <a:spcPct val="110000"/>
               </a:lnSpc>
@@ -13030,7 +12723,7 @@
       </p:sp>
       <p:sp>
         <p:nvSpPr>
-          <p:cNvPr id="183" name="Rounded Rectangle 182"/>
+          <p:cNvPr id="173" name="Rounded Rectangle 172"/>
           <p:cNvSpPr/>
           <p:nvPr/>
         </p:nvSpPr>
@@ -13083,11 +12776,11 @@
       </p:sp>
       <p:sp>
         <p:nvSpPr>
-          <p:cNvPr id="184" name="TextBox 183"/>
+          <p:cNvPr id="174" name="TextBox 173"/>
           <p:cNvSpPr txBox="1"/>
           <p:nvPr>
             <p:custDataLst>
-              <p:tags r:id="rId86"/>
+              <p:tags r:id="rId83"/>
             </p:custDataLst>
           </p:nvPr>
         </p:nvSpPr>
@@ -13134,11 +12827,11 @@
       </p:sp>
       <p:sp>
         <p:nvSpPr>
-          <p:cNvPr id="185" name="TextBox 184"/>
+          <p:cNvPr id="175" name="TextBox 174"/>
           <p:cNvSpPr txBox="1"/>
           <p:nvPr>
             <p:custDataLst>
-              <p:tags r:id="rId87"/>
+              <p:tags r:id="rId84"/>
             </p:custDataLst>
           </p:nvPr>
         </p:nvSpPr>
@@ -13185,7 +12878,7 @@
       </p:sp>
       <p:sp>
         <p:nvSpPr>
-          <p:cNvPr id="186" name="Rounded Rectangle 185"/>
+          <p:cNvPr id="176" name="Rounded Rectangle 175"/>
           <p:cNvSpPr/>
           <p:nvPr/>
         </p:nvSpPr>
@@ -13236,11 +12929,11 @@
       </p:sp>
       <p:sp>
         <p:nvSpPr>
-          <p:cNvPr id="187" name="TextBox 186"/>
+          <p:cNvPr id="177" name="TextBox 176"/>
           <p:cNvSpPr txBox="1"/>
           <p:nvPr>
             <p:custDataLst>
-              <p:tags r:id="rId88"/>
+              <p:tags r:id="rId85"/>
             </p:custDataLst>
           </p:nvPr>
         </p:nvSpPr>
@@ -13287,11 +12980,11 @@
       </p:sp>
       <p:sp>
         <p:nvSpPr>
-          <p:cNvPr id="188" name="TextBox 187"/>
+          <p:cNvPr id="178" name="TextBox 177"/>
           <p:cNvSpPr txBox="1"/>
           <p:nvPr>
             <p:custDataLst>
-              <p:tags r:id="rId89"/>
+              <p:tags r:id="rId86"/>
             </p:custDataLst>
           </p:nvPr>
         </p:nvSpPr>
@@ -13338,7 +13031,7 @@
       </p:sp>
       <p:sp>
         <p:nvSpPr>
-          <p:cNvPr id="189" name="Rounded Rectangle 188"/>
+          <p:cNvPr id="179" name="Rounded Rectangle 178"/>
           <p:cNvSpPr/>
           <p:nvPr/>
         </p:nvSpPr>
@@ -13389,11 +13082,11 @@
       </p:sp>
       <p:sp>
         <p:nvSpPr>
-          <p:cNvPr id="190" name="TextBox 189"/>
+          <p:cNvPr id="180" name="TextBox 179"/>
           <p:cNvSpPr txBox="1"/>
           <p:nvPr>
             <p:custDataLst>
-              <p:tags r:id="rId90"/>
+              <p:tags r:id="rId87"/>
             </p:custDataLst>
           </p:nvPr>
         </p:nvSpPr>
@@ -13440,11 +13133,11 @@
       </p:sp>
       <p:sp>
         <p:nvSpPr>
-          <p:cNvPr id="191" name="TextBox 190"/>
+          <p:cNvPr id="181" name="TextBox 180"/>
           <p:cNvSpPr txBox="1"/>
           <p:nvPr>
             <p:custDataLst>
-              <p:tags r:id="rId91"/>
+              <p:tags r:id="rId88"/>
             </p:custDataLst>
           </p:nvPr>
         </p:nvSpPr>
@@ -13491,7 +13184,7 @@
       </p:sp>
       <p:sp>
         <p:nvSpPr>
-          <p:cNvPr id="192" name="Rounded Rectangle 191"/>
+          <p:cNvPr id="182" name="Rounded Rectangle 181"/>
           <p:cNvSpPr/>
           <p:nvPr/>
         </p:nvSpPr>
@@ -13542,11 +13235,11 @@
       </p:sp>
       <p:sp>
         <p:nvSpPr>
-          <p:cNvPr id="193" name="TextBox 192"/>
+          <p:cNvPr id="183" name="TextBox 182"/>
           <p:cNvSpPr txBox="1"/>
           <p:nvPr>
             <p:custDataLst>
-              <p:tags r:id="rId92"/>
+              <p:tags r:id="rId89"/>
             </p:custDataLst>
           </p:nvPr>
         </p:nvSpPr>
@@ -13593,11 +13286,11 @@
       </p:sp>
       <p:sp>
         <p:nvSpPr>
-          <p:cNvPr id="194" name="TextBox 193"/>
+          <p:cNvPr id="184" name="TextBox 183"/>
           <p:cNvSpPr txBox="1"/>
           <p:nvPr>
             <p:custDataLst>
-              <p:tags r:id="rId93"/>
+              <p:tags r:id="rId90"/>
             </p:custDataLst>
           </p:nvPr>
         </p:nvSpPr>
@@ -13644,7 +13337,7 @@
       </p:sp>
       <p:sp>
         <p:nvSpPr>
-          <p:cNvPr id="195" name="Rounded Rectangle 194"/>
+          <p:cNvPr id="185" name="Rounded Rectangle 184"/>
           <p:cNvSpPr/>
           <p:nvPr/>
         </p:nvSpPr>
@@ -13697,11 +13390,11 @@
       </p:sp>
       <p:sp>
         <p:nvSpPr>
-          <p:cNvPr id="196" name="TextBox 195"/>
+          <p:cNvPr id="186" name="TextBox 185"/>
           <p:cNvSpPr txBox="1"/>
           <p:nvPr>
             <p:custDataLst>
-              <p:tags r:id="rId94"/>
+              <p:tags r:id="rId91"/>
             </p:custDataLst>
           </p:nvPr>
         </p:nvSpPr>
@@ -13748,11 +13441,11 @@
       </p:sp>
       <p:sp>
         <p:nvSpPr>
-          <p:cNvPr id="197" name="TextBox 196"/>
+          <p:cNvPr id="187" name="TextBox 186"/>
           <p:cNvSpPr txBox="1"/>
           <p:nvPr>
             <p:custDataLst>
-              <p:tags r:id="rId95"/>
+              <p:tags r:id="rId92"/>
             </p:custDataLst>
           </p:nvPr>
         </p:nvSpPr>
@@ -13799,7 +13492,7 @@
       </p:sp>
       <p:sp>
         <p:nvSpPr>
-          <p:cNvPr id="198" name="Rounded Rectangle 197"/>
+          <p:cNvPr id="188" name="Rounded Rectangle 187"/>
           <p:cNvSpPr/>
           <p:nvPr/>
         </p:nvSpPr>
@@ -13850,11 +13543,11 @@
       </p:sp>
       <p:sp>
         <p:nvSpPr>
-          <p:cNvPr id="199" name="TextBox 198"/>
+          <p:cNvPr id="189" name="TextBox 188"/>
           <p:cNvSpPr txBox="1"/>
           <p:nvPr>
             <p:custDataLst>
-              <p:tags r:id="rId96"/>
+              <p:tags r:id="rId93"/>
             </p:custDataLst>
           </p:nvPr>
         </p:nvSpPr>
@@ -13901,11 +13594,11 @@
       </p:sp>
       <p:sp>
         <p:nvSpPr>
-          <p:cNvPr id="200" name="TextBox 199"/>
+          <p:cNvPr id="190" name="TextBox 189"/>
           <p:cNvSpPr txBox="1"/>
           <p:nvPr>
             <p:custDataLst>
-              <p:tags r:id="rId97"/>
+              <p:tags r:id="rId94"/>
             </p:custDataLst>
           </p:nvPr>
         </p:nvSpPr>
@@ -13952,17 +13645,17 @@
       </p:sp>
       <p:sp>
         <p:nvSpPr>
-          <p:cNvPr id="201" name="TextBox 200"/>
+          <p:cNvPr id="191" name="TextBox 190"/>
           <p:cNvSpPr txBox="1"/>
           <p:nvPr>
             <p:custDataLst>
-              <p:tags r:id="rId98"/>
+              <p:tags r:id="rId95"/>
             </p:custDataLst>
           </p:nvPr>
         </p:nvSpPr>
         <p:spPr>
           <a:xfrm>
-            <a:off x="10592512" y="19836000"/>
+            <a:off x="10624250" y="19836000"/>
             <a:ext cx="3456000" cy="720000"/>
           </a:xfrm>
           <a:prstGeom prst="rect">
@@ -13976,7 +13669,7 @@
           </a:bodyPr>
           <a:lstStyle/>
           <a:p>
-            <a:pPr algn="r">
+            <a:pPr algn="ctr">
               <a:lnSpc>
                 <a:spcPct val="110000"/>
               </a:lnSpc>
@@ -14000,7 +13693,7 @@
             </a:r>
           </a:p>
           <a:p>
-            <a:pPr algn="r">
+            <a:pPr algn="ctr">
               <a:lnSpc>
                 <a:spcPct val="110000"/>
               </a:lnSpc>
@@ -14027,11 +13720,11 @@
       </p:sp>
       <p:sp>
         <p:nvSpPr>
-          <p:cNvPr id="202" name="TextBox 201"/>
+          <p:cNvPr id="192" name="TextBox 191"/>
           <p:cNvSpPr txBox="1"/>
           <p:nvPr>
             <p:custDataLst>
-              <p:tags r:id="rId99"/>
+              <p:tags r:id="rId96"/>
             </p:custDataLst>
           </p:nvPr>
         </p:nvSpPr>
@@ -14086,91 +13779,91 @@
 
 <file path=ppt/tags/tag1.xml><?xml version="1.0" encoding="utf-8"?>
 <p:tagLst xmlns:a="http://schemas.openxmlformats.org/drawingml/2006/main" xmlns:r="http://schemas.openxmlformats.org/officeDocument/2006/relationships" xmlns:p="http://schemas.openxmlformats.org/presentationml/2006/main">
-  <p:tag name="ALIGNMENT_TARGET_X" val="68.031494140625"/>
+  <p:tag name="ALIGNMENT_TARGET_X" val="595.27557373046875"/>
 </p:tagLst>
 </file>
 
 <file path=ppt/tags/tag10.xml><?xml version="1.0" encoding="utf-8"?>
 <p:tagLst xmlns:a="http://schemas.openxmlformats.org/drawingml/2006/main" xmlns:r="http://schemas.openxmlformats.org/officeDocument/2006/relationships" xmlns:p="http://schemas.openxmlformats.org/presentationml/2006/main">
-  <p:tag name="ALIGNMENT_TARGET_X" val="116.22047424316406"/>
+  <p:tag name="ALIGNMENT_TARGET_X" val="209.76377868652344"/>
 </p:tagLst>
 </file>
 
 <file path=ppt/tags/tag11.xml><?xml version="1.0" encoding="utf-8"?>
 <p:tagLst xmlns:a="http://schemas.openxmlformats.org/drawingml/2006/main" xmlns:r="http://schemas.openxmlformats.org/officeDocument/2006/relationships" xmlns:p="http://schemas.openxmlformats.org/presentationml/2006/main">
-  <p:tag name="ALIGNMENT_TARGET_X" val="130.39370727539063"/>
+  <p:tag name="ALIGNMENT_TARGET_X" val="209.76377868652344"/>
 </p:tagLst>
 </file>
 
 <file path=ppt/tags/tag12.xml><?xml version="1.0" encoding="utf-8"?>
 <p:tagLst xmlns:a="http://schemas.openxmlformats.org/drawingml/2006/main" xmlns:r="http://schemas.openxmlformats.org/officeDocument/2006/relationships" xmlns:p="http://schemas.openxmlformats.org/presentationml/2006/main">
-  <p:tag name="ALIGNMENT_TARGET_X" val="130.39370727539063"/>
+  <p:tag name="ALIGNMENT_TARGET_X" val="209.76377868652344"/>
 </p:tagLst>
 </file>
 
 <file path=ppt/tags/tag13.xml><?xml version="1.0" encoding="utf-8"?>
 <p:tagLst xmlns:a="http://schemas.openxmlformats.org/drawingml/2006/main" xmlns:r="http://schemas.openxmlformats.org/officeDocument/2006/relationships" xmlns:p="http://schemas.openxmlformats.org/presentationml/2006/main">
-  <p:tag name="ALIGNMENT_TARGET_X" val="85.03936767578125"/>
+  <p:tag name="ALIGNMENT_TARGET_X" val="209.76377868652344"/>
 </p:tagLst>
 </file>
 
 <file path=ppt/tags/tag14.xml><?xml version="1.0" encoding="utf-8"?>
 <p:tagLst xmlns:a="http://schemas.openxmlformats.org/drawingml/2006/main" xmlns:r="http://schemas.openxmlformats.org/officeDocument/2006/relationships" xmlns:p="http://schemas.openxmlformats.org/presentationml/2006/main">
-  <p:tag name="ALIGNMENT_TARGET_X" val="130.39370727539063"/>
+  <p:tag name="ALIGNMENT_TARGET_X" val="209.76377868652344"/>
 </p:tagLst>
 </file>
 
 <file path=ppt/tags/tag15.xml><?xml version="1.0" encoding="utf-8"?>
 <p:tagLst xmlns:a="http://schemas.openxmlformats.org/drawingml/2006/main" xmlns:r="http://schemas.openxmlformats.org/officeDocument/2006/relationships" xmlns:p="http://schemas.openxmlformats.org/presentationml/2006/main">
-  <p:tag name="ALIGNMENT_TARGET_X" val="130.39370727539063"/>
+  <p:tag name="ALIGNMENT_TARGET_X" val="209.76377868652344"/>
 </p:tagLst>
 </file>
 
 <file path=ppt/tags/tag16.xml><?xml version="1.0" encoding="utf-8"?>
 <p:tagLst xmlns:a="http://schemas.openxmlformats.org/drawingml/2006/main" xmlns:r="http://schemas.openxmlformats.org/officeDocument/2006/relationships" xmlns:p="http://schemas.openxmlformats.org/presentationml/2006/main">
-  <p:tag name="ALIGNMENT_TARGET_X" val="85.03936767578125"/>
+  <p:tag name="ALIGNMENT_TARGET_X" val="209.76377868652344"/>
 </p:tagLst>
 </file>
 
 <file path=ppt/tags/tag17.xml><?xml version="1.0" encoding="utf-8"?>
 <p:tagLst xmlns:a="http://schemas.openxmlformats.org/drawingml/2006/main" xmlns:r="http://schemas.openxmlformats.org/officeDocument/2006/relationships" xmlns:p="http://schemas.openxmlformats.org/presentationml/2006/main">
-  <p:tag name="ALIGNMENT_TARGET_X" val="130.39370727539063"/>
+  <p:tag name="ALIGNMENT_TARGET_X" val="209.76377868652344"/>
 </p:tagLst>
 </file>
 
 <file path=ppt/tags/tag18.xml><?xml version="1.0" encoding="utf-8"?>
 <p:tagLst xmlns:a="http://schemas.openxmlformats.org/drawingml/2006/main" xmlns:r="http://schemas.openxmlformats.org/officeDocument/2006/relationships" xmlns:p="http://schemas.openxmlformats.org/presentationml/2006/main">
-  <p:tag name="ALIGNMENT_TARGET_X" val="130.39370727539063"/>
+  <p:tag name="ALIGNMENT_TARGET_X" val="209.76377868652344"/>
 </p:tagLst>
 </file>
 
 <file path=ppt/tags/tag19.xml><?xml version="1.0" encoding="utf-8"?>
 <p:tagLst xmlns:a="http://schemas.openxmlformats.org/drawingml/2006/main" xmlns:r="http://schemas.openxmlformats.org/officeDocument/2006/relationships" xmlns:p="http://schemas.openxmlformats.org/presentationml/2006/main">
-  <p:tag name="ALIGNMENT_TARGET_X" val="85.03936767578125"/>
+  <p:tag name="ALIGNMENT_TARGET_X" val="209.76377868652344"/>
 </p:tagLst>
 </file>
 
 <file path=ppt/tags/tag2.xml><?xml version="1.0" encoding="utf-8"?>
 <p:tagLst xmlns:a="http://schemas.openxmlformats.org/drawingml/2006/main" xmlns:r="http://schemas.openxmlformats.org/officeDocument/2006/relationships" xmlns:p="http://schemas.openxmlformats.org/presentationml/2006/main">
-  <p:tag name="ALIGNMENT_TARGET_X" val="68.031494140625"/>
+  <p:tag name="ALIGNMENT_TARGET_X" val="595.27557373046875"/>
 </p:tagLst>
 </file>
 
 <file path=ppt/tags/tag20.xml><?xml version="1.0" encoding="utf-8"?>
 <p:tagLst xmlns:a="http://schemas.openxmlformats.org/drawingml/2006/main" xmlns:r="http://schemas.openxmlformats.org/officeDocument/2006/relationships" xmlns:p="http://schemas.openxmlformats.org/presentationml/2006/main">
-  <p:tag name="ALIGNMENT_TARGET_X" val="130.39370727539063"/>
+  <p:tag name="ALIGNMENT_TARGET_X" val="209.76377868652344"/>
 </p:tagLst>
 </file>
 
 <file path=ppt/tags/tag21.xml><?xml version="1.0" encoding="utf-8"?>
 <p:tagLst xmlns:a="http://schemas.openxmlformats.org/drawingml/2006/main" xmlns:r="http://schemas.openxmlformats.org/officeDocument/2006/relationships" xmlns:p="http://schemas.openxmlformats.org/presentationml/2006/main">
-  <p:tag name="ALIGNMENT_TARGET_X" val="130.39370727539063"/>
+  <p:tag name="ALIGNMENT_TARGET_X" val="209.76377868652344"/>
 </p:tagLst>
 </file>
 
 <file path=ppt/tags/tag22.xml><?xml version="1.0" encoding="utf-8"?>
 <p:tagLst xmlns:a="http://schemas.openxmlformats.org/drawingml/2006/main" xmlns:r="http://schemas.openxmlformats.org/officeDocument/2006/relationships" xmlns:p="http://schemas.openxmlformats.org/presentationml/2006/main">
-  <p:tag name="ALIGNMENT_TARGET_X" val="85.03936767578125"/>
+  <p:tag name="ALIGNMENT_TARGET_X" val="467.71652221679688"/>
 </p:tagLst>
 </file>
 
@@ -14194,7 +13887,7 @@
 
 <file path=ppt/tags/tag26.xml><?xml version="1.0" encoding="utf-8"?>
 <p:tagLst xmlns:a="http://schemas.openxmlformats.org/drawingml/2006/main" xmlns:r="http://schemas.openxmlformats.org/officeDocument/2006/relationships" xmlns:p="http://schemas.openxmlformats.org/presentationml/2006/main">
-  <p:tag name="ALIGNMENT_TARGET_X" val="467.71652221679688"/>
+  <p:tag name="ALIGNMENT_TARGET_X" val="748.346435546875"/>
 </p:tagLst>
 </file>
 
@@ -14206,7 +13899,7 @@
 
 <file path=ppt/tags/tag28.xml><?xml version="1.0" encoding="utf-8"?>
 <p:tagLst xmlns:a="http://schemas.openxmlformats.org/drawingml/2006/main" xmlns:r="http://schemas.openxmlformats.org/officeDocument/2006/relationships" xmlns:p="http://schemas.openxmlformats.org/presentationml/2006/main">
-  <p:tag name="ALIGNMENT_TARGET_X" val="748.346435546875"/>
+  <p:tag name="ALIGNMENT_TARGET_X" val="1009.1338500976563"/>
 </p:tagLst>
 </file>
 
@@ -14218,13 +13911,13 @@
 
 <file path=ppt/tags/tag3.xml><?xml version="1.0" encoding="utf-8"?>
 <p:tagLst xmlns:a="http://schemas.openxmlformats.org/drawingml/2006/main" xmlns:r="http://schemas.openxmlformats.org/officeDocument/2006/relationships" xmlns:p="http://schemas.openxmlformats.org/presentationml/2006/main">
-  <p:tag name="ALIGNMENT_TARGET_X" val="68.031494140625"/>
+  <p:tag name="ALIGNMENT_TARGET_X" val="595.27557373046875"/>
 </p:tagLst>
 </file>
 
 <file path=ppt/tags/tag30.xml><?xml version="1.0" encoding="utf-8"?>
 <p:tagLst xmlns:a="http://schemas.openxmlformats.org/drawingml/2006/main" xmlns:r="http://schemas.openxmlformats.org/officeDocument/2006/relationships" xmlns:p="http://schemas.openxmlformats.org/presentationml/2006/main">
-  <p:tag name="ALIGNMENT_TARGET_X" val="1009.1338500976563"/>
+  <p:tag name="ALIGNMENT_TARGET_X" val="467.71652221679688"/>
 </p:tagLst>
 </file>
 
@@ -14236,7 +13929,7 @@
 
 <file path=ppt/tags/tag32.xml><?xml version="1.0" encoding="utf-8"?>
 <p:tagLst xmlns:a="http://schemas.openxmlformats.org/drawingml/2006/main" xmlns:r="http://schemas.openxmlformats.org/officeDocument/2006/relationships" xmlns:p="http://schemas.openxmlformats.org/presentationml/2006/main">
-  <p:tag name="ALIGNMENT_TARGET_X" val="467.71652221679688"/>
+  <p:tag name="ALIGNMENT_TARGET_X" val="748.346435546875"/>
 </p:tagLst>
 </file>
 
@@ -14248,49 +13941,49 @@
 
 <file path=ppt/tags/tag34.xml><?xml version="1.0" encoding="utf-8"?>
 <p:tagLst xmlns:a="http://schemas.openxmlformats.org/drawingml/2006/main" xmlns:r="http://schemas.openxmlformats.org/officeDocument/2006/relationships" xmlns:p="http://schemas.openxmlformats.org/presentationml/2006/main">
-  <p:tag name="ALIGNMENT_TARGET_X" val="748.346435546875"/>
+  <p:tag name="ALIGNMENT_TARGET_X" val="1009.1338500976563"/>
 </p:tagLst>
 </file>
 
 <file path=ppt/tags/tag35.xml><?xml version="1.0" encoding="utf-8"?>
 <p:tagLst xmlns:a="http://schemas.openxmlformats.org/drawingml/2006/main" xmlns:r="http://schemas.openxmlformats.org/officeDocument/2006/relationships" xmlns:p="http://schemas.openxmlformats.org/presentationml/2006/main">
-  <p:tag name="ALIGNMENT_TARGET_X" val="1009.1338500976563"/>
+  <p:tag name="ALIGNMENT_TARGET_X" val="931.18112754821777"/>
 </p:tagLst>
 </file>
 
 <file path=ppt/tags/tag36.xml><?xml version="1.0" encoding="utf-8"?>
 <p:tagLst xmlns:a="http://schemas.openxmlformats.org/drawingml/2006/main" xmlns:r="http://schemas.openxmlformats.org/officeDocument/2006/relationships" xmlns:p="http://schemas.openxmlformats.org/presentationml/2006/main">
-  <p:tag name="ALIGNMENT_TARGET_X" val="931.18112754821777"/>
+  <p:tag name="ALIGNMENT_TARGET_X" val="969.16538047790527"/>
 </p:tagLst>
 </file>
 
 <file path=ppt/tags/tag37.xml><?xml version="1.0" encoding="utf-8"?>
 <p:tagLst xmlns:a="http://schemas.openxmlformats.org/drawingml/2006/main" xmlns:r="http://schemas.openxmlformats.org/officeDocument/2006/relationships" xmlns:p="http://schemas.openxmlformats.org/presentationml/2006/main">
-  <p:tag name="ALIGNMENT_TARGET_X" val="969.16538047790527"/>
+  <p:tag name="ALIGNMENT_TARGET_X" val="1007.1496334075928"/>
 </p:tagLst>
 </file>
 
 <file path=ppt/tags/tag38.xml><?xml version="1.0" encoding="utf-8"?>
 <p:tagLst xmlns:a="http://schemas.openxmlformats.org/drawingml/2006/main" xmlns:r="http://schemas.openxmlformats.org/officeDocument/2006/relationships" xmlns:p="http://schemas.openxmlformats.org/presentationml/2006/main">
-  <p:tag name="ALIGNMENT_TARGET_X" val="1007.1496334075928"/>
+  <p:tag name="ALIGNMENT_TARGET_X" val="1045.1338863372803"/>
 </p:tagLst>
 </file>
 
 <file path=ppt/tags/tag39.xml><?xml version="1.0" encoding="utf-8"?>
 <p:tagLst xmlns:a="http://schemas.openxmlformats.org/drawingml/2006/main" xmlns:r="http://schemas.openxmlformats.org/officeDocument/2006/relationships" xmlns:p="http://schemas.openxmlformats.org/presentationml/2006/main">
-  <p:tag name="ALIGNMENT_TARGET_X" val="1045.1338863372803"/>
+  <p:tag name="ALIGNMENT_TARGET_X" val="1083.1181392669678"/>
 </p:tagLst>
 </file>
 
 <file path=ppt/tags/tag4.xml><?xml version="1.0" encoding="utf-8"?>
 <p:tagLst xmlns:a="http://schemas.openxmlformats.org/drawingml/2006/main" xmlns:r="http://schemas.openxmlformats.org/officeDocument/2006/relationships" xmlns:p="http://schemas.openxmlformats.org/presentationml/2006/main">
-  <p:tag name="ALIGNMENT_TARGET_X" val="68.031494140625"/>
+  <p:tag name="ALIGNMENT_TARGET_X" val="595.27557373046875"/>
 </p:tagLst>
 </file>
 
 <file path=ppt/tags/tag40.xml><?xml version="1.0" encoding="utf-8"?>
 <p:tagLst xmlns:a="http://schemas.openxmlformats.org/drawingml/2006/main" xmlns:r="http://schemas.openxmlformats.org/officeDocument/2006/relationships" xmlns:p="http://schemas.openxmlformats.org/presentationml/2006/main">
-  <p:tag name="ALIGNMENT_TARGET_X" val="1083.1181392669678"/>
+  <p:tag name="ALIGNMENT_TARGET_X" val="467.71652221679688"/>
 </p:tagLst>
 </file>
 
@@ -14302,7 +13995,7 @@
 
 <file path=ppt/tags/tag42.xml><?xml version="1.0" encoding="utf-8"?>
 <p:tagLst xmlns:a="http://schemas.openxmlformats.org/drawingml/2006/main" xmlns:r="http://schemas.openxmlformats.org/officeDocument/2006/relationships" xmlns:p="http://schemas.openxmlformats.org/presentationml/2006/main">
-  <p:tag name="ALIGNMENT_TARGET_X" val="467.71652221679688"/>
+  <p:tag name="ALIGNMENT_TARGET_X" val="748.346435546875"/>
 </p:tagLst>
 </file>
 
@@ -14314,7 +14007,7 @@
 
 <file path=ppt/tags/tag44.xml><?xml version="1.0" encoding="utf-8"?>
 <p:tagLst xmlns:a="http://schemas.openxmlformats.org/drawingml/2006/main" xmlns:r="http://schemas.openxmlformats.org/officeDocument/2006/relationships" xmlns:p="http://schemas.openxmlformats.org/presentationml/2006/main">
-  <p:tag name="ALIGNMENT_TARGET_X" val="748.346435546875"/>
+  <p:tag name="ALIGNMENT_TARGET_X" val="1009.1338500976563"/>
 </p:tagLst>
 </file>
 
@@ -14332,19 +14025,19 @@
 
 <file path=ppt/tags/tag47.xml><?xml version="1.0" encoding="utf-8"?>
 <p:tagLst xmlns:a="http://schemas.openxmlformats.org/drawingml/2006/main" xmlns:r="http://schemas.openxmlformats.org/officeDocument/2006/relationships" xmlns:p="http://schemas.openxmlformats.org/presentationml/2006/main">
-  <p:tag name="ALIGNMENT_TARGET_X" val="1009.1338500976563"/>
+  <p:tag name="ALIGNMENT_TARGET_X" val="734.1732177734375"/>
 </p:tagLst>
 </file>
 
 <file path=ppt/tags/tag48.xml><?xml version="1.0" encoding="utf-8"?>
 <p:tagLst xmlns:a="http://schemas.openxmlformats.org/drawingml/2006/main" xmlns:r="http://schemas.openxmlformats.org/officeDocument/2006/relationships" xmlns:p="http://schemas.openxmlformats.org/presentationml/2006/main">
-  <p:tag name="ALIGNMENT_TARGET_X" val="357.16534423828125"/>
+  <p:tag name="ALIGNMENT_TARGET_X" val="467.71652221679688"/>
 </p:tagLst>
 </file>
 
 <file path=ppt/tags/tag49.xml><?xml version="1.0" encoding="utf-8"?>
 <p:tagLst xmlns:a="http://schemas.openxmlformats.org/drawingml/2006/main" xmlns:r="http://schemas.openxmlformats.org/officeDocument/2006/relationships" xmlns:p="http://schemas.openxmlformats.org/presentationml/2006/main">
-  <p:tag name="ALIGNMENT_TARGET_X" val="467.71652221679688"/>
+  <p:tag name="ALIGNMENT_TARGET_X" val="734.17324829101563"/>
 </p:tagLst>
 </file>
 
@@ -14356,19 +14049,19 @@
 
 <file path=ppt/tags/tag50.xml><?xml version="1.0" encoding="utf-8"?>
 <p:tagLst xmlns:a="http://schemas.openxmlformats.org/drawingml/2006/main" xmlns:r="http://schemas.openxmlformats.org/officeDocument/2006/relationships" xmlns:p="http://schemas.openxmlformats.org/presentationml/2006/main">
-  <p:tag name="ALIGNMENT_TARGET_X" val="739.84249877929688"/>
+  <p:tag name="ALIGNMENT_TARGET_X" val="1000.6299133300781"/>
 </p:tagLst>
 </file>
 
 <file path=ppt/tags/tag51.xml><?xml version="1.0" encoding="utf-8"?>
 <p:tagLst xmlns:a="http://schemas.openxmlformats.org/drawingml/2006/main" xmlns:r="http://schemas.openxmlformats.org/officeDocument/2006/relationships" xmlns:p="http://schemas.openxmlformats.org/presentationml/2006/main">
-  <p:tag name="ALIGNMENT_TARGET_X" val="1011.9684753417969"/>
+  <p:tag name="ALIGNMENT_TARGET_X" val="734.1732177734375"/>
 </p:tagLst>
 </file>
 
 <file path=ppt/tags/tag52.xml><?xml version="1.0" encoding="utf-8"?>
 <p:tagLst xmlns:a="http://schemas.openxmlformats.org/drawingml/2006/main" xmlns:r="http://schemas.openxmlformats.org/officeDocument/2006/relationships" xmlns:p="http://schemas.openxmlformats.org/presentationml/2006/main">
-  <p:tag name="ALIGNMENT_TARGET_X" val="357.16534423828125"/>
+  <p:tag name="ALIGNMENT_TARGET_X" val="595.27557373046875"/>
 </p:tagLst>
 </file>
 
@@ -14380,37 +14073,37 @@
 
 <file path=ppt/tags/tag54.xml><?xml version="1.0" encoding="utf-8"?>
 <p:tagLst xmlns:a="http://schemas.openxmlformats.org/drawingml/2006/main" xmlns:r="http://schemas.openxmlformats.org/officeDocument/2006/relationships" xmlns:p="http://schemas.openxmlformats.org/presentationml/2006/main">
-  <p:tag name="ALIGNMENT_TARGET_X" val="68.031494140625"/>
+  <p:tag name="ALIGNMENT_TARGET_X" val="238.11023712158203"/>
 </p:tagLst>
 </file>
 
 <file path=ppt/tags/tag55.xml><?xml version="1.0" encoding="utf-8"?>
 <p:tagLst xmlns:a="http://schemas.openxmlformats.org/drawingml/2006/main" xmlns:r="http://schemas.openxmlformats.org/officeDocument/2006/relationships" xmlns:p="http://schemas.openxmlformats.org/presentationml/2006/main">
-  <p:tag name="ALIGNMENT_TARGET_X" val="116.22047424316406"/>
+  <p:tag name="ALIGNMENT_TARGET_X" val="238.11023712158203"/>
 </p:tagLst>
 </file>
 
 <file path=ppt/tags/tag56.xml><?xml version="1.0" encoding="utf-8"?>
 <p:tagLst xmlns:a="http://schemas.openxmlformats.org/drawingml/2006/main" xmlns:r="http://schemas.openxmlformats.org/officeDocument/2006/relationships" xmlns:p="http://schemas.openxmlformats.org/presentationml/2006/main">
-  <p:tag name="ALIGNMENT_TARGET_X" val="85.03936767578125"/>
+  <p:tag name="ALIGNMENT_TARGET_X" val="595.27558898925781"/>
 </p:tagLst>
 </file>
 
 <file path=ppt/tags/tag57.xml><?xml version="1.0" encoding="utf-8"?>
 <p:tagLst xmlns:a="http://schemas.openxmlformats.org/drawingml/2006/main" xmlns:r="http://schemas.openxmlformats.org/officeDocument/2006/relationships" xmlns:p="http://schemas.openxmlformats.org/presentationml/2006/main">
-  <p:tag name="ALIGNMENT_TARGET_X" val="85.03936767578125"/>
+  <p:tag name="ALIGNMENT_TARGET_X" val="595.27558898925781"/>
 </p:tagLst>
 </file>
 
 <file path=ppt/tags/tag58.xml><?xml version="1.0" encoding="utf-8"?>
 <p:tagLst xmlns:a="http://schemas.openxmlformats.org/drawingml/2006/main" xmlns:r="http://schemas.openxmlformats.org/officeDocument/2006/relationships" xmlns:p="http://schemas.openxmlformats.org/presentationml/2006/main">
-  <p:tag name="ALIGNMENT_TARGET_X" val="442.2047119140625"/>
+  <p:tag name="ALIGNMENT_TARGET_X" val="952.44096374511719"/>
 </p:tagLst>
 </file>
 
 <file path=ppt/tags/tag59.xml><?xml version="1.0" encoding="utf-8"?>
 <p:tagLst xmlns:a="http://schemas.openxmlformats.org/drawingml/2006/main" xmlns:r="http://schemas.openxmlformats.org/officeDocument/2006/relationships" xmlns:p="http://schemas.openxmlformats.org/presentationml/2006/main">
-  <p:tag name="ALIGNMENT_TARGET_X" val="442.2047119140625"/>
+  <p:tag name="ALIGNMENT_TARGET_X" val="952.44096374511719"/>
 </p:tagLst>
 </file>
 
@@ -14422,13 +14115,13 @@
 
 <file path=ppt/tags/tag60.xml><?xml version="1.0" encoding="utf-8"?>
 <p:tagLst xmlns:a="http://schemas.openxmlformats.org/drawingml/2006/main" xmlns:r="http://schemas.openxmlformats.org/officeDocument/2006/relationships" xmlns:p="http://schemas.openxmlformats.org/presentationml/2006/main">
-  <p:tag name="ALIGNMENT_TARGET_X" val="799.37005615234375"/>
+  <p:tag name="ALIGNMENT_TARGET_X" val="595.27557373046875"/>
 </p:tagLst>
 </file>
 
 <file path=ppt/tags/tag61.xml><?xml version="1.0" encoding="utf-8"?>
 <p:tagLst xmlns:a="http://schemas.openxmlformats.org/drawingml/2006/main" xmlns:r="http://schemas.openxmlformats.org/officeDocument/2006/relationships" xmlns:p="http://schemas.openxmlformats.org/presentationml/2006/main">
-  <p:tag name="ALIGNMENT_TARGET_X" val="799.37005615234375"/>
+  <p:tag name="ALIGNMENT_TARGET_X" val="328.81890869140625"/>
 </p:tagLst>
 </file>
 
@@ -14440,7 +14133,7 @@
 
 <file path=ppt/tags/tag63.xml><?xml version="1.0" encoding="utf-8"?>
 <p:tagLst xmlns:a="http://schemas.openxmlformats.org/drawingml/2006/main" xmlns:r="http://schemas.openxmlformats.org/officeDocument/2006/relationships" xmlns:p="http://schemas.openxmlformats.org/presentationml/2006/main">
-  <p:tag name="ALIGNMENT_TARGET_X" val="116.22047424316406"/>
+  <p:tag name="ALIGNMENT_TARGET_X" val="583.93700408935547"/>
 </p:tagLst>
 </file>
 
@@ -14452,31 +14145,31 @@
 
 <file path=ppt/tags/tag65.xml><?xml version="1.0" encoding="utf-8"?>
 <p:tagLst xmlns:a="http://schemas.openxmlformats.org/drawingml/2006/main" xmlns:r="http://schemas.openxmlformats.org/officeDocument/2006/relationships" xmlns:p="http://schemas.openxmlformats.org/presentationml/2006/main">
-  <p:tag name="ALIGNMENT_TARGET_X" val="68.031494140625"/>
+  <p:tag name="ALIGNMENT_TARGET_X" val="583.93700408935547"/>
 </p:tagLst>
 </file>
 
 <file path=ppt/tags/tag66.xml><?xml version="1.0" encoding="utf-8"?>
 <p:tagLst xmlns:a="http://schemas.openxmlformats.org/drawingml/2006/main" xmlns:r="http://schemas.openxmlformats.org/officeDocument/2006/relationships" xmlns:p="http://schemas.openxmlformats.org/presentationml/2006/main">
-  <p:tag name="ALIGNMENT_TARGET_X" val="583.93700408935547"/>
+  <p:tag name="ALIGNMENT_TARGET_X" val="68.031494140625"/>
 </p:tagLst>
 </file>
 
 <file path=ppt/tags/tag67.xml><?xml version="1.0" encoding="utf-8"?>
 <p:tagLst xmlns:a="http://schemas.openxmlformats.org/drawingml/2006/main" xmlns:r="http://schemas.openxmlformats.org/officeDocument/2006/relationships" xmlns:p="http://schemas.openxmlformats.org/presentationml/2006/main">
-  <p:tag name="ALIGNMENT_TARGET_X" val="68.031494140625"/>
+  <p:tag name="ALIGNMENT_TARGET_X" val="583.93700408935547"/>
 </p:tagLst>
 </file>
 
 <file path=ppt/tags/tag68.xml><?xml version="1.0" encoding="utf-8"?>
 <p:tagLst xmlns:a="http://schemas.openxmlformats.org/drawingml/2006/main" xmlns:r="http://schemas.openxmlformats.org/officeDocument/2006/relationships" xmlns:p="http://schemas.openxmlformats.org/presentationml/2006/main">
-  <p:tag name="ALIGNMENT_TARGET_X" val="583.93700408935547"/>
+  <p:tag name="ALIGNMENT_TARGET_X" val="187.08660888671875"/>
 </p:tagLst>
 </file>
 
 <file path=ppt/tags/tag69.xml><?xml version="1.0" encoding="utf-8"?>
 <p:tagLst xmlns:a="http://schemas.openxmlformats.org/drawingml/2006/main" xmlns:r="http://schemas.openxmlformats.org/officeDocument/2006/relationships" xmlns:p="http://schemas.openxmlformats.org/presentationml/2006/main">
-  <p:tag name="ALIGNMENT_TARGET_X" val="68.031494140625"/>
+  <p:tag name="ALIGNMENT_TARGET_X" val="320.31497192382813"/>
 </p:tagLst>
 </file>
 
@@ -14488,61 +14181,61 @@
 
 <file path=ppt/tags/tag70.xml><?xml version="1.0" encoding="utf-8"?>
 <p:tagLst xmlns:a="http://schemas.openxmlformats.org/drawingml/2006/main" xmlns:r="http://schemas.openxmlformats.org/officeDocument/2006/relationships" xmlns:p="http://schemas.openxmlformats.org/presentationml/2006/main">
-  <p:tag name="ALIGNMENT_TARGET_X" val="583.93700408935547"/>
+  <p:tag name="ALIGNMENT_TARGET_X" val="453.54330444335938"/>
 </p:tagLst>
 </file>
 
 <file path=ppt/tags/tag71.xml><?xml version="1.0" encoding="utf-8"?>
 <p:tagLst xmlns:a="http://schemas.openxmlformats.org/drawingml/2006/main" xmlns:r="http://schemas.openxmlformats.org/officeDocument/2006/relationships" xmlns:p="http://schemas.openxmlformats.org/presentationml/2006/main">
-  <p:tag name="ALIGNMENT_TARGET_X" val="187.08660888671875"/>
+  <p:tag name="ALIGNMENT_TARGET_X" val="328.81890869140625"/>
 </p:tagLst>
 </file>
 
 <file path=ppt/tags/tag72.xml><?xml version="1.0" encoding="utf-8"?>
 <p:tagLst xmlns:a="http://schemas.openxmlformats.org/drawingml/2006/main" xmlns:r="http://schemas.openxmlformats.org/officeDocument/2006/relationships" xmlns:p="http://schemas.openxmlformats.org/presentationml/2006/main">
-  <p:tag name="ALIGNMENT_TARGET_X" val="320.31497192382813"/>
+  <p:tag name="ALIGNMENT_TARGET_X" val="873.07089233398438"/>
 </p:tagLst>
 </file>
 
 <file path=ppt/tags/tag73.xml><?xml version="1.0" encoding="utf-8"?>
 <p:tagLst xmlns:a="http://schemas.openxmlformats.org/drawingml/2006/main" xmlns:r="http://schemas.openxmlformats.org/officeDocument/2006/relationships" xmlns:p="http://schemas.openxmlformats.org/presentationml/2006/main">
-  <p:tag name="ALIGNMENT_TARGET_X" val="453.54330444335938"/>
+  <p:tag name="ALIGNMENT_TARGET_X" val="873.07089233398438"/>
 </p:tagLst>
 </file>
 
 <file path=ppt/tags/tag74.xml><?xml version="1.0" encoding="utf-8"?>
 <p:tagLst xmlns:a="http://schemas.openxmlformats.org/drawingml/2006/main" xmlns:r="http://schemas.openxmlformats.org/officeDocument/2006/relationships" xmlns:p="http://schemas.openxmlformats.org/presentationml/2006/main">
-  <p:tag name="ALIGNMENT_TARGET_X" val="68.031494140625"/>
+  <p:tag name="ALIGNMENT_TARGET_X" val="873.07089233398438"/>
 </p:tagLst>
 </file>
 
 <file path=ppt/tags/tag75.xml><?xml version="1.0" encoding="utf-8"?>
 <p:tagLst xmlns:a="http://schemas.openxmlformats.org/drawingml/2006/main" xmlns:r="http://schemas.openxmlformats.org/officeDocument/2006/relationships" xmlns:p="http://schemas.openxmlformats.org/presentationml/2006/main">
-  <p:tag name="ALIGNMENT_TARGET_X" val="623.6220703125"/>
+  <p:tag name="ALIGNMENT_TARGET_X" val="701.5748291015625"/>
 </p:tagLst>
 </file>
 
 <file path=ppt/tags/tag76.xml><?xml version="1.0" encoding="utf-8"?>
 <p:tagLst xmlns:a="http://schemas.openxmlformats.org/drawingml/2006/main" xmlns:r="http://schemas.openxmlformats.org/officeDocument/2006/relationships" xmlns:p="http://schemas.openxmlformats.org/presentationml/2006/main">
-  <p:tag name="ALIGNMENT_TARGET_X" val="623.6220703125"/>
+  <p:tag name="ALIGNMENT_TARGET_X" val="701.5748291015625"/>
 </p:tagLst>
 </file>
 
 <file path=ppt/tags/tag77.xml><?xml version="1.0" encoding="utf-8"?>
 <p:tagLst xmlns:a="http://schemas.openxmlformats.org/drawingml/2006/main" xmlns:r="http://schemas.openxmlformats.org/officeDocument/2006/relationships" xmlns:p="http://schemas.openxmlformats.org/presentationml/2006/main">
-  <p:tag name="ALIGNMENT_TARGET_X" val="623.6220703125"/>
+  <p:tag name="ALIGNMENT_TARGET_X" val="869.6693115234375"/>
 </p:tagLst>
 </file>
 
 <file path=ppt/tags/tag78.xml><?xml version="1.0" encoding="utf-8"?>
 <p:tagLst xmlns:a="http://schemas.openxmlformats.org/drawingml/2006/main" xmlns:r="http://schemas.openxmlformats.org/officeDocument/2006/relationships" xmlns:p="http://schemas.openxmlformats.org/presentationml/2006/main">
-  <p:tag name="ALIGNMENT_TARGET_X" val="701.5748291015625"/>
+  <p:tag name="ALIGNMENT_TARGET_X" val="869.6693115234375"/>
 </p:tagLst>
 </file>
 
 <file path=ppt/tags/tag79.xml><?xml version="1.0" encoding="utf-8"?>
 <p:tagLst xmlns:a="http://schemas.openxmlformats.org/drawingml/2006/main" xmlns:r="http://schemas.openxmlformats.org/officeDocument/2006/relationships" xmlns:p="http://schemas.openxmlformats.org/presentationml/2006/main">
-  <p:tag name="ALIGNMENT_TARGET_X" val="701.5748291015625"/>
+  <p:tag name="ALIGNMENT_TARGET_X" val="1037.7637939453125"/>
 </p:tagLst>
 </file>
 
@@ -14554,125 +14247,107 @@
 
 <file path=ppt/tags/tag80.xml><?xml version="1.0" encoding="utf-8"?>
 <p:tagLst xmlns:a="http://schemas.openxmlformats.org/drawingml/2006/main" xmlns:r="http://schemas.openxmlformats.org/officeDocument/2006/relationships" xmlns:p="http://schemas.openxmlformats.org/presentationml/2006/main">
-  <p:tag name="ALIGNMENT_TARGET_X" val="869.6693115234375"/>
+  <p:tag name="ALIGNMENT_TARGET_X" val="1037.7637939453125"/>
 </p:tagLst>
 </file>
 
 <file path=ppt/tags/tag81.xml><?xml version="1.0" encoding="utf-8"?>
 <p:tagLst xmlns:a="http://schemas.openxmlformats.org/drawingml/2006/main" xmlns:r="http://schemas.openxmlformats.org/officeDocument/2006/relationships" xmlns:p="http://schemas.openxmlformats.org/presentationml/2006/main">
-  <p:tag name="ALIGNMENT_TARGET_X" val="869.6693115234375"/>
+  <p:tag name="ALIGNMENT_TARGET_X" val="873.07089233398438"/>
 </p:tagLst>
 </file>
 
 <file path=ppt/tags/tag82.xml><?xml version="1.0" encoding="utf-8"?>
 <p:tagLst xmlns:a="http://schemas.openxmlformats.org/drawingml/2006/main" xmlns:r="http://schemas.openxmlformats.org/officeDocument/2006/relationships" xmlns:p="http://schemas.openxmlformats.org/presentationml/2006/main">
-  <p:tag name="ALIGNMENT_TARGET_X" val="1037.7637939453125"/>
+  <p:tag name="ALIGNMENT_TARGET_X" val="170.07874298095703"/>
 </p:tagLst>
 </file>
 
 <file path=ppt/tags/tag83.xml><?xml version="1.0" encoding="utf-8"?>
 <p:tagLst xmlns:a="http://schemas.openxmlformats.org/drawingml/2006/main" xmlns:r="http://schemas.openxmlformats.org/officeDocument/2006/relationships" xmlns:p="http://schemas.openxmlformats.org/presentationml/2006/main">
-  <p:tag name="ALIGNMENT_TARGET_X" val="1037.7637939453125"/>
+  <p:tag name="ALIGNMENT_TARGET_X" val="308.97637939453125"/>
 </p:tagLst>
 </file>
 
 <file path=ppt/tags/tag84.xml><?xml version="1.0" encoding="utf-8"?>
 <p:tagLst xmlns:a="http://schemas.openxmlformats.org/drawingml/2006/main" xmlns:r="http://schemas.openxmlformats.org/officeDocument/2006/relationships" xmlns:p="http://schemas.openxmlformats.org/presentationml/2006/main">
-  <p:tag name="ALIGNMENT_TARGET_X" val="623.6220703125"/>
+  <p:tag name="ALIGNMENT_TARGET_X" val="308.97637939453125"/>
 </p:tagLst>
 </file>
 
 <file path=ppt/tags/tag85.xml><?xml version="1.0" encoding="utf-8"?>
 <p:tagLst xmlns:a="http://schemas.openxmlformats.org/drawingml/2006/main" xmlns:r="http://schemas.openxmlformats.org/officeDocument/2006/relationships" xmlns:p="http://schemas.openxmlformats.org/presentationml/2006/main">
-  <p:tag name="ALIGNMENT_TARGET_X" val="79.370079040527344"/>
+  <p:tag name="ALIGNMENT_TARGET_X" val="402.51968383789063"/>
 </p:tagLst>
 </file>
 
 <file path=ppt/tags/tag86.xml><?xml version="1.0" encoding="utf-8"?>
 <p:tagLst xmlns:a="http://schemas.openxmlformats.org/drawingml/2006/main" xmlns:r="http://schemas.openxmlformats.org/officeDocument/2006/relationships" xmlns:p="http://schemas.openxmlformats.org/presentationml/2006/main">
-  <p:tag name="ALIGNMENT_TARGET_X" val="308.97637939453125"/>
+  <p:tag name="ALIGNMENT_TARGET_X" val="402.51968383789063"/>
 </p:tagLst>
 </file>
 
 <file path=ppt/tags/tag87.xml><?xml version="1.0" encoding="utf-8"?>
 <p:tagLst xmlns:a="http://schemas.openxmlformats.org/drawingml/2006/main" xmlns:r="http://schemas.openxmlformats.org/officeDocument/2006/relationships" xmlns:p="http://schemas.openxmlformats.org/presentationml/2006/main">
-  <p:tag name="ALIGNMENT_TARGET_X" val="308.97637939453125"/>
+  <p:tag name="ALIGNMENT_TARGET_X" val="496.06298828125"/>
 </p:tagLst>
 </file>
 
 <file path=ppt/tags/tag88.xml><?xml version="1.0" encoding="utf-8"?>
 <p:tagLst xmlns:a="http://schemas.openxmlformats.org/drawingml/2006/main" xmlns:r="http://schemas.openxmlformats.org/officeDocument/2006/relationships" xmlns:p="http://schemas.openxmlformats.org/presentationml/2006/main">
-  <p:tag name="ALIGNMENT_TARGET_X" val="402.51968383789063"/>
+  <p:tag name="ALIGNMENT_TARGET_X" val="496.06298828125"/>
 </p:tagLst>
 </file>
 
 <file path=ppt/tags/tag89.xml><?xml version="1.0" encoding="utf-8"?>
 <p:tagLst xmlns:a="http://schemas.openxmlformats.org/drawingml/2006/main" xmlns:r="http://schemas.openxmlformats.org/officeDocument/2006/relationships" xmlns:p="http://schemas.openxmlformats.org/presentationml/2006/main">
-  <p:tag name="ALIGNMENT_TARGET_X" val="402.51968383789063"/>
+  <p:tag name="ALIGNMENT_TARGET_X" val="589.60629272460938"/>
 </p:tagLst>
 </file>
 
 <file path=ppt/tags/tag9.xml><?xml version="1.0" encoding="utf-8"?>
 <p:tagLst xmlns:a="http://schemas.openxmlformats.org/drawingml/2006/main" xmlns:r="http://schemas.openxmlformats.org/officeDocument/2006/relationships" xmlns:p="http://schemas.openxmlformats.org/presentationml/2006/main">
-  <p:tag name="ALIGNMENT_TARGET_X" val="68.031494140625"/>
+  <p:tag name="ALIGNMENT_TARGET_X" val="595.27557373046875"/>
 </p:tagLst>
 </file>
 
 <file path=ppt/tags/tag90.xml><?xml version="1.0" encoding="utf-8"?>
 <p:tagLst xmlns:a="http://schemas.openxmlformats.org/drawingml/2006/main" xmlns:r="http://schemas.openxmlformats.org/officeDocument/2006/relationships" xmlns:p="http://schemas.openxmlformats.org/presentationml/2006/main">
-  <p:tag name="ALIGNMENT_TARGET_X" val="496.06298828125"/>
+  <p:tag name="ALIGNMENT_TARGET_X" val="589.60629272460938"/>
 </p:tagLst>
 </file>
 
 <file path=ppt/tags/tag91.xml><?xml version="1.0" encoding="utf-8"?>
 <p:tagLst xmlns:a="http://schemas.openxmlformats.org/drawingml/2006/main" xmlns:r="http://schemas.openxmlformats.org/officeDocument/2006/relationships" xmlns:p="http://schemas.openxmlformats.org/presentationml/2006/main">
-  <p:tag name="ALIGNMENT_TARGET_X" val="496.06298828125"/>
+  <p:tag name="ALIGNMENT_TARGET_X" val="683.14962768554688"/>
 </p:tagLst>
 </file>
 
 <file path=ppt/tags/tag92.xml><?xml version="1.0" encoding="utf-8"?>
 <p:tagLst xmlns:a="http://schemas.openxmlformats.org/drawingml/2006/main" xmlns:r="http://schemas.openxmlformats.org/officeDocument/2006/relationships" xmlns:p="http://schemas.openxmlformats.org/presentationml/2006/main">
-  <p:tag name="ALIGNMENT_TARGET_X" val="589.60629272460938"/>
+  <p:tag name="ALIGNMENT_TARGET_X" val="683.14962768554688"/>
 </p:tagLst>
 </file>
 
 <file path=ppt/tags/tag93.xml><?xml version="1.0" encoding="utf-8"?>
 <p:tagLst xmlns:a="http://schemas.openxmlformats.org/drawingml/2006/main" xmlns:r="http://schemas.openxmlformats.org/officeDocument/2006/relationships" xmlns:p="http://schemas.openxmlformats.org/presentationml/2006/main">
-  <p:tag name="ALIGNMENT_TARGET_X" val="589.60629272460938"/>
+  <p:tag name="ALIGNMENT_TARGET_X" val="776.69290161132813"/>
 </p:tagLst>
 </file>
 
 <file path=ppt/tags/tag94.xml><?xml version="1.0" encoding="utf-8"?>
 <p:tagLst xmlns:a="http://schemas.openxmlformats.org/drawingml/2006/main" xmlns:r="http://schemas.openxmlformats.org/officeDocument/2006/relationships" xmlns:p="http://schemas.openxmlformats.org/presentationml/2006/main">
-  <p:tag name="ALIGNMENT_TARGET_X" val="683.14962768554688"/>
+  <p:tag name="ALIGNMENT_TARGET_X" val="776.69290161132813"/>
 </p:tagLst>
 </file>
 
 <file path=ppt/tags/tag95.xml><?xml version="1.0" encoding="utf-8"?>
 <p:tagLst xmlns:a="http://schemas.openxmlformats.org/drawingml/2006/main" xmlns:r="http://schemas.openxmlformats.org/officeDocument/2006/relationships" xmlns:p="http://schemas.openxmlformats.org/presentationml/2006/main">
-  <p:tag name="ALIGNMENT_TARGET_X" val="683.14962768554688"/>
+  <p:tag name="ALIGNMENT_TARGET_X" val="975.11810302734375"/>
 </p:tagLst>
 </file>
 
 <file path=ppt/tags/tag96.xml><?xml version="1.0" encoding="utf-8"?>
-<p:tagLst xmlns:a="http://schemas.openxmlformats.org/drawingml/2006/main" xmlns:r="http://schemas.openxmlformats.org/officeDocument/2006/relationships" xmlns:p="http://schemas.openxmlformats.org/presentationml/2006/main">
-  <p:tag name="ALIGNMENT_TARGET_X" val="776.69290161132813"/>
-</p:tagLst>
-</file>
-
-<file path=ppt/tags/tag97.xml><?xml version="1.0" encoding="utf-8"?>
-<p:tagLst xmlns:a="http://schemas.openxmlformats.org/drawingml/2006/main" xmlns:r="http://schemas.openxmlformats.org/officeDocument/2006/relationships" xmlns:p="http://schemas.openxmlformats.org/presentationml/2006/main">
-  <p:tag name="ALIGNMENT_TARGET_X" val="776.69290161132813"/>
-</p:tagLst>
-</file>
-
-<file path=ppt/tags/tag98.xml><?xml version="1.0" encoding="utf-8"?>
-<p:tagLst xmlns:a="http://schemas.openxmlformats.org/drawingml/2006/main" xmlns:r="http://schemas.openxmlformats.org/officeDocument/2006/relationships" xmlns:p="http://schemas.openxmlformats.org/presentationml/2006/main">
-  <p:tag name="ALIGNMENT_TARGET_X" val="1111.1810913085938"/>
-</p:tagLst>
-</file>
-
-<file path=ppt/tags/tag99.xml><?xml version="1.0" encoding="utf-8"?>
 <p:tagLst xmlns:a="http://schemas.openxmlformats.org/drawingml/2006/main" xmlns:r="http://schemas.openxmlformats.org/officeDocument/2006/relationships" xmlns:p="http://schemas.openxmlformats.org/presentationml/2006/main">
   <p:tag name="ALIGNMENT_TARGET_X" val="595.27557373046875"/>
 </p:tagLst>

</xml_diff>

<commit_message>
Widen the poster title and mark original versus cited work
The A2 title grows from 46pt to 56pt at single line spacing, so the
three lines read wider without moving the title frame; PowerPoint finds
no overflow. A gold note under the takeaway lists the team's original
parts (CTBM, calibrated fusion, task-oriented retrieval, local AI audit,
controlled recovery) and names PBCNN as the cited existing model, and
the PBCNN node is labelled as an existing model. The evidence chain
moves down 3 mm to make room. No paper citation is added because the
repository has no source for PBCNN.

Co-Authored-By: Claude Opus 5.5 <noreply@anthropic.com>
</commit_message>
<xml_diff>
--- a/deliverables/決賽海報_AI資安框架_A2.pptx
+++ b/deliverables/決賽海報_AI資安框架_A2.pptx
@@ -4185,7 +4185,7 @@
         </p:nvSpPr>
         <p:spPr>
           <a:xfrm>
-            <a:off x="783037" y="720000"/>
+            <a:off x="765575" y="720000"/>
             <a:ext cx="13392000" cy="2556000"/>
           </a:xfrm>
           <a:prstGeom prst="rect">
@@ -4201,7 +4201,7 @@
           <a:p>
             <a:pPr algn="ctr">
               <a:lnSpc>
-                <a:spcPct val="110000"/>
+                <a:spcPct val="100000"/>
               </a:lnSpc>
               <a:spcBef>
                 <a:spcPts val="0"/>
@@ -4211,7 +4211,7 @@
               </a:spcAft>
             </a:pPr>
             <a:r>
-              <a:rPr sz="4600" b="1">
+              <a:rPr sz="5600" b="1">
                 <a:solidFill>
                   <a:srgbClr val="0B1B2E"/>
                 </a:solidFill>
@@ -4225,7 +4225,7 @@
           <a:p>
             <a:pPr algn="ctr">
               <a:lnSpc>
-                <a:spcPct val="110000"/>
+                <a:spcPct val="100000"/>
               </a:lnSpc>
               <a:spcBef>
                 <a:spcPts val="0"/>
@@ -4235,7 +4235,7 @@
               </a:spcAft>
             </a:pPr>
             <a:r>
-              <a:rPr sz="4600" b="1">
+              <a:rPr sz="5600" b="1">
                 <a:solidFill>
                   <a:srgbClr val="0B1B2E"/>
                 </a:solidFill>
@@ -4249,7 +4249,7 @@
           <a:p>
             <a:pPr algn="ctr">
               <a:lnSpc>
-                <a:spcPct val="110000"/>
+                <a:spcPct val="100000"/>
               </a:lnSpc>
               <a:spcBef>
                 <a:spcPts val="0"/>
@@ -4259,7 +4259,7 @@
               </a:spcAft>
             </a:pPr>
             <a:r>
-              <a:rPr sz="4600" b="1">
+              <a:rPr sz="5600" b="1">
                 <a:solidFill>
                   <a:srgbClr val="0B1B2E"/>
                 </a:solidFill>
@@ -4423,15 +4423,128 @@
           </a:p>
         </p:txBody>
       </p:sp>
+      <p:sp>
+        <p:nvSpPr>
+          <p:cNvPr id="9" name="Rounded Rectangle 8"/>
+          <p:cNvSpPr/>
+          <p:nvPr/>
+        </p:nvSpPr>
+        <p:spPr>
+          <a:xfrm>
+            <a:off x="2880000" y="4266000"/>
+            <a:ext cx="9360000" cy="288000"/>
+          </a:xfrm>
+          <a:prstGeom prst="roundRect">
+            <a:avLst>
+              <a:gd name="adj" fmla="val 30000"/>
+            </a:avLst>
+          </a:prstGeom>
+          <a:solidFill>
+            <a:srgbClr val="FEF3D7"/>
+          </a:solidFill>
+          <a:ln>
+            <a:noFill/>
+          </a:ln>
+          <a:effectLst/>
+        </p:spPr>
+        <p:style>
+          <a:lnRef idx="1">
+            <a:schemeClr val="accent1"/>
+          </a:lnRef>
+          <a:fillRef idx="3">
+            <a:schemeClr val="accent1"/>
+          </a:fillRef>
+          <a:effectRef idx="2">
+            <a:schemeClr val="accent1"/>
+          </a:effectRef>
+          <a:fontRef idx="minor">
+            <a:schemeClr val="lt1"/>
+          </a:fontRef>
+        </p:style>
+        <p:txBody>
+          <a:bodyPr rtlCol="0" anchor="ctr"/>
+          <a:lstStyle/>
+          <a:p>
+            <a:pPr algn="ctr"/>
+            <a:endParaRPr>
+              <a:latin typeface="Segoe UI"/>
+              <a:ea typeface="Microsoft JhengHei"/>
+              <a:cs typeface="Segoe UI"/>
+            </a:endParaRPr>
+          </a:p>
+        </p:txBody>
+      </p:sp>
+      <p:sp>
+        <p:nvSpPr>
+          <p:cNvPr id="10" name="TextBox 9"/>
+          <p:cNvSpPr txBox="1"/>
+          <p:nvPr>
+            <p:custDataLst>
+              <p:tags r:id="rId5"/>
+            </p:custDataLst>
+          </p:nvPr>
+        </p:nvSpPr>
+        <p:spPr>
+          <a:xfrm>
+            <a:off x="2855394" y="4266000"/>
+            <a:ext cx="9360000" cy="288000"/>
+          </a:xfrm>
+          <a:prstGeom prst="rect">
+            <a:avLst/>
+          </a:prstGeom>
+          <a:noFill/>
+        </p:spPr>
+        <p:txBody>
+          <a:bodyPr wrap="none" lIns="0" tIns="0" rIns="0" bIns="0" anchor="ctr">
+            <a:spAutoFit/>
+          </a:bodyPr>
+          <a:lstStyle/>
+          <a:p>
+            <a:pPr algn="ctr">
+              <a:lnSpc>
+                <a:spcPct val="110000"/>
+              </a:lnSpc>
+              <a:spcBef>
+                <a:spcPts val="0"/>
+              </a:spcBef>
+              <a:spcAft>
+                <a:spcPts val="0"/>
+              </a:spcAft>
+            </a:pPr>
+            <a:r>
+              <a:rPr sz="1400" b="1">
+                <a:solidFill>
+                  <a:srgbClr val="F59E0B"/>
+                </a:solidFill>
+                <a:latin typeface="Segoe UI"/>
+                <a:ea typeface="Microsoft JhengHei"/>
+                <a:cs typeface="Segoe UI"/>
+              </a:rPr>
+              <a:t>★ </a:t>
+            </a:r>
+            <a:r>
+              <a:rPr sz="1400" b="1">
+                <a:solidFill>
+                  <a:srgbClr val="0B1B2E"/>
+                </a:solidFill>
+                <a:latin typeface="Segoe UI"/>
+                <a:ea typeface="Microsoft JhengHei"/>
+                <a:cs typeface="Segoe UI"/>
+              </a:rPr>
+              <a:t>本團隊原創：CTBM、校準融合、任務導向檢索、本機AI稽核、受控回復　｜　引用既有：PBCNN</a:t>
+            </a:r>
+          </a:p>
+        </p:txBody>
+      </p:sp>
       <p:cxnSp>
         <p:nvCxnSpPr>
-          <p:cNvPr id="9" name="Connector 8"/>
+          <p:cNvPr id="11" name="Connector 10"/>
           <p:cNvCxnSpPr/>
           <p:nvPr/>
         </p:nvCxnSpPr>
         <p:spPr>
           <a:xfrm>
-            <a:off x="2016000" y="4896000"/>
+            <a:off x="2016000" y="5004000"/>
             <a:ext cx="11088000" cy="0"/>
           </a:xfrm>
           <a:prstGeom prst="line">
@@ -4461,13 +4574,13 @@
       </p:cxnSp>
       <p:sp>
         <p:nvSpPr>
-          <p:cNvPr id="10" name="Oval 9"/>
+          <p:cNvPr id="12" name="Oval 11"/>
           <p:cNvSpPr/>
           <p:nvPr/>
         </p:nvSpPr>
         <p:spPr>
           <a:xfrm>
-            <a:off x="1728000" y="4608000"/>
+            <a:off x="1728000" y="4716000"/>
             <a:ext cx="576000" cy="576000"/>
           </a:xfrm>
           <a:prstGeom prst="ellipse">
@@ -4512,133 +4625,7 @@
       </p:sp>
       <p:pic>
         <p:nvPicPr>
-          <p:cNvPr id="11" name="Picture 10" descr="flat-icon-2.png"/>
-          <p:cNvPicPr>
-            <a:picLocks noChangeAspect="1"/>
-          </p:cNvPicPr>
-          <p:nvPr/>
-        </p:nvPicPr>
-        <p:blipFill>
-          <a:blip r:embed="rId98"/>
-          <a:stretch>
-            <a:fillRect/>
-          </a:stretch>
-        </p:blipFill>
-        <p:spPr>
-          <a:xfrm>
-            <a:off x="1836000" y="4716000"/>
-            <a:ext cx="360000" cy="360000"/>
-          </a:xfrm>
-          <a:prstGeom prst="rect">
-            <a:avLst/>
-          </a:prstGeom>
-        </p:spPr>
-      </p:pic>
-      <p:sp>
-        <p:nvSpPr>
-          <p:cNvPr id="12" name="TextBox 11"/>
-          <p:cNvSpPr txBox="1"/>
-          <p:nvPr>
-            <p:custDataLst>
-              <p:tags r:id="rId5"/>
-            </p:custDataLst>
-          </p:nvPr>
-        </p:nvSpPr>
-        <p:spPr>
-          <a:xfrm>
-            <a:off x="1261075" y="5256000"/>
-            <a:ext cx="1440000" cy="324000"/>
-          </a:xfrm>
-          <a:prstGeom prst="rect">
-            <a:avLst/>
-          </a:prstGeom>
-          <a:noFill/>
-        </p:spPr>
-        <p:txBody>
-          <a:bodyPr wrap="none" lIns="0" tIns="0" rIns="0" bIns="0" anchor="ctr">
-            <a:spAutoFit/>
-          </a:bodyPr>
-          <a:lstStyle/>
-          <a:p>
-            <a:pPr algn="ctr">
-              <a:lnSpc>
-                <a:spcPct val="110000"/>
-              </a:lnSpc>
-              <a:spcBef>
-                <a:spcPts val="0"/>
-              </a:spcBef>
-              <a:spcAft>
-                <a:spcPts val="0"/>
-              </a:spcAft>
-            </a:pPr>
-            <a:r>
-              <a:rPr sz="2000" b="1">
-                <a:solidFill>
-                  <a:srgbClr val="0B1B2E"/>
-                </a:solidFill>
-                <a:latin typeface="Segoe UI"/>
-                <a:ea typeface="Microsoft JhengHei"/>
-                <a:cs typeface="Segoe UI"/>
-              </a:rPr>
-              <a:t>偵測</a:t>
-            </a:r>
-          </a:p>
-        </p:txBody>
-      </p:sp>
-      <p:sp>
-        <p:nvSpPr>
-          <p:cNvPr id="13" name="Oval 12"/>
-          <p:cNvSpPr/>
-          <p:nvPr/>
-        </p:nvSpPr>
-        <p:spPr>
-          <a:xfrm>
-            <a:off x="5425200" y="4608000"/>
-            <a:ext cx="576000" cy="576000"/>
-          </a:xfrm>
-          <a:prstGeom prst="ellipse">
-            <a:avLst/>
-          </a:prstGeom>
-          <a:solidFill>
-            <a:srgbClr val="FFFFFF"/>
-          </a:solidFill>
-          <a:ln w="10160">
-            <a:solidFill>
-              <a:srgbClr val="1D4ED8"/>
-            </a:solidFill>
-          </a:ln>
-          <a:effectLst/>
-        </p:spPr>
-        <p:style>
-          <a:lnRef idx="1">
-            <a:schemeClr val="accent1"/>
-          </a:lnRef>
-          <a:fillRef idx="3">
-            <a:schemeClr val="accent1"/>
-          </a:fillRef>
-          <a:effectRef idx="2">
-            <a:schemeClr val="accent1"/>
-          </a:effectRef>
-          <a:fontRef idx="minor">
-            <a:schemeClr val="lt1"/>
-          </a:fontRef>
-        </p:style>
-        <p:txBody>
-          <a:bodyPr rtlCol="0" anchor="ctr"/>
-          <a:lstStyle/>
-          <a:p>
-            <a:pPr algn="ctr"/>
-            <a:endParaRPr>
-              <a:latin typeface="Segoe UI"/>
-              <a:ea typeface="Microsoft JhengHei"/>
-              <a:cs typeface="Segoe UI"/>
-            </a:endParaRPr>
-          </a:p>
-        </p:txBody>
-      </p:sp>
-      <p:pic>
-        <p:nvPicPr>
-          <p:cNvPr id="14" name="Picture 13" descr="flat-icon-3.png"/>
+          <p:cNvPr id="13" name="Picture 12" descr="flat-icon-2.png"/>
           <p:cNvPicPr>
             <a:picLocks noChangeAspect="1"/>
           </p:cNvPicPr>
@@ -4652,7 +4639,7 @@
         </p:blipFill>
         <p:spPr>
           <a:xfrm>
-            <a:off x="5533200" y="4716000"/>
+            <a:off x="1836000" y="4824000"/>
             <a:ext cx="360000" cy="360000"/>
           </a:xfrm>
           <a:prstGeom prst="rect">
@@ -4662,7 +4649,7 @@
       </p:pic>
       <p:sp>
         <p:nvSpPr>
-          <p:cNvPr id="15" name="TextBox 14"/>
+          <p:cNvPr id="14" name="TextBox 13"/>
           <p:cNvSpPr txBox="1"/>
           <p:nvPr>
             <p:custDataLst>
@@ -4672,7 +4659,7 @@
         </p:nvSpPr>
         <p:spPr>
           <a:xfrm>
-            <a:off x="4958274" y="5256000"/>
+            <a:off x="1261075" y="5364000"/>
             <a:ext cx="1440000" cy="324000"/>
           </a:xfrm>
           <a:prstGeom prst="rect">
@@ -4706,20 +4693,20 @@
                 <a:ea typeface="Microsoft JhengHei"/>
                 <a:cs typeface="Segoe UI"/>
               </a:rPr>
-              <a:t>檢索</a:t>
-            </a:r>
-          </a:p>
-        </p:txBody>
-      </p:sp>
-      <p:sp>
-        <p:nvSpPr>
-          <p:cNvPr id="16" name="Oval 15"/>
+              <a:t>偵測</a:t>
+            </a:r>
+          </a:p>
+        </p:txBody>
+      </p:sp>
+      <p:sp>
+        <p:nvSpPr>
+          <p:cNvPr id="15" name="Oval 14"/>
           <p:cNvSpPr/>
           <p:nvPr/>
         </p:nvSpPr>
         <p:spPr>
           <a:xfrm>
-            <a:off x="9122400" y="4608000"/>
+            <a:off x="5425200" y="4716000"/>
             <a:ext cx="576000" cy="576000"/>
           </a:xfrm>
           <a:prstGeom prst="ellipse">
@@ -4762,270 +4749,9 @@
           </a:p>
         </p:txBody>
       </p:sp>
-      <p:sp>
-        <p:nvSpPr>
-          <p:cNvPr id="17" name="Rectangle 16"/>
-          <p:cNvSpPr/>
-          <p:nvPr/>
-        </p:nvSpPr>
-        <p:spPr>
-          <a:xfrm>
-            <a:off x="9295200" y="4716000"/>
-            <a:ext cx="230400" cy="360000"/>
-          </a:xfrm>
-          <a:prstGeom prst="rect">
-            <a:avLst/>
-          </a:prstGeom>
-          <a:solidFill>
-            <a:srgbClr val="FFFFFF"/>
-          </a:solidFill>
-          <a:ln w="10160">
-            <a:solidFill>
-              <a:srgbClr val="1D4ED8"/>
-            </a:solidFill>
-          </a:ln>
-          <a:effectLst/>
-        </p:spPr>
-        <p:style>
-          <a:lnRef idx="1">
-            <a:schemeClr val="accent1"/>
-          </a:lnRef>
-          <a:fillRef idx="3">
-            <a:schemeClr val="accent1"/>
-          </a:fillRef>
-          <a:effectRef idx="2">
-            <a:schemeClr val="accent1"/>
-          </a:effectRef>
-          <a:fontRef idx="minor">
-            <a:schemeClr val="lt1"/>
-          </a:fontRef>
-        </p:style>
-        <p:txBody>
-          <a:bodyPr rtlCol="0" anchor="ctr"/>
-          <a:lstStyle/>
-          <a:p>
-            <a:pPr algn="ctr"/>
-            <a:endParaRPr>
-              <a:latin typeface="Segoe UI"/>
-              <a:ea typeface="Microsoft JhengHei"/>
-              <a:cs typeface="Segoe UI"/>
-            </a:endParaRPr>
-          </a:p>
-        </p:txBody>
-      </p:sp>
-      <p:cxnSp>
-        <p:nvCxnSpPr>
-          <p:cNvPr id="18" name="Connector 17"/>
-          <p:cNvCxnSpPr/>
-          <p:nvPr/>
-        </p:nvCxnSpPr>
-        <p:spPr>
-          <a:xfrm>
-            <a:off x="9345888" y="4806000"/>
-            <a:ext cx="129024" cy="0"/>
-          </a:xfrm>
-          <a:prstGeom prst="line">
-            <a:avLst/>
-          </a:prstGeom>
-          <a:ln w="10160">
-            <a:solidFill>
-              <a:srgbClr val="1D4ED8"/>
-            </a:solidFill>
-          </a:ln>
-          <a:effectLst/>
-        </p:spPr>
-        <p:style>
-          <a:lnRef idx="2">
-            <a:schemeClr val="accent1"/>
-          </a:lnRef>
-          <a:fillRef idx="0">
-            <a:schemeClr val="accent1"/>
-          </a:fillRef>
-          <a:effectRef idx="1">
-            <a:schemeClr val="accent1"/>
-          </a:effectRef>
-          <a:fontRef idx="minor">
-            <a:schemeClr val="tx1"/>
-          </a:fontRef>
-        </p:style>
-      </p:cxnSp>
-      <p:cxnSp>
-        <p:nvCxnSpPr>
-          <p:cNvPr id="19" name="Connector 18"/>
-          <p:cNvCxnSpPr/>
-          <p:nvPr/>
-        </p:nvCxnSpPr>
-        <p:spPr>
-          <a:xfrm>
-            <a:off x="9345888" y="4896000"/>
-            <a:ext cx="129024" cy="0"/>
-          </a:xfrm>
-          <a:prstGeom prst="line">
-            <a:avLst/>
-          </a:prstGeom>
-          <a:ln w="10160">
-            <a:solidFill>
-              <a:srgbClr val="1D4ED8"/>
-            </a:solidFill>
-          </a:ln>
-          <a:effectLst/>
-        </p:spPr>
-        <p:style>
-          <a:lnRef idx="2">
-            <a:schemeClr val="accent1"/>
-          </a:lnRef>
-          <a:fillRef idx="0">
-            <a:schemeClr val="accent1"/>
-          </a:fillRef>
-          <a:effectRef idx="1">
-            <a:schemeClr val="accent1"/>
-          </a:effectRef>
-          <a:fontRef idx="minor">
-            <a:schemeClr val="tx1"/>
-          </a:fontRef>
-        </p:style>
-      </p:cxnSp>
-      <p:cxnSp>
-        <p:nvCxnSpPr>
-          <p:cNvPr id="20" name="Connector 19"/>
-          <p:cNvCxnSpPr/>
-          <p:nvPr/>
-        </p:nvCxnSpPr>
-        <p:spPr>
-          <a:xfrm>
-            <a:off x="9345888" y="4986000"/>
-            <a:ext cx="129024" cy="0"/>
-          </a:xfrm>
-          <a:prstGeom prst="line">
-            <a:avLst/>
-          </a:prstGeom>
-          <a:ln w="10160">
-            <a:solidFill>
-              <a:srgbClr val="1D4ED8"/>
-            </a:solidFill>
-          </a:ln>
-          <a:effectLst/>
-        </p:spPr>
-        <p:style>
-          <a:lnRef idx="2">
-            <a:schemeClr val="accent1"/>
-          </a:lnRef>
-          <a:fillRef idx="0">
-            <a:schemeClr val="accent1"/>
-          </a:fillRef>
-          <a:effectRef idx="1">
-            <a:schemeClr val="accent1"/>
-          </a:effectRef>
-          <a:fontRef idx="minor">
-            <a:schemeClr val="tx1"/>
-          </a:fontRef>
-        </p:style>
-      </p:cxnSp>
-      <p:sp>
-        <p:nvSpPr>
-          <p:cNvPr id="21" name="TextBox 20"/>
-          <p:cNvSpPr txBox="1"/>
-          <p:nvPr>
-            <p:custDataLst>
-              <p:tags r:id="rId7"/>
-            </p:custDataLst>
-          </p:nvPr>
-        </p:nvSpPr>
-        <p:spPr>
-          <a:xfrm>
-            <a:off x="8655475" y="5256000"/>
-            <a:ext cx="1440000" cy="324000"/>
-          </a:xfrm>
-          <a:prstGeom prst="rect">
-            <a:avLst/>
-          </a:prstGeom>
-          <a:noFill/>
-        </p:spPr>
-        <p:txBody>
-          <a:bodyPr wrap="none" lIns="0" tIns="0" rIns="0" bIns="0" anchor="ctr">
-            <a:spAutoFit/>
-          </a:bodyPr>
-          <a:lstStyle/>
-          <a:p>
-            <a:pPr algn="ctr">
-              <a:lnSpc>
-                <a:spcPct val="110000"/>
-              </a:lnSpc>
-              <a:spcBef>
-                <a:spcPts val="0"/>
-              </a:spcBef>
-              <a:spcAft>
-                <a:spcPts val="0"/>
-              </a:spcAft>
-            </a:pPr>
-            <a:r>
-              <a:rPr sz="2000" b="1">
-                <a:solidFill>
-                  <a:srgbClr val="0B1B2E"/>
-                </a:solidFill>
-                <a:latin typeface="Segoe UI"/>
-                <a:ea typeface="Microsoft JhengHei"/>
-                <a:cs typeface="Segoe UI"/>
-              </a:rPr>
-              <a:t>稽核</a:t>
-            </a:r>
-          </a:p>
-        </p:txBody>
-      </p:sp>
-      <p:sp>
-        <p:nvSpPr>
-          <p:cNvPr id="22" name="Oval 21"/>
-          <p:cNvSpPr/>
-          <p:nvPr/>
-        </p:nvSpPr>
-        <p:spPr>
-          <a:xfrm>
-            <a:off x="12819600" y="4608000"/>
-            <a:ext cx="576000" cy="576000"/>
-          </a:xfrm>
-          <a:prstGeom prst="ellipse">
-            <a:avLst/>
-          </a:prstGeom>
-          <a:solidFill>
-            <a:srgbClr val="FFFFFF"/>
-          </a:solidFill>
-          <a:ln w="10160">
-            <a:solidFill>
-              <a:srgbClr val="1D4ED8"/>
-            </a:solidFill>
-          </a:ln>
-          <a:effectLst/>
-        </p:spPr>
-        <p:style>
-          <a:lnRef idx="1">
-            <a:schemeClr val="accent1"/>
-          </a:lnRef>
-          <a:fillRef idx="3">
-            <a:schemeClr val="accent1"/>
-          </a:fillRef>
-          <a:effectRef idx="2">
-            <a:schemeClr val="accent1"/>
-          </a:effectRef>
-          <a:fontRef idx="minor">
-            <a:schemeClr val="lt1"/>
-          </a:fontRef>
-        </p:style>
-        <p:txBody>
-          <a:bodyPr rtlCol="0" anchor="ctr"/>
-          <a:lstStyle/>
-          <a:p>
-            <a:pPr algn="ctr"/>
-            <a:endParaRPr>
-              <a:latin typeface="Segoe UI"/>
-              <a:ea typeface="Microsoft JhengHei"/>
-              <a:cs typeface="Segoe UI"/>
-            </a:endParaRPr>
-          </a:p>
-        </p:txBody>
-      </p:sp>
       <p:pic>
         <p:nvPicPr>
-          <p:cNvPr id="23" name="Picture 22" descr="flat-icon-4.png"/>
+          <p:cNvPr id="16" name="Picture 15" descr="flat-icon-3.png"/>
           <p:cNvPicPr>
             <a:picLocks noChangeAspect="1"/>
           </p:cNvPicPr>
@@ -5039,7 +4765,7 @@
         </p:blipFill>
         <p:spPr>
           <a:xfrm>
-            <a:off x="12927600" y="4716000"/>
+            <a:off x="5533200" y="4824000"/>
             <a:ext cx="360000" cy="360000"/>
           </a:xfrm>
           <a:prstGeom prst="rect">
@@ -5049,17 +4775,17 @@
       </p:pic>
       <p:sp>
         <p:nvSpPr>
-          <p:cNvPr id="24" name="TextBox 23"/>
+          <p:cNvPr id="17" name="TextBox 16"/>
           <p:cNvSpPr txBox="1"/>
           <p:nvPr>
             <p:custDataLst>
-              <p:tags r:id="rId8"/>
+              <p:tags r:id="rId7"/>
             </p:custDataLst>
           </p:nvPr>
         </p:nvSpPr>
         <p:spPr>
           <a:xfrm>
-            <a:off x="12352675" y="5256000"/>
+            <a:off x="4958274" y="5364000"/>
             <a:ext cx="1440000" cy="324000"/>
           </a:xfrm>
           <a:prstGeom prst="rect">
@@ -5093,25 +4819,235 @@
                 <a:ea typeface="Microsoft JhengHei"/>
                 <a:cs typeface="Segoe UI"/>
               </a:rPr>
-              <a:t>回復</a:t>
-            </a:r>
-          </a:p>
-        </p:txBody>
-      </p:sp>
-      <p:sp>
-        <p:nvSpPr>
-          <p:cNvPr id="25" name="TextBox 24"/>
+              <a:t>檢索</a:t>
+            </a:r>
+          </a:p>
+        </p:txBody>
+      </p:sp>
+      <p:sp>
+        <p:nvSpPr>
+          <p:cNvPr id="18" name="Oval 17"/>
+          <p:cNvSpPr/>
+          <p:nvPr/>
+        </p:nvSpPr>
+        <p:spPr>
+          <a:xfrm>
+            <a:off x="9122400" y="4716000"/>
+            <a:ext cx="576000" cy="576000"/>
+          </a:xfrm>
+          <a:prstGeom prst="ellipse">
+            <a:avLst/>
+          </a:prstGeom>
+          <a:solidFill>
+            <a:srgbClr val="FFFFFF"/>
+          </a:solidFill>
+          <a:ln w="10160">
+            <a:solidFill>
+              <a:srgbClr val="1D4ED8"/>
+            </a:solidFill>
+          </a:ln>
+          <a:effectLst/>
+        </p:spPr>
+        <p:style>
+          <a:lnRef idx="1">
+            <a:schemeClr val="accent1"/>
+          </a:lnRef>
+          <a:fillRef idx="3">
+            <a:schemeClr val="accent1"/>
+          </a:fillRef>
+          <a:effectRef idx="2">
+            <a:schemeClr val="accent1"/>
+          </a:effectRef>
+          <a:fontRef idx="minor">
+            <a:schemeClr val="lt1"/>
+          </a:fontRef>
+        </p:style>
+        <p:txBody>
+          <a:bodyPr rtlCol="0" anchor="ctr"/>
+          <a:lstStyle/>
+          <a:p>
+            <a:pPr algn="ctr"/>
+            <a:endParaRPr>
+              <a:latin typeface="Segoe UI"/>
+              <a:ea typeface="Microsoft JhengHei"/>
+              <a:cs typeface="Segoe UI"/>
+            </a:endParaRPr>
+          </a:p>
+        </p:txBody>
+      </p:sp>
+      <p:sp>
+        <p:nvSpPr>
+          <p:cNvPr id="19" name="Rectangle 18"/>
+          <p:cNvSpPr/>
+          <p:nvPr/>
+        </p:nvSpPr>
+        <p:spPr>
+          <a:xfrm>
+            <a:off x="9295200" y="4824000"/>
+            <a:ext cx="230400" cy="360000"/>
+          </a:xfrm>
+          <a:prstGeom prst="rect">
+            <a:avLst/>
+          </a:prstGeom>
+          <a:solidFill>
+            <a:srgbClr val="FFFFFF"/>
+          </a:solidFill>
+          <a:ln w="10160">
+            <a:solidFill>
+              <a:srgbClr val="1D4ED8"/>
+            </a:solidFill>
+          </a:ln>
+          <a:effectLst/>
+        </p:spPr>
+        <p:style>
+          <a:lnRef idx="1">
+            <a:schemeClr val="accent1"/>
+          </a:lnRef>
+          <a:fillRef idx="3">
+            <a:schemeClr val="accent1"/>
+          </a:fillRef>
+          <a:effectRef idx="2">
+            <a:schemeClr val="accent1"/>
+          </a:effectRef>
+          <a:fontRef idx="minor">
+            <a:schemeClr val="lt1"/>
+          </a:fontRef>
+        </p:style>
+        <p:txBody>
+          <a:bodyPr rtlCol="0" anchor="ctr"/>
+          <a:lstStyle/>
+          <a:p>
+            <a:pPr algn="ctr"/>
+            <a:endParaRPr>
+              <a:latin typeface="Segoe UI"/>
+              <a:ea typeface="Microsoft JhengHei"/>
+              <a:cs typeface="Segoe UI"/>
+            </a:endParaRPr>
+          </a:p>
+        </p:txBody>
+      </p:sp>
+      <p:cxnSp>
+        <p:nvCxnSpPr>
+          <p:cNvPr id="20" name="Connector 19"/>
+          <p:cNvCxnSpPr/>
+          <p:nvPr/>
+        </p:nvCxnSpPr>
+        <p:spPr>
+          <a:xfrm>
+            <a:off x="9345888" y="4914000"/>
+            <a:ext cx="129024" cy="0"/>
+          </a:xfrm>
+          <a:prstGeom prst="line">
+            <a:avLst/>
+          </a:prstGeom>
+          <a:ln w="10160">
+            <a:solidFill>
+              <a:srgbClr val="1D4ED8"/>
+            </a:solidFill>
+          </a:ln>
+          <a:effectLst/>
+        </p:spPr>
+        <p:style>
+          <a:lnRef idx="2">
+            <a:schemeClr val="accent1"/>
+          </a:lnRef>
+          <a:fillRef idx="0">
+            <a:schemeClr val="accent1"/>
+          </a:fillRef>
+          <a:effectRef idx="1">
+            <a:schemeClr val="accent1"/>
+          </a:effectRef>
+          <a:fontRef idx="minor">
+            <a:schemeClr val="tx1"/>
+          </a:fontRef>
+        </p:style>
+      </p:cxnSp>
+      <p:cxnSp>
+        <p:nvCxnSpPr>
+          <p:cNvPr id="21" name="Connector 20"/>
+          <p:cNvCxnSpPr/>
+          <p:nvPr/>
+        </p:nvCxnSpPr>
+        <p:spPr>
+          <a:xfrm>
+            <a:off x="9345888" y="5004000"/>
+            <a:ext cx="129024" cy="0"/>
+          </a:xfrm>
+          <a:prstGeom prst="line">
+            <a:avLst/>
+          </a:prstGeom>
+          <a:ln w="10160">
+            <a:solidFill>
+              <a:srgbClr val="1D4ED8"/>
+            </a:solidFill>
+          </a:ln>
+          <a:effectLst/>
+        </p:spPr>
+        <p:style>
+          <a:lnRef idx="2">
+            <a:schemeClr val="accent1"/>
+          </a:lnRef>
+          <a:fillRef idx="0">
+            <a:schemeClr val="accent1"/>
+          </a:fillRef>
+          <a:effectRef idx="1">
+            <a:schemeClr val="accent1"/>
+          </a:effectRef>
+          <a:fontRef idx="minor">
+            <a:schemeClr val="tx1"/>
+          </a:fontRef>
+        </p:style>
+      </p:cxnSp>
+      <p:cxnSp>
+        <p:nvCxnSpPr>
+          <p:cNvPr id="22" name="Connector 21"/>
+          <p:cNvCxnSpPr/>
+          <p:nvPr/>
+        </p:nvCxnSpPr>
+        <p:spPr>
+          <a:xfrm>
+            <a:off x="9345888" y="5094000"/>
+            <a:ext cx="129024" cy="0"/>
+          </a:xfrm>
+          <a:prstGeom prst="line">
+            <a:avLst/>
+          </a:prstGeom>
+          <a:ln w="10160">
+            <a:solidFill>
+              <a:srgbClr val="1D4ED8"/>
+            </a:solidFill>
+          </a:ln>
+          <a:effectLst/>
+        </p:spPr>
+        <p:style>
+          <a:lnRef idx="2">
+            <a:schemeClr val="accent1"/>
+          </a:lnRef>
+          <a:fillRef idx="0">
+            <a:schemeClr val="accent1"/>
+          </a:fillRef>
+          <a:effectRef idx="1">
+            <a:schemeClr val="accent1"/>
+          </a:effectRef>
+          <a:fontRef idx="minor">
+            <a:schemeClr val="tx1"/>
+          </a:fontRef>
+        </p:style>
+      </p:cxnSp>
+      <p:sp>
+        <p:nvSpPr>
+          <p:cNvPr id="23" name="TextBox 22"/>
           <p:cNvSpPr txBox="1"/>
           <p:nvPr>
             <p:custDataLst>
-              <p:tags r:id="rId9"/>
+              <p:tags r:id="rId8"/>
             </p:custDataLst>
           </p:nvPr>
         </p:nvSpPr>
         <p:spPr>
           <a:xfrm>
-            <a:off x="818756" y="6030000"/>
-            <a:ext cx="13392000" cy="468000"/>
+            <a:off x="8655475" y="5364000"/>
+            <a:ext cx="1440000" cy="324000"/>
           </a:xfrm>
           <a:prstGeom prst="rect">
             <a:avLst/>
@@ -5136,6 +5072,183 @@
               </a:spcAft>
             </a:pPr>
             <a:r>
+              <a:rPr sz="2000" b="1">
+                <a:solidFill>
+                  <a:srgbClr val="0B1B2E"/>
+                </a:solidFill>
+                <a:latin typeface="Segoe UI"/>
+                <a:ea typeface="Microsoft JhengHei"/>
+                <a:cs typeface="Segoe UI"/>
+              </a:rPr>
+              <a:t>稽核</a:t>
+            </a:r>
+          </a:p>
+        </p:txBody>
+      </p:sp>
+      <p:sp>
+        <p:nvSpPr>
+          <p:cNvPr id="24" name="Oval 23"/>
+          <p:cNvSpPr/>
+          <p:nvPr/>
+        </p:nvSpPr>
+        <p:spPr>
+          <a:xfrm>
+            <a:off x="12819600" y="4716000"/>
+            <a:ext cx="576000" cy="576000"/>
+          </a:xfrm>
+          <a:prstGeom prst="ellipse">
+            <a:avLst/>
+          </a:prstGeom>
+          <a:solidFill>
+            <a:srgbClr val="FFFFFF"/>
+          </a:solidFill>
+          <a:ln w="10160">
+            <a:solidFill>
+              <a:srgbClr val="1D4ED8"/>
+            </a:solidFill>
+          </a:ln>
+          <a:effectLst/>
+        </p:spPr>
+        <p:style>
+          <a:lnRef idx="1">
+            <a:schemeClr val="accent1"/>
+          </a:lnRef>
+          <a:fillRef idx="3">
+            <a:schemeClr val="accent1"/>
+          </a:fillRef>
+          <a:effectRef idx="2">
+            <a:schemeClr val="accent1"/>
+          </a:effectRef>
+          <a:fontRef idx="minor">
+            <a:schemeClr val="lt1"/>
+          </a:fontRef>
+        </p:style>
+        <p:txBody>
+          <a:bodyPr rtlCol="0" anchor="ctr"/>
+          <a:lstStyle/>
+          <a:p>
+            <a:pPr algn="ctr"/>
+            <a:endParaRPr>
+              <a:latin typeface="Segoe UI"/>
+              <a:ea typeface="Microsoft JhengHei"/>
+              <a:cs typeface="Segoe UI"/>
+            </a:endParaRPr>
+          </a:p>
+        </p:txBody>
+      </p:sp>
+      <p:pic>
+        <p:nvPicPr>
+          <p:cNvPr id="25" name="Picture 24" descr="flat-icon-4.png"/>
+          <p:cNvPicPr>
+            <a:picLocks noChangeAspect="1"/>
+          </p:cNvPicPr>
+          <p:nvPr/>
+        </p:nvPicPr>
+        <p:blipFill>
+          <a:blip r:embed="rId101"/>
+          <a:stretch>
+            <a:fillRect/>
+          </a:stretch>
+        </p:blipFill>
+        <p:spPr>
+          <a:xfrm>
+            <a:off x="12927600" y="4824000"/>
+            <a:ext cx="360000" cy="360000"/>
+          </a:xfrm>
+          <a:prstGeom prst="rect">
+            <a:avLst/>
+          </a:prstGeom>
+        </p:spPr>
+      </p:pic>
+      <p:sp>
+        <p:nvSpPr>
+          <p:cNvPr id="26" name="TextBox 25"/>
+          <p:cNvSpPr txBox="1"/>
+          <p:nvPr>
+            <p:custDataLst>
+              <p:tags r:id="rId9"/>
+            </p:custDataLst>
+          </p:nvPr>
+        </p:nvSpPr>
+        <p:spPr>
+          <a:xfrm>
+            <a:off x="12352675" y="5364000"/>
+            <a:ext cx="1440000" cy="324000"/>
+          </a:xfrm>
+          <a:prstGeom prst="rect">
+            <a:avLst/>
+          </a:prstGeom>
+          <a:noFill/>
+        </p:spPr>
+        <p:txBody>
+          <a:bodyPr wrap="none" lIns="0" tIns="0" rIns="0" bIns="0" anchor="ctr">
+            <a:spAutoFit/>
+          </a:bodyPr>
+          <a:lstStyle/>
+          <a:p>
+            <a:pPr algn="ctr">
+              <a:lnSpc>
+                <a:spcPct val="110000"/>
+              </a:lnSpc>
+              <a:spcBef>
+                <a:spcPts val="0"/>
+              </a:spcBef>
+              <a:spcAft>
+                <a:spcPts val="0"/>
+              </a:spcAft>
+            </a:pPr>
+            <a:r>
+              <a:rPr sz="2000" b="1">
+                <a:solidFill>
+                  <a:srgbClr val="0B1B2E"/>
+                </a:solidFill>
+                <a:latin typeface="Segoe UI"/>
+                <a:ea typeface="Microsoft JhengHei"/>
+                <a:cs typeface="Segoe UI"/>
+              </a:rPr>
+              <a:t>回復</a:t>
+            </a:r>
+          </a:p>
+        </p:txBody>
+      </p:sp>
+      <p:sp>
+        <p:nvSpPr>
+          <p:cNvPr id="27" name="TextBox 26"/>
+          <p:cNvSpPr txBox="1"/>
+          <p:nvPr>
+            <p:custDataLst>
+              <p:tags r:id="rId10"/>
+            </p:custDataLst>
+          </p:nvPr>
+        </p:nvSpPr>
+        <p:spPr>
+          <a:xfrm>
+            <a:off x="818756" y="6030000"/>
+            <a:ext cx="13392000" cy="468000"/>
+          </a:xfrm>
+          <a:prstGeom prst="rect">
+            <a:avLst/>
+          </a:prstGeom>
+          <a:noFill/>
+        </p:spPr>
+        <p:txBody>
+          <a:bodyPr wrap="none" lIns="0" tIns="0" rIns="0" bIns="0" anchor="ctr">
+            <a:spAutoFit/>
+          </a:bodyPr>
+          <a:lstStyle/>
+          <a:p>
+            <a:pPr algn="ctr">
+              <a:lnSpc>
+                <a:spcPct val="110000"/>
+              </a:lnSpc>
+              <a:spcBef>
+                <a:spcPts val="0"/>
+              </a:spcBef>
+              <a:spcAft>
+                <a:spcPts val="0"/>
+              </a:spcAft>
+            </a:pPr>
+            <a:r>
               <a:rPr sz="2600" b="1">
                 <a:solidFill>
                   <a:srgbClr val="0F766E"/>
@@ -5162,7 +5275,7 @@
       </p:sp>
       <p:cxnSp>
         <p:nvCxnSpPr>
-          <p:cNvPr id="26" name="Connector 25"/>
+          <p:cNvPr id="28" name="Connector 27"/>
           <p:cNvCxnSpPr/>
           <p:nvPr/>
         </p:nvCxnSpPr>
@@ -5198,7 +5311,7 @@
       </p:cxnSp>
       <p:sp>
         <p:nvSpPr>
-          <p:cNvPr id="27" name="Rounded Rectangle 26"/>
+          <p:cNvPr id="29" name="Rounded Rectangle 28"/>
           <p:cNvSpPr/>
           <p:nvPr/>
         </p:nvSpPr>
@@ -5249,11 +5362,11 @@
       </p:sp>
       <p:sp>
         <p:nvSpPr>
-          <p:cNvPr id="28" name="TextBox 27"/>
+          <p:cNvPr id="30" name="TextBox 29"/>
           <p:cNvSpPr txBox="1"/>
           <p:nvPr>
             <p:custDataLst>
-              <p:tags r:id="rId10"/>
+              <p:tags r:id="rId11"/>
             </p:custDataLst>
           </p:nvPr>
         </p:nvSpPr>
@@ -5311,11 +5424,11 @@
       </p:sp>
       <p:sp>
         <p:nvSpPr>
-          <p:cNvPr id="29" name="TextBox 28"/>
+          <p:cNvPr id="31" name="TextBox 30"/>
           <p:cNvSpPr txBox="1"/>
           <p:nvPr>
             <p:custDataLst>
-              <p:tags r:id="rId11"/>
+              <p:tags r:id="rId12"/>
             </p:custDataLst>
           </p:nvPr>
         </p:nvSpPr>
@@ -5362,11 +5475,11 @@
       </p:sp>
       <p:sp>
         <p:nvSpPr>
-          <p:cNvPr id="30" name="TextBox 29"/>
+          <p:cNvPr id="32" name="TextBox 31"/>
           <p:cNvSpPr txBox="1"/>
           <p:nvPr>
             <p:custDataLst>
-              <p:tags r:id="rId12"/>
+              <p:tags r:id="rId13"/>
             </p:custDataLst>
           </p:nvPr>
         </p:nvSpPr>
@@ -5437,7 +5550,7 @@
       </p:sp>
       <p:sp>
         <p:nvSpPr>
-          <p:cNvPr id="31" name="Down Arrow 30"/>
+          <p:cNvPr id="33" name="Down Arrow 32"/>
           <p:cNvSpPr/>
           <p:nvPr/>
         </p:nvSpPr>
@@ -5486,7 +5599,7 @@
       </p:sp>
       <p:sp>
         <p:nvSpPr>
-          <p:cNvPr id="32" name="Rounded Rectangle 31"/>
+          <p:cNvPr id="34" name="Rounded Rectangle 33"/>
           <p:cNvSpPr/>
           <p:nvPr/>
         </p:nvSpPr>
@@ -5537,11 +5650,11 @@
       </p:sp>
       <p:sp>
         <p:nvSpPr>
-          <p:cNvPr id="33" name="TextBox 32"/>
+          <p:cNvPr id="35" name="TextBox 34"/>
           <p:cNvSpPr txBox="1"/>
           <p:nvPr>
             <p:custDataLst>
-              <p:tags r:id="rId13"/>
+              <p:tags r:id="rId14"/>
             </p:custDataLst>
           </p:nvPr>
         </p:nvSpPr>
@@ -5599,11 +5712,11 @@
       </p:sp>
       <p:sp>
         <p:nvSpPr>
-          <p:cNvPr id="34" name="TextBox 33"/>
+          <p:cNvPr id="36" name="TextBox 35"/>
           <p:cNvSpPr txBox="1"/>
           <p:nvPr>
             <p:custDataLst>
-              <p:tags r:id="rId14"/>
+              <p:tags r:id="rId15"/>
             </p:custDataLst>
           </p:nvPr>
         </p:nvSpPr>
@@ -5650,11 +5763,11 @@
       </p:sp>
       <p:sp>
         <p:nvSpPr>
-          <p:cNvPr id="35" name="TextBox 34"/>
+          <p:cNvPr id="37" name="TextBox 36"/>
           <p:cNvSpPr txBox="1"/>
           <p:nvPr>
             <p:custDataLst>
-              <p:tags r:id="rId15"/>
+              <p:tags r:id="rId16"/>
             </p:custDataLst>
           </p:nvPr>
         </p:nvSpPr>
@@ -5725,7 +5838,7 @@
       </p:sp>
       <p:sp>
         <p:nvSpPr>
-          <p:cNvPr id="36" name="Down Arrow 35"/>
+          <p:cNvPr id="38" name="Down Arrow 37"/>
           <p:cNvSpPr/>
           <p:nvPr/>
         </p:nvSpPr>
@@ -5774,7 +5887,7 @@
       </p:sp>
       <p:sp>
         <p:nvSpPr>
-          <p:cNvPr id="37" name="Rounded Rectangle 36"/>
+          <p:cNvPr id="39" name="Rounded Rectangle 38"/>
           <p:cNvSpPr/>
           <p:nvPr/>
         </p:nvSpPr>
@@ -5825,11 +5938,11 @@
       </p:sp>
       <p:sp>
         <p:nvSpPr>
-          <p:cNvPr id="38" name="TextBox 37"/>
+          <p:cNvPr id="40" name="TextBox 39"/>
           <p:cNvSpPr txBox="1"/>
           <p:nvPr>
             <p:custDataLst>
-              <p:tags r:id="rId16"/>
+              <p:tags r:id="rId17"/>
             </p:custDataLst>
           </p:nvPr>
         </p:nvSpPr>
@@ -5887,11 +6000,11 @@
       </p:sp>
       <p:sp>
         <p:nvSpPr>
-          <p:cNvPr id="39" name="TextBox 38"/>
+          <p:cNvPr id="41" name="TextBox 40"/>
           <p:cNvSpPr txBox="1"/>
           <p:nvPr>
             <p:custDataLst>
-              <p:tags r:id="rId17"/>
+              <p:tags r:id="rId18"/>
             </p:custDataLst>
           </p:nvPr>
         </p:nvSpPr>
@@ -5938,11 +6051,11 @@
       </p:sp>
       <p:sp>
         <p:nvSpPr>
-          <p:cNvPr id="40" name="TextBox 39"/>
+          <p:cNvPr id="42" name="TextBox 41"/>
           <p:cNvSpPr txBox="1"/>
           <p:nvPr>
             <p:custDataLst>
-              <p:tags r:id="rId18"/>
+              <p:tags r:id="rId19"/>
             </p:custDataLst>
           </p:nvPr>
         </p:nvSpPr>
@@ -6013,7 +6126,7 @@
       </p:sp>
       <p:sp>
         <p:nvSpPr>
-          <p:cNvPr id="41" name="Down Arrow 40"/>
+          <p:cNvPr id="43" name="Down Arrow 42"/>
           <p:cNvSpPr/>
           <p:nvPr/>
         </p:nvSpPr>
@@ -6062,7 +6175,7 @@
       </p:sp>
       <p:sp>
         <p:nvSpPr>
-          <p:cNvPr id="42" name="Rounded Rectangle 41"/>
+          <p:cNvPr id="44" name="Rounded Rectangle 43"/>
           <p:cNvSpPr/>
           <p:nvPr/>
         </p:nvSpPr>
@@ -6113,11 +6226,11 @@
       </p:sp>
       <p:sp>
         <p:nvSpPr>
-          <p:cNvPr id="43" name="TextBox 42"/>
+          <p:cNvPr id="45" name="TextBox 44"/>
           <p:cNvSpPr txBox="1"/>
           <p:nvPr>
             <p:custDataLst>
-              <p:tags r:id="rId19"/>
+              <p:tags r:id="rId20"/>
             </p:custDataLst>
           </p:nvPr>
         </p:nvSpPr>
@@ -6175,11 +6288,11 @@
       </p:sp>
       <p:sp>
         <p:nvSpPr>
-          <p:cNvPr id="44" name="TextBox 43"/>
+          <p:cNvPr id="46" name="TextBox 45"/>
           <p:cNvSpPr txBox="1"/>
           <p:nvPr>
             <p:custDataLst>
-              <p:tags r:id="rId20"/>
+              <p:tags r:id="rId21"/>
             </p:custDataLst>
           </p:nvPr>
         </p:nvSpPr>
@@ -6226,11 +6339,11 @@
       </p:sp>
       <p:sp>
         <p:nvSpPr>
-          <p:cNvPr id="45" name="TextBox 44"/>
+          <p:cNvPr id="47" name="TextBox 46"/>
           <p:cNvSpPr txBox="1"/>
           <p:nvPr>
             <p:custDataLst>
-              <p:tags r:id="rId21"/>
+              <p:tags r:id="rId22"/>
             </p:custDataLst>
           </p:nvPr>
         </p:nvSpPr>
@@ -6301,7 +6414,7 @@
       </p:sp>
       <p:sp>
         <p:nvSpPr>
-          <p:cNvPr id="46" name="Rounded Rectangle 45"/>
+          <p:cNvPr id="48" name="Rounded Rectangle 47"/>
           <p:cNvSpPr/>
           <p:nvPr/>
         </p:nvSpPr>
@@ -6354,11 +6467,11 @@
       </p:sp>
       <p:sp>
         <p:nvSpPr>
-          <p:cNvPr id="47" name="TextBox 46"/>
+          <p:cNvPr id="49" name="TextBox 48"/>
           <p:cNvSpPr txBox="1"/>
           <p:nvPr>
             <p:custDataLst>
-              <p:tags r:id="rId22"/>
+              <p:tags r:id="rId23"/>
             </p:custDataLst>
           </p:nvPr>
         </p:nvSpPr>
@@ -6405,11 +6518,11 @@
       </p:sp>
       <p:sp>
         <p:nvSpPr>
-          <p:cNvPr id="48" name="TextBox 47"/>
+          <p:cNvPr id="50" name="TextBox 49"/>
           <p:cNvSpPr txBox="1"/>
           <p:nvPr>
             <p:custDataLst>
-              <p:tags r:id="rId23"/>
+              <p:tags r:id="rId24"/>
             </p:custDataLst>
           </p:nvPr>
         </p:nvSpPr>
@@ -6456,7 +6569,7 @@
       </p:sp>
       <p:sp>
         <p:nvSpPr>
-          <p:cNvPr id="49" name="Rounded Rectangle 48"/>
+          <p:cNvPr id="51" name="Rounded Rectangle 50"/>
           <p:cNvSpPr/>
           <p:nvPr/>
         </p:nvSpPr>
@@ -6509,11 +6622,11 @@
       </p:sp>
       <p:sp>
         <p:nvSpPr>
-          <p:cNvPr id="50" name="TextBox 49"/>
+          <p:cNvPr id="52" name="TextBox 51"/>
           <p:cNvSpPr txBox="1"/>
           <p:nvPr>
             <p:custDataLst>
-              <p:tags r:id="rId24"/>
+              <p:tags r:id="rId25"/>
             </p:custDataLst>
           </p:nvPr>
         </p:nvSpPr>
@@ -6560,11 +6673,11 @@
       </p:sp>
       <p:sp>
         <p:nvSpPr>
-          <p:cNvPr id="51" name="TextBox 50"/>
+          <p:cNvPr id="53" name="TextBox 52"/>
           <p:cNvSpPr txBox="1"/>
           <p:nvPr>
             <p:custDataLst>
-              <p:tags r:id="rId25"/>
+              <p:tags r:id="rId26"/>
             </p:custDataLst>
           </p:nvPr>
         </p:nvSpPr>
@@ -6604,14 +6717,14 @@
                 <a:ea typeface="Microsoft JhengHei"/>
                 <a:cs typeface="Segoe UI"/>
               </a:rPr>
-              <a:t>短窗位元組模式</a:t>
+              <a:t>短窗位元組模式·既有模型</a:t>
             </a:r>
           </a:p>
         </p:txBody>
       </p:sp>
       <p:cxnSp>
         <p:nvCxnSpPr>
-          <p:cNvPr id="52" name="Connector 51"/>
+          <p:cNvPr id="54" name="Connector 53"/>
           <p:cNvCxnSpPr/>
           <p:nvPr/>
         </p:nvCxnSpPr>
@@ -6647,7 +6760,7 @@
       </p:cxnSp>
       <p:cxnSp>
         <p:nvCxnSpPr>
-          <p:cNvPr id="53" name="Connector 52"/>
+          <p:cNvPr id="55" name="Connector 54"/>
           <p:cNvCxnSpPr/>
           <p:nvPr/>
         </p:nvCxnSpPr>
@@ -6683,7 +6796,7 @@
       </p:cxnSp>
       <p:cxnSp>
         <p:nvCxnSpPr>
-          <p:cNvPr id="54" name="Connector 53"/>
+          <p:cNvPr id="56" name="Connector 55"/>
           <p:cNvCxnSpPr/>
           <p:nvPr/>
         </p:nvCxnSpPr>
@@ -6719,7 +6832,7 @@
       </p:cxnSp>
       <p:sp>
         <p:nvSpPr>
-          <p:cNvPr id="55" name="Right Arrow 54"/>
+          <p:cNvPr id="57" name="Right Arrow 56"/>
           <p:cNvSpPr/>
           <p:nvPr/>
         </p:nvSpPr>
@@ -6768,7 +6881,7 @@
       </p:sp>
       <p:sp>
         <p:nvSpPr>
-          <p:cNvPr id="56" name="Rounded Rectangle 55"/>
+          <p:cNvPr id="58" name="Rounded Rectangle 57"/>
           <p:cNvSpPr/>
           <p:nvPr/>
         </p:nvSpPr>
@@ -6819,11 +6932,11 @@
       </p:sp>
       <p:sp>
         <p:nvSpPr>
-          <p:cNvPr id="57" name="TextBox 56"/>
+          <p:cNvPr id="59" name="TextBox 58"/>
           <p:cNvSpPr txBox="1"/>
           <p:nvPr>
             <p:custDataLst>
-              <p:tags r:id="rId26"/>
+              <p:tags r:id="rId27"/>
             </p:custDataLst>
           </p:nvPr>
         </p:nvSpPr>
@@ -6870,11 +6983,11 @@
       </p:sp>
       <p:sp>
         <p:nvSpPr>
-          <p:cNvPr id="58" name="TextBox 57"/>
+          <p:cNvPr id="60" name="TextBox 59"/>
           <p:cNvSpPr txBox="1"/>
           <p:nvPr>
             <p:custDataLst>
-              <p:tags r:id="rId27"/>
+              <p:tags r:id="rId28"/>
             </p:custDataLst>
           </p:nvPr>
         </p:nvSpPr>
@@ -6921,7 +7034,7 @@
       </p:sp>
       <p:sp>
         <p:nvSpPr>
-          <p:cNvPr id="59" name="Right Arrow 58"/>
+          <p:cNvPr id="61" name="Right Arrow 60"/>
           <p:cNvSpPr/>
           <p:nvPr/>
         </p:nvSpPr>
@@ -6970,7 +7083,7 @@
       </p:sp>
       <p:sp>
         <p:nvSpPr>
-          <p:cNvPr id="60" name="Rounded Rectangle 59"/>
+          <p:cNvPr id="62" name="Rounded Rectangle 61"/>
           <p:cNvSpPr/>
           <p:nvPr/>
         </p:nvSpPr>
@@ -7021,11 +7134,11 @@
       </p:sp>
       <p:sp>
         <p:nvSpPr>
-          <p:cNvPr id="61" name="TextBox 60"/>
+          <p:cNvPr id="63" name="TextBox 62"/>
           <p:cNvSpPr txBox="1"/>
           <p:nvPr>
             <p:custDataLst>
-              <p:tags r:id="rId28"/>
+              <p:tags r:id="rId29"/>
             </p:custDataLst>
           </p:nvPr>
         </p:nvSpPr>
@@ -7072,11 +7185,11 @@
       </p:sp>
       <p:sp>
         <p:nvSpPr>
-          <p:cNvPr id="62" name="TextBox 61"/>
+          <p:cNvPr id="64" name="TextBox 63"/>
           <p:cNvSpPr txBox="1"/>
           <p:nvPr>
             <p:custDataLst>
-              <p:tags r:id="rId29"/>
+              <p:tags r:id="rId30"/>
             </p:custDataLst>
           </p:nvPr>
         </p:nvSpPr>
@@ -7123,7 +7236,7 @@
       </p:sp>
       <p:sp>
         <p:nvSpPr>
-          <p:cNvPr id="63" name="Rounded Rectangle 62"/>
+          <p:cNvPr id="65" name="Rounded Rectangle 64"/>
           <p:cNvSpPr/>
           <p:nvPr/>
         </p:nvSpPr>
@@ -7176,11 +7289,11 @@
       </p:sp>
       <p:sp>
         <p:nvSpPr>
-          <p:cNvPr id="64" name="TextBox 63"/>
+          <p:cNvPr id="66" name="TextBox 65"/>
           <p:cNvSpPr txBox="1"/>
           <p:nvPr>
             <p:custDataLst>
-              <p:tags r:id="rId30"/>
+              <p:tags r:id="rId31"/>
             </p:custDataLst>
           </p:nvPr>
         </p:nvSpPr>
@@ -7227,7 +7340,7 @@
       </p:sp>
       <p:sp>
         <p:nvSpPr>
-          <p:cNvPr id="65" name="Rounded Rectangle 64"/>
+          <p:cNvPr id="67" name="Rounded Rectangle 66"/>
           <p:cNvSpPr/>
           <p:nvPr/>
         </p:nvSpPr>
@@ -7280,11 +7393,11 @@
       </p:sp>
       <p:sp>
         <p:nvSpPr>
-          <p:cNvPr id="66" name="TextBox 65"/>
+          <p:cNvPr id="68" name="TextBox 67"/>
           <p:cNvSpPr txBox="1"/>
           <p:nvPr>
             <p:custDataLst>
-              <p:tags r:id="rId31"/>
+              <p:tags r:id="rId32"/>
             </p:custDataLst>
           </p:nvPr>
         </p:nvSpPr>
@@ -7331,7 +7444,7 @@
       </p:sp>
       <p:cxnSp>
         <p:nvCxnSpPr>
-          <p:cNvPr id="67" name="Connector 66"/>
+          <p:cNvPr id="69" name="Connector 68"/>
           <p:cNvCxnSpPr/>
           <p:nvPr/>
         </p:nvCxnSpPr>
@@ -7367,7 +7480,7 @@
       </p:cxnSp>
       <p:cxnSp>
         <p:nvCxnSpPr>
-          <p:cNvPr id="68" name="Connector 67"/>
+          <p:cNvPr id="70" name="Connector 69"/>
           <p:cNvCxnSpPr/>
           <p:nvPr/>
         </p:nvCxnSpPr>
@@ -7403,7 +7516,7 @@
       </p:cxnSp>
       <p:cxnSp>
         <p:nvCxnSpPr>
-          <p:cNvPr id="69" name="Connector 68"/>
+          <p:cNvPr id="71" name="Connector 70"/>
           <p:cNvCxnSpPr/>
           <p:nvPr/>
         </p:nvCxnSpPr>
@@ -7439,7 +7552,7 @@
       </p:cxnSp>
       <p:sp>
         <p:nvSpPr>
-          <p:cNvPr id="70" name="Right Arrow 69"/>
+          <p:cNvPr id="72" name="Right Arrow 71"/>
           <p:cNvSpPr/>
           <p:nvPr/>
         </p:nvSpPr>
@@ -7488,7 +7601,7 @@
       </p:sp>
       <p:sp>
         <p:nvSpPr>
-          <p:cNvPr id="71" name="Rounded Rectangle 70"/>
+          <p:cNvPr id="73" name="Rounded Rectangle 72"/>
           <p:cNvSpPr/>
           <p:nvPr/>
         </p:nvSpPr>
@@ -7539,11 +7652,11 @@
       </p:sp>
       <p:sp>
         <p:nvSpPr>
-          <p:cNvPr id="72" name="TextBox 71"/>
+          <p:cNvPr id="74" name="TextBox 73"/>
           <p:cNvSpPr txBox="1"/>
           <p:nvPr>
             <p:custDataLst>
-              <p:tags r:id="rId32"/>
+              <p:tags r:id="rId33"/>
             </p:custDataLst>
           </p:nvPr>
         </p:nvSpPr>
@@ -7590,11 +7703,11 @@
       </p:sp>
       <p:sp>
         <p:nvSpPr>
-          <p:cNvPr id="73" name="TextBox 72"/>
+          <p:cNvPr id="75" name="TextBox 74"/>
           <p:cNvSpPr txBox="1"/>
           <p:nvPr>
             <p:custDataLst>
-              <p:tags r:id="rId33"/>
+              <p:tags r:id="rId34"/>
             </p:custDataLst>
           </p:nvPr>
         </p:nvSpPr>
@@ -7641,7 +7754,7 @@
       </p:sp>
       <p:sp>
         <p:nvSpPr>
-          <p:cNvPr id="74" name="Right Arrow 73"/>
+          <p:cNvPr id="76" name="Right Arrow 75"/>
           <p:cNvSpPr/>
           <p:nvPr/>
         </p:nvSpPr>
@@ -7690,7 +7803,7 @@
       </p:sp>
       <p:sp>
         <p:nvSpPr>
-          <p:cNvPr id="75" name="Rounded Rectangle 74"/>
+          <p:cNvPr id="77" name="Rounded Rectangle 76"/>
           <p:cNvSpPr/>
           <p:nvPr/>
         </p:nvSpPr>
@@ -7741,11 +7854,11 @@
       </p:sp>
       <p:sp>
         <p:nvSpPr>
-          <p:cNvPr id="76" name="TextBox 75"/>
+          <p:cNvPr id="78" name="TextBox 77"/>
           <p:cNvSpPr txBox="1"/>
           <p:nvPr>
             <p:custDataLst>
-              <p:tags r:id="rId34"/>
+              <p:tags r:id="rId35"/>
             </p:custDataLst>
           </p:nvPr>
         </p:nvSpPr>
@@ -7792,7 +7905,7 @@
       </p:sp>
       <p:sp>
         <p:nvSpPr>
-          <p:cNvPr id="77" name="Rounded Rectangle 76"/>
+          <p:cNvPr id="79" name="Rounded Rectangle 78"/>
           <p:cNvSpPr/>
           <p:nvPr/>
         </p:nvSpPr>
@@ -7843,11 +7956,11 @@
       </p:sp>
       <p:sp>
         <p:nvSpPr>
-          <p:cNvPr id="78" name="TextBox 77"/>
+          <p:cNvPr id="80" name="TextBox 79"/>
           <p:cNvSpPr txBox="1"/>
           <p:nvPr>
             <p:custDataLst>
-              <p:tags r:id="rId35"/>
+              <p:tags r:id="rId36"/>
             </p:custDataLst>
           </p:nvPr>
         </p:nvSpPr>
@@ -7894,7 +8007,7 @@
       </p:sp>
       <p:sp>
         <p:nvSpPr>
-          <p:cNvPr id="79" name="Rounded Rectangle 78"/>
+          <p:cNvPr id="81" name="Rounded Rectangle 80"/>
           <p:cNvSpPr/>
           <p:nvPr/>
         </p:nvSpPr>
@@ -7945,11 +8058,11 @@
       </p:sp>
       <p:sp>
         <p:nvSpPr>
-          <p:cNvPr id="80" name="TextBox 79"/>
+          <p:cNvPr id="82" name="TextBox 81"/>
           <p:cNvSpPr txBox="1"/>
           <p:nvPr>
             <p:custDataLst>
-              <p:tags r:id="rId36"/>
+              <p:tags r:id="rId37"/>
             </p:custDataLst>
           </p:nvPr>
         </p:nvSpPr>
@@ -7996,7 +8109,7 @@
       </p:sp>
       <p:sp>
         <p:nvSpPr>
-          <p:cNvPr id="81" name="Rounded Rectangle 80"/>
+          <p:cNvPr id="83" name="Rounded Rectangle 82"/>
           <p:cNvSpPr/>
           <p:nvPr/>
         </p:nvSpPr>
@@ -8047,11 +8160,11 @@
       </p:sp>
       <p:sp>
         <p:nvSpPr>
-          <p:cNvPr id="82" name="TextBox 81"/>
+          <p:cNvPr id="84" name="TextBox 83"/>
           <p:cNvSpPr txBox="1"/>
           <p:nvPr>
             <p:custDataLst>
-              <p:tags r:id="rId37"/>
+              <p:tags r:id="rId38"/>
             </p:custDataLst>
           </p:nvPr>
         </p:nvSpPr>
@@ -8098,7 +8211,7 @@
       </p:sp>
       <p:sp>
         <p:nvSpPr>
-          <p:cNvPr id="83" name="Rounded Rectangle 82"/>
+          <p:cNvPr id="85" name="Rounded Rectangle 84"/>
           <p:cNvSpPr/>
           <p:nvPr/>
         </p:nvSpPr>
@@ -8149,11 +8262,11 @@
       </p:sp>
       <p:sp>
         <p:nvSpPr>
-          <p:cNvPr id="84" name="TextBox 83"/>
+          <p:cNvPr id="86" name="TextBox 85"/>
           <p:cNvSpPr txBox="1"/>
           <p:nvPr>
             <p:custDataLst>
-              <p:tags r:id="rId38"/>
+              <p:tags r:id="rId39"/>
             </p:custDataLst>
           </p:nvPr>
         </p:nvSpPr>
@@ -8200,7 +8313,7 @@
       </p:sp>
       <p:sp>
         <p:nvSpPr>
-          <p:cNvPr id="85" name="Rounded Rectangle 84"/>
+          <p:cNvPr id="87" name="Rounded Rectangle 86"/>
           <p:cNvSpPr/>
           <p:nvPr/>
         </p:nvSpPr>
@@ -8251,11 +8364,11 @@
       </p:sp>
       <p:sp>
         <p:nvSpPr>
-          <p:cNvPr id="86" name="TextBox 85"/>
+          <p:cNvPr id="88" name="TextBox 87"/>
           <p:cNvSpPr txBox="1"/>
           <p:nvPr>
             <p:custDataLst>
-              <p:tags r:id="rId39"/>
+              <p:tags r:id="rId40"/>
             </p:custDataLst>
           </p:nvPr>
         </p:nvSpPr>
@@ -8302,7 +8415,7 @@
       </p:sp>
       <p:sp>
         <p:nvSpPr>
-          <p:cNvPr id="87" name="Rounded Rectangle 86"/>
+          <p:cNvPr id="89" name="Rounded Rectangle 88"/>
           <p:cNvSpPr/>
           <p:nvPr/>
         </p:nvSpPr>
@@ -8355,11 +8468,11 @@
       </p:sp>
       <p:sp>
         <p:nvSpPr>
-          <p:cNvPr id="88" name="TextBox 87"/>
+          <p:cNvPr id="90" name="TextBox 89"/>
           <p:cNvSpPr txBox="1"/>
           <p:nvPr>
             <p:custDataLst>
-              <p:tags r:id="rId40"/>
+              <p:tags r:id="rId41"/>
             </p:custDataLst>
           </p:nvPr>
         </p:nvSpPr>
@@ -8406,7 +8519,7 @@
       </p:sp>
       <p:sp>
         <p:nvSpPr>
-          <p:cNvPr id="89" name="Rounded Rectangle 88"/>
+          <p:cNvPr id="91" name="Rounded Rectangle 90"/>
           <p:cNvSpPr/>
           <p:nvPr/>
         </p:nvSpPr>
@@ -8459,11 +8572,11 @@
       </p:sp>
       <p:sp>
         <p:nvSpPr>
-          <p:cNvPr id="90" name="TextBox 89"/>
+          <p:cNvPr id="92" name="TextBox 91"/>
           <p:cNvSpPr txBox="1"/>
           <p:nvPr>
             <p:custDataLst>
-              <p:tags r:id="rId41"/>
+              <p:tags r:id="rId42"/>
             </p:custDataLst>
           </p:nvPr>
         </p:nvSpPr>
@@ -8510,7 +8623,7 @@
       </p:sp>
       <p:cxnSp>
         <p:nvCxnSpPr>
-          <p:cNvPr id="91" name="Connector 90"/>
+          <p:cNvPr id="93" name="Connector 92"/>
           <p:cNvCxnSpPr/>
           <p:nvPr/>
         </p:nvCxnSpPr>
@@ -8546,7 +8659,7 @@
       </p:cxnSp>
       <p:cxnSp>
         <p:nvCxnSpPr>
-          <p:cNvPr id="92" name="Connector 91"/>
+          <p:cNvPr id="94" name="Connector 93"/>
           <p:cNvCxnSpPr/>
           <p:nvPr/>
         </p:nvCxnSpPr>
@@ -8582,7 +8695,7 @@
       </p:cxnSp>
       <p:cxnSp>
         <p:nvCxnSpPr>
-          <p:cNvPr id="93" name="Connector 92"/>
+          <p:cNvPr id="95" name="Connector 94"/>
           <p:cNvCxnSpPr/>
           <p:nvPr/>
         </p:nvCxnSpPr>
@@ -8618,7 +8731,7 @@
       </p:cxnSp>
       <p:sp>
         <p:nvSpPr>
-          <p:cNvPr id="94" name="Right Arrow 93"/>
+          <p:cNvPr id="96" name="Right Arrow 95"/>
           <p:cNvSpPr/>
           <p:nvPr/>
         </p:nvSpPr>
@@ -8667,7 +8780,7 @@
       </p:sp>
       <p:sp>
         <p:nvSpPr>
-          <p:cNvPr id="95" name="Rounded Rectangle 94"/>
+          <p:cNvPr id="97" name="Rounded Rectangle 96"/>
           <p:cNvSpPr/>
           <p:nvPr/>
         </p:nvSpPr>
@@ -8718,11 +8831,11 @@
       </p:sp>
       <p:sp>
         <p:nvSpPr>
-          <p:cNvPr id="96" name="TextBox 95"/>
+          <p:cNvPr id="98" name="TextBox 97"/>
           <p:cNvSpPr txBox="1"/>
           <p:nvPr>
             <p:custDataLst>
-              <p:tags r:id="rId42"/>
+              <p:tags r:id="rId43"/>
             </p:custDataLst>
           </p:nvPr>
         </p:nvSpPr>
@@ -8769,11 +8882,11 @@
       </p:sp>
       <p:sp>
         <p:nvSpPr>
-          <p:cNvPr id="97" name="TextBox 96"/>
+          <p:cNvPr id="99" name="TextBox 98"/>
           <p:cNvSpPr txBox="1"/>
           <p:nvPr>
             <p:custDataLst>
-              <p:tags r:id="rId43"/>
+              <p:tags r:id="rId44"/>
             </p:custDataLst>
           </p:nvPr>
         </p:nvSpPr>
@@ -8820,7 +8933,7 @@
       </p:sp>
       <p:sp>
         <p:nvSpPr>
-          <p:cNvPr id="98" name="Right Arrow 97"/>
+          <p:cNvPr id="100" name="Right Arrow 99"/>
           <p:cNvSpPr/>
           <p:nvPr/>
         </p:nvSpPr>
@@ -8869,7 +8982,7 @@
       </p:sp>
       <p:sp>
         <p:nvSpPr>
-          <p:cNvPr id="99" name="Rounded Rectangle 98"/>
+          <p:cNvPr id="101" name="Rounded Rectangle 100"/>
           <p:cNvSpPr/>
           <p:nvPr/>
         </p:nvSpPr>
@@ -8920,11 +9033,11 @@
       </p:sp>
       <p:sp>
         <p:nvSpPr>
-          <p:cNvPr id="100" name="TextBox 99"/>
+          <p:cNvPr id="102" name="TextBox 101"/>
           <p:cNvSpPr txBox="1"/>
           <p:nvPr>
             <p:custDataLst>
-              <p:tags r:id="rId44"/>
+              <p:tags r:id="rId45"/>
             </p:custDataLst>
           </p:nvPr>
         </p:nvSpPr>
@@ -8971,7 +9084,7 @@
       </p:sp>
       <p:sp>
         <p:nvSpPr>
-          <p:cNvPr id="101" name="Rounded Rectangle 100"/>
+          <p:cNvPr id="103" name="Rounded Rectangle 102"/>
           <p:cNvSpPr/>
           <p:nvPr/>
         </p:nvSpPr>
@@ -9022,11 +9135,11 @@
       </p:sp>
       <p:sp>
         <p:nvSpPr>
-          <p:cNvPr id="102" name="TextBox 101"/>
+          <p:cNvPr id="104" name="TextBox 103"/>
           <p:cNvSpPr txBox="1"/>
           <p:nvPr>
             <p:custDataLst>
-              <p:tags r:id="rId45"/>
+              <p:tags r:id="rId46"/>
             </p:custDataLst>
           </p:nvPr>
         </p:nvSpPr>
@@ -9073,7 +9186,7 @@
       </p:sp>
       <p:sp>
         <p:nvSpPr>
-          <p:cNvPr id="103" name="Rounded Rectangle 102"/>
+          <p:cNvPr id="105" name="Rounded Rectangle 104"/>
           <p:cNvSpPr/>
           <p:nvPr/>
         </p:nvSpPr>
@@ -9124,11 +9237,11 @@
       </p:sp>
       <p:sp>
         <p:nvSpPr>
-          <p:cNvPr id="104" name="TextBox 103"/>
+          <p:cNvPr id="106" name="TextBox 105"/>
           <p:cNvSpPr txBox="1"/>
           <p:nvPr>
             <p:custDataLst>
-              <p:tags r:id="rId46"/>
+              <p:tags r:id="rId47"/>
             </p:custDataLst>
           </p:nvPr>
         </p:nvSpPr>
@@ -9175,11 +9288,11 @@
       </p:sp>
       <p:sp>
         <p:nvSpPr>
-          <p:cNvPr id="105" name="TextBox 104"/>
+          <p:cNvPr id="107" name="TextBox 106"/>
           <p:cNvSpPr txBox="1"/>
           <p:nvPr>
             <p:custDataLst>
-              <p:tags r:id="rId47"/>
+              <p:tags r:id="rId48"/>
             </p:custDataLst>
           </p:nvPr>
         </p:nvSpPr>
@@ -9226,7 +9339,7 @@
       </p:sp>
       <p:sp>
         <p:nvSpPr>
-          <p:cNvPr id="106" name="Rounded Rectangle 105"/>
+          <p:cNvPr id="108" name="Rounded Rectangle 107"/>
           <p:cNvSpPr/>
           <p:nvPr/>
         </p:nvSpPr>
@@ -9279,11 +9392,11 @@
       </p:sp>
       <p:sp>
         <p:nvSpPr>
-          <p:cNvPr id="107" name="TextBox 106"/>
+          <p:cNvPr id="109" name="TextBox 108"/>
           <p:cNvSpPr txBox="1"/>
           <p:nvPr>
             <p:custDataLst>
-              <p:tags r:id="rId48"/>
+              <p:tags r:id="rId49"/>
             </p:custDataLst>
           </p:nvPr>
         </p:nvSpPr>
@@ -9330,7 +9443,7 @@
       </p:sp>
       <p:sp>
         <p:nvSpPr>
-          <p:cNvPr id="108" name="Right Arrow 107"/>
+          <p:cNvPr id="110" name="Right Arrow 109"/>
           <p:cNvSpPr/>
           <p:nvPr/>
         </p:nvSpPr>
@@ -9379,7 +9492,7 @@
       </p:sp>
       <p:sp>
         <p:nvSpPr>
-          <p:cNvPr id="109" name="Rounded Rectangle 108"/>
+          <p:cNvPr id="111" name="Rounded Rectangle 110"/>
           <p:cNvSpPr/>
           <p:nvPr/>
         </p:nvSpPr>
@@ -9432,11 +9545,11 @@
       </p:sp>
       <p:sp>
         <p:nvSpPr>
-          <p:cNvPr id="110" name="TextBox 109"/>
+          <p:cNvPr id="112" name="TextBox 111"/>
           <p:cNvSpPr txBox="1"/>
           <p:nvPr>
             <p:custDataLst>
-              <p:tags r:id="rId49"/>
+              <p:tags r:id="rId50"/>
             </p:custDataLst>
           </p:nvPr>
         </p:nvSpPr>
@@ -9483,7 +9596,7 @@
       </p:sp>
       <p:sp>
         <p:nvSpPr>
-          <p:cNvPr id="111" name="Right Arrow 110"/>
+          <p:cNvPr id="113" name="Right Arrow 112"/>
           <p:cNvSpPr/>
           <p:nvPr/>
         </p:nvSpPr>
@@ -9532,7 +9645,7 @@
       </p:sp>
       <p:sp>
         <p:nvSpPr>
-          <p:cNvPr id="112" name="Rounded Rectangle 111"/>
+          <p:cNvPr id="114" name="Rounded Rectangle 113"/>
           <p:cNvSpPr/>
           <p:nvPr/>
         </p:nvSpPr>
@@ -9583,11 +9696,11 @@
       </p:sp>
       <p:sp>
         <p:nvSpPr>
-          <p:cNvPr id="113" name="TextBox 112"/>
+          <p:cNvPr id="115" name="TextBox 114"/>
           <p:cNvSpPr txBox="1"/>
           <p:nvPr>
             <p:custDataLst>
-              <p:tags r:id="rId50"/>
+              <p:tags r:id="rId51"/>
             </p:custDataLst>
           </p:nvPr>
         </p:nvSpPr>
@@ -9634,11 +9747,11 @@
       </p:sp>
       <p:sp>
         <p:nvSpPr>
-          <p:cNvPr id="114" name="TextBox 113"/>
+          <p:cNvPr id="116" name="TextBox 115"/>
           <p:cNvSpPr txBox="1"/>
           <p:nvPr>
             <p:custDataLst>
-              <p:tags r:id="rId51"/>
+              <p:tags r:id="rId52"/>
             </p:custDataLst>
           </p:nvPr>
         </p:nvSpPr>
@@ -9685,7 +9798,7 @@
       </p:sp>
       <p:sp>
         <p:nvSpPr>
-          <p:cNvPr id="115" name="Rounded Rectangle 114"/>
+          <p:cNvPr id="117" name="Rounded Rectangle 116"/>
           <p:cNvSpPr/>
           <p:nvPr/>
         </p:nvSpPr>
@@ -9736,7 +9849,7 @@
       </p:sp>
       <p:sp>
         <p:nvSpPr>
-          <p:cNvPr id="116" name="Oval 115"/>
+          <p:cNvPr id="118" name="Oval 117"/>
           <p:cNvSpPr/>
           <p:nvPr/>
         </p:nvSpPr>
@@ -9785,7 +9898,7 @@
       </p:sp>
       <p:sp>
         <p:nvSpPr>
-          <p:cNvPr id="117" name="Oval 116"/>
+          <p:cNvPr id="119" name="Oval 118"/>
           <p:cNvSpPr/>
           <p:nvPr/>
         </p:nvSpPr>
@@ -9834,7 +9947,7 @@
       </p:sp>
       <p:sp>
         <p:nvSpPr>
-          <p:cNvPr id="118" name="Oval 117"/>
+          <p:cNvPr id="120" name="Oval 119"/>
           <p:cNvSpPr/>
           <p:nvPr/>
         </p:nvSpPr>
@@ -9883,7 +9996,7 @@
       </p:sp>
       <p:sp>
         <p:nvSpPr>
-          <p:cNvPr id="119" name="Oval 118"/>
+          <p:cNvPr id="121" name="Oval 120"/>
           <p:cNvSpPr/>
           <p:nvPr/>
         </p:nvSpPr>
@@ -9932,11 +10045,11 @@
       </p:sp>
       <p:sp>
         <p:nvSpPr>
-          <p:cNvPr id="120" name="TextBox 119"/>
+          <p:cNvPr id="122" name="TextBox 121"/>
           <p:cNvSpPr txBox="1"/>
           <p:nvPr>
             <p:custDataLst>
-              <p:tags r:id="rId52"/>
+              <p:tags r:id="rId53"/>
             </p:custDataLst>
           </p:nvPr>
         </p:nvSpPr>
@@ -9983,11 +10096,11 @@
       </p:sp>
       <p:sp>
         <p:nvSpPr>
-          <p:cNvPr id="121" name="TextBox 120"/>
+          <p:cNvPr id="123" name="TextBox 122"/>
           <p:cNvSpPr txBox="1"/>
           <p:nvPr>
             <p:custDataLst>
-              <p:tags r:id="rId53"/>
+              <p:tags r:id="rId54"/>
             </p:custDataLst>
           </p:nvPr>
         </p:nvSpPr>
@@ -10045,7 +10158,7 @@
       </p:sp>
       <p:cxnSp>
         <p:nvCxnSpPr>
-          <p:cNvPr id="122" name="Connector 121"/>
+          <p:cNvPr id="124" name="Connector 123"/>
           <p:cNvCxnSpPr/>
           <p:nvPr/>
         </p:nvCxnSpPr>
@@ -10081,7 +10194,7 @@
       </p:cxnSp>
       <p:sp>
         <p:nvSpPr>
-          <p:cNvPr id="123" name="Rounded Rectangle 122"/>
+          <p:cNvPr id="125" name="Rounded Rectangle 124"/>
           <p:cNvSpPr/>
           <p:nvPr/>
         </p:nvSpPr>
@@ -10134,7 +10247,7 @@
       </p:sp>
       <p:sp>
         <p:nvSpPr>
-          <p:cNvPr id="124" name="Rectangle 123"/>
+          <p:cNvPr id="126" name="Rectangle 125"/>
           <p:cNvSpPr/>
           <p:nvPr/>
         </p:nvSpPr>
@@ -10183,11 +10296,11 @@
       </p:sp>
       <p:sp>
         <p:nvSpPr>
-          <p:cNvPr id="125" name="TextBox 124"/>
+          <p:cNvPr id="127" name="TextBox 126"/>
           <p:cNvSpPr txBox="1"/>
           <p:nvPr>
             <p:custDataLst>
-              <p:tags r:id="rId54"/>
+              <p:tags r:id="rId55"/>
             </p:custDataLst>
           </p:nvPr>
         </p:nvSpPr>
@@ -10234,11 +10347,11 @@
       </p:sp>
       <p:sp>
         <p:nvSpPr>
-          <p:cNvPr id="126" name="TextBox 125"/>
+          <p:cNvPr id="128" name="TextBox 127"/>
           <p:cNvSpPr txBox="1"/>
           <p:nvPr>
             <p:custDataLst>
-              <p:tags r:id="rId55"/>
+              <p:tags r:id="rId56"/>
             </p:custDataLst>
           </p:nvPr>
         </p:nvSpPr>
@@ -10333,7 +10446,7 @@
       </p:sp>
       <p:sp>
         <p:nvSpPr>
-          <p:cNvPr id="127" name="Rounded Rectangle 126"/>
+          <p:cNvPr id="129" name="Rounded Rectangle 128"/>
           <p:cNvSpPr/>
           <p:nvPr/>
         </p:nvSpPr>
@@ -10386,7 +10499,7 @@
       </p:sp>
       <p:sp>
         <p:nvSpPr>
-          <p:cNvPr id="128" name="Rectangle 127"/>
+          <p:cNvPr id="130" name="Rectangle 129"/>
           <p:cNvSpPr/>
           <p:nvPr/>
         </p:nvSpPr>
@@ -10435,11 +10548,11 @@
       </p:sp>
       <p:sp>
         <p:nvSpPr>
-          <p:cNvPr id="129" name="TextBox 128"/>
+          <p:cNvPr id="131" name="TextBox 130"/>
           <p:cNvSpPr txBox="1"/>
           <p:nvPr>
             <p:custDataLst>
-              <p:tags r:id="rId56"/>
+              <p:tags r:id="rId57"/>
             </p:custDataLst>
           </p:nvPr>
         </p:nvSpPr>
@@ -10486,11 +10599,11 @@
       </p:sp>
       <p:sp>
         <p:nvSpPr>
-          <p:cNvPr id="130" name="TextBox 129"/>
+          <p:cNvPr id="132" name="TextBox 131"/>
           <p:cNvSpPr txBox="1"/>
           <p:nvPr>
             <p:custDataLst>
-              <p:tags r:id="rId57"/>
+              <p:tags r:id="rId58"/>
             </p:custDataLst>
           </p:nvPr>
         </p:nvSpPr>
@@ -10585,7 +10698,7 @@
       </p:sp>
       <p:sp>
         <p:nvSpPr>
-          <p:cNvPr id="131" name="Rounded Rectangle 130"/>
+          <p:cNvPr id="133" name="Rounded Rectangle 132"/>
           <p:cNvSpPr/>
           <p:nvPr/>
         </p:nvSpPr>
@@ -10638,7 +10751,7 @@
       </p:sp>
       <p:sp>
         <p:nvSpPr>
-          <p:cNvPr id="132" name="Rectangle 131"/>
+          <p:cNvPr id="134" name="Rectangle 133"/>
           <p:cNvSpPr/>
           <p:nvPr/>
         </p:nvSpPr>
@@ -10687,11 +10800,11 @@
       </p:sp>
       <p:sp>
         <p:nvSpPr>
-          <p:cNvPr id="133" name="TextBox 132"/>
+          <p:cNvPr id="135" name="TextBox 134"/>
           <p:cNvSpPr txBox="1"/>
           <p:nvPr>
             <p:custDataLst>
-              <p:tags r:id="rId58"/>
+              <p:tags r:id="rId59"/>
             </p:custDataLst>
           </p:nvPr>
         </p:nvSpPr>
@@ -10738,11 +10851,11 @@
       </p:sp>
       <p:sp>
         <p:nvSpPr>
-          <p:cNvPr id="134" name="TextBox 133"/>
+          <p:cNvPr id="136" name="TextBox 135"/>
           <p:cNvSpPr txBox="1"/>
           <p:nvPr>
             <p:custDataLst>
-              <p:tags r:id="rId59"/>
+              <p:tags r:id="rId60"/>
             </p:custDataLst>
           </p:nvPr>
         </p:nvSpPr>
@@ -10837,11 +10950,11 @@
       </p:sp>
       <p:sp>
         <p:nvSpPr>
-          <p:cNvPr id="135" name="TextBox 134"/>
+          <p:cNvPr id="137" name="TextBox 136"/>
           <p:cNvSpPr txBox="1"/>
           <p:nvPr>
             <p:custDataLst>
-              <p:tags r:id="rId60"/>
+              <p:tags r:id="rId61"/>
             </p:custDataLst>
           </p:nvPr>
         </p:nvSpPr>
@@ -10899,7 +11012,7 @@
       </p:sp>
       <p:cxnSp>
         <p:nvCxnSpPr>
-          <p:cNvPr id="136" name="Connector 135"/>
+          <p:cNvPr id="138" name="Connector 137"/>
           <p:cNvCxnSpPr/>
           <p:nvPr/>
         </p:nvCxnSpPr>
@@ -10935,11 +11048,11 @@
       </p:cxnSp>
       <p:sp>
         <p:nvSpPr>
-          <p:cNvPr id="137" name="TextBox 136"/>
+          <p:cNvPr id="139" name="TextBox 138"/>
           <p:cNvSpPr txBox="1"/>
           <p:nvPr>
             <p:custDataLst>
-              <p:tags r:id="rId61"/>
+              <p:tags r:id="rId62"/>
             </p:custDataLst>
           </p:nvPr>
         </p:nvSpPr>
@@ -10986,11 +11099,11 @@
       </p:sp>
       <p:sp>
         <p:nvSpPr>
-          <p:cNvPr id="138" name="TextBox 137"/>
+          <p:cNvPr id="140" name="TextBox 139"/>
           <p:cNvSpPr txBox="1"/>
           <p:nvPr>
             <p:custDataLst>
-              <p:tags r:id="rId62"/>
+              <p:tags r:id="rId63"/>
             </p:custDataLst>
           </p:nvPr>
         </p:nvSpPr>
@@ -11037,7 +11150,7 @@
       </p:sp>
       <p:sp>
         <p:nvSpPr>
-          <p:cNvPr id="139" name="Rectangle 138"/>
+          <p:cNvPr id="141" name="Rectangle 140"/>
           <p:cNvSpPr/>
           <p:nvPr/>
         </p:nvSpPr>
@@ -11086,7 +11199,7 @@
       </p:sp>
       <p:sp>
         <p:nvSpPr>
-          <p:cNvPr id="140" name="Rectangle 139"/>
+          <p:cNvPr id="142" name="Rectangle 141"/>
           <p:cNvSpPr/>
           <p:nvPr/>
         </p:nvSpPr>
@@ -11135,11 +11248,11 @@
       </p:sp>
       <p:sp>
         <p:nvSpPr>
-          <p:cNvPr id="141" name="TextBox 140"/>
+          <p:cNvPr id="143" name="TextBox 142"/>
           <p:cNvSpPr txBox="1"/>
           <p:nvPr>
             <p:custDataLst>
-              <p:tags r:id="rId63"/>
+              <p:tags r:id="rId64"/>
             </p:custDataLst>
           </p:nvPr>
         </p:nvSpPr>
@@ -11186,11 +11299,11 @@
       </p:sp>
       <p:sp>
         <p:nvSpPr>
-          <p:cNvPr id="142" name="TextBox 141"/>
+          <p:cNvPr id="144" name="TextBox 143"/>
           <p:cNvSpPr txBox="1"/>
           <p:nvPr>
             <p:custDataLst>
-              <p:tags r:id="rId64"/>
+              <p:tags r:id="rId65"/>
             </p:custDataLst>
           </p:nvPr>
         </p:nvSpPr>
@@ -11237,7 +11350,7 @@
       </p:sp>
       <p:sp>
         <p:nvSpPr>
-          <p:cNvPr id="143" name="Rectangle 142"/>
+          <p:cNvPr id="145" name="Rectangle 144"/>
           <p:cNvSpPr/>
           <p:nvPr/>
         </p:nvSpPr>
@@ -11286,7 +11399,7 @@
       </p:sp>
       <p:sp>
         <p:nvSpPr>
-          <p:cNvPr id="144" name="Rectangle 143"/>
+          <p:cNvPr id="146" name="Rectangle 145"/>
           <p:cNvSpPr/>
           <p:nvPr/>
         </p:nvSpPr>
@@ -11335,11 +11448,11 @@
       </p:sp>
       <p:sp>
         <p:nvSpPr>
-          <p:cNvPr id="145" name="TextBox 144"/>
+          <p:cNvPr id="147" name="TextBox 146"/>
           <p:cNvSpPr txBox="1"/>
           <p:nvPr>
             <p:custDataLst>
-              <p:tags r:id="rId65"/>
+              <p:tags r:id="rId66"/>
             </p:custDataLst>
           </p:nvPr>
         </p:nvSpPr>
@@ -11386,11 +11499,11 @@
       </p:sp>
       <p:sp>
         <p:nvSpPr>
-          <p:cNvPr id="146" name="TextBox 145"/>
+          <p:cNvPr id="148" name="TextBox 147"/>
           <p:cNvSpPr txBox="1"/>
           <p:nvPr>
             <p:custDataLst>
-              <p:tags r:id="rId66"/>
+              <p:tags r:id="rId67"/>
             </p:custDataLst>
           </p:nvPr>
         </p:nvSpPr>
@@ -11437,7 +11550,7 @@
       </p:sp>
       <p:sp>
         <p:nvSpPr>
-          <p:cNvPr id="147" name="Rectangle 146"/>
+          <p:cNvPr id="149" name="Rectangle 148"/>
           <p:cNvSpPr/>
           <p:nvPr/>
         </p:nvSpPr>
@@ -11486,7 +11599,7 @@
       </p:sp>
       <p:sp>
         <p:nvSpPr>
-          <p:cNvPr id="148" name="Rectangle 147"/>
+          <p:cNvPr id="150" name="Rectangle 149"/>
           <p:cNvSpPr/>
           <p:nvPr/>
         </p:nvSpPr>
@@ -11535,11 +11648,11 @@
       </p:sp>
       <p:sp>
         <p:nvSpPr>
-          <p:cNvPr id="149" name="TextBox 148"/>
+          <p:cNvPr id="151" name="TextBox 150"/>
           <p:cNvSpPr txBox="1"/>
           <p:nvPr>
             <p:custDataLst>
-              <p:tags r:id="rId67"/>
+              <p:tags r:id="rId68"/>
             </p:custDataLst>
           </p:nvPr>
         </p:nvSpPr>
@@ -11586,7 +11699,7 @@
       </p:sp>
       <p:cxnSp>
         <p:nvCxnSpPr>
-          <p:cNvPr id="150" name="Connector 149"/>
+          <p:cNvPr id="152" name="Connector 151"/>
           <p:cNvCxnSpPr/>
           <p:nvPr/>
         </p:nvCxnSpPr>
@@ -11622,11 +11735,11 @@
       </p:cxnSp>
       <p:sp>
         <p:nvSpPr>
-          <p:cNvPr id="151" name="TextBox 150"/>
+          <p:cNvPr id="153" name="TextBox 152"/>
           <p:cNvSpPr txBox="1"/>
           <p:nvPr>
             <p:custDataLst>
-              <p:tags r:id="rId68"/>
+              <p:tags r:id="rId69"/>
             </p:custDataLst>
           </p:nvPr>
         </p:nvSpPr>
@@ -11673,7 +11786,7 @@
       </p:sp>
       <p:cxnSp>
         <p:nvCxnSpPr>
-          <p:cNvPr id="152" name="Connector 151"/>
+          <p:cNvPr id="154" name="Connector 153"/>
           <p:cNvCxnSpPr/>
           <p:nvPr/>
         </p:nvCxnSpPr>
@@ -11709,11 +11822,11 @@
       </p:cxnSp>
       <p:sp>
         <p:nvSpPr>
-          <p:cNvPr id="153" name="TextBox 152"/>
+          <p:cNvPr id="155" name="TextBox 154"/>
           <p:cNvSpPr txBox="1"/>
           <p:nvPr>
             <p:custDataLst>
-              <p:tags r:id="rId69"/>
+              <p:tags r:id="rId70"/>
             </p:custDataLst>
           </p:nvPr>
         </p:nvSpPr>
@@ -11760,7 +11873,7 @@
       </p:sp>
       <p:cxnSp>
         <p:nvCxnSpPr>
-          <p:cNvPr id="154" name="Connector 153"/>
+          <p:cNvPr id="156" name="Connector 155"/>
           <p:cNvCxnSpPr/>
           <p:nvPr/>
         </p:nvCxnSpPr>
@@ -11796,11 +11909,11 @@
       </p:cxnSp>
       <p:sp>
         <p:nvSpPr>
-          <p:cNvPr id="155" name="TextBox 154"/>
+          <p:cNvPr id="157" name="TextBox 156"/>
           <p:cNvSpPr txBox="1"/>
           <p:nvPr>
             <p:custDataLst>
-              <p:tags r:id="rId70"/>
+              <p:tags r:id="rId71"/>
             </p:custDataLst>
           </p:nvPr>
         </p:nvSpPr>
@@ -11847,11 +11960,11 @@
       </p:sp>
       <p:sp>
         <p:nvSpPr>
-          <p:cNvPr id="156" name="TextBox 155"/>
+          <p:cNvPr id="158" name="TextBox 157"/>
           <p:cNvSpPr txBox="1"/>
           <p:nvPr>
             <p:custDataLst>
-              <p:tags r:id="rId71"/>
+              <p:tags r:id="rId72"/>
             </p:custDataLst>
           </p:nvPr>
         </p:nvSpPr>
@@ -11898,7 +12011,7 @@
       </p:sp>
       <p:cxnSp>
         <p:nvCxnSpPr>
-          <p:cNvPr id="157" name="Connector 156"/>
+          <p:cNvPr id="159" name="Connector 158"/>
           <p:cNvCxnSpPr/>
           <p:nvPr/>
         </p:nvCxnSpPr>
@@ -11934,11 +12047,11 @@
       </p:cxnSp>
       <p:sp>
         <p:nvSpPr>
-          <p:cNvPr id="158" name="TextBox 157"/>
+          <p:cNvPr id="160" name="TextBox 159"/>
           <p:cNvSpPr txBox="1"/>
           <p:nvPr>
             <p:custDataLst>
-              <p:tags r:id="rId72"/>
+              <p:tags r:id="rId73"/>
             </p:custDataLst>
           </p:nvPr>
         </p:nvSpPr>
@@ -11985,11 +12098,11 @@
       </p:sp>
       <p:sp>
         <p:nvSpPr>
-          <p:cNvPr id="159" name="TextBox 158"/>
+          <p:cNvPr id="161" name="TextBox 160"/>
           <p:cNvSpPr txBox="1"/>
           <p:nvPr>
             <p:custDataLst>
-              <p:tags r:id="rId73"/>
+              <p:tags r:id="rId74"/>
             </p:custDataLst>
           </p:nvPr>
         </p:nvSpPr>
@@ -12036,11 +12149,11 @@
       </p:sp>
       <p:sp>
         <p:nvSpPr>
-          <p:cNvPr id="160" name="TextBox 159"/>
+          <p:cNvPr id="162" name="TextBox 161"/>
           <p:cNvSpPr txBox="1"/>
           <p:nvPr>
             <p:custDataLst>
-              <p:tags r:id="rId74"/>
+              <p:tags r:id="rId75"/>
             </p:custDataLst>
           </p:nvPr>
         </p:nvSpPr>
@@ -12087,7 +12200,7 @@
       </p:sp>
       <p:sp>
         <p:nvSpPr>
-          <p:cNvPr id="161" name="Rounded Rectangle 160"/>
+          <p:cNvPr id="163" name="Rounded Rectangle 162"/>
           <p:cNvSpPr/>
           <p:nvPr/>
         </p:nvSpPr>
@@ -12138,11 +12251,11 @@
       </p:sp>
       <p:sp>
         <p:nvSpPr>
-          <p:cNvPr id="162" name="TextBox 161"/>
+          <p:cNvPr id="164" name="TextBox 163"/>
           <p:cNvSpPr txBox="1"/>
           <p:nvPr>
             <p:custDataLst>
-              <p:tags r:id="rId75"/>
+              <p:tags r:id="rId76"/>
             </p:custDataLst>
           </p:nvPr>
         </p:nvSpPr>
@@ -12189,11 +12302,11 @@
       </p:sp>
       <p:sp>
         <p:nvSpPr>
-          <p:cNvPr id="163" name="TextBox 162"/>
+          <p:cNvPr id="165" name="TextBox 164"/>
           <p:cNvSpPr txBox="1"/>
           <p:nvPr>
             <p:custDataLst>
-              <p:tags r:id="rId76"/>
+              <p:tags r:id="rId77"/>
             </p:custDataLst>
           </p:nvPr>
         </p:nvSpPr>
@@ -12240,7 +12353,7 @@
       </p:sp>
       <p:sp>
         <p:nvSpPr>
-          <p:cNvPr id="164" name="Rounded Rectangle 163"/>
+          <p:cNvPr id="166" name="Rounded Rectangle 165"/>
           <p:cNvSpPr/>
           <p:nvPr/>
         </p:nvSpPr>
@@ -12291,11 +12404,11 @@
       </p:sp>
       <p:sp>
         <p:nvSpPr>
-          <p:cNvPr id="165" name="TextBox 164"/>
+          <p:cNvPr id="167" name="TextBox 166"/>
           <p:cNvSpPr txBox="1"/>
           <p:nvPr>
             <p:custDataLst>
-              <p:tags r:id="rId77"/>
+              <p:tags r:id="rId78"/>
             </p:custDataLst>
           </p:nvPr>
         </p:nvSpPr>
@@ -12342,11 +12455,11 @@
       </p:sp>
       <p:sp>
         <p:nvSpPr>
-          <p:cNvPr id="166" name="TextBox 165"/>
+          <p:cNvPr id="168" name="TextBox 167"/>
           <p:cNvSpPr txBox="1"/>
           <p:nvPr>
             <p:custDataLst>
-              <p:tags r:id="rId78"/>
+              <p:tags r:id="rId79"/>
             </p:custDataLst>
           </p:nvPr>
         </p:nvSpPr>
@@ -12393,7 +12506,7 @@
       </p:sp>
       <p:sp>
         <p:nvSpPr>
-          <p:cNvPr id="167" name="Rounded Rectangle 166"/>
+          <p:cNvPr id="169" name="Rounded Rectangle 168"/>
           <p:cNvSpPr/>
           <p:nvPr/>
         </p:nvSpPr>
@@ -12444,11 +12557,11 @@
       </p:sp>
       <p:sp>
         <p:nvSpPr>
-          <p:cNvPr id="168" name="TextBox 167"/>
+          <p:cNvPr id="170" name="TextBox 169"/>
           <p:cNvSpPr txBox="1"/>
           <p:nvPr>
             <p:custDataLst>
-              <p:tags r:id="rId79"/>
+              <p:tags r:id="rId80"/>
             </p:custDataLst>
           </p:nvPr>
         </p:nvSpPr>
@@ -12495,11 +12608,11 @@
       </p:sp>
       <p:sp>
         <p:nvSpPr>
-          <p:cNvPr id="169" name="TextBox 168"/>
+          <p:cNvPr id="171" name="TextBox 170"/>
           <p:cNvSpPr txBox="1"/>
           <p:nvPr>
             <p:custDataLst>
-              <p:tags r:id="rId80"/>
+              <p:tags r:id="rId81"/>
             </p:custDataLst>
           </p:nvPr>
         </p:nvSpPr>
@@ -12546,11 +12659,11 @@
       </p:sp>
       <p:sp>
         <p:nvSpPr>
-          <p:cNvPr id="170" name="TextBox 169"/>
+          <p:cNvPr id="172" name="TextBox 171"/>
           <p:cNvSpPr txBox="1"/>
           <p:nvPr>
             <p:custDataLst>
-              <p:tags r:id="rId81"/>
+              <p:tags r:id="rId82"/>
             </p:custDataLst>
           </p:nvPr>
         </p:nvSpPr>
@@ -12597,7 +12710,7 @@
       </p:sp>
       <p:sp>
         <p:nvSpPr>
-          <p:cNvPr id="171" name="Rounded Rectangle 170"/>
+          <p:cNvPr id="173" name="Rounded Rectangle 172"/>
           <p:cNvSpPr/>
           <p:nvPr/>
         </p:nvSpPr>
@@ -12648,11 +12761,11 @@
       </p:sp>
       <p:sp>
         <p:nvSpPr>
-          <p:cNvPr id="172" name="TextBox 171"/>
+          <p:cNvPr id="174" name="TextBox 173"/>
           <p:cNvSpPr txBox="1"/>
           <p:nvPr>
             <p:custDataLst>
-              <p:tags r:id="rId82"/>
+              <p:tags r:id="rId83"/>
             </p:custDataLst>
           </p:nvPr>
         </p:nvSpPr>
@@ -12723,7 +12836,7 @@
       </p:sp>
       <p:sp>
         <p:nvSpPr>
-          <p:cNvPr id="173" name="Rounded Rectangle 172"/>
+          <p:cNvPr id="175" name="Rounded Rectangle 174"/>
           <p:cNvSpPr/>
           <p:nvPr/>
         </p:nvSpPr>
@@ -12776,11 +12889,11 @@
       </p:sp>
       <p:sp>
         <p:nvSpPr>
-          <p:cNvPr id="174" name="TextBox 173"/>
+          <p:cNvPr id="176" name="TextBox 175"/>
           <p:cNvSpPr txBox="1"/>
           <p:nvPr>
             <p:custDataLst>
-              <p:tags r:id="rId83"/>
+              <p:tags r:id="rId84"/>
             </p:custDataLst>
           </p:nvPr>
         </p:nvSpPr>
@@ -12827,11 +12940,11 @@
       </p:sp>
       <p:sp>
         <p:nvSpPr>
-          <p:cNvPr id="175" name="TextBox 174"/>
+          <p:cNvPr id="177" name="TextBox 176"/>
           <p:cNvSpPr txBox="1"/>
           <p:nvPr>
             <p:custDataLst>
-              <p:tags r:id="rId84"/>
+              <p:tags r:id="rId85"/>
             </p:custDataLst>
           </p:nvPr>
         </p:nvSpPr>
@@ -12878,7 +12991,7 @@
       </p:sp>
       <p:sp>
         <p:nvSpPr>
-          <p:cNvPr id="176" name="Rounded Rectangle 175"/>
+          <p:cNvPr id="178" name="Rounded Rectangle 177"/>
           <p:cNvSpPr/>
           <p:nvPr/>
         </p:nvSpPr>
@@ -12929,11 +13042,11 @@
       </p:sp>
       <p:sp>
         <p:nvSpPr>
-          <p:cNvPr id="177" name="TextBox 176"/>
+          <p:cNvPr id="179" name="TextBox 178"/>
           <p:cNvSpPr txBox="1"/>
           <p:nvPr>
             <p:custDataLst>
-              <p:tags r:id="rId85"/>
+              <p:tags r:id="rId86"/>
             </p:custDataLst>
           </p:nvPr>
         </p:nvSpPr>
@@ -12980,11 +13093,11 @@
       </p:sp>
       <p:sp>
         <p:nvSpPr>
-          <p:cNvPr id="178" name="TextBox 177"/>
+          <p:cNvPr id="180" name="TextBox 179"/>
           <p:cNvSpPr txBox="1"/>
           <p:nvPr>
             <p:custDataLst>
-              <p:tags r:id="rId86"/>
+              <p:tags r:id="rId87"/>
             </p:custDataLst>
           </p:nvPr>
         </p:nvSpPr>
@@ -13031,7 +13144,7 @@
       </p:sp>
       <p:sp>
         <p:nvSpPr>
-          <p:cNvPr id="179" name="Rounded Rectangle 178"/>
+          <p:cNvPr id="181" name="Rounded Rectangle 180"/>
           <p:cNvSpPr/>
           <p:nvPr/>
         </p:nvSpPr>
@@ -13082,11 +13195,11 @@
       </p:sp>
       <p:sp>
         <p:nvSpPr>
-          <p:cNvPr id="180" name="TextBox 179"/>
+          <p:cNvPr id="182" name="TextBox 181"/>
           <p:cNvSpPr txBox="1"/>
           <p:nvPr>
             <p:custDataLst>
-              <p:tags r:id="rId87"/>
+              <p:tags r:id="rId88"/>
             </p:custDataLst>
           </p:nvPr>
         </p:nvSpPr>
@@ -13133,11 +13246,11 @@
       </p:sp>
       <p:sp>
         <p:nvSpPr>
-          <p:cNvPr id="181" name="TextBox 180"/>
+          <p:cNvPr id="183" name="TextBox 182"/>
           <p:cNvSpPr txBox="1"/>
           <p:nvPr>
             <p:custDataLst>
-              <p:tags r:id="rId88"/>
+              <p:tags r:id="rId89"/>
             </p:custDataLst>
           </p:nvPr>
         </p:nvSpPr>
@@ -13184,7 +13297,7 @@
       </p:sp>
       <p:sp>
         <p:nvSpPr>
-          <p:cNvPr id="182" name="Rounded Rectangle 181"/>
+          <p:cNvPr id="184" name="Rounded Rectangle 183"/>
           <p:cNvSpPr/>
           <p:nvPr/>
         </p:nvSpPr>
@@ -13235,11 +13348,11 @@
       </p:sp>
       <p:sp>
         <p:nvSpPr>
-          <p:cNvPr id="183" name="TextBox 182"/>
+          <p:cNvPr id="185" name="TextBox 184"/>
           <p:cNvSpPr txBox="1"/>
           <p:nvPr>
             <p:custDataLst>
-              <p:tags r:id="rId89"/>
+              <p:tags r:id="rId90"/>
             </p:custDataLst>
           </p:nvPr>
         </p:nvSpPr>
@@ -13286,11 +13399,11 @@
       </p:sp>
       <p:sp>
         <p:nvSpPr>
-          <p:cNvPr id="184" name="TextBox 183"/>
+          <p:cNvPr id="186" name="TextBox 185"/>
           <p:cNvSpPr txBox="1"/>
           <p:nvPr>
             <p:custDataLst>
-              <p:tags r:id="rId90"/>
+              <p:tags r:id="rId91"/>
             </p:custDataLst>
           </p:nvPr>
         </p:nvSpPr>
@@ -13337,7 +13450,7 @@
       </p:sp>
       <p:sp>
         <p:nvSpPr>
-          <p:cNvPr id="185" name="Rounded Rectangle 184"/>
+          <p:cNvPr id="187" name="Rounded Rectangle 186"/>
           <p:cNvSpPr/>
           <p:nvPr/>
         </p:nvSpPr>
@@ -13390,11 +13503,11 @@
       </p:sp>
       <p:sp>
         <p:nvSpPr>
-          <p:cNvPr id="186" name="TextBox 185"/>
+          <p:cNvPr id="188" name="TextBox 187"/>
           <p:cNvSpPr txBox="1"/>
           <p:nvPr>
             <p:custDataLst>
-              <p:tags r:id="rId91"/>
+              <p:tags r:id="rId92"/>
             </p:custDataLst>
           </p:nvPr>
         </p:nvSpPr>
@@ -13441,11 +13554,11 @@
       </p:sp>
       <p:sp>
         <p:nvSpPr>
-          <p:cNvPr id="187" name="TextBox 186"/>
+          <p:cNvPr id="189" name="TextBox 188"/>
           <p:cNvSpPr txBox="1"/>
           <p:nvPr>
             <p:custDataLst>
-              <p:tags r:id="rId92"/>
+              <p:tags r:id="rId93"/>
             </p:custDataLst>
           </p:nvPr>
         </p:nvSpPr>
@@ -13492,7 +13605,7 @@
       </p:sp>
       <p:sp>
         <p:nvSpPr>
-          <p:cNvPr id="188" name="Rounded Rectangle 187"/>
+          <p:cNvPr id="190" name="Rounded Rectangle 189"/>
           <p:cNvSpPr/>
           <p:nvPr/>
         </p:nvSpPr>
@@ -13543,11 +13656,11 @@
       </p:sp>
       <p:sp>
         <p:nvSpPr>
-          <p:cNvPr id="189" name="TextBox 188"/>
+          <p:cNvPr id="191" name="TextBox 190"/>
           <p:cNvSpPr txBox="1"/>
           <p:nvPr>
             <p:custDataLst>
-              <p:tags r:id="rId93"/>
+              <p:tags r:id="rId94"/>
             </p:custDataLst>
           </p:nvPr>
         </p:nvSpPr>
@@ -13594,11 +13707,11 @@
       </p:sp>
       <p:sp>
         <p:nvSpPr>
-          <p:cNvPr id="190" name="TextBox 189"/>
+          <p:cNvPr id="192" name="TextBox 191"/>
           <p:cNvSpPr txBox="1"/>
           <p:nvPr>
             <p:custDataLst>
-              <p:tags r:id="rId94"/>
+              <p:tags r:id="rId95"/>
             </p:custDataLst>
           </p:nvPr>
         </p:nvSpPr>
@@ -13645,11 +13758,11 @@
       </p:sp>
       <p:sp>
         <p:nvSpPr>
-          <p:cNvPr id="191" name="TextBox 190"/>
+          <p:cNvPr id="193" name="TextBox 192"/>
           <p:cNvSpPr txBox="1"/>
           <p:nvPr>
             <p:custDataLst>
-              <p:tags r:id="rId95"/>
+              <p:tags r:id="rId96"/>
             </p:custDataLst>
           </p:nvPr>
         </p:nvSpPr>
@@ -13720,11 +13833,11 @@
       </p:sp>
       <p:sp>
         <p:nvSpPr>
-          <p:cNvPr id="192" name="TextBox 191"/>
+          <p:cNvPr id="194" name="TextBox 193"/>
           <p:cNvSpPr txBox="1"/>
           <p:nvPr>
             <p:custDataLst>
-              <p:tags r:id="rId96"/>
+              <p:tags r:id="rId97"/>
             </p:custDataLst>
           </p:nvPr>
         </p:nvSpPr>
@@ -13785,7 +13898,7 @@
 
 <file path=ppt/tags/tag10.xml><?xml version="1.0" encoding="utf-8"?>
 <p:tagLst xmlns:a="http://schemas.openxmlformats.org/drawingml/2006/main" xmlns:r="http://schemas.openxmlformats.org/officeDocument/2006/relationships" xmlns:p="http://schemas.openxmlformats.org/presentationml/2006/main">
-  <p:tag name="ALIGNMENT_TARGET_X" val="209.76377868652344"/>
+  <p:tag name="ALIGNMENT_TARGET_X" val="595.27557373046875"/>
 </p:tagLst>
 </file>
 
@@ -13863,7 +13976,7 @@
 
 <file path=ppt/tags/tag22.xml><?xml version="1.0" encoding="utf-8"?>
 <p:tagLst xmlns:a="http://schemas.openxmlformats.org/drawingml/2006/main" xmlns:r="http://schemas.openxmlformats.org/officeDocument/2006/relationships" xmlns:p="http://schemas.openxmlformats.org/presentationml/2006/main">
-  <p:tag name="ALIGNMENT_TARGET_X" val="467.71652221679688"/>
+  <p:tag name="ALIGNMENT_TARGET_X" val="209.76377868652344"/>
 </p:tagLst>
 </file>
 
@@ -13887,7 +14000,7 @@
 
 <file path=ppt/tags/tag26.xml><?xml version="1.0" encoding="utf-8"?>
 <p:tagLst xmlns:a="http://schemas.openxmlformats.org/drawingml/2006/main" xmlns:r="http://schemas.openxmlformats.org/officeDocument/2006/relationships" xmlns:p="http://schemas.openxmlformats.org/presentationml/2006/main">
-  <p:tag name="ALIGNMENT_TARGET_X" val="748.346435546875"/>
+  <p:tag name="ALIGNMENT_TARGET_X" val="467.71652221679688"/>
 </p:tagLst>
 </file>
 
@@ -13899,7 +14012,7 @@
 
 <file path=ppt/tags/tag28.xml><?xml version="1.0" encoding="utf-8"?>
 <p:tagLst xmlns:a="http://schemas.openxmlformats.org/drawingml/2006/main" xmlns:r="http://schemas.openxmlformats.org/officeDocument/2006/relationships" xmlns:p="http://schemas.openxmlformats.org/presentationml/2006/main">
-  <p:tag name="ALIGNMENT_TARGET_X" val="1009.1338500976563"/>
+  <p:tag name="ALIGNMENT_TARGET_X" val="748.346435546875"/>
 </p:tagLst>
 </file>
 
@@ -13917,7 +14030,7 @@
 
 <file path=ppt/tags/tag30.xml><?xml version="1.0" encoding="utf-8"?>
 <p:tagLst xmlns:a="http://schemas.openxmlformats.org/drawingml/2006/main" xmlns:r="http://schemas.openxmlformats.org/officeDocument/2006/relationships" xmlns:p="http://schemas.openxmlformats.org/presentationml/2006/main">
-  <p:tag name="ALIGNMENT_TARGET_X" val="467.71652221679688"/>
+  <p:tag name="ALIGNMENT_TARGET_X" val="1009.1338500976563"/>
 </p:tagLst>
 </file>
 
@@ -13929,7 +14042,7 @@
 
 <file path=ppt/tags/tag32.xml><?xml version="1.0" encoding="utf-8"?>
 <p:tagLst xmlns:a="http://schemas.openxmlformats.org/drawingml/2006/main" xmlns:r="http://schemas.openxmlformats.org/officeDocument/2006/relationships" xmlns:p="http://schemas.openxmlformats.org/presentationml/2006/main">
-  <p:tag name="ALIGNMENT_TARGET_X" val="748.346435546875"/>
+  <p:tag name="ALIGNMENT_TARGET_X" val="467.71652221679688"/>
 </p:tagLst>
 </file>
 
@@ -13941,37 +14054,37 @@
 
 <file path=ppt/tags/tag34.xml><?xml version="1.0" encoding="utf-8"?>
 <p:tagLst xmlns:a="http://schemas.openxmlformats.org/drawingml/2006/main" xmlns:r="http://schemas.openxmlformats.org/officeDocument/2006/relationships" xmlns:p="http://schemas.openxmlformats.org/presentationml/2006/main">
-  <p:tag name="ALIGNMENT_TARGET_X" val="1009.1338500976563"/>
+  <p:tag name="ALIGNMENT_TARGET_X" val="748.346435546875"/>
 </p:tagLst>
 </file>
 
 <file path=ppt/tags/tag35.xml><?xml version="1.0" encoding="utf-8"?>
 <p:tagLst xmlns:a="http://schemas.openxmlformats.org/drawingml/2006/main" xmlns:r="http://schemas.openxmlformats.org/officeDocument/2006/relationships" xmlns:p="http://schemas.openxmlformats.org/presentationml/2006/main">
-  <p:tag name="ALIGNMENT_TARGET_X" val="931.18112754821777"/>
+  <p:tag name="ALIGNMENT_TARGET_X" val="1009.1338500976563"/>
 </p:tagLst>
 </file>
 
 <file path=ppt/tags/tag36.xml><?xml version="1.0" encoding="utf-8"?>
 <p:tagLst xmlns:a="http://schemas.openxmlformats.org/drawingml/2006/main" xmlns:r="http://schemas.openxmlformats.org/officeDocument/2006/relationships" xmlns:p="http://schemas.openxmlformats.org/presentationml/2006/main">
-  <p:tag name="ALIGNMENT_TARGET_X" val="969.16538047790527"/>
+  <p:tag name="ALIGNMENT_TARGET_X" val="931.18112754821777"/>
 </p:tagLst>
 </file>
 
 <file path=ppt/tags/tag37.xml><?xml version="1.0" encoding="utf-8"?>
 <p:tagLst xmlns:a="http://schemas.openxmlformats.org/drawingml/2006/main" xmlns:r="http://schemas.openxmlformats.org/officeDocument/2006/relationships" xmlns:p="http://schemas.openxmlformats.org/presentationml/2006/main">
-  <p:tag name="ALIGNMENT_TARGET_X" val="1007.1496334075928"/>
+  <p:tag name="ALIGNMENT_TARGET_X" val="969.16538047790527"/>
 </p:tagLst>
 </file>
 
 <file path=ppt/tags/tag38.xml><?xml version="1.0" encoding="utf-8"?>
 <p:tagLst xmlns:a="http://schemas.openxmlformats.org/drawingml/2006/main" xmlns:r="http://schemas.openxmlformats.org/officeDocument/2006/relationships" xmlns:p="http://schemas.openxmlformats.org/presentationml/2006/main">
-  <p:tag name="ALIGNMENT_TARGET_X" val="1045.1338863372803"/>
+  <p:tag name="ALIGNMENT_TARGET_X" val="1007.1496334075928"/>
 </p:tagLst>
 </file>
 
 <file path=ppt/tags/tag39.xml><?xml version="1.0" encoding="utf-8"?>
 <p:tagLst xmlns:a="http://schemas.openxmlformats.org/drawingml/2006/main" xmlns:r="http://schemas.openxmlformats.org/officeDocument/2006/relationships" xmlns:p="http://schemas.openxmlformats.org/presentationml/2006/main">
-  <p:tag name="ALIGNMENT_TARGET_X" val="1083.1181392669678"/>
+  <p:tag name="ALIGNMENT_TARGET_X" val="1045.1338863372803"/>
 </p:tagLst>
 </file>
 
@@ -13983,7 +14096,7 @@
 
 <file path=ppt/tags/tag40.xml><?xml version="1.0" encoding="utf-8"?>
 <p:tagLst xmlns:a="http://schemas.openxmlformats.org/drawingml/2006/main" xmlns:r="http://schemas.openxmlformats.org/officeDocument/2006/relationships" xmlns:p="http://schemas.openxmlformats.org/presentationml/2006/main">
-  <p:tag name="ALIGNMENT_TARGET_X" val="467.71652221679688"/>
+  <p:tag name="ALIGNMENT_TARGET_X" val="1083.1181392669678"/>
 </p:tagLst>
 </file>
 
@@ -13995,7 +14108,7 @@
 
 <file path=ppt/tags/tag42.xml><?xml version="1.0" encoding="utf-8"?>
 <p:tagLst xmlns:a="http://schemas.openxmlformats.org/drawingml/2006/main" xmlns:r="http://schemas.openxmlformats.org/officeDocument/2006/relationships" xmlns:p="http://schemas.openxmlformats.org/presentationml/2006/main">
-  <p:tag name="ALIGNMENT_TARGET_X" val="748.346435546875"/>
+  <p:tag name="ALIGNMENT_TARGET_X" val="467.71652221679688"/>
 </p:tagLst>
 </file>
 
@@ -14007,7 +14120,7 @@
 
 <file path=ppt/tags/tag44.xml><?xml version="1.0" encoding="utf-8"?>
 <p:tagLst xmlns:a="http://schemas.openxmlformats.org/drawingml/2006/main" xmlns:r="http://schemas.openxmlformats.org/officeDocument/2006/relationships" xmlns:p="http://schemas.openxmlformats.org/presentationml/2006/main">
-  <p:tag name="ALIGNMENT_TARGET_X" val="1009.1338500976563"/>
+  <p:tag name="ALIGNMENT_TARGET_X" val="748.346435546875"/>
 </p:tagLst>
 </file>
 
@@ -14025,43 +14138,43 @@
 
 <file path=ppt/tags/tag47.xml><?xml version="1.0" encoding="utf-8"?>
 <p:tagLst xmlns:a="http://schemas.openxmlformats.org/drawingml/2006/main" xmlns:r="http://schemas.openxmlformats.org/officeDocument/2006/relationships" xmlns:p="http://schemas.openxmlformats.org/presentationml/2006/main">
-  <p:tag name="ALIGNMENT_TARGET_X" val="734.1732177734375"/>
+  <p:tag name="ALIGNMENT_TARGET_X" val="1009.1338500976563"/>
 </p:tagLst>
 </file>
 
 <file path=ppt/tags/tag48.xml><?xml version="1.0" encoding="utf-8"?>
 <p:tagLst xmlns:a="http://schemas.openxmlformats.org/drawingml/2006/main" xmlns:r="http://schemas.openxmlformats.org/officeDocument/2006/relationships" xmlns:p="http://schemas.openxmlformats.org/presentationml/2006/main">
-  <p:tag name="ALIGNMENT_TARGET_X" val="467.71652221679688"/>
+  <p:tag name="ALIGNMENT_TARGET_X" val="734.1732177734375"/>
 </p:tagLst>
 </file>
 
 <file path=ppt/tags/tag49.xml><?xml version="1.0" encoding="utf-8"?>
 <p:tagLst xmlns:a="http://schemas.openxmlformats.org/drawingml/2006/main" xmlns:r="http://schemas.openxmlformats.org/officeDocument/2006/relationships" xmlns:p="http://schemas.openxmlformats.org/presentationml/2006/main">
-  <p:tag name="ALIGNMENT_TARGET_X" val="734.17324829101563"/>
+  <p:tag name="ALIGNMENT_TARGET_X" val="467.71652221679688"/>
 </p:tagLst>
 </file>
 
 <file path=ppt/tags/tag5.xml><?xml version="1.0" encoding="utf-8"?>
 <p:tagLst xmlns:a="http://schemas.openxmlformats.org/drawingml/2006/main" xmlns:r="http://schemas.openxmlformats.org/officeDocument/2006/relationships" xmlns:p="http://schemas.openxmlformats.org/presentationml/2006/main">
-  <p:tag name="ALIGNMENT_TARGET_X" val="158.74015426635742"/>
+  <p:tag name="ALIGNMENT_TARGET_X" val="595.27558898925781"/>
 </p:tagLst>
 </file>
 
 <file path=ppt/tags/tag50.xml><?xml version="1.0" encoding="utf-8"?>
 <p:tagLst xmlns:a="http://schemas.openxmlformats.org/drawingml/2006/main" xmlns:r="http://schemas.openxmlformats.org/officeDocument/2006/relationships" xmlns:p="http://schemas.openxmlformats.org/presentationml/2006/main">
-  <p:tag name="ALIGNMENT_TARGET_X" val="1000.6299133300781"/>
+  <p:tag name="ALIGNMENT_TARGET_X" val="734.17324829101563"/>
 </p:tagLst>
 </file>
 
 <file path=ppt/tags/tag51.xml><?xml version="1.0" encoding="utf-8"?>
 <p:tagLst xmlns:a="http://schemas.openxmlformats.org/drawingml/2006/main" xmlns:r="http://schemas.openxmlformats.org/officeDocument/2006/relationships" xmlns:p="http://schemas.openxmlformats.org/presentationml/2006/main">
-  <p:tag name="ALIGNMENT_TARGET_X" val="734.1732177734375"/>
+  <p:tag name="ALIGNMENT_TARGET_X" val="1000.6299133300781"/>
 </p:tagLst>
 </file>
 
 <file path=ppt/tags/tag52.xml><?xml version="1.0" encoding="utf-8"?>
 <p:tagLst xmlns:a="http://schemas.openxmlformats.org/drawingml/2006/main" xmlns:r="http://schemas.openxmlformats.org/officeDocument/2006/relationships" xmlns:p="http://schemas.openxmlformats.org/presentationml/2006/main">
-  <p:tag name="ALIGNMENT_TARGET_X" val="595.27557373046875"/>
+  <p:tag name="ALIGNMENT_TARGET_X" val="734.1732177734375"/>
 </p:tagLst>
 </file>
 
@@ -14073,7 +14186,7 @@
 
 <file path=ppt/tags/tag54.xml><?xml version="1.0" encoding="utf-8"?>
 <p:tagLst xmlns:a="http://schemas.openxmlformats.org/drawingml/2006/main" xmlns:r="http://schemas.openxmlformats.org/officeDocument/2006/relationships" xmlns:p="http://schemas.openxmlformats.org/presentationml/2006/main">
-  <p:tag name="ALIGNMENT_TARGET_X" val="238.11023712158203"/>
+  <p:tag name="ALIGNMENT_TARGET_X" val="595.27557373046875"/>
 </p:tagLst>
 </file>
 
@@ -14085,7 +14198,7 @@
 
 <file path=ppt/tags/tag56.xml><?xml version="1.0" encoding="utf-8"?>
 <p:tagLst xmlns:a="http://schemas.openxmlformats.org/drawingml/2006/main" xmlns:r="http://schemas.openxmlformats.org/officeDocument/2006/relationships" xmlns:p="http://schemas.openxmlformats.org/presentationml/2006/main">
-  <p:tag name="ALIGNMENT_TARGET_X" val="595.27558898925781"/>
+  <p:tag name="ALIGNMENT_TARGET_X" val="238.11023712158203"/>
 </p:tagLst>
 </file>
 
@@ -14097,7 +14210,7 @@
 
 <file path=ppt/tags/tag58.xml><?xml version="1.0" encoding="utf-8"?>
 <p:tagLst xmlns:a="http://schemas.openxmlformats.org/drawingml/2006/main" xmlns:r="http://schemas.openxmlformats.org/officeDocument/2006/relationships" xmlns:p="http://schemas.openxmlformats.org/presentationml/2006/main">
-  <p:tag name="ALIGNMENT_TARGET_X" val="952.44096374511719"/>
+  <p:tag name="ALIGNMENT_TARGET_X" val="595.27558898925781"/>
 </p:tagLst>
 </file>
 
@@ -14109,91 +14222,91 @@
 
 <file path=ppt/tags/tag6.xml><?xml version="1.0" encoding="utf-8"?>
 <p:tagLst xmlns:a="http://schemas.openxmlformats.org/drawingml/2006/main" xmlns:r="http://schemas.openxmlformats.org/officeDocument/2006/relationships" xmlns:p="http://schemas.openxmlformats.org/presentationml/2006/main">
-  <p:tag name="ALIGNMENT_TARGET_X" val="449.85825729370117"/>
+  <p:tag name="ALIGNMENT_TARGET_X" val="158.74015426635742"/>
 </p:tagLst>
 </file>
 
 <file path=ppt/tags/tag60.xml><?xml version="1.0" encoding="utf-8"?>
 <p:tagLst xmlns:a="http://schemas.openxmlformats.org/drawingml/2006/main" xmlns:r="http://schemas.openxmlformats.org/officeDocument/2006/relationships" xmlns:p="http://schemas.openxmlformats.org/presentationml/2006/main">
-  <p:tag name="ALIGNMENT_TARGET_X" val="595.27557373046875"/>
+  <p:tag name="ALIGNMENT_TARGET_X" val="952.44096374511719"/>
 </p:tagLst>
 </file>
 
 <file path=ppt/tags/tag61.xml><?xml version="1.0" encoding="utf-8"?>
 <p:tagLst xmlns:a="http://schemas.openxmlformats.org/drawingml/2006/main" xmlns:r="http://schemas.openxmlformats.org/officeDocument/2006/relationships" xmlns:p="http://schemas.openxmlformats.org/presentationml/2006/main">
-  <p:tag name="ALIGNMENT_TARGET_X" val="328.81890869140625"/>
+  <p:tag name="ALIGNMENT_TARGET_X" val="595.27557373046875"/>
 </p:tagLst>
 </file>
 
 <file path=ppt/tags/tag62.xml><?xml version="1.0" encoding="utf-8"?>
 <p:tagLst xmlns:a="http://schemas.openxmlformats.org/drawingml/2006/main" xmlns:r="http://schemas.openxmlformats.org/officeDocument/2006/relationships" xmlns:p="http://schemas.openxmlformats.org/presentationml/2006/main">
-  <p:tag name="ALIGNMENT_TARGET_X" val="68.031494140625"/>
+  <p:tag name="ALIGNMENT_TARGET_X" val="328.81890869140625"/>
 </p:tagLst>
 </file>
 
 <file path=ppt/tags/tag63.xml><?xml version="1.0" encoding="utf-8"?>
 <p:tagLst xmlns:a="http://schemas.openxmlformats.org/drawingml/2006/main" xmlns:r="http://schemas.openxmlformats.org/officeDocument/2006/relationships" xmlns:p="http://schemas.openxmlformats.org/presentationml/2006/main">
-  <p:tag name="ALIGNMENT_TARGET_X" val="583.93700408935547"/>
+  <p:tag name="ALIGNMENT_TARGET_X" val="68.031494140625"/>
 </p:tagLst>
 </file>
 
 <file path=ppt/tags/tag64.xml><?xml version="1.0" encoding="utf-8"?>
 <p:tagLst xmlns:a="http://schemas.openxmlformats.org/drawingml/2006/main" xmlns:r="http://schemas.openxmlformats.org/officeDocument/2006/relationships" xmlns:p="http://schemas.openxmlformats.org/presentationml/2006/main">
-  <p:tag name="ALIGNMENT_TARGET_X" val="68.031494140625"/>
+  <p:tag name="ALIGNMENT_TARGET_X" val="583.93700408935547"/>
 </p:tagLst>
 </file>
 
 <file path=ppt/tags/tag65.xml><?xml version="1.0" encoding="utf-8"?>
 <p:tagLst xmlns:a="http://schemas.openxmlformats.org/drawingml/2006/main" xmlns:r="http://schemas.openxmlformats.org/officeDocument/2006/relationships" xmlns:p="http://schemas.openxmlformats.org/presentationml/2006/main">
-  <p:tag name="ALIGNMENT_TARGET_X" val="583.93700408935547"/>
+  <p:tag name="ALIGNMENT_TARGET_X" val="68.031494140625"/>
 </p:tagLst>
 </file>
 
 <file path=ppt/tags/tag66.xml><?xml version="1.0" encoding="utf-8"?>
 <p:tagLst xmlns:a="http://schemas.openxmlformats.org/drawingml/2006/main" xmlns:r="http://schemas.openxmlformats.org/officeDocument/2006/relationships" xmlns:p="http://schemas.openxmlformats.org/presentationml/2006/main">
-  <p:tag name="ALIGNMENT_TARGET_X" val="68.031494140625"/>
+  <p:tag name="ALIGNMENT_TARGET_X" val="583.93700408935547"/>
 </p:tagLst>
 </file>
 
 <file path=ppt/tags/tag67.xml><?xml version="1.0" encoding="utf-8"?>
 <p:tagLst xmlns:a="http://schemas.openxmlformats.org/drawingml/2006/main" xmlns:r="http://schemas.openxmlformats.org/officeDocument/2006/relationships" xmlns:p="http://schemas.openxmlformats.org/presentationml/2006/main">
-  <p:tag name="ALIGNMENT_TARGET_X" val="583.93700408935547"/>
+  <p:tag name="ALIGNMENT_TARGET_X" val="68.031494140625"/>
 </p:tagLst>
 </file>
 
 <file path=ppt/tags/tag68.xml><?xml version="1.0" encoding="utf-8"?>
 <p:tagLst xmlns:a="http://schemas.openxmlformats.org/drawingml/2006/main" xmlns:r="http://schemas.openxmlformats.org/officeDocument/2006/relationships" xmlns:p="http://schemas.openxmlformats.org/presentationml/2006/main">
-  <p:tag name="ALIGNMENT_TARGET_X" val="187.08660888671875"/>
+  <p:tag name="ALIGNMENT_TARGET_X" val="583.93700408935547"/>
 </p:tagLst>
 </file>
 
 <file path=ppt/tags/tag69.xml><?xml version="1.0" encoding="utf-8"?>
 <p:tagLst xmlns:a="http://schemas.openxmlformats.org/drawingml/2006/main" xmlns:r="http://schemas.openxmlformats.org/officeDocument/2006/relationships" xmlns:p="http://schemas.openxmlformats.org/presentationml/2006/main">
-  <p:tag name="ALIGNMENT_TARGET_X" val="320.31497192382813"/>
+  <p:tag name="ALIGNMENT_TARGET_X" val="187.08660888671875"/>
 </p:tagLst>
 </file>
 
 <file path=ppt/tags/tag7.xml><?xml version="1.0" encoding="utf-8"?>
 <p:tagLst xmlns:a="http://schemas.openxmlformats.org/drawingml/2006/main" xmlns:r="http://schemas.openxmlformats.org/officeDocument/2006/relationships" xmlns:p="http://schemas.openxmlformats.org/presentationml/2006/main">
-  <p:tag name="ALIGNMENT_TARGET_X" val="740.97636032104492"/>
+  <p:tag name="ALIGNMENT_TARGET_X" val="449.85825729370117"/>
 </p:tagLst>
 </file>
 
 <file path=ppt/tags/tag70.xml><?xml version="1.0" encoding="utf-8"?>
 <p:tagLst xmlns:a="http://schemas.openxmlformats.org/drawingml/2006/main" xmlns:r="http://schemas.openxmlformats.org/officeDocument/2006/relationships" xmlns:p="http://schemas.openxmlformats.org/presentationml/2006/main">
-  <p:tag name="ALIGNMENT_TARGET_X" val="453.54330444335938"/>
+  <p:tag name="ALIGNMENT_TARGET_X" val="320.31497192382813"/>
 </p:tagLst>
 </file>
 
 <file path=ppt/tags/tag71.xml><?xml version="1.0" encoding="utf-8"?>
 <p:tagLst xmlns:a="http://schemas.openxmlformats.org/drawingml/2006/main" xmlns:r="http://schemas.openxmlformats.org/officeDocument/2006/relationships" xmlns:p="http://schemas.openxmlformats.org/presentationml/2006/main">
-  <p:tag name="ALIGNMENT_TARGET_X" val="328.81890869140625"/>
+  <p:tag name="ALIGNMENT_TARGET_X" val="453.54330444335938"/>
 </p:tagLst>
 </file>
 
 <file path=ppt/tags/tag72.xml><?xml version="1.0" encoding="utf-8"?>
 <p:tagLst xmlns:a="http://schemas.openxmlformats.org/drawingml/2006/main" xmlns:r="http://schemas.openxmlformats.org/officeDocument/2006/relationships" xmlns:p="http://schemas.openxmlformats.org/presentationml/2006/main">
-  <p:tag name="ALIGNMENT_TARGET_X" val="873.07089233398438"/>
+  <p:tag name="ALIGNMENT_TARGET_X" val="328.81890869140625"/>
 </p:tagLst>
 </file>
 
@@ -14211,7 +14324,7 @@
 
 <file path=ppt/tags/tag75.xml><?xml version="1.0" encoding="utf-8"?>
 <p:tagLst xmlns:a="http://schemas.openxmlformats.org/drawingml/2006/main" xmlns:r="http://schemas.openxmlformats.org/officeDocument/2006/relationships" xmlns:p="http://schemas.openxmlformats.org/presentationml/2006/main">
-  <p:tag name="ALIGNMENT_TARGET_X" val="701.5748291015625"/>
+  <p:tag name="ALIGNMENT_TARGET_X" val="873.07089233398438"/>
 </p:tagLst>
 </file>
 
@@ -14223,7 +14336,7 @@
 
 <file path=ppt/tags/tag77.xml><?xml version="1.0" encoding="utf-8"?>
 <p:tagLst xmlns:a="http://schemas.openxmlformats.org/drawingml/2006/main" xmlns:r="http://schemas.openxmlformats.org/officeDocument/2006/relationships" xmlns:p="http://schemas.openxmlformats.org/presentationml/2006/main">
-  <p:tag name="ALIGNMENT_TARGET_X" val="869.6693115234375"/>
+  <p:tag name="ALIGNMENT_TARGET_X" val="701.5748291015625"/>
 </p:tagLst>
 </file>
 
@@ -14235,13 +14348,13 @@
 
 <file path=ppt/tags/tag79.xml><?xml version="1.0" encoding="utf-8"?>
 <p:tagLst xmlns:a="http://schemas.openxmlformats.org/drawingml/2006/main" xmlns:r="http://schemas.openxmlformats.org/officeDocument/2006/relationships" xmlns:p="http://schemas.openxmlformats.org/presentationml/2006/main">
-  <p:tag name="ALIGNMENT_TARGET_X" val="1037.7637939453125"/>
+  <p:tag name="ALIGNMENT_TARGET_X" val="869.6693115234375"/>
 </p:tagLst>
 </file>
 
 <file path=ppt/tags/tag8.xml><?xml version="1.0" encoding="utf-8"?>
 <p:tagLst xmlns:a="http://schemas.openxmlformats.org/drawingml/2006/main" xmlns:r="http://schemas.openxmlformats.org/officeDocument/2006/relationships" xmlns:p="http://schemas.openxmlformats.org/presentationml/2006/main">
-  <p:tag name="ALIGNMENT_TARGET_X" val="1032.0944633483887"/>
+  <p:tag name="ALIGNMENT_TARGET_X" val="740.97636032104492"/>
 </p:tagLst>
 </file>
 
@@ -14253,19 +14366,19 @@
 
 <file path=ppt/tags/tag81.xml><?xml version="1.0" encoding="utf-8"?>
 <p:tagLst xmlns:a="http://schemas.openxmlformats.org/drawingml/2006/main" xmlns:r="http://schemas.openxmlformats.org/officeDocument/2006/relationships" xmlns:p="http://schemas.openxmlformats.org/presentationml/2006/main">
-  <p:tag name="ALIGNMENT_TARGET_X" val="873.07089233398438"/>
+  <p:tag name="ALIGNMENT_TARGET_X" val="1037.7637939453125"/>
 </p:tagLst>
 </file>
 
 <file path=ppt/tags/tag82.xml><?xml version="1.0" encoding="utf-8"?>
 <p:tagLst xmlns:a="http://schemas.openxmlformats.org/drawingml/2006/main" xmlns:r="http://schemas.openxmlformats.org/officeDocument/2006/relationships" xmlns:p="http://schemas.openxmlformats.org/presentationml/2006/main">
-  <p:tag name="ALIGNMENT_TARGET_X" val="170.07874298095703"/>
+  <p:tag name="ALIGNMENT_TARGET_X" val="873.07089233398438"/>
 </p:tagLst>
 </file>
 
 <file path=ppt/tags/tag83.xml><?xml version="1.0" encoding="utf-8"?>
 <p:tagLst xmlns:a="http://schemas.openxmlformats.org/drawingml/2006/main" xmlns:r="http://schemas.openxmlformats.org/officeDocument/2006/relationships" xmlns:p="http://schemas.openxmlformats.org/presentationml/2006/main">
-  <p:tag name="ALIGNMENT_TARGET_X" val="308.97637939453125"/>
+  <p:tag name="ALIGNMENT_TARGET_X" val="170.07874298095703"/>
 </p:tagLst>
 </file>
 
@@ -14277,7 +14390,7 @@
 
 <file path=ppt/tags/tag85.xml><?xml version="1.0" encoding="utf-8"?>
 <p:tagLst xmlns:a="http://schemas.openxmlformats.org/drawingml/2006/main" xmlns:r="http://schemas.openxmlformats.org/officeDocument/2006/relationships" xmlns:p="http://schemas.openxmlformats.org/presentationml/2006/main">
-  <p:tag name="ALIGNMENT_TARGET_X" val="402.51968383789063"/>
+  <p:tag name="ALIGNMENT_TARGET_X" val="308.97637939453125"/>
 </p:tagLst>
 </file>
 
@@ -14289,7 +14402,7 @@
 
 <file path=ppt/tags/tag87.xml><?xml version="1.0" encoding="utf-8"?>
 <p:tagLst xmlns:a="http://schemas.openxmlformats.org/drawingml/2006/main" xmlns:r="http://schemas.openxmlformats.org/officeDocument/2006/relationships" xmlns:p="http://schemas.openxmlformats.org/presentationml/2006/main">
-  <p:tag name="ALIGNMENT_TARGET_X" val="496.06298828125"/>
+  <p:tag name="ALIGNMENT_TARGET_X" val="402.51968383789063"/>
 </p:tagLst>
 </file>
 
@@ -14301,13 +14414,13 @@
 
 <file path=ppt/tags/tag89.xml><?xml version="1.0" encoding="utf-8"?>
 <p:tagLst xmlns:a="http://schemas.openxmlformats.org/drawingml/2006/main" xmlns:r="http://schemas.openxmlformats.org/officeDocument/2006/relationships" xmlns:p="http://schemas.openxmlformats.org/presentationml/2006/main">
-  <p:tag name="ALIGNMENT_TARGET_X" val="589.60629272460938"/>
+  <p:tag name="ALIGNMENT_TARGET_X" val="496.06298828125"/>
 </p:tagLst>
 </file>
 
 <file path=ppt/tags/tag9.xml><?xml version="1.0" encoding="utf-8"?>
 <p:tagLst xmlns:a="http://schemas.openxmlformats.org/drawingml/2006/main" xmlns:r="http://schemas.openxmlformats.org/officeDocument/2006/relationships" xmlns:p="http://schemas.openxmlformats.org/presentationml/2006/main">
-  <p:tag name="ALIGNMENT_TARGET_X" val="595.27557373046875"/>
+  <p:tag name="ALIGNMENT_TARGET_X" val="1032.0944633483887"/>
 </p:tagLst>
 </file>
 
@@ -14319,7 +14432,7 @@
 
 <file path=ppt/tags/tag91.xml><?xml version="1.0" encoding="utf-8"?>
 <p:tagLst xmlns:a="http://schemas.openxmlformats.org/drawingml/2006/main" xmlns:r="http://schemas.openxmlformats.org/officeDocument/2006/relationships" xmlns:p="http://schemas.openxmlformats.org/presentationml/2006/main">
-  <p:tag name="ALIGNMENT_TARGET_X" val="683.14962768554688"/>
+  <p:tag name="ALIGNMENT_TARGET_X" val="589.60629272460938"/>
 </p:tagLst>
 </file>
 
@@ -14331,7 +14444,7 @@
 
 <file path=ppt/tags/tag93.xml><?xml version="1.0" encoding="utf-8"?>
 <p:tagLst xmlns:a="http://schemas.openxmlformats.org/drawingml/2006/main" xmlns:r="http://schemas.openxmlformats.org/officeDocument/2006/relationships" xmlns:p="http://schemas.openxmlformats.org/presentationml/2006/main">
-  <p:tag name="ALIGNMENT_TARGET_X" val="776.69290161132813"/>
+  <p:tag name="ALIGNMENT_TARGET_X" val="683.14962768554688"/>
 </p:tagLst>
 </file>
 
@@ -14343,11 +14456,17 @@
 
 <file path=ppt/tags/tag95.xml><?xml version="1.0" encoding="utf-8"?>
 <p:tagLst xmlns:a="http://schemas.openxmlformats.org/drawingml/2006/main" xmlns:r="http://schemas.openxmlformats.org/officeDocument/2006/relationships" xmlns:p="http://schemas.openxmlformats.org/presentationml/2006/main">
+  <p:tag name="ALIGNMENT_TARGET_X" val="776.69290161132813"/>
+</p:tagLst>
+</file>
+
+<file path=ppt/tags/tag96.xml><?xml version="1.0" encoding="utf-8"?>
+<p:tagLst xmlns:a="http://schemas.openxmlformats.org/drawingml/2006/main" xmlns:r="http://schemas.openxmlformats.org/officeDocument/2006/relationships" xmlns:p="http://schemas.openxmlformats.org/presentationml/2006/main">
   <p:tag name="ALIGNMENT_TARGET_X" val="975.11810302734375"/>
 </p:tagLst>
 </file>
 
-<file path=ppt/tags/tag96.xml><?xml version="1.0" encoding="utf-8"?>
+<file path=ppt/tags/tag97.xml><?xml version="1.0" encoding="utf-8"?>
 <p:tagLst xmlns:a="http://schemas.openxmlformats.org/drawingml/2006/main" xmlns:r="http://schemas.openxmlformats.org/officeDocument/2006/relationships" xmlns:p="http://schemas.openxmlformats.org/presentationml/2006/main">
   <p:tag name="ALIGNMENT_TARGET_X" val="595.27557373046875"/>
 </p:tagLst>

</xml_diff>

<commit_message>
Set the poster title on two wide lines
The A2 title now breaks after 入侵偵測 into two lines at 57pt with 1.1
line spacing. PowerPoint measures the first line at 367.6 mm of the
372 mm frame and the block at 51 mm high, with no overflow; the frame
and the rest of the layout are unchanged.

Co-Authored-By: Claude Opus 5.5 <noreply@anthropic.com>
</commit_message>
<xml_diff>
--- a/deliverables/決賽海報_AI資安框架_A2.pptx
+++ b/deliverables/決賽海報_AI資安框架_A2.pptx
@@ -4185,7 +4185,7 @@
         </p:nvSpPr>
         <p:spPr>
           <a:xfrm>
-            <a:off x="765575" y="720000"/>
+            <a:off x="763987" y="720000"/>
             <a:ext cx="13392000" cy="2556000"/>
           </a:xfrm>
           <a:prstGeom prst="rect">
@@ -4201,7 +4201,7 @@
           <a:p>
             <a:pPr algn="ctr">
               <a:lnSpc>
-                <a:spcPct val="100000"/>
+                <a:spcPct val="110000"/>
               </a:lnSpc>
               <a:spcBef>
                 <a:spcPts val="0"/>
@@ -4211,7 +4211,7 @@
               </a:spcAft>
             </a:pPr>
             <a:r>
-              <a:rPr sz="5600" b="1">
+              <a:rPr sz="5700" b="1">
                 <a:solidFill>
                   <a:srgbClr val="0B1B2E"/>
                 </a:solidFill>
@@ -4219,13 +4219,13 @@
                 <a:ea typeface="Microsoft JhengHei"/>
                 <a:cs typeface="Segoe UI"/>
               </a:rPr>
-              <a:t>融合新型內容相依時序方向模型</a:t>
+              <a:t>融合新型內容相依時序方向模型入侵偵測</a:t>
             </a:r>
           </a:p>
           <a:p>
             <a:pPr algn="ctr">
               <a:lnSpc>
-                <a:spcPct val="100000"/>
+                <a:spcPct val="110000"/>
               </a:lnSpc>
               <a:spcBef>
                 <a:spcPts val="0"/>
@@ -4235,7 +4235,7 @@
               </a:spcAft>
             </a:pPr>
             <a:r>
-              <a:rPr sz="5600" b="1">
+              <a:rPr sz="5700" b="1">
                 <a:solidFill>
                   <a:srgbClr val="0B1B2E"/>
                 </a:solidFill>
@@ -4243,31 +4243,7 @@
                 <a:ea typeface="Microsoft JhengHei"/>
                 <a:cs typeface="Segoe UI"/>
               </a:rPr>
-              <a:t>入侵偵測與任務導向檢索增強稽核</a:t>
-            </a:r>
-          </a:p>
-          <a:p>
-            <a:pPr algn="ctr">
-              <a:lnSpc>
-                <a:spcPct val="100000"/>
-              </a:lnSpc>
-              <a:spcBef>
-                <a:spcPts val="0"/>
-              </a:spcBef>
-              <a:spcAft>
-                <a:spcPts val="0"/>
-              </a:spcAft>
-            </a:pPr>
-            <a:r>
-              <a:rPr sz="5600" b="1">
-                <a:solidFill>
-                  <a:srgbClr val="0B1B2E"/>
-                </a:solidFill>
-                <a:latin typeface="Segoe UI"/>
-                <a:ea typeface="Microsoft JhengHei"/>
-                <a:cs typeface="Segoe UI"/>
-              </a:rPr>
-              <a:t>之 AI 資安框架</a:t>
+              <a:t>與任務導向檢索增強稽核之 AI 資安框架</a:t>
             </a:r>
           </a:p>
         </p:txBody>

</xml_diff>

<commit_message>
Cite the original PBCNN paper
Crossref confirms PBCNN as Yu et al., Computer Networks 194 (2021)
108117, DOI 10.1016/j.comnet.2021.108117. The poster and cover
originality notes and the slide 4 footer now cite (Yu et al., 2021),
and the README method section gives the full reference alongside the
originality statement. Poster and deck rebuilt, aligned and exported;
slide sources, previews, zip and manifests regenerated.

Co-Authored-By: Claude Opus 5.5 <noreply@anthropic.com>
</commit_message>
<xml_diff>
--- a/deliverables/決賽海報_AI資安框架_A2.pptx
+++ b/deliverables/決賽海報_AI資安框架_A2.pptx
@@ -4407,8 +4407,8 @@
         </p:nvSpPr>
         <p:spPr>
           <a:xfrm>
-            <a:off x="2880000" y="4266000"/>
-            <a:ext cx="9360000" cy="288000"/>
+            <a:off x="1800000" y="4266000"/>
+            <a:ext cx="11520000" cy="288000"/>
           </a:xfrm>
           <a:prstGeom prst="roundRect">
             <a:avLst>
@@ -4462,8 +4462,8 @@
         </p:nvSpPr>
         <p:spPr>
           <a:xfrm>
-            <a:off x="2855394" y="4266000"/>
-            <a:ext cx="9360000" cy="288000"/>
+            <a:off x="1775394" y="4266000"/>
+            <a:ext cx="11520000" cy="288000"/>
           </a:xfrm>
           <a:prstGeom prst="rect">
             <a:avLst/>
@@ -4507,7 +4507,7 @@
                 <a:ea typeface="Microsoft JhengHei"/>
                 <a:cs typeface="Segoe UI"/>
               </a:rPr>
-              <a:t>本團隊原創：CTBM、校準融合、任務導向檢索、本機AI稽核、受控回復　｜　引用既有：PBCNN</a:t>
+              <a:t>本團隊原創：CTBM、校準融合、任務導向檢索、本機AI稽核、受控回復　｜　引用既有：PBCNN（Yu et al., 2021）</a:t>
             </a:r>
           </a:p>
         </p:txBody>

</xml_diff>